<commit_message>
Focus report on 20s-30s hiring goal; add selection-funnel slide
- State the 20s-30s target explicitly in summary and overview slides
- Add age-breakdown of applicants (8 of 12 in target range) to results
- New slide: selection transition rates, blockers, and countermeasures
- Strengthen recommendation on improving young-applicant follow-up

Co-Authored-By: Claude Fable 5 <noreply@anthropic.com>
Claude-Session: https://claude.ai/code/session_019t7NW6utTEgroUuPVV8xiA
</commit_message>
<xml_diff>
--- a/reports/matsushita-kogyo/松下工業様_採用強化支援_総括レポート.pptx
+++ b/reports/matsushita-kogyo/松下工業様_採用強化支援_総括レポート.pptx
@@ -18,9 +18,10 @@
     <p:sldId id="266" r:id="rId12"/>
     <p:sldId id="267" r:id="rId13"/>
     <p:sldId id="268" r:id="rId14"/>
+    <p:sldId id="269" r:id="rId15"/>
   </p:sldIdLst>
   <p:notesMasterIdLst>
-    <p:notesMasterId r:id="rId15"/>
+    <p:notesMasterId r:id="rId16"/>
   </p:notesMasterIdLst>
   <p:sldSz cx="12192000" cy="6858000"/>
   <p:notesSz cx="6858000" cy="12192000"/>
@@ -1465,6 +1466,94 @@
             <a:fld id="{F7021451-1387-4CA6-816F-3879F97B5CBC}" type="slidenum">
               <a:rPr lang="en-US"/>
               <a:t>13</a:t>
+            </a:fld>
+            <a:endParaRPr lang="en-US"/>
+          </a:p>
+        </p:txBody>
+      </p:sp>
+    </p:spTree>
+    <p:extLst>
+      <p:ext uri="{BB962C8B-B14F-4D97-AF65-F5344CB8AC3E}">
+        <p14:creationId xmlns:p14="http://schemas.microsoft.com/office/powerpoint/2010/main" val="1024086991"/>
+      </p:ext>
+    </p:extLst>
+  </p:cSld>
+  <p:clrMapOvr>
+    <a:masterClrMapping/>
+  </p:clrMapOvr>
+</p:notes>
+</file>
+
+<file path=ppt/notesSlides/notesSlide14.xml><?xml version="1.0" encoding="utf-8"?>
+<p:notes xmlns:a="http://schemas.openxmlformats.org/drawingml/2006/main" xmlns:r="http://schemas.openxmlformats.org/officeDocument/2006/relationships" xmlns:p="http://schemas.openxmlformats.org/presentationml/2006/main">
+  <p:cSld>
+    <p:spTree>
+      <p:nvGrpSpPr>
+        <p:cNvPr id="1" name=""/>
+        <p:cNvGrpSpPr/>
+        <p:nvPr/>
+      </p:nvGrpSpPr>
+      <p:grpSpPr>
+        <a:xfrm>
+          <a:off x="0" y="0"/>
+          <a:ext cx="0" cy="0"/>
+          <a:chOff x="0" y="0"/>
+          <a:chExt cx="0" cy="0"/>
+        </a:xfrm>
+      </p:grpSpPr>
+      <p:sp>
+        <p:nvSpPr>
+          <p:cNvPr id="2" name="Slide Image Placeholder 1"/>
+          <p:cNvSpPr>
+            <a:spLocks noGrp="1" noRot="1" noChangeAspect="1"/>
+          </p:cNvSpPr>
+          <p:nvPr>
+            <p:ph type="sldImg"/>
+          </p:nvPr>
+        </p:nvSpPr>
+        <p:spPr/>
+      </p:sp>
+      <p:sp>
+        <p:nvSpPr>
+          <p:cNvPr id="3" name="Notes Placeholder 2"/>
+          <p:cNvSpPr>
+            <a:spLocks noGrp="1"/>
+          </p:cNvSpPr>
+          <p:nvPr>
+            <p:ph type="body" idx="1"/>
+          </p:nvPr>
+        </p:nvSpPr>
+        <p:spPr/>
+        <p:txBody>
+          <a:bodyPr/>
+          <a:lstStyle/>
+          <a:p>
+            <a:r>
+              <a:rPr lang="en-US" dirty="0"/>
+              <a:t/>
+            </a:r>
+            <a:endParaRPr lang="en-US" dirty="0"/>
+          </a:p>
+        </p:txBody>
+      </p:sp>
+      <p:sp>
+        <p:nvSpPr>
+          <p:cNvPr id="4" name="Slide Number Placeholder 3"/>
+          <p:cNvSpPr>
+            <a:spLocks noGrp="1"/>
+          </p:cNvSpPr>
+          <p:nvPr>
+            <p:ph type="sldNum" sz="quarter" idx="10"/>
+          </p:nvPr>
+        </p:nvSpPr>
+        <p:spPr/>
+        <p:txBody>
+          <a:bodyPr/>
+          <a:lstStyle/>
+          <a:p>
+            <a:fld id="{F7021451-1387-4CA6-816F-3879F97B5CBC}" type="slidenum">
+              <a:rPr lang="en-US"/>
+              <a:t>14</a:t>
             </a:fld>
             <a:endParaRPr lang="en-US"/>
           </a:p>
@@ -2860,7 +2949,7 @@
                 <a:ea typeface="Yu Gothic" pitchFamily="34" charset="-122"/>
                 <a:cs typeface="Yu Gothic" pitchFamily="34" charset="-120"/>
               </a:rPr>
-              <a:t>応募ゼロの状態から、複数媒体で毎月応募が発生する状態へ</a:t>
+              <a:t>応募ゼロの状態から、20〜30代を中心に毎月応募が発生する状態へ</a:t>
             </a:r>
             <a:endParaRPr lang="en-US" sz="1300" dirty="0"/>
           </a:p>
@@ -3029,7 +3118,7 @@
                 <a:ea typeface="Yu Gothic" pitchFamily="34" charset="-122"/>
                 <a:cs typeface="Yu Gothic" pitchFamily="34" charset="-120"/>
               </a:rPr>
-              <a:t>採用ファネルの現在地</a:t>
+              <a:t>年齢帯別の応募実績 ─ ターゲット層(20・30代)に到達</a:t>
             </a:r>
             <a:endParaRPr lang="en-US" sz="1500" dirty="0"/>
           </a:p>
@@ -3044,7 +3133,7 @@
         <p:spPr>
           <a:xfrm>
             <a:off x="6309360" y="2148840"/>
-            <a:ext cx="5303520" cy="566928"/>
+            <a:ext cx="5349240" cy="566928"/>
           </a:xfrm>
           <a:prstGeom prst="roundRect">
             <a:avLst>
@@ -3052,7 +3141,7 @@
             </a:avLst>
           </a:prstGeom>
           <a:solidFill>
-            <a:srgbClr val="1B3A5C"/>
+            <a:srgbClr val="E8762C"/>
           </a:solidFill>
           <a:ln/>
         </p:spPr>
@@ -3066,7 +3155,7 @@
         <p:spPr>
           <a:xfrm>
             <a:off x="6492240" y="2148840"/>
-            <a:ext cx="5029200" cy="566928"/>
+            <a:ext cx="5074920" cy="566928"/>
           </a:xfrm>
           <a:prstGeom prst="rect">
             <a:avLst/>
@@ -3082,7 +3171,7 @@
               <a:buNone/>
             </a:pPr>
             <a:r>
-              <a:rPr lang="en-US" sz="1200" b="1" dirty="0">
+              <a:rPr lang="en-US" sz="1250" b="1" dirty="0">
                 <a:solidFill>
                   <a:srgbClr val="FFFFFF"/>
                 </a:solidFill>
@@ -3090,13 +3179,13 @@
                 <a:ea typeface="Yu Gothic" pitchFamily="34" charset="-122"/>
                 <a:cs typeface="Yu Gothic" pitchFamily="34" charset="-120"/>
               </a:rPr>
-              <a:t>表示(露出)  </a:t>
+              <a:t>20代  </a:t>
             </a:r>
             <a:pPr indent="0" marL="0">
               <a:buNone/>
             </a:pPr>
             <a:r>
-              <a:rPr lang="en-US" sz="1200" dirty="0">
+              <a:rPr lang="en-US" sz="1250" b="1" dirty="0">
                 <a:solidFill>
                   <a:srgbClr val="FFFFFF"/>
                 </a:solidFill>
@@ -3104,9 +3193,23 @@
                 <a:ea typeface="Yu Gothic" pitchFamily="34" charset="-122"/>
                 <a:cs typeface="Yu Gothic" pitchFamily="34" charset="-120"/>
               </a:rPr>
-              <a:t>約28,000回+</a:t>
-            </a:r>
-            <a:endParaRPr lang="en-US" sz="1200" dirty="0"/>
+              <a:t>5名  </a:t>
+            </a:r>
+            <a:pPr indent="0" marL="0">
+              <a:buNone/>
+            </a:pPr>
+            <a:r>
+              <a:rPr lang="en-US" sz="950" dirty="0">
+                <a:solidFill>
+                  <a:srgbClr val="FFFFFF"/>
+                </a:solidFill>
+                <a:latin typeface="Yu Gothic" pitchFamily="34" charset="0"/>
+                <a:ea typeface="Yu Gothic" pitchFamily="34" charset="-122"/>
+                <a:cs typeface="Yu Gothic" pitchFamily="34" charset="-120"/>
+              </a:rPr>
+              <a:t>(21・23・24・29・29歳)</a:t>
+            </a:r>
+            <a:endParaRPr lang="en-US" sz="1250" dirty="0"/>
           </a:p>
         </p:txBody>
       </p:sp>
@@ -3118,8 +3221,8 @@
         </p:nvSpPr>
         <p:spPr>
           <a:xfrm>
-            <a:off x="6309360" y="2807208"/>
-            <a:ext cx="4206240" cy="566928"/>
+            <a:off x="6309360" y="2825496"/>
+            <a:ext cx="3977640" cy="566928"/>
           </a:xfrm>
           <a:prstGeom prst="roundRect">
             <a:avLst>
@@ -3127,7 +3230,7 @@
             </a:avLst>
           </a:prstGeom>
           <a:solidFill>
-            <a:srgbClr val="1B3A5C"/>
+            <a:srgbClr val="E8762C"/>
           </a:solidFill>
           <a:ln/>
         </p:spPr>
@@ -3140,8 +3243,8 @@
         </p:nvSpPr>
         <p:spPr>
           <a:xfrm>
-            <a:off x="6492240" y="2807208"/>
-            <a:ext cx="3931920" cy="566928"/>
+            <a:off x="6492240" y="2825496"/>
+            <a:ext cx="3703320" cy="566928"/>
           </a:xfrm>
           <a:prstGeom prst="rect">
             <a:avLst/>
@@ -3157,7 +3260,7 @@
               <a:buNone/>
             </a:pPr>
             <a:r>
-              <a:rPr lang="en-US" sz="1200" b="1" dirty="0">
+              <a:rPr lang="en-US" sz="1250" b="1" dirty="0">
                 <a:solidFill>
                   <a:srgbClr val="FFFFFF"/>
                 </a:solidFill>
@@ -3165,13 +3268,13 @@
                 <a:ea typeface="Yu Gothic" pitchFamily="34" charset="-122"/>
                 <a:cs typeface="Yu Gothic" pitchFamily="34" charset="-120"/>
               </a:rPr>
-              <a:t>クリック  </a:t>
+              <a:t>30代  </a:t>
             </a:r>
             <a:pPr indent="0" marL="0">
               <a:buNone/>
             </a:pPr>
             <a:r>
-              <a:rPr lang="en-US" sz="1200" dirty="0">
+              <a:rPr lang="en-US" sz="1250" b="1" dirty="0">
                 <a:solidFill>
                   <a:srgbClr val="FFFFFF"/>
                 </a:solidFill>
@@ -3179,9 +3282,23 @@
                 <a:ea typeface="Yu Gothic" pitchFamily="34" charset="-122"/>
                 <a:cs typeface="Yu Gothic" pitchFamily="34" charset="-120"/>
               </a:rPr>
-              <a:t>約1,550回</a:t>
-            </a:r>
-            <a:endParaRPr lang="en-US" sz="1200" dirty="0"/>
+              <a:t>3名  </a:t>
+            </a:r>
+            <a:pPr indent="0" marL="0">
+              <a:buNone/>
+            </a:pPr>
+            <a:r>
+              <a:rPr lang="en-US" sz="950" dirty="0">
+                <a:solidFill>
+                  <a:srgbClr val="FFFFFF"/>
+                </a:solidFill>
+                <a:latin typeface="Yu Gothic" pitchFamily="34" charset="0"/>
+                <a:ea typeface="Yu Gothic" pitchFamily="34" charset="-122"/>
+                <a:cs typeface="Yu Gothic" pitchFamily="34" charset="-120"/>
+              </a:rPr>
+              <a:t>(31・35・36歳)</a:t>
+            </a:r>
+            <a:endParaRPr lang="en-US" sz="1250" dirty="0"/>
           </a:p>
         </p:txBody>
       </p:sp>
@@ -3193,8 +3310,8 @@
         </p:nvSpPr>
         <p:spPr>
           <a:xfrm>
-            <a:off x="6309360" y="3465576"/>
-            <a:ext cx="3108960" cy="566928"/>
+            <a:off x="6309360" y="3502152"/>
+            <a:ext cx="4434840" cy="566928"/>
           </a:xfrm>
           <a:prstGeom prst="roundRect">
             <a:avLst>
@@ -3202,81 +3319,6 @@
             </a:avLst>
           </a:prstGeom>
           <a:solidFill>
-            <a:srgbClr val="E8762C"/>
-          </a:solidFill>
-          <a:ln/>
-        </p:spPr>
-      </p:sp>
-      <p:sp>
-        <p:nvSpPr>
-          <p:cNvPr id="14" name="Text 11"/>
-          <p:cNvSpPr/>
-          <p:nvPr/>
-        </p:nvSpPr>
-        <p:spPr>
-          <a:xfrm>
-            <a:off x="6492240" y="3465576"/>
-            <a:ext cx="2834640" cy="566928"/>
-          </a:xfrm>
-          <a:prstGeom prst="rect">
-            <a:avLst/>
-          </a:prstGeom>
-          <a:noFill/>
-          <a:ln/>
-        </p:spPr>
-        <p:txBody>
-          <a:bodyPr wrap="square" lIns="0" tIns="0" rIns="0" bIns="0" rtlCol="0" anchor="ctr"/>
-          <a:lstStyle/>
-          <a:p>
-            <a:pPr indent="0" marL="0">
-              <a:buNone/>
-            </a:pPr>
-            <a:r>
-              <a:rPr lang="en-US" sz="1200" b="1" dirty="0">
-                <a:solidFill>
-                  <a:srgbClr val="FFFFFF"/>
-                </a:solidFill>
-                <a:latin typeface="Yu Gothic" pitchFamily="34" charset="0"/>
-                <a:ea typeface="Yu Gothic" pitchFamily="34" charset="-122"/>
-                <a:cs typeface="Yu Gothic" pitchFamily="34" charset="-120"/>
-              </a:rPr>
-              <a:t>応募  </a:t>
-            </a:r>
-            <a:pPr indent="0" marL="0">
-              <a:buNone/>
-            </a:pPr>
-            <a:r>
-              <a:rPr lang="en-US" sz="1200" dirty="0">
-                <a:solidFill>
-                  <a:srgbClr val="FFFFFF"/>
-                </a:solidFill>
-                <a:latin typeface="Yu Gothic" pitchFamily="34" charset="0"/>
-                <a:ea typeface="Yu Gothic" pitchFamily="34" charset="-122"/>
-                <a:cs typeface="Yu Gothic" pitchFamily="34" charset="-120"/>
-              </a:rPr>
-              <a:t>13件</a:t>
-            </a:r>
-            <a:endParaRPr lang="en-US" sz="1200" dirty="0"/>
-          </a:p>
-        </p:txBody>
-      </p:sp>
-      <p:sp>
-        <p:nvSpPr>
-          <p:cNvPr id="15" name="Shape 12"/>
-          <p:cNvSpPr/>
-          <p:nvPr/>
-        </p:nvSpPr>
-        <p:spPr>
-          <a:xfrm>
-            <a:off x="6309360" y="4123944"/>
-            <a:ext cx="2011680" cy="566928"/>
-          </a:xfrm>
-          <a:prstGeom prst="roundRect">
-            <a:avLst>
-              <a:gd name="adj" fmla="val 9677"/>
-            </a:avLst>
-          </a:prstGeom>
-          <a:solidFill>
             <a:srgbClr val="5A7A99"/>
           </a:solidFill>
           <a:ln/>
@@ -3284,14 +3326,14 @@
       </p:sp>
       <p:sp>
         <p:nvSpPr>
-          <p:cNvPr id="16" name="Text 13"/>
-          <p:cNvSpPr/>
-          <p:nvPr/>
-        </p:nvSpPr>
-        <p:spPr>
-          <a:xfrm>
-            <a:off x="6492240" y="4123944"/>
-            <a:ext cx="1737360" cy="566928"/>
+          <p:cNvPr id="14" name="Text 11"/>
+          <p:cNvSpPr/>
+          <p:nvPr/>
+        </p:nvSpPr>
+        <p:spPr>
+          <a:xfrm>
+            <a:off x="6492240" y="3502152"/>
+            <a:ext cx="4160520" cy="566928"/>
           </a:xfrm>
           <a:prstGeom prst="rect">
             <a:avLst/>
@@ -3307,7 +3349,7 @@
               <a:buNone/>
             </a:pPr>
             <a:r>
-              <a:rPr lang="en-US" sz="1200" b="1" dirty="0">
+              <a:rPr lang="en-US" sz="1250" b="1" dirty="0">
                 <a:solidFill>
                   <a:srgbClr val="FFFFFF"/>
                 </a:solidFill>
@@ -3315,13 +3357,13 @@
                 <a:ea typeface="Yu Gothic" pitchFamily="34" charset="-122"/>
                 <a:cs typeface="Yu Gothic" pitchFamily="34" charset="-120"/>
               </a:rPr>
-              <a:t>面接・入社  </a:t>
+              <a:t>40代以上  </a:t>
             </a:r>
             <a:pPr indent="0" marL="0">
               <a:buNone/>
             </a:pPr>
             <a:r>
-              <a:rPr lang="en-US" sz="1200" dirty="0">
+              <a:rPr lang="en-US" sz="1250" b="1" dirty="0">
                 <a:solidFill>
                   <a:srgbClr val="FFFFFF"/>
                 </a:solidFill>
@@ -3329,21 +3371,35 @@
                 <a:ea typeface="Yu Gothic" pitchFamily="34" charset="-122"/>
                 <a:cs typeface="Yu Gothic" pitchFamily="34" charset="-120"/>
               </a:rPr>
-              <a:t>0名</a:t>
-            </a:r>
-            <a:endParaRPr lang="en-US" sz="1200" dirty="0"/>
-          </a:p>
-        </p:txBody>
-      </p:sp>
-      <p:sp>
-        <p:nvSpPr>
-          <p:cNvPr id="17" name="Text 14"/>
-          <p:cNvSpPr/>
-          <p:nvPr/>
-        </p:nvSpPr>
-        <p:spPr>
-          <a:xfrm>
-            <a:off x="6309360" y="4727448"/>
+              <a:t>4名  </a:t>
+            </a:r>
+            <a:pPr indent="0" marL="0">
+              <a:buNone/>
+            </a:pPr>
+            <a:r>
+              <a:rPr lang="en-US" sz="950" dirty="0">
+                <a:solidFill>
+                  <a:srgbClr val="FFFFFF"/>
+                </a:solidFill>
+                <a:latin typeface="Yu Gothic" pitchFamily="34" charset="0"/>
+                <a:ea typeface="Yu Gothic" pitchFamily="34" charset="-122"/>
+                <a:cs typeface="Yu Gothic" pitchFamily="34" charset="-120"/>
+              </a:rPr>
+              <a:t>(48〜77歳・ターゲット外)</a:t>
+            </a:r>
+            <a:endParaRPr lang="en-US" sz="1250" dirty="0"/>
+          </a:p>
+        </p:txBody>
+      </p:sp>
+      <p:sp>
+        <p:nvSpPr>
+          <p:cNvPr id="15" name="Text 12"/>
+          <p:cNvSpPr/>
+          <p:nvPr/>
+        </p:nvSpPr>
+        <p:spPr>
+          <a:xfrm>
+            <a:off x="6309360" y="4142232"/>
             <a:ext cx="5394960" cy="237744"/>
           </a:xfrm>
           <a:prstGeom prst="rect">
@@ -3368,7 +3424,7 @@
                 <a:ea typeface="Yu Gothic" pitchFamily="34" charset="-122"/>
                 <a:cs typeface="Yu Gothic" pitchFamily="34" charset="-120"/>
               </a:rPr>
-              <a:t>※表示・クリックはIndeed+求人BOXの有料課金分合計</a:t>
+              <a:t>※応募13件のうち1名は2媒体からの重複応募のため、実人数12名で集計</a:t>
             </a:r>
             <a:endParaRPr lang="en-US" sz="900" dirty="0"/>
           </a:p>
@@ -3376,7 +3432,7 @@
       </p:sp>
       <p:sp>
         <p:nvSpPr>
-          <p:cNvPr id="18" name="Shape 15"/>
+          <p:cNvPr id="16" name="Shape 13"/>
           <p:cNvSpPr/>
           <p:nvPr/>
         </p:nvSpPr>
@@ -3398,7 +3454,7 @@
       </p:sp>
       <p:sp>
         <p:nvSpPr>
-          <p:cNvPr id="19" name="Text 16"/>
+          <p:cNvPr id="17" name="Text 14"/>
           <p:cNvSpPr/>
           <p:nvPr/>
         </p:nvSpPr>
@@ -3429,7 +3485,7 @@
                 <a:ea typeface="Yu Gothic" pitchFamily="34" charset="-122"/>
                 <a:cs typeface="Yu Gothic" pitchFamily="34" charset="-120"/>
               </a:rPr>
-              <a:t>率直な課題: </a:t>
+              <a:t>応募者の67%(12名中8名)が20〜30代。</a:t>
             </a:r>
             <a:pPr indent="0" marL="0">
               <a:buNone/>
@@ -3443,7 +3499,7 @@
                 <a:ea typeface="Yu Gothic" pitchFamily="34" charset="-122"/>
                 <a:cs typeface="Yu Gothic" pitchFamily="34" charset="-120"/>
               </a:rPr>
-              <a:t>応募者の年齢・条件のミスマッチが多く、面接・入社への転換は未達です。「応募の質」を高める打ち手を次章でご提案します。</a:t>
+              <a:t>訴求転換(4月)以降も毎月2名ペースでターゲット年代の応募が継続しており、「若手に届く求人」への転換が数字で確認できます。</a:t>
             </a:r>
             <a:endParaRPr lang="en-US" sz="1150" dirty="0"/>
           </a:p>
@@ -3514,7 +3570,7 @@
                 <a:ea typeface="Yu Gothic" pitchFamily="34" charset="-122"/>
                 <a:cs typeface="Yu Gothic" pitchFamily="34" charset="-120"/>
               </a:rPr>
-              <a:t>活動履歴 ─ 定例ミーティング・説明会</a:t>
+              <a:t>選考移行率の現在地と課題</a:t>
             </a:r>
             <a:endParaRPr lang="en-US" sz="3000" dirty="0"/>
           </a:p>
@@ -3553,7 +3609,7 @@
                 <a:ea typeface="Yu Gothic" pitchFamily="34" charset="-122"/>
                 <a:cs typeface="Yu Gothic" pitchFamily="34" charset="-120"/>
               </a:rPr>
-              <a:t>毎回議事録を共有し、決定事項を翌週までに実行するサイクルを継続</a:t>
+              <a:t>応募は生まれましたが、選考への移行が壁 ─ ここが次の主戦場です</a:t>
             </a:r>
             <a:endParaRPr lang="en-US" sz="1300" dirty="0"/>
           </a:p>
@@ -3598,9 +3654,1210 @@
           </a:p>
         </p:txBody>
       </p:sp>
+      <p:sp>
+        <p:nvSpPr>
+          <p:cNvPr id="5" name="Text 3"/>
+          <p:cNvSpPr/>
+          <p:nvPr/>
+        </p:nvSpPr>
+        <p:spPr>
+          <a:xfrm>
+            <a:off x="548640" y="1600200"/>
+            <a:ext cx="5486400" cy="365760"/>
+          </a:xfrm>
+          <a:prstGeom prst="rect">
+            <a:avLst/>
+          </a:prstGeom>
+          <a:noFill/>
+          <a:ln/>
+        </p:spPr>
+        <p:txBody>
+          <a:bodyPr wrap="square" lIns="0" tIns="0" rIns="0" bIns="0" rtlCol="0" anchor="ctr"/>
+          <a:lstStyle/>
+          <a:p>
+            <a:pPr indent="0" marL="0">
+              <a:buNone/>
+            </a:pPr>
+            <a:r>
+              <a:rPr lang="en-US" sz="1400" b="1" dirty="0">
+                <a:solidFill>
+                  <a:srgbClr val="1B3A5C"/>
+                </a:solidFill>
+                <a:latin typeface="Yu Gothic" pitchFamily="34" charset="0"/>
+                <a:ea typeface="Yu Gothic" pitchFamily="34" charset="-122"/>
+                <a:cs typeface="Yu Gothic" pitchFamily="34" charset="-120"/>
+              </a:rPr>
+              <a:t>選考ファネル(2026年3〜7月・実人数ベース)</a:t>
+            </a:r>
+            <a:endParaRPr lang="en-US" sz="1400" dirty="0"/>
+          </a:p>
+        </p:txBody>
+      </p:sp>
+      <p:sp>
+        <p:nvSpPr>
+          <p:cNvPr id="6" name="Shape 4"/>
+          <p:cNvSpPr/>
+          <p:nvPr/>
+        </p:nvSpPr>
+        <p:spPr>
+          <a:xfrm>
+            <a:off x="548640" y="2103120"/>
+            <a:ext cx="5394960" cy="603504"/>
+          </a:xfrm>
+          <a:prstGeom prst="roundRect">
+            <a:avLst>
+              <a:gd name="adj" fmla="val 9091"/>
+            </a:avLst>
+          </a:prstGeom>
+          <a:solidFill>
+            <a:srgbClr val="1B3A5C"/>
+          </a:solidFill>
+          <a:ln/>
+        </p:spPr>
+      </p:sp>
+      <p:sp>
+        <p:nvSpPr>
+          <p:cNvPr id="7" name="Text 5"/>
+          <p:cNvSpPr/>
+          <p:nvPr/>
+        </p:nvSpPr>
+        <p:spPr>
+          <a:xfrm>
+            <a:off x="731520" y="2103120"/>
+            <a:ext cx="5120640" cy="603504"/>
+          </a:xfrm>
+          <a:prstGeom prst="rect">
+            <a:avLst/>
+          </a:prstGeom>
+          <a:noFill/>
+          <a:ln/>
+        </p:spPr>
+        <p:txBody>
+          <a:bodyPr wrap="square" lIns="0" tIns="0" rIns="0" bIns="0" rtlCol="0" anchor="ctr"/>
+          <a:lstStyle/>
+          <a:p>
+            <a:pPr indent="0" marL="0">
+              <a:buNone/>
+            </a:pPr>
+            <a:r>
+              <a:rPr lang="en-US" sz="1150" b="1" dirty="0">
+                <a:solidFill>
+                  <a:srgbClr val="FFFFFF"/>
+                </a:solidFill>
+                <a:latin typeface="Yu Gothic" pitchFamily="34" charset="0"/>
+                <a:ea typeface="Yu Gothic" pitchFamily="34" charset="-122"/>
+                <a:cs typeface="Yu Gothic" pitchFamily="34" charset="-120"/>
+              </a:rPr>
+              <a:t>応募  </a:t>
+            </a:r>
+            <a:pPr indent="0" marL="0">
+              <a:buNone/>
+            </a:pPr>
+            <a:r>
+              <a:rPr lang="en-US" sz="1150" dirty="0">
+                <a:solidFill>
+                  <a:srgbClr val="FFFFFF"/>
+                </a:solidFill>
+                <a:latin typeface="Yu Gothic" pitchFamily="34" charset="0"/>
+                <a:ea typeface="Yu Gothic" pitchFamily="34" charset="-122"/>
+                <a:cs typeface="Yu Gothic" pitchFamily="34" charset="-120"/>
+              </a:rPr>
+              <a:t>12名(うち20〜30代8名)</a:t>
+            </a:r>
+            <a:endParaRPr lang="en-US" sz="1150" dirty="0"/>
+          </a:p>
+        </p:txBody>
+      </p:sp>
+      <p:sp>
+        <p:nvSpPr>
+          <p:cNvPr id="8" name="Shape 6"/>
+          <p:cNvSpPr/>
+          <p:nvPr/>
+        </p:nvSpPr>
+        <p:spPr>
+          <a:xfrm>
+            <a:off x="548640" y="2816352"/>
+            <a:ext cx="4114800" cy="603504"/>
+          </a:xfrm>
+          <a:prstGeom prst="roundRect">
+            <a:avLst>
+              <a:gd name="adj" fmla="val 9091"/>
+            </a:avLst>
+          </a:prstGeom>
+          <a:solidFill>
+            <a:srgbClr val="E8762C"/>
+          </a:solidFill>
+          <a:ln/>
+        </p:spPr>
+      </p:sp>
+      <p:sp>
+        <p:nvSpPr>
+          <p:cNvPr id="9" name="Text 7"/>
+          <p:cNvSpPr/>
+          <p:nvPr/>
+        </p:nvSpPr>
+        <p:spPr>
+          <a:xfrm>
+            <a:off x="731520" y="2816352"/>
+            <a:ext cx="3840480" cy="603504"/>
+          </a:xfrm>
+          <a:prstGeom prst="rect">
+            <a:avLst/>
+          </a:prstGeom>
+          <a:noFill/>
+          <a:ln/>
+        </p:spPr>
+        <p:txBody>
+          <a:bodyPr wrap="square" lIns="0" tIns="0" rIns="0" bIns="0" rtlCol="0" anchor="ctr"/>
+          <a:lstStyle/>
+          <a:p>
+            <a:pPr indent="0" marL="0">
+              <a:buNone/>
+            </a:pPr>
+            <a:r>
+              <a:rPr lang="en-US" sz="1150" b="1" dirty="0">
+                <a:solidFill>
+                  <a:srgbClr val="FFFFFF"/>
+                </a:solidFill>
+                <a:latin typeface="Yu Gothic" pitchFamily="34" charset="0"/>
+                <a:ea typeface="Yu Gothic" pitchFamily="34" charset="-122"/>
+                <a:cs typeface="Yu Gothic" pitchFamily="34" charset="-120"/>
+              </a:rPr>
+              <a:t>説明会・選考ヒアリングへ移行  </a:t>
+            </a:r>
+            <a:pPr indent="0" marL="0">
+              <a:buNone/>
+            </a:pPr>
+            <a:r>
+              <a:rPr lang="en-US" sz="1150" dirty="0">
+                <a:solidFill>
+                  <a:srgbClr val="FFFFFF"/>
+                </a:solidFill>
+                <a:latin typeface="Yu Gothic" pitchFamily="34" charset="0"/>
+                <a:ea typeface="Yu Gothic" pitchFamily="34" charset="-122"/>
+                <a:cs typeface="Yu Gothic" pitchFamily="34" charset="-120"/>
+              </a:rPr>
+              <a:t>3名</a:t>
+            </a:r>
+            <a:endParaRPr lang="en-US" sz="1150" dirty="0"/>
+          </a:p>
+        </p:txBody>
+      </p:sp>
+      <p:sp>
+        <p:nvSpPr>
+          <p:cNvPr id="10" name="Text 8"/>
+          <p:cNvSpPr/>
+          <p:nvPr/>
+        </p:nvSpPr>
+        <p:spPr>
+          <a:xfrm>
+            <a:off x="4800600" y="2816352"/>
+            <a:ext cx="1463040" cy="603504"/>
+          </a:xfrm>
+          <a:prstGeom prst="rect">
+            <a:avLst/>
+          </a:prstGeom>
+          <a:noFill/>
+          <a:ln/>
+        </p:spPr>
+        <p:txBody>
+          <a:bodyPr wrap="square" lIns="0" tIns="0" rIns="0" bIns="0" rtlCol="0" anchor="ctr"/>
+          <a:lstStyle/>
+          <a:p>
+            <a:pPr indent="0" marL="0">
+              <a:buNone/>
+            </a:pPr>
+            <a:r>
+              <a:rPr lang="en-US" sz="1050" b="1" dirty="0">
+                <a:solidFill>
+                  <a:srgbClr val="E8762C"/>
+                </a:solidFill>
+                <a:latin typeface="Yu Gothic" pitchFamily="34" charset="0"/>
+                <a:ea typeface="Yu Gothic" pitchFamily="34" charset="-122"/>
+                <a:cs typeface="Yu Gothic" pitchFamily="34" charset="-120"/>
+              </a:rPr>
+              <a:t>移行率 25%</a:t>
+            </a:r>
+            <a:endParaRPr lang="en-US" sz="1050" dirty="0"/>
+          </a:p>
+        </p:txBody>
+      </p:sp>
+      <p:sp>
+        <p:nvSpPr>
+          <p:cNvPr id="11" name="Shape 9"/>
+          <p:cNvSpPr/>
+          <p:nvPr/>
+        </p:nvSpPr>
+        <p:spPr>
+          <a:xfrm>
+            <a:off x="548640" y="3529584"/>
+            <a:ext cx="2834640" cy="603504"/>
+          </a:xfrm>
+          <a:prstGeom prst="roundRect">
+            <a:avLst>
+              <a:gd name="adj" fmla="val 9091"/>
+            </a:avLst>
+          </a:prstGeom>
+          <a:solidFill>
+            <a:srgbClr val="5A7A99"/>
+          </a:solidFill>
+          <a:ln/>
+        </p:spPr>
+      </p:sp>
+      <p:sp>
+        <p:nvSpPr>
+          <p:cNvPr id="12" name="Text 10"/>
+          <p:cNvSpPr/>
+          <p:nvPr/>
+        </p:nvSpPr>
+        <p:spPr>
+          <a:xfrm>
+            <a:off x="731520" y="3529584"/>
+            <a:ext cx="2560320" cy="603504"/>
+          </a:xfrm>
+          <a:prstGeom prst="rect">
+            <a:avLst/>
+          </a:prstGeom>
+          <a:noFill/>
+          <a:ln/>
+        </p:spPr>
+        <p:txBody>
+          <a:bodyPr wrap="square" lIns="0" tIns="0" rIns="0" bIns="0" rtlCol="0" anchor="ctr"/>
+          <a:lstStyle/>
+          <a:p>
+            <a:pPr indent="0" marL="0">
+              <a:buNone/>
+            </a:pPr>
+            <a:r>
+              <a:rPr lang="en-US" sz="1150" b="1" dirty="0">
+                <a:solidFill>
+                  <a:srgbClr val="FFFFFF"/>
+                </a:solidFill>
+                <a:latin typeface="Yu Gothic" pitchFamily="34" charset="0"/>
+                <a:ea typeface="Yu Gothic" pitchFamily="34" charset="-122"/>
+                <a:cs typeface="Yu Gothic" pitchFamily="34" charset="-120"/>
+              </a:rPr>
+              <a:t>書類選考通過(有効応募)  </a:t>
+            </a:r>
+            <a:pPr indent="0" marL="0">
+              <a:buNone/>
+            </a:pPr>
+            <a:r>
+              <a:rPr lang="en-US" sz="1150" dirty="0">
+                <a:solidFill>
+                  <a:srgbClr val="FFFFFF"/>
+                </a:solidFill>
+                <a:latin typeface="Yu Gothic" pitchFamily="34" charset="0"/>
+                <a:ea typeface="Yu Gothic" pitchFamily="34" charset="-122"/>
+                <a:cs typeface="Yu Gothic" pitchFamily="34" charset="-120"/>
+              </a:rPr>
+              <a:t>0名</a:t>
+            </a:r>
+            <a:endParaRPr lang="en-US" sz="1150" dirty="0"/>
+          </a:p>
+        </p:txBody>
+      </p:sp>
+      <p:sp>
+        <p:nvSpPr>
+          <p:cNvPr id="13" name="Text 11"/>
+          <p:cNvSpPr/>
+          <p:nvPr/>
+        </p:nvSpPr>
+        <p:spPr>
+          <a:xfrm>
+            <a:off x="3520440" y="3529584"/>
+            <a:ext cx="1463040" cy="603504"/>
+          </a:xfrm>
+          <a:prstGeom prst="rect">
+            <a:avLst/>
+          </a:prstGeom>
+          <a:noFill/>
+          <a:ln/>
+        </p:spPr>
+        <p:txBody>
+          <a:bodyPr wrap="square" lIns="0" tIns="0" rIns="0" bIns="0" rtlCol="0" anchor="ctr"/>
+          <a:lstStyle/>
+          <a:p>
+            <a:pPr indent="0" marL="0">
+              <a:buNone/>
+            </a:pPr>
+            <a:r>
+              <a:rPr lang="en-US" sz="1050" b="1" dirty="0">
+                <a:solidFill>
+                  <a:srgbClr val="5A7A99"/>
+                </a:solidFill>
+                <a:latin typeface="Yu Gothic" pitchFamily="34" charset="0"/>
+                <a:ea typeface="Yu Gothic" pitchFamily="34" charset="-122"/>
+                <a:cs typeface="Yu Gothic" pitchFamily="34" charset="-120"/>
+              </a:rPr>
+              <a:t>移行率 0%</a:t>
+            </a:r>
+            <a:endParaRPr lang="en-US" sz="1050" dirty="0"/>
+          </a:p>
+        </p:txBody>
+      </p:sp>
+      <p:sp>
+        <p:nvSpPr>
+          <p:cNvPr id="14" name="Shape 12"/>
+          <p:cNvSpPr/>
+          <p:nvPr/>
+        </p:nvSpPr>
+        <p:spPr>
+          <a:xfrm>
+            <a:off x="548640" y="4242816"/>
+            <a:ext cx="2194560" cy="603504"/>
+          </a:xfrm>
+          <a:prstGeom prst="roundRect">
+            <a:avLst>
+              <a:gd name="adj" fmla="val 9091"/>
+            </a:avLst>
+          </a:prstGeom>
+          <a:solidFill>
+            <a:srgbClr val="5A7A99"/>
+          </a:solidFill>
+          <a:ln/>
+        </p:spPr>
+      </p:sp>
+      <p:sp>
+        <p:nvSpPr>
+          <p:cNvPr id="15" name="Text 13"/>
+          <p:cNvSpPr/>
+          <p:nvPr/>
+        </p:nvSpPr>
+        <p:spPr>
+          <a:xfrm>
+            <a:off x="731520" y="4242816"/>
+            <a:ext cx="1920240" cy="603504"/>
+          </a:xfrm>
+          <a:prstGeom prst="rect">
+            <a:avLst/>
+          </a:prstGeom>
+          <a:noFill/>
+          <a:ln/>
+        </p:spPr>
+        <p:txBody>
+          <a:bodyPr wrap="square" lIns="0" tIns="0" rIns="0" bIns="0" rtlCol="0" anchor="ctr"/>
+          <a:lstStyle/>
+          <a:p>
+            <a:pPr indent="0" marL="0">
+              <a:buNone/>
+            </a:pPr>
+            <a:r>
+              <a:rPr lang="en-US" sz="1150" b="1" dirty="0">
+                <a:solidFill>
+                  <a:srgbClr val="FFFFFF"/>
+                </a:solidFill>
+                <a:latin typeface="Yu Gothic" pitchFamily="34" charset="0"/>
+                <a:ea typeface="Yu Gothic" pitchFamily="34" charset="-122"/>
+                <a:cs typeface="Yu Gothic" pitchFamily="34" charset="-120"/>
+              </a:rPr>
+              <a:t>1次面接・入社  </a:t>
+            </a:r>
+            <a:pPr indent="0" marL="0">
+              <a:buNone/>
+            </a:pPr>
+            <a:r>
+              <a:rPr lang="en-US" sz="1150" dirty="0">
+                <a:solidFill>
+                  <a:srgbClr val="FFFFFF"/>
+                </a:solidFill>
+                <a:latin typeface="Yu Gothic" pitchFamily="34" charset="0"/>
+                <a:ea typeface="Yu Gothic" pitchFamily="34" charset="-122"/>
+                <a:cs typeface="Yu Gothic" pitchFamily="34" charset="-120"/>
+              </a:rPr>
+              <a:t>0名</a:t>
+            </a:r>
+            <a:endParaRPr lang="en-US" sz="1150" dirty="0"/>
+          </a:p>
+        </p:txBody>
+      </p:sp>
+      <p:sp>
+        <p:nvSpPr>
+          <p:cNvPr id="16" name="Text 14"/>
+          <p:cNvSpPr/>
+          <p:nvPr/>
+        </p:nvSpPr>
+        <p:spPr>
+          <a:xfrm>
+            <a:off x="548640" y="4974336"/>
+            <a:ext cx="5669280" cy="457200"/>
+          </a:xfrm>
+          <a:prstGeom prst="rect">
+            <a:avLst/>
+          </a:prstGeom>
+          <a:noFill/>
+          <a:ln/>
+        </p:spPr>
+        <p:txBody>
+          <a:bodyPr wrap="square" lIns="0" tIns="0" rIns="0" bIns="0" rtlCol="0" anchor="ctr"/>
+          <a:lstStyle/>
+          <a:p>
+            <a:pPr indent="0" marL="0">
+              <a:buNone/>
+            </a:pPr>
+            <a:r>
+              <a:rPr lang="en-US" sz="1000" dirty="0">
+                <a:solidFill>
+                  <a:srgbClr val="6B7280"/>
+                </a:solidFill>
+                <a:latin typeface="Yu Gothic" pitchFamily="34" charset="0"/>
+                <a:ea typeface="Yu Gothic" pitchFamily="34" charset="-122"/>
+                <a:cs typeface="Yu Gothic" pitchFamily="34" charset="-120"/>
+              </a:rPr>
+              <a:t>対応中: 説明会誘導中1名(36歳)・選考/説明会ヒアリング中2名(23歳・53歳) ※8月継続対応</a:t>
+            </a:r>
+            <a:endParaRPr lang="en-US" sz="1000" dirty="0"/>
+          </a:p>
+        </p:txBody>
+      </p:sp>
+      <p:sp>
+        <p:nvSpPr>
+          <p:cNvPr id="17" name="Shape 15"/>
+          <p:cNvSpPr/>
+          <p:nvPr/>
+        </p:nvSpPr>
+        <p:spPr>
+          <a:xfrm>
+            <a:off x="548640" y="5532120"/>
+            <a:ext cx="5577840" cy="914400"/>
+          </a:xfrm>
+          <a:prstGeom prst="roundRect">
+            <a:avLst>
+              <a:gd name="adj" fmla="val 8000"/>
+            </a:avLst>
+          </a:prstGeom>
+          <a:solidFill>
+            <a:srgbClr val="FDF0E6"/>
+          </a:solidFill>
+          <a:ln/>
+        </p:spPr>
+      </p:sp>
+      <p:sp>
+        <p:nvSpPr>
+          <p:cNvPr id="18" name="Text 16"/>
+          <p:cNvSpPr/>
+          <p:nvPr/>
+        </p:nvSpPr>
+        <p:spPr>
+          <a:xfrm>
+            <a:off x="777240" y="5650992"/>
+            <a:ext cx="5120640" cy="731520"/>
+          </a:xfrm>
+          <a:prstGeom prst="rect">
+            <a:avLst/>
+          </a:prstGeom>
+          <a:noFill/>
+          <a:ln/>
+        </p:spPr>
+        <p:txBody>
+          <a:bodyPr wrap="square" lIns="0" tIns="0" rIns="0" bIns="0" rtlCol="0" anchor="t"/>
+          <a:lstStyle/>
+          <a:p>
+            <a:pPr indent="0" marL="0">
+              <a:buNone/>
+            </a:pPr>
+            <a:r>
+              <a:rPr lang="en-US" sz="1100" b="1" dirty="0">
+                <a:solidFill>
+                  <a:srgbClr val="B45309"/>
+                </a:solidFill>
+                <a:latin typeface="Yu Gothic" pitchFamily="34" charset="0"/>
+                <a:ea typeface="Yu Gothic" pitchFamily="34" charset="-122"/>
+                <a:cs typeface="Yu Gothic" pitchFamily="34" charset="-120"/>
+              </a:rPr>
+              <a:t>20〜30代8名のうち選考対応が継続できているのは1名(23歳)。</a:t>
+            </a:r>
+            <a:pPr indent="0" marL="0">
+              <a:buNone/>
+            </a:pPr>
+            <a:r>
+              <a:rPr lang="en-US" sz="1100" dirty="0">
+                <a:solidFill>
+                  <a:srgbClr val="374151"/>
+                </a:solidFill>
+                <a:latin typeface="Yu Gothic" pitchFamily="34" charset="0"/>
+                <a:ea typeface="Yu Gothic" pitchFamily="34" charset="-122"/>
+                <a:cs typeface="Yu Gothic" pitchFamily="34" charset="-120"/>
+              </a:rPr>
+              <a:t>応募獲得の次は「つながり続ける仕組み」が成果の鍵です。</a:t>
+            </a:r>
+            <a:endParaRPr lang="en-US" sz="1100" dirty="0"/>
+          </a:p>
+        </p:txBody>
+      </p:sp>
+      <p:sp>
+        <p:nvSpPr>
+          <p:cNvPr id="19" name="Text 17"/>
+          <p:cNvSpPr/>
+          <p:nvPr/>
+        </p:nvSpPr>
+        <p:spPr>
+          <a:xfrm>
+            <a:off x="6537960" y="1600200"/>
+            <a:ext cx="5120640" cy="365760"/>
+          </a:xfrm>
+          <a:prstGeom prst="rect">
+            <a:avLst/>
+          </a:prstGeom>
+          <a:noFill/>
+          <a:ln/>
+        </p:spPr>
+        <p:txBody>
+          <a:bodyPr wrap="square" lIns="0" tIns="0" rIns="0" bIns="0" rtlCol="0" anchor="ctr"/>
+          <a:lstStyle/>
+          <a:p>
+            <a:pPr indent="0" marL="0">
+              <a:buNone/>
+            </a:pPr>
+            <a:r>
+              <a:rPr lang="en-US" sz="1400" b="1" dirty="0">
+                <a:solidFill>
+                  <a:srgbClr val="1B3A5C"/>
+                </a:solidFill>
+                <a:latin typeface="Yu Gothic" pitchFamily="34" charset="0"/>
+                <a:ea typeface="Yu Gothic" pitchFamily="34" charset="-122"/>
+                <a:cs typeface="Yu Gothic" pitchFamily="34" charset="-120"/>
+              </a:rPr>
+              <a:t>移行を阻んだ3つの要因</a:t>
+            </a:r>
+            <a:endParaRPr lang="en-US" sz="1400" dirty="0"/>
+          </a:p>
+        </p:txBody>
+      </p:sp>
+      <p:sp>
+        <p:nvSpPr>
+          <p:cNvPr id="20" name="Shape 18"/>
+          <p:cNvSpPr/>
+          <p:nvPr/>
+        </p:nvSpPr>
+        <p:spPr>
+          <a:xfrm>
+            <a:off x="6537960" y="2029968"/>
+            <a:ext cx="384048" cy="384048"/>
+          </a:xfrm>
+          <a:prstGeom prst="ellipse">
+            <a:avLst/>
+          </a:prstGeom>
+          <a:solidFill>
+            <a:srgbClr val="5A7A99"/>
+          </a:solidFill>
+          <a:ln/>
+        </p:spPr>
+      </p:sp>
+      <p:sp>
+        <p:nvSpPr>
+          <p:cNvPr id="21" name="Text 19"/>
+          <p:cNvSpPr/>
+          <p:nvPr/>
+        </p:nvSpPr>
+        <p:spPr>
+          <a:xfrm>
+            <a:off x="6537960" y="2025396"/>
+            <a:ext cx="384048" cy="384048"/>
+          </a:xfrm>
+          <a:prstGeom prst="rect">
+            <a:avLst/>
+          </a:prstGeom>
+          <a:noFill/>
+          <a:ln/>
+        </p:spPr>
+        <p:txBody>
+          <a:bodyPr wrap="square" lIns="0" tIns="0" rIns="0" bIns="0" rtlCol="0" anchor="ctr"/>
+          <a:lstStyle/>
+          <a:p>
+            <a:pPr algn="ctr" indent="0" marL="0">
+              <a:buNone/>
+            </a:pPr>
+            <a:r>
+              <a:rPr lang="en-US" sz="1500" b="1" dirty="0">
+                <a:solidFill>
+                  <a:srgbClr val="FFFFFF"/>
+                </a:solidFill>
+                <a:latin typeface="Yu Gothic" pitchFamily="34" charset="0"/>
+                <a:ea typeface="Yu Gothic" pitchFamily="34" charset="-122"/>
+                <a:cs typeface="Yu Gothic" pitchFamily="34" charset="-120"/>
+              </a:rPr>
+              <a:t>1</a:t>
+            </a:r>
+            <a:endParaRPr lang="en-US" sz="1500" dirty="0"/>
+          </a:p>
+        </p:txBody>
+      </p:sp>
+      <p:sp>
+        <p:nvSpPr>
+          <p:cNvPr id="22" name="Text 20"/>
+          <p:cNvSpPr/>
+          <p:nvPr/>
+        </p:nvSpPr>
+        <p:spPr>
+          <a:xfrm>
+            <a:off x="7059168" y="1965960"/>
+            <a:ext cx="4572000" cy="777240"/>
+          </a:xfrm>
+          <a:prstGeom prst="rect">
+            <a:avLst/>
+          </a:prstGeom>
+          <a:noFill/>
+          <a:ln/>
+        </p:spPr>
+        <p:txBody>
+          <a:bodyPr wrap="square" lIns="0" tIns="0" rIns="0" bIns="0" rtlCol="0" anchor="t"/>
+          <a:lstStyle/>
+          <a:p>
+            <a:pPr indent="0" marL="0">
+              <a:buNone/>
+            </a:pPr>
+            <a:r>
+              <a:rPr lang="en-US" sz="1100" b="1" dirty="0">
+                <a:solidFill>
+                  <a:srgbClr val="1B3A5C"/>
+                </a:solidFill>
+                <a:latin typeface="Yu Gothic" pitchFamily="34" charset="0"/>
+                <a:ea typeface="Yu Gothic" pitchFamily="34" charset="-122"/>
+                <a:cs typeface="Yu Gothic" pitchFamily="34" charset="-120"/>
+              </a:rPr>
+              <a:t>20代前半の連絡途絶  </a:t>
+            </a:r>
+            <a:pPr indent="0" marL="0">
+              <a:buNone/>
+            </a:pPr>
+            <a:r>
+              <a:rPr lang="en-US" sz="1100" dirty="0">
+                <a:solidFill>
+                  <a:srgbClr val="374151"/>
+                </a:solidFill>
+                <a:latin typeface="Yu Gothic" pitchFamily="34" charset="0"/>
+                <a:ea typeface="Yu Gothic" pitchFamily="34" charset="-122"/>
+                <a:cs typeface="Yu Gothic" pitchFamily="34" charset="-120"/>
+              </a:rPr>
+              <a:t>メールを見ない・返信が途切れる傾向(21歳は書類依頼後に連絡なし)。若手ほど発生しやすい</a:t>
+            </a:r>
+            <a:endParaRPr lang="en-US" sz="1100" dirty="0"/>
+          </a:p>
+        </p:txBody>
+      </p:sp>
+      <p:sp>
+        <p:nvSpPr>
+          <p:cNvPr id="23" name="Shape 21"/>
+          <p:cNvSpPr/>
+          <p:nvPr/>
+        </p:nvSpPr>
+        <p:spPr>
+          <a:xfrm>
+            <a:off x="6537960" y="2871216"/>
+            <a:ext cx="384048" cy="384048"/>
+          </a:xfrm>
+          <a:prstGeom prst="ellipse">
+            <a:avLst/>
+          </a:prstGeom>
+          <a:solidFill>
+            <a:srgbClr val="5A7A99"/>
+          </a:solidFill>
+          <a:ln/>
+        </p:spPr>
+      </p:sp>
+      <p:sp>
+        <p:nvSpPr>
+          <p:cNvPr id="24" name="Text 22"/>
+          <p:cNvSpPr/>
+          <p:nvPr/>
+        </p:nvSpPr>
+        <p:spPr>
+          <a:xfrm>
+            <a:off x="6537960" y="2866644"/>
+            <a:ext cx="384048" cy="384048"/>
+          </a:xfrm>
+          <a:prstGeom prst="rect">
+            <a:avLst/>
+          </a:prstGeom>
+          <a:noFill/>
+          <a:ln/>
+        </p:spPr>
+        <p:txBody>
+          <a:bodyPr wrap="square" lIns="0" tIns="0" rIns="0" bIns="0" rtlCol="0" anchor="ctr"/>
+          <a:lstStyle/>
+          <a:p>
+            <a:pPr algn="ctr" indent="0" marL="0">
+              <a:buNone/>
+            </a:pPr>
+            <a:r>
+              <a:rPr lang="en-US" sz="1500" b="1" dirty="0">
+                <a:solidFill>
+                  <a:srgbClr val="FFFFFF"/>
+                </a:solidFill>
+                <a:latin typeface="Yu Gothic" pitchFamily="34" charset="0"/>
+                <a:ea typeface="Yu Gothic" pitchFamily="34" charset="-122"/>
+                <a:cs typeface="Yu Gothic" pitchFamily="34" charset="-120"/>
+              </a:rPr>
+              <a:t>2</a:t>
+            </a:r>
+            <a:endParaRPr lang="en-US" sz="1500" dirty="0"/>
+          </a:p>
+        </p:txBody>
+      </p:sp>
+      <p:sp>
+        <p:nvSpPr>
+          <p:cNvPr id="25" name="Text 23"/>
+          <p:cNvSpPr/>
+          <p:nvPr/>
+        </p:nvSpPr>
+        <p:spPr>
+          <a:xfrm>
+            <a:off x="7059168" y="2807208"/>
+            <a:ext cx="4572000" cy="777240"/>
+          </a:xfrm>
+          <a:prstGeom prst="rect">
+            <a:avLst/>
+          </a:prstGeom>
+          <a:noFill/>
+          <a:ln/>
+        </p:spPr>
+        <p:txBody>
+          <a:bodyPr wrap="square" lIns="0" tIns="0" rIns="0" bIns="0" rtlCol="0" anchor="t"/>
+          <a:lstStyle/>
+          <a:p>
+            <a:pPr indent="0" marL="0">
+              <a:buNone/>
+            </a:pPr>
+            <a:r>
+              <a:rPr lang="en-US" sz="1100" b="1" dirty="0">
+                <a:solidFill>
+                  <a:srgbClr val="1B3A5C"/>
+                </a:solidFill>
+                <a:latin typeface="Yu Gothic" pitchFamily="34" charset="0"/>
+                <a:ea typeface="Yu Gothic" pitchFamily="34" charset="-122"/>
+                <a:cs typeface="Yu Gothic" pitchFamily="34" charset="-120"/>
+              </a:rPr>
+              <a:t>ターゲット外応募の混在  </a:t>
+            </a:r>
+            <a:pPr indent="0" marL="0">
+              <a:buNone/>
+            </a:pPr>
+            <a:r>
+              <a:rPr lang="en-US" sz="1100" dirty="0">
+                <a:solidFill>
+                  <a:srgbClr val="374151"/>
+                </a:solidFill>
+                <a:latin typeface="Yu Gothic" pitchFamily="34" charset="0"/>
+                <a:ea typeface="Yu Gothic" pitchFamily="34" charset="-122"/>
+                <a:cs typeface="Yu Gothic" pitchFamily="34" charset="-120"/>
+              </a:rPr>
+              <a:t>77歳×2・53歳・48歳など、応募12名のうち4名(33%)がターゲット外。お断り対応が負担に</a:t>
+            </a:r>
+            <a:endParaRPr lang="en-US" sz="1100" dirty="0"/>
+          </a:p>
+        </p:txBody>
+      </p:sp>
+      <p:sp>
+        <p:nvSpPr>
+          <p:cNvPr id="26" name="Shape 24"/>
+          <p:cNvSpPr/>
+          <p:nvPr/>
+        </p:nvSpPr>
+        <p:spPr>
+          <a:xfrm>
+            <a:off x="6537960" y="3712464"/>
+            <a:ext cx="384048" cy="384048"/>
+          </a:xfrm>
+          <a:prstGeom prst="ellipse">
+            <a:avLst/>
+          </a:prstGeom>
+          <a:solidFill>
+            <a:srgbClr val="5A7A99"/>
+          </a:solidFill>
+          <a:ln/>
+        </p:spPr>
+      </p:sp>
+      <p:sp>
+        <p:nvSpPr>
+          <p:cNvPr id="27" name="Text 25"/>
+          <p:cNvSpPr/>
+          <p:nvPr/>
+        </p:nvSpPr>
+        <p:spPr>
+          <a:xfrm>
+            <a:off x="6537960" y="3707892"/>
+            <a:ext cx="384048" cy="384048"/>
+          </a:xfrm>
+          <a:prstGeom prst="rect">
+            <a:avLst/>
+          </a:prstGeom>
+          <a:noFill/>
+          <a:ln/>
+        </p:spPr>
+        <p:txBody>
+          <a:bodyPr wrap="square" lIns="0" tIns="0" rIns="0" bIns="0" rtlCol="0" anchor="ctr"/>
+          <a:lstStyle/>
+          <a:p>
+            <a:pPr algn="ctr" indent="0" marL="0">
+              <a:buNone/>
+            </a:pPr>
+            <a:r>
+              <a:rPr lang="en-US" sz="1500" b="1" dirty="0">
+                <a:solidFill>
+                  <a:srgbClr val="FFFFFF"/>
+                </a:solidFill>
+                <a:latin typeface="Yu Gothic" pitchFamily="34" charset="0"/>
+                <a:ea typeface="Yu Gothic" pitchFamily="34" charset="-122"/>
+                <a:cs typeface="Yu Gothic" pitchFamily="34" charset="-120"/>
+              </a:rPr>
+              <a:t>3</a:t>
+            </a:r>
+            <a:endParaRPr lang="en-US" sz="1500" dirty="0"/>
+          </a:p>
+        </p:txBody>
+      </p:sp>
+      <p:sp>
+        <p:nvSpPr>
+          <p:cNvPr id="28" name="Text 26"/>
+          <p:cNvSpPr/>
+          <p:nvPr/>
+        </p:nvSpPr>
+        <p:spPr>
+          <a:xfrm>
+            <a:off x="7059168" y="3648456"/>
+            <a:ext cx="4572000" cy="777240"/>
+          </a:xfrm>
+          <a:prstGeom prst="rect">
+            <a:avLst/>
+          </a:prstGeom>
+          <a:noFill/>
+          <a:ln/>
+        </p:spPr>
+        <p:txBody>
+          <a:bodyPr wrap="square" lIns="0" tIns="0" rIns="0" bIns="0" rtlCol="0" anchor="t"/>
+          <a:lstStyle/>
+          <a:p>
+            <a:pPr indent="0" marL="0">
+              <a:buNone/>
+            </a:pPr>
+            <a:r>
+              <a:rPr lang="en-US" sz="1100" b="1" dirty="0">
+                <a:solidFill>
+                  <a:srgbClr val="1B3A5C"/>
+                </a:solidFill>
+                <a:latin typeface="Yu Gothic" pitchFamily="34" charset="0"/>
+                <a:ea typeface="Yu Gothic" pitchFamily="34" charset="-122"/>
+                <a:cs typeface="Yu Gothic" pitchFamily="34" charset="-120"/>
+              </a:rPr>
+              <a:t>スカウト承認後の音信不通  </a:t>
+            </a:r>
+            <a:pPr indent="0" marL="0">
+              <a:buNone/>
+            </a:pPr>
+            <a:r>
+              <a:rPr lang="en-US" sz="1100" dirty="0">
+                <a:solidFill>
+                  <a:srgbClr val="374151"/>
+                </a:solidFill>
+                <a:latin typeface="Yu Gothic" pitchFamily="34" charset="0"/>
+                <a:ea typeface="Yu Gothic" pitchFamily="34" charset="-122"/>
+                <a:cs typeface="Yu Gothic" pitchFamily="34" charset="-120"/>
+              </a:rPr>
+              <a:t>説明会誘導後にSMS既読が付かないケース(36歳)。接点の維持が課題</a:t>
+            </a:r>
+            <a:endParaRPr lang="en-US" sz="1100" dirty="0"/>
+          </a:p>
+        </p:txBody>
+      </p:sp>
+      <p:sp>
+        <p:nvSpPr>
+          <p:cNvPr id="29" name="Shape 27"/>
+          <p:cNvSpPr/>
+          <p:nvPr/>
+        </p:nvSpPr>
+        <p:spPr>
+          <a:xfrm>
+            <a:off x="6537960" y="4617720"/>
+            <a:ext cx="5120640" cy="1828800"/>
+          </a:xfrm>
+          <a:prstGeom prst="roundRect">
+            <a:avLst>
+              <a:gd name="adj" fmla="val 4000"/>
+            </a:avLst>
+          </a:prstGeom>
+          <a:solidFill>
+            <a:srgbClr val="F2F6FA"/>
+          </a:solidFill>
+          <a:ln/>
+        </p:spPr>
+      </p:sp>
+      <p:sp>
+        <p:nvSpPr>
+          <p:cNvPr id="30" name="Text 28"/>
+          <p:cNvSpPr/>
+          <p:nvPr/>
+        </p:nvSpPr>
+        <p:spPr>
+          <a:xfrm>
+            <a:off x="6766560" y="4754880"/>
+            <a:ext cx="4663440" cy="320040"/>
+          </a:xfrm>
+          <a:prstGeom prst="rect">
+            <a:avLst/>
+          </a:prstGeom>
+          <a:noFill/>
+          <a:ln/>
+        </p:spPr>
+        <p:txBody>
+          <a:bodyPr wrap="square" lIns="0" tIns="0" rIns="0" bIns="0" rtlCol="0" anchor="ctr"/>
+          <a:lstStyle/>
+          <a:p>
+            <a:pPr indent="0" marL="0">
+              <a:buNone/>
+            </a:pPr>
+            <a:r>
+              <a:rPr lang="en-US" sz="1250" b="1" dirty="0">
+                <a:solidFill>
+                  <a:srgbClr val="E8762C"/>
+                </a:solidFill>
+                <a:latin typeface="Yu Gothic" pitchFamily="34" charset="0"/>
+                <a:ea typeface="Yu Gothic" pitchFamily="34" charset="-122"/>
+                <a:cs typeface="Yu Gothic" pitchFamily="34" charset="-120"/>
+              </a:rPr>
+              <a:t>実施済みの対応</a:t>
+            </a:r>
+            <a:endParaRPr lang="en-US" sz="1250" dirty="0"/>
+          </a:p>
+        </p:txBody>
+      </p:sp>
+      <p:sp>
+        <p:nvSpPr>
+          <p:cNvPr id="31" name="Text 29"/>
+          <p:cNvSpPr/>
+          <p:nvPr/>
+        </p:nvSpPr>
+        <p:spPr>
+          <a:xfrm>
+            <a:off x="6766560" y="5120640"/>
+            <a:ext cx="4709160" cy="1234440"/>
+          </a:xfrm>
+          <a:prstGeom prst="rect">
+            <a:avLst/>
+          </a:prstGeom>
+          <a:noFill/>
+          <a:ln/>
+        </p:spPr>
+        <p:txBody>
+          <a:bodyPr wrap="square" lIns="0" tIns="0" rIns="0" bIns="0" rtlCol="0" anchor="t"/>
+          <a:lstStyle/>
+          <a:p>
+            <a:pPr marL="342900" indent="-342900">
+              <a:spcAft>
+                <a:spcPts val="700"/>
+              </a:spcAft>
+              <a:buSzPct val="100000"/>
+              <a:buChar char="•"/>
+            </a:pPr>
+            <a:r>
+              <a:rPr lang="en-US" sz="1050" dirty="0">
+                <a:solidFill>
+                  <a:srgbClr val="374151"/>
+                </a:solidFill>
+                <a:latin typeface="Yu Gothic" pitchFamily="34" charset="0"/>
+                <a:ea typeface="Yu Gothic" pitchFamily="34" charset="-122"/>
+                <a:cs typeface="Yu Gothic" pitchFamily="34" charset="-120"/>
+              </a:rPr>
+              <a:t>連絡順序を「固定電話→SMS」に変更(若手はメールを見ないため)</a:t>
+            </a:r>
+            <a:endParaRPr lang="en-US" sz="1050" dirty="0"/>
+          </a:p>
+          <a:p>
+            <a:pPr marL="342900" indent="-342900">
+              <a:spcAft>
+                <a:spcPts val="700"/>
+              </a:spcAft>
+              <a:buSzPct val="100000"/>
+              <a:buChar char="•"/>
+            </a:pPr>
+            <a:r>
+              <a:rPr lang="en-US" sz="1050" dirty="0">
+                <a:solidFill>
+                  <a:srgbClr val="374151"/>
+                </a:solidFill>
+                <a:latin typeface="Yu Gothic" pitchFamily="34" charset="0"/>
+                <a:ea typeface="Yu Gothic" pitchFamily="34" charset="-122"/>
+                <a:cs typeface="Yu Gothic" pitchFamily="34" charset="-120"/>
+              </a:rPr>
+              <a:t>応募者をSMS・電話でオンライン説明会(顔出しなし)へ誘導</a:t>
+            </a:r>
+            <a:endParaRPr lang="en-US" sz="1050" dirty="0"/>
+          </a:p>
+          <a:p>
+            <a:pPr marL="342900" indent="-342900">
+              <a:spcAft>
+                <a:spcPts val="700"/>
+              </a:spcAft>
+              <a:buSzPct val="100000"/>
+              <a:buChar char="•"/>
+            </a:pPr>
+            <a:r>
+              <a:rPr lang="en-US" sz="1050" dirty="0">
+                <a:solidFill>
+                  <a:srgbClr val="374151"/>
+                </a:solidFill>
+                <a:latin typeface="Yu Gothic" pitchFamily="34" charset="0"/>
+                <a:ea typeface="Yu Gothic" pitchFamily="34" charset="-122"/>
+                <a:cs typeface="Yu Gothic" pitchFamily="34" charset="-120"/>
+              </a:rPr>
+              <a:t>LINE公式アカウントで若手が返信しやすい接点を追加</a:t>
+            </a:r>
+            <a:endParaRPr lang="en-US" sz="1050" dirty="0"/>
+          </a:p>
+        </p:txBody>
+      </p:sp>
+    </p:spTree>
+  </p:cSld>
+  <p:clrMapOvr>
+    <a:masterClrMapping/>
+  </p:clrMapOvr>
+</p:sld>
+</file>
+
+<file path=ppt/slides/slide12.xml><?xml version="1.0" encoding="utf-8"?>
+<p:sld xmlns:a="http://schemas.openxmlformats.org/drawingml/2006/main" xmlns:r="http://schemas.openxmlformats.org/officeDocument/2006/relationships" xmlns:p="http://schemas.openxmlformats.org/presentationml/2006/main">
+  <p:cSld name="Slide 12">
+    <p:bg>
+      <p:bgPr>
+        <a:solidFill>
+          <a:srgbClr val="FFFFFF"/>
+        </a:solidFill>
+      </p:bgPr>
+    </p:bg>
+    <p:spTree>
+      <p:nvGrpSpPr>
+        <p:cNvPr id="1" name=""/>
+        <p:cNvGrpSpPr/>
+        <p:nvPr/>
+      </p:nvGrpSpPr>
+      <p:grpSpPr>
+        <a:xfrm>
+          <a:off x="0" y="0"/>
+          <a:ext cx="0" cy="0"/>
+          <a:chOff x="0" y="0"/>
+          <a:chExt cx="0" cy="0"/>
+        </a:xfrm>
+      </p:grpSpPr>
+      <p:sp>
+        <p:nvSpPr>
+          <p:cNvPr id="2" name="Text 0"/>
+          <p:cNvSpPr/>
+          <p:nvPr/>
+        </p:nvSpPr>
+        <p:spPr>
+          <a:xfrm>
+            <a:off x="548640" y="292608"/>
+            <a:ext cx="9601200" cy="685800"/>
+          </a:xfrm>
+          <a:prstGeom prst="rect">
+            <a:avLst/>
+          </a:prstGeom>
+          <a:noFill/>
+          <a:ln/>
+        </p:spPr>
+        <p:txBody>
+          <a:bodyPr wrap="square" lIns="0" tIns="0" rIns="0" bIns="0" rtlCol="0" anchor="ctr"/>
+          <a:lstStyle/>
+          <a:p>
+            <a:pPr indent="0" marL="0">
+              <a:buNone/>
+            </a:pPr>
+            <a:r>
+              <a:rPr lang="en-US" sz="3000" b="1" dirty="0">
+                <a:solidFill>
+                  <a:srgbClr val="1B3A5C"/>
+                </a:solidFill>
+                <a:latin typeface="Yu Gothic" pitchFamily="34" charset="0"/>
+                <a:ea typeface="Yu Gothic" pitchFamily="34" charset="-122"/>
+                <a:cs typeface="Yu Gothic" pitchFamily="34" charset="-120"/>
+              </a:rPr>
+              <a:t>活動履歴 ─ 定例ミーティング・説明会</a:t>
+            </a:r>
+            <a:endParaRPr lang="en-US" sz="3000" dirty="0"/>
+          </a:p>
+        </p:txBody>
+      </p:sp>
+      <p:sp>
+        <p:nvSpPr>
+          <p:cNvPr id="3" name="Text 1"/>
+          <p:cNvSpPr/>
+          <p:nvPr/>
+        </p:nvSpPr>
+        <p:spPr>
+          <a:xfrm>
+            <a:off x="566928" y="932688"/>
+            <a:ext cx="10515600" cy="365760"/>
+          </a:xfrm>
+          <a:prstGeom prst="rect">
+            <a:avLst/>
+          </a:prstGeom>
+          <a:noFill/>
+          <a:ln/>
+        </p:spPr>
+        <p:txBody>
+          <a:bodyPr wrap="square" lIns="0" tIns="0" rIns="0" bIns="0" rtlCol="0" anchor="ctr"/>
+          <a:lstStyle/>
+          <a:p>
+            <a:pPr indent="0" marL="0">
+              <a:buNone/>
+            </a:pPr>
+            <a:r>
+              <a:rPr lang="en-US" sz="1300" dirty="0">
+                <a:solidFill>
+                  <a:srgbClr val="6B7280"/>
+                </a:solidFill>
+                <a:latin typeface="Yu Gothic" pitchFamily="34" charset="0"/>
+                <a:ea typeface="Yu Gothic" pitchFamily="34" charset="-122"/>
+                <a:cs typeface="Yu Gothic" pitchFamily="34" charset="-120"/>
+              </a:rPr>
+              <a:t>毎回議事録を共有し、決定事項を翌週までに実行するサイクルを継続</a:t>
+            </a:r>
+            <a:endParaRPr lang="en-US" sz="1300" dirty="0"/>
+          </a:p>
+        </p:txBody>
+      </p:sp>
+      <p:sp>
+        <p:nvSpPr>
+          <p:cNvPr id="4" name="Text 2"/>
+          <p:cNvSpPr/>
+          <p:nvPr/>
+        </p:nvSpPr>
+        <p:spPr>
+          <a:xfrm>
+            <a:off x="11292840" y="320040"/>
+            <a:ext cx="640080" cy="457200"/>
+          </a:xfrm>
+          <a:prstGeom prst="rect">
+            <a:avLst/>
+          </a:prstGeom>
+          <a:noFill/>
+          <a:ln/>
+        </p:spPr>
+        <p:txBody>
+          <a:bodyPr wrap="square" lIns="0" tIns="0" rIns="0" bIns="0" rtlCol="0" anchor="ctr"/>
+          <a:lstStyle/>
+          <a:p>
+            <a:pPr algn="r" indent="0" marL="0">
+              <a:buNone/>
+            </a:pPr>
+            <a:r>
+              <a:rPr lang="en-US" sz="1600" b="1" dirty="0">
+                <a:solidFill>
+                  <a:srgbClr val="5A7A99"/>
+                </a:solidFill>
+                <a:latin typeface="Arial" pitchFamily="34" charset="0"/>
+                <a:ea typeface="Arial" pitchFamily="34" charset="-122"/>
+                <a:cs typeface="Arial" pitchFamily="34" charset="-120"/>
+              </a:rPr>
+              <a:t>12</a:t>
+            </a:r>
+            <a:endParaRPr lang="en-US" sz="1600" dirty="0"/>
+          </a:p>
+        </p:txBody>
+      </p:sp>
       <p:graphicFrame>
         <p:nvGraphicFramePr>
-          <p:cNvPr id="12" name="Table 0"/>
+          <p:cNvPr id="13" name="Table 0"/>
           <p:cNvGraphicFramePr>
             <a:graphicFrameLocks noGrp="1"/>
           </p:cNvGraphicFramePr>
@@ -5286,7 +6543,7 @@
       </p:graphicFrame>
       <p:graphicFrame>
         <p:nvGraphicFramePr>
-          <p:cNvPr id="23" name="Table 1"/>
+          <p:cNvPr id="25" name="Table 1"/>
           <p:cNvGraphicFramePr>
             <a:graphicFrameLocks noGrp="1"/>
           </p:cNvGraphicFramePr>
@@ -7017,9 +8274,9 @@
 </p:sld>
 </file>
 
-<file path=ppt/slides/slide12.xml><?xml version="1.0" encoding="utf-8"?>
+<file path=ppt/slides/slide13.xml><?xml version="1.0" encoding="utf-8"?>
 <p:sld xmlns:a="http://schemas.openxmlformats.org/drawingml/2006/main" xmlns:r="http://schemas.openxmlformats.org/officeDocument/2006/relationships" xmlns:p="http://schemas.openxmlformats.org/presentationml/2006/main">
-  <p:cSld name="Slide 12">
+  <p:cSld name="Slide 13">
     <p:bg>
       <p:bgPr>
         <a:solidFill>
@@ -7152,7 +8409,7 @@
                 <a:ea typeface="Arial" pitchFamily="34" charset="-122"/>
                 <a:cs typeface="Arial" pitchFamily="34" charset="-120"/>
               </a:rPr>
-              <a:t>12</a:t>
+              <a:t>13</a:t>
             </a:r>
             <a:endParaRPr lang="en-US" sz="1600" dirty="0"/>
           </a:p>
@@ -7476,7 +8733,7 @@
                 <a:ea typeface="Yu Gothic" pitchFamily="34" charset="-122"/>
                 <a:cs typeface="Yu Gothic" pitchFamily="34" charset="-120"/>
               </a:rPr>
-              <a:t>応募の「質」への転換
+              <a:t>20〜30代の選考移行率の改善(最重要)
 </a:t>
             </a:r>
             <a:pPr indent="0" marL="0">
@@ -7491,7 +8748,7 @@
                 <a:ea typeface="Yu Gothic" pitchFamily="34" charset="-122"/>
                 <a:cs typeface="Yu Gothic" pitchFamily="34" charset="-120"/>
               </a:rPr>
-              <a:t>オンライン説明会を起点に、応募前ヒアリングで年齢・条件のミスマッチを削減。ヤギオファーの好反応文面を横展開し、ターゲット層(20〜30代オタク気質)への到達を強化</a:t>
+              <a:t>初回接触を24時間以内・固定電話→SMS→LINEの順で徹底し、若手の連絡途絶を防止。オンライン説明会への誘導を全応募者の標準フローにし、「応募→説明会参加」の移行率をKPIとして毎週計測</a:t>
             </a:r>
             <a:endParaRPr lang="en-US" sz="1300" dirty="0"/>
           </a:p>
@@ -7731,9 +8988,9 @@
 </p:sld>
 </file>
 
-<file path=ppt/slides/slide13.xml><?xml version="1.0" encoding="utf-8"?>
+<file path=ppt/slides/slide14.xml><?xml version="1.0" encoding="utf-8"?>
 <p:sld xmlns:a="http://schemas.openxmlformats.org/drawingml/2006/main" xmlns:r="http://schemas.openxmlformats.org/officeDocument/2006/relationships" xmlns:p="http://schemas.openxmlformats.org/presentationml/2006/main">
-  <p:cSld name="Slide 13">
+  <p:cSld name="Slide 14">
     <p:bg>
       <p:bgPr>
         <a:solidFill>
@@ -8030,7 +9287,7 @@
                 <a:ea typeface="Yu Gothic" pitchFamily="34" charset="-122"/>
                 <a:cs typeface="Yu Gothic" pitchFamily="34" charset="-120"/>
               </a:rPr>
-              <a:t>9ヶ月間の支援で「採用の土台」を構築し、応募が発生する状態までを実現しました</a:t>
+              <a:t>目的である「20・30代の若手採用」に向け、応募の3分の2がターゲット年代という状態を実現しました</a:t>
             </a:r>
             <a:endParaRPr lang="en-US" sz="1300" dirty="0"/>
           </a:p>
@@ -8130,7 +9387,7 @@
                 <a:ea typeface="Yu Gothic" pitchFamily="34" charset="-122"/>
                 <a:cs typeface="Yu Gothic" pitchFamily="34" charset="-120"/>
               </a:rPr>
-              <a:t>20回+</a:t>
+              <a:t>8/12名</a:t>
             </a:r>
             <a:endParaRPr lang="en-US" sz="3200" dirty="0"/>
           </a:p>
@@ -8169,7 +9426,7 @@
                 <a:ea typeface="Yu Gothic" pitchFamily="34" charset="-122"/>
                 <a:cs typeface="Yu Gothic" pitchFamily="34" charset="-120"/>
               </a:rPr>
-              <a:t>定例ミーティング</a:t>
+              <a:t>20〜30代の応募</a:t>
             </a:r>
             <a:endParaRPr lang="en-US" sz="1250" dirty="0"/>
           </a:p>
@@ -8208,7 +9465,7 @@
                 <a:ea typeface="Yu Gothic" pitchFamily="34" charset="-122"/>
                 <a:cs typeface="Yu Gothic" pitchFamily="34" charset="-120"/>
               </a:rPr>
-              <a:t>週次〜隔週で継続実施(社員インタビュー・説明会直前MTG含む)</a:t>
+              <a:t>全応募者12名中8名(67%)がターゲット年代。毎月継続的に発生</a:t>
             </a:r>
             <a:endParaRPr lang="en-US" sz="950" dirty="0"/>
           </a:p>
@@ -8835,7 +10092,7 @@
                 <a:ea typeface="Yu Gothic" pitchFamily="34" charset="-122"/>
                 <a:cs typeface="Yu Gothic" pitchFamily="34" charset="-120"/>
               </a:rPr>
-              <a:t>独自ポジションの確立  </a:t>
+              <a:t>20・30代に届く独自ポジションの確立  </a:t>
             </a:r>
             <a:pPr indent="0" marL="0">
               <a:buNone/>
@@ -8849,7 +10106,7 @@
                 <a:ea typeface="Yu Gothic" pitchFamily="34" charset="-122"/>
                 <a:cs typeface="Yu Gothic" pitchFamily="34" charset="-120"/>
               </a:rPr>
-              <a:t>検証を重ね、ペルソナを「オタク気質・マニア層」へ転換。「AIに代替されない技術」との2軸で、富山の採用競争における独自の立ち位置を確立。</a:t>
+              <a:t>検証を重ね、ペルソナを「オタク気質・マニア層」へ転換。「AIに代替されない技術」との2軸が奏功し、20〜30代が応募の中心に。</a:t>
             </a:r>
             <a:endParaRPr lang="en-US" sz="1250" dirty="0"/>
           </a:p>
@@ -8961,7 +10218,7 @@
                 <a:ea typeface="Yu Gothic" pitchFamily="34" charset="-122"/>
                 <a:cs typeface="Yu Gothic" pitchFamily="34" charset="-120"/>
               </a:rPr>
-              <a:t>自社説明会→オンライン説明会、LP改善、LINE公式、SNSと、応募ハードルを下げる導線を段階的に整備。</a:t>
+              <a:t>自社説明会→オンライン説明会、LP改善、LINE公式、SNSと、若手の応募ハードルを下げる導線を段階的に整備。</a:t>
             </a:r>
             <a:endParaRPr lang="en-US" sz="1250" dirty="0"/>
           </a:p>
@@ -9073,7 +10330,7 @@
                 <a:ea typeface="Yu Gothic" pitchFamily="34" charset="-122"/>
                 <a:cs typeface="Yu Gothic" pitchFamily="34" charset="-120"/>
               </a:rPr>
-              <a:t>応募から面接・入社への転換が未達(入社0名)。8月以降の転職市場の再活性化に向けた具体策を本レポート末尾でご提案します。</a:t>
+              <a:t>応募から選考への移行が壁(書類通過・面接0名)。20代の連絡途絶への対策と選考移行率の改善策を本レポートでご提案します。</a:t>
             </a:r>
             <a:endParaRPr lang="en-US" sz="1250" dirty="0"/>
           </a:p>
@@ -9509,6 +10766,144 @@
                           <a:ea typeface="Yu Gothic" pitchFamily="34" charset="-122"/>
                           <a:cs typeface="Yu Gothic" pitchFamily="34" charset="-120"/>
                         </a:rPr>
+                        <a:t>ターゲット</a:t>
+                      </a:r>
+                      <a:endParaRPr lang="en-US" sz="1250" dirty="0">
+                        <a:latin typeface="Yu Gothic" charset="0"/>
+                        <a:ea typeface="Yu Gothic" charset="0"/>
+                        <a:cs typeface="Yu Gothic" charset="0"/>
+                      </a:endParaRPr>
+                    </a:p>
+                  </a:txBody>
+                  <a:tcPr marL="73152" marR="73152" marT="73152" marB="73152" anchor="ctr">
+                    <a:lnL w="25400" cap="flat" cmpd="sng" algn="ctr">
+                      <a:solidFill>
+                        <a:srgbClr val="FFFFFF"/>
+                      </a:solidFill>
+                      <a:prstDash val="solid"/>
+                      <a:round/>
+                      <a:headEnd type="none" w="med" len="med"/>
+                      <a:tailEnd type="none" w="med" len="med"/>
+                    </a:lnL>
+                    <a:lnR w="25400" cap="flat" cmpd="sng" algn="ctr">
+                      <a:solidFill>
+                        <a:srgbClr val="FFFFFF"/>
+                      </a:solidFill>
+                      <a:prstDash val="solid"/>
+                      <a:round/>
+                      <a:headEnd type="none" w="med" len="med"/>
+                      <a:tailEnd type="none" w="med" len="med"/>
+                    </a:lnR>
+                    <a:lnT w="25400" cap="flat" cmpd="sng" algn="ctr">
+                      <a:solidFill>
+                        <a:srgbClr val="FFFFFF"/>
+                      </a:solidFill>
+                      <a:prstDash val="solid"/>
+                      <a:round/>
+                      <a:headEnd type="none" w="med" len="med"/>
+                      <a:tailEnd type="none" w="med" len="med"/>
+                    </a:lnT>
+                    <a:lnB w="25400" cap="flat" cmpd="sng" algn="ctr">
+                      <a:solidFill>
+                        <a:srgbClr val="FFFFFF"/>
+                      </a:solidFill>
+                      <a:prstDash val="solid"/>
+                      <a:round/>
+                      <a:headEnd type="none" w="med" len="med"/>
+                      <a:tailEnd type="none" w="med" len="med"/>
+                    </a:lnB>
+                    <a:solidFill>
+                      <a:srgbClr val="1B3A5C"/>
+                    </a:solidFill>
+                  </a:tcPr>
+                </a:tc>
+                <a:tc>
+                  <a:txBody>
+                    <a:bodyPr/>
+                    <a:lstStyle/>
+                    <a:p>
+                      <a:pPr indent="0" marL="0">
+                        <a:buNone/>
+                      </a:pPr>
+                      <a:r>
+                        <a:rPr lang="en-US" sz="1250" dirty="0">
+                          <a:solidFill>
+                            <a:srgbClr val="374151"/>
+                          </a:solidFill>
+                          <a:latin typeface="Yu Gothic" pitchFamily="34" charset="0"/>
+                          <a:ea typeface="Yu Gothic" pitchFamily="34" charset="-122"/>
+                          <a:cs typeface="Yu Gothic" pitchFamily="34" charset="-120"/>
+                        </a:rPr>
+                        <a:t>20・30代の未経験/第二新卒(オタク気質層)を主軸に、経験者を併用</a:t>
+                      </a:r>
+                      <a:endParaRPr lang="en-US" sz="1250" dirty="0">
+                        <a:latin typeface="Yu Gothic" charset="0"/>
+                        <a:ea typeface="Yu Gothic" charset="0"/>
+                        <a:cs typeface="Yu Gothic" charset="0"/>
+                      </a:endParaRPr>
+                    </a:p>
+                  </a:txBody>
+                  <a:tcPr marL="73152" marR="73152" marT="73152" marB="73152" anchor="ctr">
+                    <a:lnL w="25400" cap="flat" cmpd="sng" algn="ctr">
+                      <a:solidFill>
+                        <a:srgbClr val="FFFFFF"/>
+                      </a:solidFill>
+                      <a:prstDash val="solid"/>
+                      <a:round/>
+                      <a:headEnd type="none" w="med" len="med"/>
+                      <a:tailEnd type="none" w="med" len="med"/>
+                    </a:lnL>
+                    <a:lnR w="25400" cap="flat" cmpd="sng" algn="ctr">
+                      <a:solidFill>
+                        <a:srgbClr val="FFFFFF"/>
+                      </a:solidFill>
+                      <a:prstDash val="solid"/>
+                      <a:round/>
+                      <a:headEnd type="none" w="med" len="med"/>
+                      <a:tailEnd type="none" w="med" len="med"/>
+                    </a:lnR>
+                    <a:lnT w="25400" cap="flat" cmpd="sng" algn="ctr">
+                      <a:solidFill>
+                        <a:srgbClr val="FFFFFF"/>
+                      </a:solidFill>
+                      <a:prstDash val="solid"/>
+                      <a:round/>
+                      <a:headEnd type="none" w="med" len="med"/>
+                      <a:tailEnd type="none" w="med" len="med"/>
+                    </a:lnT>
+                    <a:lnB w="25400" cap="flat" cmpd="sng" algn="ctr">
+                      <a:solidFill>
+                        <a:srgbClr val="FFFFFF"/>
+                      </a:solidFill>
+                      <a:prstDash val="solid"/>
+                      <a:round/>
+                      <a:headEnd type="none" w="med" len="med"/>
+                      <a:tailEnd type="none" w="med" len="med"/>
+                    </a:lnB>
+                    <a:solidFill>
+                      <a:srgbClr val="F2F6FA"/>
+                    </a:solidFill>
+                  </a:tcPr>
+                </a:tc>
+              </a:tr>
+              <a:tr h="566928">
+                <a:tc>
+                  <a:txBody>
+                    <a:bodyPr/>
+                    <a:lstStyle/>
+                    <a:p>
+                      <a:pPr indent="0" marL="0">
+                        <a:buNone/>
+                      </a:pPr>
+                      <a:r>
+                        <a:rPr lang="en-US" sz="1250" b="1" dirty="0">
+                          <a:solidFill>
+                            <a:srgbClr val="FFFFFF"/>
+                          </a:solidFill>
+                          <a:latin typeface="Yu Gothic" pitchFamily="34" charset="0"/>
+                          <a:ea typeface="Yu Gothic" pitchFamily="34" charset="-122"/>
+                          <a:cs typeface="Yu Gothic" pitchFamily="34" charset="-120"/>
+                        </a:rPr>
                         <a:t>体制</a:t>
                       </a:r>
                       <a:endParaRPr lang="en-US" sz="1250" dirty="0">
@@ -9991,7 +11386,7 @@
                           <a:ea typeface="Yu Gothic" pitchFamily="34" charset="-122"/>
                           <a:cs typeface="Yu Gothic" pitchFamily="34" charset="-120"/>
                         </a:rPr>
-                        <a:t>配管工の採用(週次進捗管理:目標1名・2026年2月〜52週)</a:t>
+                        <a:t>20・30代の配管工採用(週次進捗管理:目標1名・2026年2月〜52週)</a:t>
                       </a:r>
                       <a:endParaRPr lang="en-US" sz="1250" dirty="0">
                         <a:latin typeface="Yu Gothic" charset="0"/>
@@ -14349,15 +15744,15 @@
               <a:buNone/>
             </a:pPr>
             <a:r>
-              <a:rPr lang="en-US" sz="1200" dirty="0">
-                <a:solidFill>
-                  <a:srgbClr val="CADCFC"/>
-                </a:solidFill>
-                <a:latin typeface="Yu Gothic" pitchFamily="34" charset="0"/>
-                <a:ea typeface="Yu Gothic" pitchFamily="34" charset="-122"/>
-                <a:cs typeface="Yu Gothic" pitchFamily="34" charset="-120"/>
-              </a:rPr>
-              <a:t>技術のパズル性・専門性で20〜30代の関心層に訴求</a:t>
+              <a:rPr lang="en-US" sz="1200" b="1" dirty="0">
+                <a:solidFill>
+                  <a:srgbClr val="FFFFFF"/>
+                </a:solidFill>
+                <a:latin typeface="Yu Gothic" pitchFamily="34" charset="0"/>
+                <a:ea typeface="Yu Gothic" pitchFamily="34" charset="-122"/>
+                <a:cs typeface="Yu Gothic" pitchFamily="34" charset="-120"/>
+              </a:rPr>
+              <a:t>→ 結果: 応募者の67%(12名中8名)が20〜30代に</a:t>
             </a:r>
             <a:endParaRPr lang="en-US" sz="1200" dirty="0"/>
           </a:p>

</xml_diff>

<commit_message>
Add 20s-30s applicant metrics: per-media age split and monthly trend
Co-Authored-By: Claude Fable 5 <noreply@anthropic.com>
Claude-Session: https://claude.ai/code/session_019t7NW6utTEgroUuPVV8xiA
</commit_message>
<xml_diff>
--- a/reports/matsushita-kogyo/松下工業様_採用強化支援_総括レポート.pptx
+++ b/reports/matsushita-kogyo/松下工業様_採用強化支援_総括レポート.pptx
@@ -445,7 +445,7 @@
                 </a:solidFill>
                 <a:latin typeface="Yu Gothic"/>
               </a:rPr>
-              <a:t>媒体別 応募数(2026年3〜7月・計13件)</a:t>
+              <a:t>媒体別 応募者数と年代内訳(実人数12名)</a:t>
             </a:r>
           </a:p>
         </c:rich>
@@ -458,7 +458,7 @@
       <c:layout/>
       <c:barChart>
         <c:barDir val="bar"/>
-        <c:grouping val="clustered"/>
+        <c:grouping val="stacked"/>
         <c:varyColors val="0"/>
         <c:ser>
           <c:idx val="0"/>
@@ -469,7 +469,7 @@
               <c:strCache>
                 <c:ptCount val="1"/>
                 <c:pt idx="0">
-                  <c:v>応募数</c:v>
+                  <c:v>20〜30代</c:v>
                 </c:pt>
               </c:strCache>
             </c:strRef>
@@ -488,15 +488,16 @@
               <a:lstStyle/>
               <a:p>
                 <a:pPr>
-                  <a:defRPr b="0" i="0" strike="noStrike" sz="1100" u="none">
+                  <a:defRPr b="0" i="0" strike="noStrike" sz="1000" u="none">
                     <a:solidFill>
-                      <a:srgbClr val="1B3A5C"/>
+                      <a:srgbClr val="FFFFFF"/>
                     </a:solidFill>
                     <a:latin typeface="Yu Gothic"/>
                   </a:defRPr>
                 </a:pPr>
               </a:p>
             </c:txPr>
+            <c:dLblPos val="ctr"/>
             <c:showLegendKey val="0"/>
             <c:showVal val="1"/>
             <c:showCatName val="0"/>
@@ -515,10 +516,10 @@
                     <c:v>ヤギオファー</c:v>
                   </c:pt>
                   <c:pt idx="1">
-                    <c:v>求人BOX</c:v>
+                    <c:v>Indeed</c:v>
                   </c:pt>
                   <c:pt idx="2">
-                    <c:v>Indeed</c:v>
+                    <c:v>求人BOX</c:v>
                   </c:pt>
                   <c:pt idx="3">
                     <c:v>AirWork</c:v>
@@ -534,16 +535,106 @@
                 <c:formatCode>General</c:formatCode>
                 <c:ptCount val="4"/>
                 <c:pt idx="0">
-                  <c:v>5</c:v>
+                  <c:v>4</c:v>
                 </c:pt>
                 <c:pt idx="1">
-                  <c:v>3</c:v>
+                  <c:v>2</c:v>
                 </c:pt>
                 <c:pt idx="2">
-                  <c:v>3</c:v>
+                  <c:v>1</c:v>
                 </c:pt>
                 <c:pt idx="3">
+                  <c:v>1</c:v>
+                </c:pt>
+              </c:numCache>
+            </c:numRef>
+          </c:val>
+        </c:ser>
+        <c:ser>
+          <c:idx val="1"/>
+          <c:order val="1"/>
+          <c:tx>
+            <c:strRef>
+              <c:f>Sheet1!$C$1</c:f>
+              <c:strCache>
+                <c:ptCount val="1"/>
+                <c:pt idx="0">
+                  <c:v>40代以上</c:v>
+                </c:pt>
+              </c:strCache>
+            </c:strRef>
+          </c:tx>
+          <c:spPr>
+            <a:solidFill>
+              <a:srgbClr val="5A7A99"/>
+            </a:solidFill>
+            <a:effectLst/>
+          </c:spPr>
+          <c:invertIfNegative val="0"/>
+          <c:dLbls>
+            <c:numFmt formatCode="#,##0" sourceLinked="0"/>
+            <c:txPr>
+              <a:bodyPr/>
+              <a:lstStyle/>
+              <a:p>
+                <a:pPr>
+                  <a:defRPr b="0" i="0" strike="noStrike" sz="1000" u="none">
+                    <a:solidFill>
+                      <a:srgbClr val="FFFFFF"/>
+                    </a:solidFill>
+                    <a:latin typeface="Yu Gothic"/>
+                  </a:defRPr>
+                </a:pPr>
+              </a:p>
+            </c:txPr>
+            <c:dLblPos val="ctr"/>
+            <c:showLegendKey val="0"/>
+            <c:showVal val="1"/>
+            <c:showCatName val="0"/>
+            <c:showSerName val="0"/>
+            <c:showPercent val="0"/>
+            <c:showBubbleSize val="0"/>
+            <c:showLeaderLines val="0"/>
+          </c:dLbls>
+          <c:cat>
+            <c:multiLvlStrRef>
+              <c:f>Sheet1!$A$2:$A$5</c:f>
+              <c:multiLvlStrCache>
+                <c:ptCount val="4"/>
+                <c:lvl>
+                  <c:pt idx="0">
+                    <c:v>ヤギオファー</c:v>
+                  </c:pt>
+                  <c:pt idx="1">
+                    <c:v>Indeed</c:v>
+                  </c:pt>
+                  <c:pt idx="2">
+                    <c:v>求人BOX</c:v>
+                  </c:pt>
+                  <c:pt idx="3">
+                    <c:v>AirWork</c:v>
+                  </c:pt>
+                </c:lvl>
+              </c:multiLvlStrCache>
+            </c:multiLvlStrRef>
+          </c:cat>
+          <c:val>
+            <c:numRef>
+              <c:f>Sheet1!$C$2:$C$5</c:f>
+              <c:numCache>
+                <c:formatCode>General</c:formatCode>
+                <c:ptCount val="4"/>
+                <c:pt idx="0">
+                  <c:v>1</c:v>
+                </c:pt>
+                <c:pt idx="1">
+                  <c:v>1</c:v>
+                </c:pt>
+                <c:pt idx="2">
                   <c:v>2</c:v>
+                </c:pt>
+                <c:pt idx="3">
+                  <c:v>0</c:v>
                 </c:pt>
               </c:numCache>
             </c:numRef>
@@ -556,15 +647,16 @@
             <a:lstStyle/>
             <a:p>
               <a:pPr>
-                <a:defRPr b="0" i="0" strike="noStrike" sz="1100" u="none">
+                <a:defRPr b="0" i="0" strike="noStrike" sz="1000" u="none">
                   <a:solidFill>
-                    <a:srgbClr val="1B3A5C"/>
+                    <a:srgbClr val="FFFFFF"/>
                   </a:solidFill>
                   <a:latin typeface="Yu Gothic"/>
                 </a:defRPr>
               </a:pPr>
             </a:p>
           </c:txPr>
+          <c:dLblPos val="ctr"/>
           <c:showLegendKey val="0"/>
           <c:showVal val="1"/>
           <c:showCatName val="0"/>
@@ -573,8 +665,8 @@
           <c:showBubbleSize val="0"/>
           <c:showLeaderLines val="0"/>
         </c:dLbls>
-        <c:gapWidth val="150"/>
-        <c:overlap val="0"/>
+        <c:gapWidth val="50"/>
+        <c:overlap val="100"/>
         <c:axId val="2094734554"/>
         <c:axId val="2094734552"/>
         <c:axId val="2094734556"/>
@@ -679,6 +771,26 @@
         <a:effectLst/>
       </c:spPr>
     </c:plotArea>
+    <c:legend>
+      <c:legendPos val="b"/>
+      <c:overlay val="0"/>
+      <c:txPr>
+        <a:bodyPr/>
+        <a:lstStyle/>
+        <a:p>
+          <a:pPr>
+            <a:defRPr sz="1000">
+              <a:solidFill>
+                <a:srgbClr val="374151"/>
+              </a:solidFill>
+              <a:latin typeface="Yu Gothic"/>
+              <a:cs typeface="Yu Gothic"/>
+            </a:defRPr>
+          </a:pPr>
+          <a:endParaRPr lang="en-US"/>
+        </a:p>
+      </c:txPr>
+    </c:legend>
     <c:plotVisOnly val="1"/>
     <c:dispBlanksAs val="span"/>
   </c:chart>
@@ -3002,7 +3114,7 @@
         </p:nvGraphicFramePr>
         <p:xfrm>
           <a:off x="548640" y="1691640"/>
-          <a:ext cx="5120640" cy="3017520"/>
+          <a:ext cx="5120640" cy="3200400"/>
         </p:xfrm>
         <a:graphic xmlns:a="http://schemas.openxmlformats.org/drawingml/2006/main">
           <a:graphicData uri="http://schemas.openxmlformats.org/drawingml/2006/chart">
@@ -3018,12 +3130,12 @@
         </p:nvSpPr>
         <p:spPr>
           <a:xfrm>
-            <a:off x="548640" y="4937760"/>
-            <a:ext cx="5120640" cy="1188720"/>
+            <a:off x="548640" y="5074920"/>
+            <a:ext cx="5120640" cy="1143000"/>
           </a:xfrm>
           <a:prstGeom prst="roundRect">
             <a:avLst>
-              <a:gd name="adj" fmla="val 6154"/>
+              <a:gd name="adj" fmla="val 6400"/>
             </a:avLst>
           </a:prstGeom>
           <a:solidFill>
@@ -3040,7 +3152,7 @@
         </p:nvSpPr>
         <p:spPr>
           <a:xfrm>
-            <a:off x="777240" y="5074920"/>
+            <a:off x="777240" y="5193792"/>
             <a:ext cx="4663440" cy="914400"/>
           </a:xfrm>
           <a:prstGeom prst="rect">
@@ -3057,7 +3169,7 @@
               <a:buNone/>
             </a:pPr>
             <a:r>
-              <a:rPr lang="en-US" sz="1150" b="1" dirty="0">
+              <a:rPr lang="en-US" sz="1100" b="1" dirty="0">
                 <a:solidFill>
                   <a:srgbClr val="1B3A5C"/>
                 </a:solidFill>
@@ -3065,13 +3177,13 @@
                 <a:ea typeface="Yu Gothic" pitchFamily="34" charset="-122"/>
                 <a:cs typeface="Yu Gothic" pitchFamily="34" charset="-120"/>
               </a:rPr>
-              <a:t>スカウト型(ヤギオファー)が最多。</a:t>
+              <a:t>20〜30代の最大の獲得源はスカウト型(ヤギオファー: 4名)。</a:t>
             </a:r>
             <a:pPr indent="0" marL="0">
               <a:buNone/>
             </a:pPr>
             <a:r>
-              <a:rPr lang="en-US" sz="1150" dirty="0">
+              <a:rPr lang="en-US" sz="1100" dirty="0">
                 <a:solidFill>
                   <a:srgbClr val="374151"/>
                 </a:solidFill>
@@ -3081,7 +3193,7 @@
               </a:rPr>
               <a:t>100通で2〜3名の反響と、業界平均(500通で1〜2名)を大きく上回る文面の刺さりを実証しました。</a:t>
             </a:r>
-            <a:endParaRPr lang="en-US" sz="1150" dirty="0"/>
+            <a:endParaRPr lang="en-US" sz="1100" dirty="0"/>
           </a:p>
         </p:txBody>
       </p:sp>
@@ -3432,18 +3544,432 @@
       </p:sp>
       <p:sp>
         <p:nvSpPr>
-          <p:cNvPr id="16" name="Shape 13"/>
-          <p:cNvSpPr/>
-          <p:nvPr/>
-        </p:nvSpPr>
-        <p:spPr>
-          <a:xfrm>
-            <a:off x="6309360" y="5074920"/>
-            <a:ext cx="5349240" cy="1143000"/>
+          <p:cNvPr id="16" name="Text 13"/>
+          <p:cNvSpPr/>
+          <p:nvPr/>
+        </p:nvSpPr>
+        <p:spPr>
+          <a:xfrm>
+            <a:off x="6309360" y="4471416"/>
+            <a:ext cx="5349240" cy="274320"/>
+          </a:xfrm>
+          <a:prstGeom prst="rect">
+            <a:avLst/>
+          </a:prstGeom>
+          <a:noFill/>
+          <a:ln/>
+        </p:spPr>
+        <p:txBody>
+          <a:bodyPr wrap="square" lIns="0" tIns="0" rIns="0" bIns="0" rtlCol="0" anchor="ctr"/>
+          <a:lstStyle/>
+          <a:p>
+            <a:pPr indent="0" marL="0">
+              <a:buNone/>
+            </a:pPr>
+            <a:r>
+              <a:rPr lang="en-US" sz="1200" b="1" dirty="0">
+                <a:solidFill>
+                  <a:srgbClr val="1B3A5C"/>
+                </a:solidFill>
+                <a:latin typeface="Yu Gothic" pitchFamily="34" charset="0"/>
+                <a:ea typeface="Yu Gothic" pitchFamily="34" charset="-122"/>
+                <a:cs typeface="Yu Gothic" pitchFamily="34" charset="-120"/>
+              </a:rPr>
+              <a:t>20〜30代応募の月別推移</a:t>
+            </a:r>
+            <a:endParaRPr lang="en-US" sz="1200" dirty="0"/>
+          </a:p>
+        </p:txBody>
+      </p:sp>
+      <p:sp>
+        <p:nvSpPr>
+          <p:cNvPr id="17" name="Shape 14"/>
+          <p:cNvSpPr/>
+          <p:nvPr/>
+        </p:nvSpPr>
+        <p:spPr>
+          <a:xfrm>
+            <a:off x="6309360" y="4782312"/>
+            <a:ext cx="960120" cy="475488"/>
           </a:xfrm>
           <a:prstGeom prst="roundRect">
             <a:avLst>
-              <a:gd name="adj" fmla="val 6400"/>
+              <a:gd name="adj" fmla="val 9615"/>
+            </a:avLst>
+          </a:prstGeom>
+          <a:solidFill>
+            <a:srgbClr val="E8762C"/>
+          </a:solidFill>
+          <a:ln/>
+        </p:spPr>
+      </p:sp>
+      <p:sp>
+        <p:nvSpPr>
+          <p:cNvPr id="18" name="Text 15"/>
+          <p:cNvSpPr/>
+          <p:nvPr/>
+        </p:nvSpPr>
+        <p:spPr>
+          <a:xfrm>
+            <a:off x="6309360" y="4782312"/>
+            <a:ext cx="960120" cy="475488"/>
+          </a:xfrm>
+          <a:prstGeom prst="rect">
+            <a:avLst/>
+          </a:prstGeom>
+          <a:noFill/>
+          <a:ln/>
+        </p:spPr>
+        <p:txBody>
+          <a:bodyPr wrap="square" lIns="0" tIns="0" rIns="0" bIns="0" rtlCol="0" anchor="ctr"/>
+          <a:lstStyle/>
+          <a:p>
+            <a:pPr algn="ctr" indent="0" marL="0">
+              <a:buNone/>
+            </a:pPr>
+            <a:r>
+              <a:rPr lang="en-US" sz="950" dirty="0">
+                <a:solidFill>
+                  <a:srgbClr val="FFFFFF"/>
+                </a:solidFill>
+                <a:latin typeface="Yu Gothic" pitchFamily="34" charset="0"/>
+                <a:ea typeface="Yu Gothic" pitchFamily="34" charset="-122"/>
+                <a:cs typeface="Yu Gothic" pitchFamily="34" charset="-120"/>
+              </a:rPr>
+              <a:t>3月  </a:t>
+            </a:r>
+            <a:pPr algn="ctr" indent="0" marL="0">
+              <a:buNone/>
+            </a:pPr>
+            <a:r>
+              <a:rPr lang="en-US" sz="1100" b="1" dirty="0">
+                <a:solidFill>
+                  <a:srgbClr val="FFFFFF"/>
+                </a:solidFill>
+                <a:latin typeface="Yu Gothic" pitchFamily="34" charset="0"/>
+                <a:ea typeface="Yu Gothic" pitchFamily="34" charset="-122"/>
+                <a:cs typeface="Yu Gothic" pitchFamily="34" charset="-120"/>
+              </a:rPr>
+              <a:t>2名</a:t>
+            </a:r>
+            <a:endParaRPr lang="en-US" sz="950" dirty="0"/>
+          </a:p>
+        </p:txBody>
+      </p:sp>
+      <p:sp>
+        <p:nvSpPr>
+          <p:cNvPr id="19" name="Shape 16"/>
+          <p:cNvSpPr/>
+          <p:nvPr/>
+        </p:nvSpPr>
+        <p:spPr>
+          <a:xfrm>
+            <a:off x="7406640" y="4782312"/>
+            <a:ext cx="960120" cy="475488"/>
+          </a:xfrm>
+          <a:prstGeom prst="roundRect">
+            <a:avLst>
+              <a:gd name="adj" fmla="val 9615"/>
+            </a:avLst>
+          </a:prstGeom>
+          <a:solidFill>
+            <a:srgbClr val="E5E7EB"/>
+          </a:solidFill>
+          <a:ln/>
+        </p:spPr>
+      </p:sp>
+      <p:sp>
+        <p:nvSpPr>
+          <p:cNvPr id="20" name="Text 17"/>
+          <p:cNvSpPr/>
+          <p:nvPr/>
+        </p:nvSpPr>
+        <p:spPr>
+          <a:xfrm>
+            <a:off x="7406640" y="4782312"/>
+            <a:ext cx="960120" cy="475488"/>
+          </a:xfrm>
+          <a:prstGeom prst="rect">
+            <a:avLst/>
+          </a:prstGeom>
+          <a:noFill/>
+          <a:ln/>
+        </p:spPr>
+        <p:txBody>
+          <a:bodyPr wrap="square" lIns="0" tIns="0" rIns="0" bIns="0" rtlCol="0" anchor="ctr"/>
+          <a:lstStyle/>
+          <a:p>
+            <a:pPr algn="ctr" indent="0" marL="0">
+              <a:buNone/>
+            </a:pPr>
+            <a:r>
+              <a:rPr lang="en-US" sz="950" dirty="0">
+                <a:solidFill>
+                  <a:srgbClr val="6B7280"/>
+                </a:solidFill>
+                <a:latin typeface="Yu Gothic" pitchFamily="34" charset="0"/>
+                <a:ea typeface="Yu Gothic" pitchFamily="34" charset="-122"/>
+                <a:cs typeface="Yu Gothic" pitchFamily="34" charset="-120"/>
+              </a:rPr>
+              <a:t>4月  </a:t>
+            </a:r>
+            <a:pPr algn="ctr" indent="0" marL="0">
+              <a:buNone/>
+            </a:pPr>
+            <a:r>
+              <a:rPr lang="en-US" sz="1100" b="1" dirty="0">
+                <a:solidFill>
+                  <a:srgbClr val="6B7280"/>
+                </a:solidFill>
+                <a:latin typeface="Yu Gothic" pitchFamily="34" charset="0"/>
+                <a:ea typeface="Yu Gothic" pitchFamily="34" charset="-122"/>
+                <a:cs typeface="Yu Gothic" pitchFamily="34" charset="-120"/>
+              </a:rPr>
+              <a:t>0名</a:t>
+            </a:r>
+            <a:endParaRPr lang="en-US" sz="950" dirty="0"/>
+          </a:p>
+        </p:txBody>
+      </p:sp>
+      <p:sp>
+        <p:nvSpPr>
+          <p:cNvPr id="21" name="Shape 18"/>
+          <p:cNvSpPr/>
+          <p:nvPr/>
+        </p:nvSpPr>
+        <p:spPr>
+          <a:xfrm>
+            <a:off x="8503920" y="4782312"/>
+            <a:ext cx="960120" cy="475488"/>
+          </a:xfrm>
+          <a:prstGeom prst="roundRect">
+            <a:avLst>
+              <a:gd name="adj" fmla="val 9615"/>
+            </a:avLst>
+          </a:prstGeom>
+          <a:solidFill>
+            <a:srgbClr val="E8762C"/>
+          </a:solidFill>
+          <a:ln/>
+        </p:spPr>
+      </p:sp>
+      <p:sp>
+        <p:nvSpPr>
+          <p:cNvPr id="22" name="Text 19"/>
+          <p:cNvSpPr/>
+          <p:nvPr/>
+        </p:nvSpPr>
+        <p:spPr>
+          <a:xfrm>
+            <a:off x="8503920" y="4782312"/>
+            <a:ext cx="960120" cy="475488"/>
+          </a:xfrm>
+          <a:prstGeom prst="rect">
+            <a:avLst/>
+          </a:prstGeom>
+          <a:noFill/>
+          <a:ln/>
+        </p:spPr>
+        <p:txBody>
+          <a:bodyPr wrap="square" lIns="0" tIns="0" rIns="0" bIns="0" rtlCol="0" anchor="ctr"/>
+          <a:lstStyle/>
+          <a:p>
+            <a:pPr algn="ctr" indent="0" marL="0">
+              <a:buNone/>
+            </a:pPr>
+            <a:r>
+              <a:rPr lang="en-US" sz="950" dirty="0">
+                <a:solidFill>
+                  <a:srgbClr val="FFFFFF"/>
+                </a:solidFill>
+                <a:latin typeface="Yu Gothic" pitchFamily="34" charset="0"/>
+                <a:ea typeface="Yu Gothic" pitchFamily="34" charset="-122"/>
+                <a:cs typeface="Yu Gothic" pitchFamily="34" charset="-120"/>
+              </a:rPr>
+              <a:t>5月  </a:t>
+            </a:r>
+            <a:pPr algn="ctr" indent="0" marL="0">
+              <a:buNone/>
+            </a:pPr>
+            <a:r>
+              <a:rPr lang="en-US" sz="1100" b="1" dirty="0">
+                <a:solidFill>
+                  <a:srgbClr val="FFFFFF"/>
+                </a:solidFill>
+                <a:latin typeface="Yu Gothic" pitchFamily="34" charset="0"/>
+                <a:ea typeface="Yu Gothic" pitchFamily="34" charset="-122"/>
+                <a:cs typeface="Yu Gothic" pitchFamily="34" charset="-120"/>
+              </a:rPr>
+              <a:t>2名</a:t>
+            </a:r>
+            <a:endParaRPr lang="en-US" sz="950" dirty="0"/>
+          </a:p>
+        </p:txBody>
+      </p:sp>
+      <p:sp>
+        <p:nvSpPr>
+          <p:cNvPr id="23" name="Shape 20"/>
+          <p:cNvSpPr/>
+          <p:nvPr/>
+        </p:nvSpPr>
+        <p:spPr>
+          <a:xfrm>
+            <a:off x="9601200" y="4782312"/>
+            <a:ext cx="960120" cy="475488"/>
+          </a:xfrm>
+          <a:prstGeom prst="roundRect">
+            <a:avLst>
+              <a:gd name="adj" fmla="val 9615"/>
+            </a:avLst>
+          </a:prstGeom>
+          <a:solidFill>
+            <a:srgbClr val="E8762C"/>
+          </a:solidFill>
+          <a:ln/>
+        </p:spPr>
+      </p:sp>
+      <p:sp>
+        <p:nvSpPr>
+          <p:cNvPr id="24" name="Text 21"/>
+          <p:cNvSpPr/>
+          <p:nvPr/>
+        </p:nvSpPr>
+        <p:spPr>
+          <a:xfrm>
+            <a:off x="9601200" y="4782312"/>
+            <a:ext cx="960120" cy="475488"/>
+          </a:xfrm>
+          <a:prstGeom prst="rect">
+            <a:avLst/>
+          </a:prstGeom>
+          <a:noFill/>
+          <a:ln/>
+        </p:spPr>
+        <p:txBody>
+          <a:bodyPr wrap="square" lIns="0" tIns="0" rIns="0" bIns="0" rtlCol="0" anchor="ctr"/>
+          <a:lstStyle/>
+          <a:p>
+            <a:pPr algn="ctr" indent="0" marL="0">
+              <a:buNone/>
+            </a:pPr>
+            <a:r>
+              <a:rPr lang="en-US" sz="950" dirty="0">
+                <a:solidFill>
+                  <a:srgbClr val="FFFFFF"/>
+                </a:solidFill>
+                <a:latin typeface="Yu Gothic" pitchFamily="34" charset="0"/>
+                <a:ea typeface="Yu Gothic" pitchFamily="34" charset="-122"/>
+                <a:cs typeface="Yu Gothic" pitchFamily="34" charset="-120"/>
+              </a:rPr>
+              <a:t>6月  </a:t>
+            </a:r>
+            <a:pPr algn="ctr" indent="0" marL="0">
+              <a:buNone/>
+            </a:pPr>
+            <a:r>
+              <a:rPr lang="en-US" sz="1100" b="1" dirty="0">
+                <a:solidFill>
+                  <a:srgbClr val="FFFFFF"/>
+                </a:solidFill>
+                <a:latin typeface="Yu Gothic" pitchFamily="34" charset="0"/>
+                <a:ea typeface="Yu Gothic" pitchFamily="34" charset="-122"/>
+                <a:cs typeface="Yu Gothic" pitchFamily="34" charset="-120"/>
+              </a:rPr>
+              <a:t>2名</a:t>
+            </a:r>
+            <a:endParaRPr lang="en-US" sz="950" dirty="0"/>
+          </a:p>
+        </p:txBody>
+      </p:sp>
+      <p:sp>
+        <p:nvSpPr>
+          <p:cNvPr id="25" name="Shape 22"/>
+          <p:cNvSpPr/>
+          <p:nvPr/>
+        </p:nvSpPr>
+        <p:spPr>
+          <a:xfrm>
+            <a:off x="10698480" y="4782312"/>
+            <a:ext cx="960120" cy="475488"/>
+          </a:xfrm>
+          <a:prstGeom prst="roundRect">
+            <a:avLst>
+              <a:gd name="adj" fmla="val 9615"/>
+            </a:avLst>
+          </a:prstGeom>
+          <a:solidFill>
+            <a:srgbClr val="E8762C"/>
+          </a:solidFill>
+          <a:ln/>
+        </p:spPr>
+      </p:sp>
+      <p:sp>
+        <p:nvSpPr>
+          <p:cNvPr id="26" name="Text 23"/>
+          <p:cNvSpPr/>
+          <p:nvPr/>
+        </p:nvSpPr>
+        <p:spPr>
+          <a:xfrm>
+            <a:off x="10698480" y="4782312"/>
+            <a:ext cx="960120" cy="475488"/>
+          </a:xfrm>
+          <a:prstGeom prst="rect">
+            <a:avLst/>
+          </a:prstGeom>
+          <a:noFill/>
+          <a:ln/>
+        </p:spPr>
+        <p:txBody>
+          <a:bodyPr wrap="square" lIns="0" tIns="0" rIns="0" bIns="0" rtlCol="0" anchor="ctr"/>
+          <a:lstStyle/>
+          <a:p>
+            <a:pPr algn="ctr" indent="0" marL="0">
+              <a:buNone/>
+            </a:pPr>
+            <a:r>
+              <a:rPr lang="en-US" sz="950" dirty="0">
+                <a:solidFill>
+                  <a:srgbClr val="FFFFFF"/>
+                </a:solidFill>
+                <a:latin typeface="Yu Gothic" pitchFamily="34" charset="0"/>
+                <a:ea typeface="Yu Gothic" pitchFamily="34" charset="-122"/>
+                <a:cs typeface="Yu Gothic" pitchFamily="34" charset="-120"/>
+              </a:rPr>
+              <a:t>7月  </a:t>
+            </a:r>
+            <a:pPr algn="ctr" indent="0" marL="0">
+              <a:buNone/>
+            </a:pPr>
+            <a:r>
+              <a:rPr lang="en-US" sz="1100" b="1" dirty="0">
+                <a:solidFill>
+                  <a:srgbClr val="FFFFFF"/>
+                </a:solidFill>
+                <a:latin typeface="Yu Gothic" pitchFamily="34" charset="0"/>
+                <a:ea typeface="Yu Gothic" pitchFamily="34" charset="-122"/>
+                <a:cs typeface="Yu Gothic" pitchFamily="34" charset="-120"/>
+              </a:rPr>
+              <a:t>2名</a:t>
+            </a:r>
+            <a:endParaRPr lang="en-US" sz="950" dirty="0"/>
+          </a:p>
+        </p:txBody>
+      </p:sp>
+      <p:sp>
+        <p:nvSpPr>
+          <p:cNvPr id="27" name="Shape 24"/>
+          <p:cNvSpPr/>
+          <p:nvPr/>
+        </p:nvSpPr>
+        <p:spPr>
+          <a:xfrm>
+            <a:off x="6309360" y="5440680"/>
+            <a:ext cx="5349240" cy="960120"/>
+          </a:xfrm>
+          <a:prstGeom prst="roundRect">
+            <a:avLst>
+              <a:gd name="adj" fmla="val 7619"/>
             </a:avLst>
           </a:prstGeom>
           <a:solidFill>
@@ -3454,14 +3980,14 @@
       </p:sp>
       <p:sp>
         <p:nvSpPr>
-          <p:cNvPr id="17" name="Text 14"/>
-          <p:cNvSpPr/>
-          <p:nvPr/>
-        </p:nvSpPr>
-        <p:spPr>
-          <a:xfrm>
-            <a:off x="6537960" y="5212080"/>
-            <a:ext cx="4892040" cy="914400"/>
+          <p:cNvPr id="28" name="Text 25"/>
+          <p:cNvSpPr/>
+          <p:nvPr/>
+        </p:nvSpPr>
+        <p:spPr>
+          <a:xfrm>
+            <a:off x="6537960" y="5559552"/>
+            <a:ext cx="4892040" cy="777240"/>
           </a:xfrm>
           <a:prstGeom prst="rect">
             <a:avLst/>
@@ -3477,7 +4003,7 @@
               <a:buNone/>
             </a:pPr>
             <a:r>
-              <a:rPr lang="en-US" sz="1150" b="1" dirty="0">
+              <a:rPr lang="en-US" sz="1100" b="1" dirty="0">
                 <a:solidFill>
                   <a:srgbClr val="B45309"/>
                 </a:solidFill>
@@ -3491,7 +4017,7 @@
               <a:buNone/>
             </a:pPr>
             <a:r>
-              <a:rPr lang="en-US" sz="1150" dirty="0">
+              <a:rPr lang="en-US" sz="1100" dirty="0">
                 <a:solidFill>
                   <a:srgbClr val="374151"/>
                 </a:solidFill>
@@ -3499,9 +4025,9 @@
                 <a:ea typeface="Yu Gothic" pitchFamily="34" charset="-122"/>
                 <a:cs typeface="Yu Gothic" pitchFamily="34" charset="-120"/>
               </a:rPr>
-              <a:t>訴求転換(4月)以降も毎月2名ペースでターゲット年代の応募が継続しており、「若手に届く求人」への転換が数字で確認できます。</a:t>
-            </a:r>
-            <a:endParaRPr lang="en-US" sz="1150" dirty="0"/>
+              <a:t>毎月2名ペースでターゲット年代の応募が継続しており、「若手に届く求人」への転換が数字で確認できます。</a:t>
+            </a:r>
+            <a:endParaRPr lang="en-US" sz="1100" dirty="0"/>
           </a:p>
         </p:txBody>
       </p:sp>

</xml_diff>

<commit_message>
Restructure closing section around three structural challenges
- New slide: challenge recognition (experienced-hire scarcity,
  information transparency gap for young candidates, lack of direct
  candidate touchpoints)
- Recommendations rewritten to map to each challenge with tags
- Move activity-history slide after recommendations

Co-Authored-By: Claude Fable 5 <noreply@anthropic.com>
Claude-Session: https://claude.ai/code/session_019t7NW6utTEgroUuPVV8xiA
</commit_message>
<xml_diff>
--- a/reports/matsushita-kogyo/松下工業様_採用強化支援_総括レポート.pptx
+++ b/reports/matsushita-kogyo/松下工業様_採用強化支援_総括レポート.pptx
@@ -19,9 +19,10 @@
     <p:sldId id="267" r:id="rId13"/>
     <p:sldId id="268" r:id="rId14"/>
     <p:sldId id="269" r:id="rId15"/>
+    <p:sldId id="270" r:id="rId16"/>
   </p:sldIdLst>
   <p:notesMasterIdLst>
-    <p:notesMasterId r:id="rId16"/>
+    <p:notesMasterId r:id="rId17"/>
   </p:notesMasterIdLst>
   <p:sldSz cx="12192000" cy="6858000"/>
   <p:notesSz cx="6858000" cy="12192000"/>
@@ -1666,6 +1667,94 @@
             <a:fld id="{F7021451-1387-4CA6-816F-3879F97B5CBC}" type="slidenum">
               <a:rPr lang="en-US"/>
               <a:t>14</a:t>
+            </a:fld>
+            <a:endParaRPr lang="en-US"/>
+          </a:p>
+        </p:txBody>
+      </p:sp>
+    </p:spTree>
+    <p:extLst>
+      <p:ext uri="{BB962C8B-B14F-4D97-AF65-F5344CB8AC3E}">
+        <p14:creationId xmlns:p14="http://schemas.microsoft.com/office/powerpoint/2010/main" val="1024086991"/>
+      </p:ext>
+    </p:extLst>
+  </p:cSld>
+  <p:clrMapOvr>
+    <a:masterClrMapping/>
+  </p:clrMapOvr>
+</p:notes>
+</file>
+
+<file path=ppt/notesSlides/notesSlide15.xml><?xml version="1.0" encoding="utf-8"?>
+<p:notes xmlns:a="http://schemas.openxmlformats.org/drawingml/2006/main" xmlns:r="http://schemas.openxmlformats.org/officeDocument/2006/relationships" xmlns:p="http://schemas.openxmlformats.org/presentationml/2006/main">
+  <p:cSld>
+    <p:spTree>
+      <p:nvGrpSpPr>
+        <p:cNvPr id="1" name=""/>
+        <p:cNvGrpSpPr/>
+        <p:nvPr/>
+      </p:nvGrpSpPr>
+      <p:grpSpPr>
+        <a:xfrm>
+          <a:off x="0" y="0"/>
+          <a:ext cx="0" cy="0"/>
+          <a:chOff x="0" y="0"/>
+          <a:chExt cx="0" cy="0"/>
+        </a:xfrm>
+      </p:grpSpPr>
+      <p:sp>
+        <p:nvSpPr>
+          <p:cNvPr id="2" name="Slide Image Placeholder 1"/>
+          <p:cNvSpPr>
+            <a:spLocks noGrp="1" noRot="1" noChangeAspect="1"/>
+          </p:cNvSpPr>
+          <p:nvPr>
+            <p:ph type="sldImg"/>
+          </p:nvPr>
+        </p:nvSpPr>
+        <p:spPr/>
+      </p:sp>
+      <p:sp>
+        <p:nvSpPr>
+          <p:cNvPr id="3" name="Notes Placeholder 2"/>
+          <p:cNvSpPr>
+            <a:spLocks noGrp="1"/>
+          </p:cNvSpPr>
+          <p:nvPr>
+            <p:ph type="body" idx="1"/>
+          </p:nvPr>
+        </p:nvSpPr>
+        <p:spPr/>
+        <p:txBody>
+          <a:bodyPr/>
+          <a:lstStyle/>
+          <a:p>
+            <a:r>
+              <a:rPr lang="en-US" dirty="0"/>
+              <a:t/>
+            </a:r>
+            <a:endParaRPr lang="en-US" dirty="0"/>
+          </a:p>
+        </p:txBody>
+      </p:sp>
+      <p:sp>
+        <p:nvSpPr>
+          <p:cNvPr id="4" name="Slide Number Placeholder 3"/>
+          <p:cNvSpPr>
+            <a:spLocks noGrp="1"/>
+          </p:cNvSpPr>
+          <p:nvPr>
+            <p:ph type="sldNum" sz="quarter" idx="10"/>
+          </p:nvPr>
+        </p:nvSpPr>
+        <p:spPr/>
+        <p:txBody>
+          <a:bodyPr/>
+          <a:lstStyle/>
+          <a:p>
+            <a:fld id="{F7021451-1387-4CA6-816F-3879F97B5CBC}" type="slidenum">
+              <a:rPr lang="en-US"/>
+              <a:t>15</a:t>
             </a:fld>
             <a:endParaRPr lang="en-US"/>
           </a:p>
@@ -5297,7 +5386,7 @@
                 <a:ea typeface="Yu Gothic" pitchFamily="34" charset="-122"/>
                 <a:cs typeface="Yu Gothic" pitchFamily="34" charset="-120"/>
               </a:rPr>
-              <a:t>活動履歴 ─ 定例ミーティング・説明会</a:t>
+              <a:t>課題認識 ─ 3つの構造的課題</a:t>
             </a:r>
             <a:endParaRPr lang="en-US" sz="3000" dirty="0"/>
           </a:p>
@@ -5336,7 +5425,7 @@
                 <a:ea typeface="Yu Gothic" pitchFamily="34" charset="-122"/>
                 <a:cs typeface="Yu Gothic" pitchFamily="34" charset="-120"/>
               </a:rPr>
-              <a:t>毎回議事録を共有し、決定事項を翌週までに実行するサイクルを継続</a:t>
+              <a:t>9ヶ月の検証から見えた、次のステージで乗り越えるべき壁</a:t>
             </a:r>
             <a:endParaRPr lang="en-US" sz="1300" dirty="0"/>
           </a:p>
@@ -5381,9 +5470,1888 @@
           </a:p>
         </p:txBody>
       </p:sp>
+      <p:sp>
+        <p:nvSpPr>
+          <p:cNvPr id="5" name="Shape 3"/>
+          <p:cNvSpPr/>
+          <p:nvPr/>
+        </p:nvSpPr>
+        <p:spPr>
+          <a:xfrm>
+            <a:off x="548640" y="1645920"/>
+            <a:ext cx="3566160" cy="4754880"/>
+          </a:xfrm>
+          <a:prstGeom prst="roundRect">
+            <a:avLst>
+              <a:gd name="adj" fmla="val 2564"/>
+            </a:avLst>
+          </a:prstGeom>
+          <a:solidFill>
+            <a:srgbClr val="F2F6FA"/>
+          </a:solidFill>
+          <a:ln/>
+        </p:spPr>
+      </p:sp>
+      <p:sp>
+        <p:nvSpPr>
+          <p:cNvPr id="6" name="Shape 4"/>
+          <p:cNvSpPr/>
+          <p:nvPr/>
+        </p:nvSpPr>
+        <p:spPr>
+          <a:xfrm>
+            <a:off x="804672" y="1874520"/>
+            <a:ext cx="384048" cy="384048"/>
+          </a:xfrm>
+          <a:prstGeom prst="ellipse">
+            <a:avLst/>
+          </a:prstGeom>
+          <a:solidFill>
+            <a:srgbClr val="1B3A5C"/>
+          </a:solidFill>
+          <a:ln/>
+        </p:spPr>
+      </p:sp>
+      <p:sp>
+        <p:nvSpPr>
+          <p:cNvPr id="7" name="Text 5"/>
+          <p:cNvSpPr/>
+          <p:nvPr/>
+        </p:nvSpPr>
+        <p:spPr>
+          <a:xfrm>
+            <a:off x="804672" y="1869948"/>
+            <a:ext cx="384048" cy="384048"/>
+          </a:xfrm>
+          <a:prstGeom prst="rect">
+            <a:avLst/>
+          </a:prstGeom>
+          <a:noFill/>
+          <a:ln/>
+        </p:spPr>
+        <p:txBody>
+          <a:bodyPr wrap="square" lIns="0" tIns="0" rIns="0" bIns="0" rtlCol="0" anchor="ctr"/>
+          <a:lstStyle/>
+          <a:p>
+            <a:pPr algn="ctr" indent="0" marL="0">
+              <a:buNone/>
+            </a:pPr>
+            <a:r>
+              <a:rPr lang="en-US" sz="1500" b="1" dirty="0">
+                <a:solidFill>
+                  <a:srgbClr val="FFFFFF"/>
+                </a:solidFill>
+                <a:latin typeface="Yu Gothic" pitchFamily="34" charset="0"/>
+                <a:ea typeface="Yu Gothic" pitchFamily="34" charset="-122"/>
+                <a:cs typeface="Yu Gothic" pitchFamily="34" charset="-120"/>
+              </a:rPr>
+              <a:t>1</a:t>
+            </a:r>
+            <a:endParaRPr lang="en-US" sz="1500" dirty="0"/>
+          </a:p>
+        </p:txBody>
+      </p:sp>
+      <p:sp>
+        <p:nvSpPr>
+          <p:cNvPr id="8" name="Text 6"/>
+          <p:cNvSpPr/>
+          <p:nvPr/>
+        </p:nvSpPr>
+        <p:spPr>
+          <a:xfrm>
+            <a:off x="1325880" y="1783080"/>
+            <a:ext cx="2651760" cy="685800"/>
+          </a:xfrm>
+          <a:prstGeom prst="rect">
+            <a:avLst/>
+          </a:prstGeom>
+          <a:noFill/>
+          <a:ln/>
+        </p:spPr>
+        <p:txBody>
+          <a:bodyPr wrap="square" lIns="0" tIns="0" rIns="0" bIns="0" rtlCol="0" anchor="t"/>
+          <a:lstStyle/>
+          <a:p>
+            <a:pPr indent="0" marL="0">
+              <a:buNone/>
+            </a:pPr>
+            <a:r>
+              <a:rPr lang="en-US" sz="1350" b="1" dirty="0">
+                <a:solidFill>
+                  <a:srgbClr val="1B3A5C"/>
+                </a:solidFill>
+                <a:latin typeface="Yu Gothic" pitchFamily="34" charset="0"/>
+                <a:ea typeface="Yu Gothic" pitchFamily="34" charset="-122"/>
+                <a:cs typeface="Yu Gothic" pitchFamily="34" charset="-120"/>
+              </a:rPr>
+              <a:t>経験者・関連業種の</a:t>
+            </a:r>
+            <a:endParaRPr lang="en-US" sz="1350" dirty="0"/>
+          </a:p>
+          <a:p>
+            <a:pPr indent="0" marL="0">
+              <a:buNone/>
+            </a:pPr>
+            <a:r>
+              <a:rPr lang="en-US" sz="1350" b="1" dirty="0">
+                <a:solidFill>
+                  <a:srgbClr val="1B3A5C"/>
+                </a:solidFill>
+                <a:latin typeface="Yu Gothic" pitchFamily="34" charset="0"/>
+                <a:ea typeface="Yu Gothic" pitchFamily="34" charset="-122"/>
+                <a:cs typeface="Yu Gothic" pitchFamily="34" charset="-120"/>
+              </a:rPr>
+              <a:t>人材不足</a:t>
+            </a:r>
+            <a:endParaRPr lang="en-US" sz="1350" dirty="0"/>
+          </a:p>
+        </p:txBody>
+      </p:sp>
+      <p:sp>
+        <p:nvSpPr>
+          <p:cNvPr id="9" name="Text 7"/>
+          <p:cNvSpPr/>
+          <p:nvPr/>
+        </p:nvSpPr>
+        <p:spPr>
+          <a:xfrm>
+            <a:off x="822960" y="2606040"/>
+            <a:ext cx="3017520" cy="1920240"/>
+          </a:xfrm>
+          <a:prstGeom prst="rect">
+            <a:avLst/>
+          </a:prstGeom>
+          <a:noFill/>
+          <a:ln/>
+        </p:spPr>
+        <p:txBody>
+          <a:bodyPr wrap="square" lIns="0" tIns="0" rIns="0" bIns="0" rtlCol="0" anchor="t"/>
+          <a:lstStyle/>
+          <a:p>
+            <a:pPr indent="0" marL="0">
+              <a:buNone/>
+            </a:pPr>
+            <a:r>
+              <a:rPr lang="en-US" sz="1050" dirty="0">
+                <a:solidFill>
+                  <a:srgbClr val="374151"/>
+                </a:solidFill>
+                <a:latin typeface="Yu Gothic" pitchFamily="34" charset="0"/>
+                <a:ea typeface="Yu Gothic" pitchFamily="34" charset="-122"/>
+                <a:cs typeface="Yu Gothic" pitchFamily="34" charset="-120"/>
+              </a:rPr>
+              <a:t>配管工の経験者がそもそも市場に少ない構造的制約。経験者向け求人は表示は伸びるものの応募に繋がらず、スカウトの対象母数も枯渇(22〜39歳・通勤30分圏で残0名)。</a:t>
+            </a:r>
+            <a:endParaRPr lang="en-US" sz="1050" dirty="0"/>
+          </a:p>
+        </p:txBody>
+      </p:sp>
+      <p:sp>
+        <p:nvSpPr>
+          <p:cNvPr id="10" name="Shape 8"/>
+          <p:cNvSpPr/>
+          <p:nvPr/>
+        </p:nvSpPr>
+        <p:spPr>
+          <a:xfrm>
+            <a:off x="822960" y="4617720"/>
+            <a:ext cx="3017520" cy="1554480"/>
+          </a:xfrm>
+          <a:prstGeom prst="roundRect">
+            <a:avLst>
+              <a:gd name="adj" fmla="val 3529"/>
+            </a:avLst>
+          </a:prstGeom>
+          <a:solidFill>
+            <a:srgbClr val="1B3A5C"/>
+          </a:solidFill>
+          <a:ln/>
+        </p:spPr>
+      </p:sp>
+      <p:sp>
+        <p:nvSpPr>
+          <p:cNvPr id="11" name="Text 9"/>
+          <p:cNvSpPr/>
+          <p:nvPr/>
+        </p:nvSpPr>
+        <p:spPr>
+          <a:xfrm>
+            <a:off x="1005840" y="4617720"/>
+            <a:ext cx="2651760" cy="1554480"/>
+          </a:xfrm>
+          <a:prstGeom prst="rect">
+            <a:avLst/>
+          </a:prstGeom>
+          <a:noFill/>
+          <a:ln/>
+        </p:spPr>
+        <p:txBody>
+          <a:bodyPr wrap="square" lIns="0" tIns="0" rIns="0" bIns="0" rtlCol="0" anchor="ctr"/>
+          <a:lstStyle/>
+          <a:p>
+            <a:pPr indent="0" marL="0">
+              <a:buNone/>
+            </a:pPr>
+            <a:r>
+              <a:rPr lang="en-US" sz="1000" dirty="0">
+                <a:solidFill>
+                  <a:srgbClr val="CADCFC"/>
+                </a:solidFill>
+                <a:latin typeface="Yu Gothic" pitchFamily="34" charset="0"/>
+                <a:ea typeface="Yu Gothic" pitchFamily="34" charset="-122"/>
+                <a:cs typeface="Yu Gothic" pitchFamily="34" charset="-120"/>
+              </a:rPr>
+              <a:t>周辺の電気工事業種では応募・採用実績が出ており、職種による市場規模の差が大きい。→ 未経験×20・30代への注力が合理的</a:t>
+            </a:r>
+            <a:endParaRPr lang="en-US" sz="1000" dirty="0"/>
+          </a:p>
+        </p:txBody>
+      </p:sp>
+      <p:sp>
+        <p:nvSpPr>
+          <p:cNvPr id="12" name="Shape 10"/>
+          <p:cNvSpPr/>
+          <p:nvPr/>
+        </p:nvSpPr>
+        <p:spPr>
+          <a:xfrm>
+            <a:off x="4379976" y="1645920"/>
+            <a:ext cx="3566160" cy="4754880"/>
+          </a:xfrm>
+          <a:prstGeom prst="roundRect">
+            <a:avLst>
+              <a:gd name="adj" fmla="val 2564"/>
+            </a:avLst>
+          </a:prstGeom>
+          <a:solidFill>
+            <a:srgbClr val="F2F6FA"/>
+          </a:solidFill>
+          <a:ln/>
+        </p:spPr>
+      </p:sp>
+      <p:sp>
+        <p:nvSpPr>
+          <p:cNvPr id="13" name="Shape 11"/>
+          <p:cNvSpPr/>
+          <p:nvPr/>
+        </p:nvSpPr>
+        <p:spPr>
+          <a:xfrm>
+            <a:off x="4636008" y="1874520"/>
+            <a:ext cx="384048" cy="384048"/>
+          </a:xfrm>
+          <a:prstGeom prst="ellipse">
+            <a:avLst/>
+          </a:prstGeom>
+          <a:solidFill>
+            <a:srgbClr val="1B3A5C"/>
+          </a:solidFill>
+          <a:ln/>
+        </p:spPr>
+      </p:sp>
+      <p:sp>
+        <p:nvSpPr>
+          <p:cNvPr id="14" name="Text 12"/>
+          <p:cNvSpPr/>
+          <p:nvPr/>
+        </p:nvSpPr>
+        <p:spPr>
+          <a:xfrm>
+            <a:off x="4636008" y="1869948"/>
+            <a:ext cx="384048" cy="384048"/>
+          </a:xfrm>
+          <a:prstGeom prst="rect">
+            <a:avLst/>
+          </a:prstGeom>
+          <a:noFill/>
+          <a:ln/>
+        </p:spPr>
+        <p:txBody>
+          <a:bodyPr wrap="square" lIns="0" tIns="0" rIns="0" bIns="0" rtlCol="0" anchor="ctr"/>
+          <a:lstStyle/>
+          <a:p>
+            <a:pPr algn="ctr" indent="0" marL="0">
+              <a:buNone/>
+            </a:pPr>
+            <a:r>
+              <a:rPr lang="en-US" sz="1500" b="1" dirty="0">
+                <a:solidFill>
+                  <a:srgbClr val="FFFFFF"/>
+                </a:solidFill>
+                <a:latin typeface="Yu Gothic" pitchFamily="34" charset="0"/>
+                <a:ea typeface="Yu Gothic" pitchFamily="34" charset="-122"/>
+                <a:cs typeface="Yu Gothic" pitchFamily="34" charset="-120"/>
+              </a:rPr>
+              <a:t>2</a:t>
+            </a:r>
+            <a:endParaRPr lang="en-US" sz="1500" dirty="0"/>
+          </a:p>
+        </p:txBody>
+      </p:sp>
+      <p:sp>
+        <p:nvSpPr>
+          <p:cNvPr id="15" name="Text 13"/>
+          <p:cNvSpPr/>
+          <p:nvPr/>
+        </p:nvSpPr>
+        <p:spPr>
+          <a:xfrm>
+            <a:off x="5157216" y="1783080"/>
+            <a:ext cx="2651760" cy="685800"/>
+          </a:xfrm>
+          <a:prstGeom prst="rect">
+            <a:avLst/>
+          </a:prstGeom>
+          <a:noFill/>
+          <a:ln/>
+        </p:spPr>
+        <p:txBody>
+          <a:bodyPr wrap="square" lIns="0" tIns="0" rIns="0" bIns="0" rtlCol="0" anchor="t"/>
+          <a:lstStyle/>
+          <a:p>
+            <a:pPr indent="0" marL="0">
+              <a:buNone/>
+            </a:pPr>
+            <a:r>
+              <a:rPr lang="en-US" sz="1350" b="1" dirty="0">
+                <a:solidFill>
+                  <a:srgbClr val="1B3A5C"/>
+                </a:solidFill>
+                <a:latin typeface="Yu Gothic" pitchFamily="34" charset="0"/>
+                <a:ea typeface="Yu Gothic" pitchFamily="34" charset="-122"/>
+                <a:cs typeface="Yu Gothic" pitchFamily="34" charset="-120"/>
+              </a:rPr>
+              <a:t>未経験・20/30代に対する</a:t>
+            </a:r>
+            <a:endParaRPr lang="en-US" sz="1350" dirty="0"/>
+          </a:p>
+          <a:p>
+            <a:pPr indent="0" marL="0">
+              <a:buNone/>
+            </a:pPr>
+            <a:r>
+              <a:rPr lang="en-US" sz="1350" b="1" dirty="0">
+                <a:solidFill>
+                  <a:srgbClr val="1B3A5C"/>
+                </a:solidFill>
+                <a:latin typeface="Yu Gothic" pitchFamily="34" charset="0"/>
+                <a:ea typeface="Yu Gothic" pitchFamily="34" charset="-122"/>
+                <a:cs typeface="Yu Gothic" pitchFamily="34" charset="-120"/>
+              </a:rPr>
+              <a:t>情報の透明性不足</a:t>
+            </a:r>
+            <a:endParaRPr lang="en-US" sz="1350" dirty="0"/>
+          </a:p>
+        </p:txBody>
+      </p:sp>
+      <p:sp>
+        <p:nvSpPr>
+          <p:cNvPr id="16" name="Text 14"/>
+          <p:cNvSpPr/>
+          <p:nvPr/>
+        </p:nvSpPr>
+        <p:spPr>
+          <a:xfrm>
+            <a:off x="4654296" y="2606040"/>
+            <a:ext cx="3017520" cy="1920240"/>
+          </a:xfrm>
+          <a:prstGeom prst="rect">
+            <a:avLst/>
+          </a:prstGeom>
+          <a:noFill/>
+          <a:ln/>
+        </p:spPr>
+        <p:txBody>
+          <a:bodyPr wrap="square" lIns="0" tIns="0" rIns="0" bIns="0" rtlCol="0" anchor="t"/>
+          <a:lstStyle/>
+          <a:p>
+            <a:pPr indent="0" marL="0">
+              <a:buNone/>
+            </a:pPr>
+            <a:r>
+              <a:rPr lang="en-US" sz="1050" dirty="0">
+                <a:solidFill>
+                  <a:srgbClr val="374151"/>
+                </a:solidFill>
+                <a:latin typeface="Yu Gothic" pitchFamily="34" charset="0"/>
+                <a:ea typeface="Yu Gothic" pitchFamily="34" charset="-122"/>
+                <a:cs typeface="Yu Gothic" pitchFamily="34" charset="-120"/>
+              </a:rPr>
+              <a:t>求人を入口に興味を持った求職者が、裏付けを取りに複数媒体を見に行っても松下工業の情報がない(口コミなし・採用サイトなし)。Xは尖った発信のため、未経験者が求める情報が不在。</a:t>
+            </a:r>
+            <a:endParaRPr lang="en-US" sz="1050" dirty="0"/>
+          </a:p>
+        </p:txBody>
+      </p:sp>
+      <p:sp>
+        <p:nvSpPr>
+          <p:cNvPr id="17" name="Shape 15"/>
+          <p:cNvSpPr/>
+          <p:nvPr/>
+        </p:nvSpPr>
+        <p:spPr>
+          <a:xfrm>
+            <a:off x="4654296" y="4617720"/>
+            <a:ext cx="3017520" cy="1554480"/>
+          </a:xfrm>
+          <a:prstGeom prst="roundRect">
+            <a:avLst>
+              <a:gd name="adj" fmla="val 3529"/>
+            </a:avLst>
+          </a:prstGeom>
+          <a:solidFill>
+            <a:srgbClr val="1B3A5C"/>
+          </a:solidFill>
+          <a:ln/>
+        </p:spPr>
+      </p:sp>
+      <p:sp>
+        <p:nvSpPr>
+          <p:cNvPr id="18" name="Text 16"/>
+          <p:cNvSpPr/>
+          <p:nvPr/>
+        </p:nvSpPr>
+        <p:spPr>
+          <a:xfrm>
+            <a:off x="4837176" y="4617720"/>
+            <a:ext cx="2651760" cy="1554480"/>
+          </a:xfrm>
+          <a:prstGeom prst="rect">
+            <a:avLst/>
+          </a:prstGeom>
+          <a:noFill/>
+          <a:ln/>
+        </p:spPr>
+        <p:txBody>
+          <a:bodyPr wrap="square" lIns="0" tIns="0" rIns="0" bIns="0" rtlCol="0" anchor="ctr"/>
+          <a:lstStyle/>
+          <a:p>
+            <a:pPr indent="0" marL="0">
+              <a:buNone/>
+            </a:pPr>
+            <a:r>
+              <a:rPr lang="en-US" sz="1000" dirty="0">
+                <a:solidFill>
+                  <a:srgbClr val="CADCFC"/>
+                </a:solidFill>
+                <a:latin typeface="Yu Gothic" pitchFamily="34" charset="0"/>
+                <a:ea typeface="Yu Gothic" pitchFamily="34" charset="-122"/>
+                <a:cs typeface="Yu Gothic" pitchFamily="34" charset="-120"/>
+              </a:rPr>
+              <a:t>「働き方」「業務内容」「どんな人が働いているか」の情報がなく、応募の一歩手前で離脱。→ 採用HPリニューアル+Instagram発信の拡充</a:t>
+            </a:r>
+            <a:endParaRPr lang="en-US" sz="1000" dirty="0"/>
+          </a:p>
+        </p:txBody>
+      </p:sp>
+      <p:sp>
+        <p:nvSpPr>
+          <p:cNvPr id="19" name="Shape 17"/>
+          <p:cNvSpPr/>
+          <p:nvPr/>
+        </p:nvSpPr>
+        <p:spPr>
+          <a:xfrm>
+            <a:off x="8211312" y="1645920"/>
+            <a:ext cx="3566160" cy="4754880"/>
+          </a:xfrm>
+          <a:prstGeom prst="roundRect">
+            <a:avLst>
+              <a:gd name="adj" fmla="val 2564"/>
+            </a:avLst>
+          </a:prstGeom>
+          <a:solidFill>
+            <a:srgbClr val="F2F6FA"/>
+          </a:solidFill>
+          <a:ln/>
+        </p:spPr>
+      </p:sp>
+      <p:sp>
+        <p:nvSpPr>
+          <p:cNvPr id="20" name="Shape 18"/>
+          <p:cNvSpPr/>
+          <p:nvPr/>
+        </p:nvSpPr>
+        <p:spPr>
+          <a:xfrm>
+            <a:off x="8467344" y="1874520"/>
+            <a:ext cx="384048" cy="384048"/>
+          </a:xfrm>
+          <a:prstGeom prst="ellipse">
+            <a:avLst/>
+          </a:prstGeom>
+          <a:solidFill>
+            <a:srgbClr val="1B3A5C"/>
+          </a:solidFill>
+          <a:ln/>
+        </p:spPr>
+      </p:sp>
+      <p:sp>
+        <p:nvSpPr>
+          <p:cNvPr id="21" name="Text 19"/>
+          <p:cNvSpPr/>
+          <p:nvPr/>
+        </p:nvSpPr>
+        <p:spPr>
+          <a:xfrm>
+            <a:off x="8467344" y="1869948"/>
+            <a:ext cx="384048" cy="384048"/>
+          </a:xfrm>
+          <a:prstGeom prst="rect">
+            <a:avLst/>
+          </a:prstGeom>
+          <a:noFill/>
+          <a:ln/>
+        </p:spPr>
+        <p:txBody>
+          <a:bodyPr wrap="square" lIns="0" tIns="0" rIns="0" bIns="0" rtlCol="0" anchor="ctr"/>
+          <a:lstStyle/>
+          <a:p>
+            <a:pPr algn="ctr" indent="0" marL="0">
+              <a:buNone/>
+            </a:pPr>
+            <a:r>
+              <a:rPr lang="en-US" sz="1500" b="1" dirty="0">
+                <a:solidFill>
+                  <a:srgbClr val="FFFFFF"/>
+                </a:solidFill>
+                <a:latin typeface="Yu Gothic" pitchFamily="34" charset="0"/>
+                <a:ea typeface="Yu Gothic" pitchFamily="34" charset="-122"/>
+                <a:cs typeface="Yu Gothic" pitchFamily="34" charset="-120"/>
+              </a:rPr>
+              <a:t>3</a:t>
+            </a:r>
+            <a:endParaRPr lang="en-US" sz="1500" dirty="0"/>
+          </a:p>
+        </p:txBody>
+      </p:sp>
+      <p:sp>
+        <p:nvSpPr>
+          <p:cNvPr id="22" name="Text 20"/>
+          <p:cNvSpPr/>
+          <p:nvPr/>
+        </p:nvSpPr>
+        <p:spPr>
+          <a:xfrm>
+            <a:off x="8988552" y="1783080"/>
+            <a:ext cx="2651760" cy="685800"/>
+          </a:xfrm>
+          <a:prstGeom prst="rect">
+            <a:avLst/>
+          </a:prstGeom>
+          <a:noFill/>
+          <a:ln/>
+        </p:spPr>
+        <p:txBody>
+          <a:bodyPr wrap="square" lIns="0" tIns="0" rIns="0" bIns="0" rtlCol="0" anchor="t"/>
+          <a:lstStyle/>
+          <a:p>
+            <a:pPr indent="0" marL="0">
+              <a:buNone/>
+            </a:pPr>
+            <a:r>
+              <a:rPr lang="en-US" sz="1350" b="1" dirty="0">
+                <a:solidFill>
+                  <a:srgbClr val="1B3A5C"/>
+                </a:solidFill>
+                <a:latin typeface="Yu Gothic" pitchFamily="34" charset="0"/>
+                <a:ea typeface="Yu Gothic" pitchFamily="34" charset="-122"/>
+                <a:cs typeface="Yu Gothic" pitchFamily="34" charset="-120"/>
+              </a:rPr>
+              <a:t>求職者との</a:t>
+            </a:r>
+            <a:endParaRPr lang="en-US" sz="1350" dirty="0"/>
+          </a:p>
+          <a:p>
+            <a:pPr indent="0" marL="0">
+              <a:buNone/>
+            </a:pPr>
+            <a:r>
+              <a:rPr lang="en-US" sz="1350" b="1" dirty="0">
+                <a:solidFill>
+                  <a:srgbClr val="1B3A5C"/>
+                </a:solidFill>
+                <a:latin typeface="Yu Gothic" pitchFamily="34" charset="0"/>
+                <a:ea typeface="Yu Gothic" pitchFamily="34" charset="-122"/>
+                <a:cs typeface="Yu Gothic" pitchFamily="34" charset="-120"/>
+              </a:rPr>
+              <a:t>直接接点の不足</a:t>
+            </a:r>
+            <a:endParaRPr lang="en-US" sz="1350" dirty="0"/>
+          </a:p>
+        </p:txBody>
+      </p:sp>
+      <p:sp>
+        <p:nvSpPr>
+          <p:cNvPr id="23" name="Text 21"/>
+          <p:cNvSpPr/>
+          <p:nvPr/>
+        </p:nvSpPr>
+        <p:spPr>
+          <a:xfrm>
+            <a:off x="8485632" y="2606040"/>
+            <a:ext cx="3017520" cy="1920240"/>
+          </a:xfrm>
+          <a:prstGeom prst="rect">
+            <a:avLst/>
+          </a:prstGeom>
+          <a:noFill/>
+          <a:ln/>
+        </p:spPr>
+        <p:txBody>
+          <a:bodyPr wrap="square" lIns="0" tIns="0" rIns="0" bIns="0" rtlCol="0" anchor="t"/>
+          <a:lstStyle/>
+          <a:p>
+            <a:pPr indent="0" marL="0">
+              <a:buNone/>
+            </a:pPr>
+            <a:r>
+              <a:rPr lang="en-US" sz="1050" dirty="0">
+                <a:solidFill>
+                  <a:srgbClr val="374151"/>
+                </a:solidFill>
+                <a:latin typeface="Yu Gothic" pitchFamily="34" charset="0"/>
+                <a:ea typeface="Yu Gothic" pitchFamily="34" charset="-122"/>
+                <a:cs typeface="Yu Gothic" pitchFamily="34" charset="-120"/>
+              </a:rPr>
+              <a:t>情報の不透明性を補うには、求職者と直接交流して不安を解消することが不可欠。自社集客の説明会は集客に苦戦(申込0〜1名)しており、自前の集客力だけでは接点をつくれない。</a:t>
+            </a:r>
+            <a:endParaRPr lang="en-US" sz="1050" dirty="0"/>
+          </a:p>
+        </p:txBody>
+      </p:sp>
+      <p:sp>
+        <p:nvSpPr>
+          <p:cNvPr id="24" name="Shape 22"/>
+          <p:cNvSpPr/>
+          <p:nvPr/>
+        </p:nvSpPr>
+        <p:spPr>
+          <a:xfrm>
+            <a:off x="8485632" y="4617720"/>
+            <a:ext cx="3017520" cy="1554480"/>
+          </a:xfrm>
+          <a:prstGeom prst="roundRect">
+            <a:avLst>
+              <a:gd name="adj" fmla="val 3529"/>
+            </a:avLst>
+          </a:prstGeom>
+          <a:solidFill>
+            <a:srgbClr val="1B3A5C"/>
+          </a:solidFill>
+          <a:ln/>
+        </p:spPr>
+      </p:sp>
+      <p:sp>
+        <p:nvSpPr>
+          <p:cNvPr id="25" name="Text 23"/>
+          <p:cNvSpPr/>
+          <p:nvPr/>
+        </p:nvSpPr>
+        <p:spPr>
+          <a:xfrm>
+            <a:off x="8668512" y="4617720"/>
+            <a:ext cx="2651760" cy="1554480"/>
+          </a:xfrm>
+          <a:prstGeom prst="rect">
+            <a:avLst/>
+          </a:prstGeom>
+          <a:noFill/>
+          <a:ln/>
+        </p:spPr>
+        <p:txBody>
+          <a:bodyPr wrap="square" lIns="0" tIns="0" rIns="0" bIns="0" rtlCol="0" anchor="ctr"/>
+          <a:lstStyle/>
+          <a:p>
+            <a:pPr indent="0" marL="0">
+              <a:buNone/>
+            </a:pPr>
+            <a:r>
+              <a:rPr lang="en-US" sz="1000" dirty="0">
+                <a:solidFill>
+                  <a:srgbClr val="CADCFC"/>
+                </a:solidFill>
+                <a:latin typeface="Yu Gothic" pitchFamily="34" charset="0"/>
+                <a:ea typeface="Yu Gothic" pitchFamily="34" charset="-122"/>
+                <a:cs typeface="Yu Gothic" pitchFamily="34" charset="-120"/>
+              </a:rPr>
+              <a:t>他社が集客するイベントの活用が必要。→ ハローワーク説明会・マイナビ等の合同説明会への参加</a:t>
+            </a:r>
+            <a:endParaRPr lang="en-US" sz="1000" dirty="0"/>
+          </a:p>
+        </p:txBody>
+      </p:sp>
+    </p:spTree>
+  </p:cSld>
+  <p:clrMapOvr>
+    <a:masterClrMapping/>
+  </p:clrMapOvr>
+</p:sld>
+</file>
+
+<file path=ppt/slides/slide13.xml><?xml version="1.0" encoding="utf-8"?>
+<p:sld xmlns:a="http://schemas.openxmlformats.org/drawingml/2006/main" xmlns:r="http://schemas.openxmlformats.org/officeDocument/2006/relationships" xmlns:p="http://schemas.openxmlformats.org/presentationml/2006/main">
+  <p:cSld name="Slide 13">
+    <p:bg>
+      <p:bgPr>
+        <a:solidFill>
+          <a:srgbClr val="FFFFFF"/>
+        </a:solidFill>
+      </p:bgPr>
+    </p:bg>
+    <p:spTree>
+      <p:nvGrpSpPr>
+        <p:cNvPr id="1" name=""/>
+        <p:cNvGrpSpPr/>
+        <p:nvPr/>
+      </p:nvGrpSpPr>
+      <p:grpSpPr>
+        <a:xfrm>
+          <a:off x="0" y="0"/>
+          <a:ext cx="0" cy="0"/>
+          <a:chOff x="0" y="0"/>
+          <a:chExt cx="0" cy="0"/>
+        </a:xfrm>
+      </p:grpSpPr>
+      <p:sp>
+        <p:nvSpPr>
+          <p:cNvPr id="2" name="Text 0"/>
+          <p:cNvSpPr/>
+          <p:nvPr/>
+        </p:nvSpPr>
+        <p:spPr>
+          <a:xfrm>
+            <a:off x="548640" y="292608"/>
+            <a:ext cx="9601200" cy="685800"/>
+          </a:xfrm>
+          <a:prstGeom prst="rect">
+            <a:avLst/>
+          </a:prstGeom>
+          <a:noFill/>
+          <a:ln/>
+        </p:spPr>
+        <p:txBody>
+          <a:bodyPr wrap="square" lIns="0" tIns="0" rIns="0" bIns="0" rtlCol="0" anchor="ctr"/>
+          <a:lstStyle/>
+          <a:p>
+            <a:pPr indent="0" marL="0">
+              <a:buNone/>
+            </a:pPr>
+            <a:r>
+              <a:rPr lang="en-US" sz="3000" b="1" dirty="0">
+                <a:solidFill>
+                  <a:srgbClr val="1B3A5C"/>
+                </a:solidFill>
+                <a:latin typeface="Yu Gothic" pitchFamily="34" charset="0"/>
+                <a:ea typeface="Yu Gothic" pitchFamily="34" charset="-122"/>
+                <a:cs typeface="Yu Gothic" pitchFamily="34" charset="-120"/>
+              </a:rPr>
+              <a:t>今後のご提言 ─ 3つの課題に対応する打ち手</a:t>
+            </a:r>
+            <a:endParaRPr lang="en-US" sz="3000" dirty="0"/>
+          </a:p>
+        </p:txBody>
+      </p:sp>
+      <p:sp>
+        <p:nvSpPr>
+          <p:cNvPr id="3" name="Text 1"/>
+          <p:cNvSpPr/>
+          <p:nvPr/>
+        </p:nvSpPr>
+        <p:spPr>
+          <a:xfrm>
+            <a:off x="566928" y="932688"/>
+            <a:ext cx="10515600" cy="365760"/>
+          </a:xfrm>
+          <a:prstGeom prst="rect">
+            <a:avLst/>
+          </a:prstGeom>
+          <a:noFill/>
+          <a:ln/>
+        </p:spPr>
+        <p:txBody>
+          <a:bodyPr wrap="square" lIns="0" tIns="0" rIns="0" bIns="0" rtlCol="0" anchor="ctr"/>
+          <a:lstStyle/>
+          <a:p>
+            <a:pPr indent="0" marL="0">
+              <a:buNone/>
+            </a:pPr>
+            <a:r>
+              <a:rPr lang="en-US" sz="1300" dirty="0">
+                <a:solidFill>
+                  <a:srgbClr val="6B7280"/>
+                </a:solidFill>
+                <a:latin typeface="Yu Gothic" pitchFamily="34" charset="0"/>
+                <a:ea typeface="Yu Gothic" pitchFamily="34" charset="-122"/>
+                <a:cs typeface="Yu Gothic" pitchFamily="34" charset="-120"/>
+              </a:rPr>
+              <a:t>8月以降の転職市場再活性化(ピーク:9〜10月)を最大限に活かすために</a:t>
+            </a:r>
+            <a:endParaRPr lang="en-US" sz="1300" dirty="0"/>
+          </a:p>
+        </p:txBody>
+      </p:sp>
+      <p:sp>
+        <p:nvSpPr>
+          <p:cNvPr id="4" name="Text 2"/>
+          <p:cNvSpPr/>
+          <p:nvPr/>
+        </p:nvSpPr>
+        <p:spPr>
+          <a:xfrm>
+            <a:off x="11292840" y="320040"/>
+            <a:ext cx="640080" cy="457200"/>
+          </a:xfrm>
+          <a:prstGeom prst="rect">
+            <a:avLst/>
+          </a:prstGeom>
+          <a:noFill/>
+          <a:ln/>
+        </p:spPr>
+        <p:txBody>
+          <a:bodyPr wrap="square" lIns="0" tIns="0" rIns="0" bIns="0" rtlCol="0" anchor="ctr"/>
+          <a:lstStyle/>
+          <a:p>
+            <a:pPr algn="r" indent="0" marL="0">
+              <a:buNone/>
+            </a:pPr>
+            <a:r>
+              <a:rPr lang="en-US" sz="1600" b="1" dirty="0">
+                <a:solidFill>
+                  <a:srgbClr val="5A7A99"/>
+                </a:solidFill>
+                <a:latin typeface="Arial" pitchFamily="34" charset="0"/>
+                <a:ea typeface="Arial" pitchFamily="34" charset="-122"/>
+                <a:cs typeface="Arial" pitchFamily="34" charset="-120"/>
+              </a:rPr>
+              <a:t>13</a:t>
+            </a:r>
+            <a:endParaRPr lang="en-US" sz="1600" dirty="0"/>
+          </a:p>
+        </p:txBody>
+      </p:sp>
+      <p:sp>
+        <p:nvSpPr>
+          <p:cNvPr id="5" name="Shape 3"/>
+          <p:cNvSpPr/>
+          <p:nvPr/>
+        </p:nvSpPr>
+        <p:spPr>
+          <a:xfrm>
+            <a:off x="594360" y="1609344"/>
+            <a:ext cx="384048" cy="384048"/>
+          </a:xfrm>
+          <a:prstGeom prst="ellipse">
+            <a:avLst/>
+          </a:prstGeom>
+          <a:solidFill>
+            <a:srgbClr val="E8762C"/>
+          </a:solidFill>
+          <a:ln/>
+        </p:spPr>
+      </p:sp>
+      <p:sp>
+        <p:nvSpPr>
+          <p:cNvPr id="6" name="Text 4"/>
+          <p:cNvSpPr/>
+          <p:nvPr/>
+        </p:nvSpPr>
+        <p:spPr>
+          <a:xfrm>
+            <a:off x="594360" y="1604772"/>
+            <a:ext cx="384048" cy="384048"/>
+          </a:xfrm>
+          <a:prstGeom prst="rect">
+            <a:avLst/>
+          </a:prstGeom>
+          <a:noFill/>
+          <a:ln/>
+        </p:spPr>
+        <p:txBody>
+          <a:bodyPr wrap="square" lIns="0" tIns="0" rIns="0" bIns="0" rtlCol="0" anchor="ctr"/>
+          <a:lstStyle/>
+          <a:p>
+            <a:pPr algn="ctr" indent="0" marL="0">
+              <a:buNone/>
+            </a:pPr>
+            <a:r>
+              <a:rPr lang="en-US" sz="1500" b="1" dirty="0">
+                <a:solidFill>
+                  <a:srgbClr val="FFFFFF"/>
+                </a:solidFill>
+                <a:latin typeface="Yu Gothic" pitchFamily="34" charset="0"/>
+                <a:ea typeface="Yu Gothic" pitchFamily="34" charset="-122"/>
+                <a:cs typeface="Yu Gothic" pitchFamily="34" charset="-120"/>
+              </a:rPr>
+              <a:t>1</a:t>
+            </a:r>
+            <a:endParaRPr lang="en-US" sz="1500" dirty="0"/>
+          </a:p>
+        </p:txBody>
+      </p:sp>
+      <p:sp>
+        <p:nvSpPr>
+          <p:cNvPr id="7" name="Shape 5"/>
+          <p:cNvSpPr/>
+          <p:nvPr/>
+        </p:nvSpPr>
+        <p:spPr>
+          <a:xfrm>
+            <a:off x="10561320" y="1591056"/>
+            <a:ext cx="1051560" cy="384048"/>
+          </a:xfrm>
+          <a:prstGeom prst="roundRect">
+            <a:avLst>
+              <a:gd name="adj" fmla="val 14286"/>
+            </a:avLst>
+          </a:prstGeom>
+          <a:solidFill>
+            <a:srgbClr val="FDF0E6"/>
+          </a:solidFill>
+          <a:ln/>
+        </p:spPr>
+      </p:sp>
+      <p:sp>
+        <p:nvSpPr>
+          <p:cNvPr id="8" name="Text 6"/>
+          <p:cNvSpPr/>
+          <p:nvPr/>
+        </p:nvSpPr>
+        <p:spPr>
+          <a:xfrm>
+            <a:off x="10561320" y="1591056"/>
+            <a:ext cx="1051560" cy="384048"/>
+          </a:xfrm>
+          <a:prstGeom prst="rect">
+            <a:avLst/>
+          </a:prstGeom>
+          <a:noFill/>
+          <a:ln/>
+        </p:spPr>
+        <p:txBody>
+          <a:bodyPr wrap="square" lIns="0" tIns="0" rIns="0" bIns="0" rtlCol="0" anchor="ctr"/>
+          <a:lstStyle/>
+          <a:p>
+            <a:pPr algn="ctr" indent="0" marL="0">
+              <a:buNone/>
+            </a:pPr>
+            <a:r>
+              <a:rPr lang="en-US" sz="950" b="1" dirty="0">
+                <a:solidFill>
+                  <a:srgbClr val="B45309"/>
+                </a:solidFill>
+                <a:latin typeface="Yu Gothic" pitchFamily="34" charset="0"/>
+                <a:ea typeface="Yu Gothic" pitchFamily="34" charset="-122"/>
+                <a:cs typeface="Yu Gothic" pitchFamily="34" charset="-120"/>
+              </a:rPr>
+              <a:t>課題②対応</a:t>
+            </a:r>
+            <a:endParaRPr lang="en-US" sz="950" dirty="0"/>
+          </a:p>
+        </p:txBody>
+      </p:sp>
+      <p:sp>
+        <p:nvSpPr>
+          <p:cNvPr id="9" name="Text 7"/>
+          <p:cNvSpPr/>
+          <p:nvPr/>
+        </p:nvSpPr>
+        <p:spPr>
+          <a:xfrm>
+            <a:off x="1188720" y="1536192"/>
+            <a:ext cx="9235440" cy="914400"/>
+          </a:xfrm>
+          <a:prstGeom prst="rect">
+            <a:avLst/>
+          </a:prstGeom>
+          <a:noFill/>
+          <a:ln/>
+        </p:spPr>
+        <p:txBody>
+          <a:bodyPr wrap="square" lIns="0" tIns="0" rIns="0" bIns="0" rtlCol="0" anchor="t"/>
+          <a:lstStyle/>
+          <a:p>
+            <a:pPr indent="0" marL="0">
+              <a:buNone/>
+            </a:pPr>
+            <a:r>
+              <a:rPr lang="en-US" sz="1300" b="1" dirty="0">
+                <a:solidFill>
+                  <a:srgbClr val="1B3A5C"/>
+                </a:solidFill>
+                <a:latin typeface="Yu Gothic" pitchFamily="34" charset="0"/>
+                <a:ea typeface="Yu Gothic" pitchFamily="34" charset="-122"/>
+                <a:cs typeface="Yu Gothic" pitchFamily="34" charset="-120"/>
+              </a:rPr>
+              <a:t>採用HPリニューアル+Instagramで「情報の透明性」を確保
+</a:t>
+            </a:r>
+            <a:pPr indent="0" marL="0">
+              <a:buNone/>
+            </a:pPr>
+            <a:r>
+              <a:rPr lang="en-US" sz="1100" dirty="0">
+                <a:solidFill>
+                  <a:srgbClr val="374151"/>
+                </a:solidFill>
+                <a:latin typeface="Yu Gothic" pitchFamily="34" charset="0"/>
+                <a:ea typeface="Yu Gothic" pitchFamily="34" charset="-122"/>
+                <a:cs typeface="Yu Gothic" pitchFamily="34" charset="-120"/>
+              </a:rPr>
+              <a:t>「働き方・業務内容・どんな人が働いているか」を軸に発信を強化。リニューアルHP(お盆前完了予定)とInstagramを紐付け、求人から裏付けを取りに来た求職者が必ず情報に辿り着ける状態をつくる</a:t>
+            </a:r>
+            <a:endParaRPr lang="en-US" sz="1300" dirty="0"/>
+          </a:p>
+        </p:txBody>
+      </p:sp>
+      <p:sp>
+        <p:nvSpPr>
+          <p:cNvPr id="10" name="Shape 8"/>
+          <p:cNvSpPr/>
+          <p:nvPr/>
+        </p:nvSpPr>
+        <p:spPr>
+          <a:xfrm>
+            <a:off x="594360" y="2542032"/>
+            <a:ext cx="384048" cy="384048"/>
+          </a:xfrm>
+          <a:prstGeom prst="ellipse">
+            <a:avLst/>
+          </a:prstGeom>
+          <a:solidFill>
+            <a:srgbClr val="E8762C"/>
+          </a:solidFill>
+          <a:ln/>
+        </p:spPr>
+      </p:sp>
+      <p:sp>
+        <p:nvSpPr>
+          <p:cNvPr id="11" name="Text 9"/>
+          <p:cNvSpPr/>
+          <p:nvPr/>
+        </p:nvSpPr>
+        <p:spPr>
+          <a:xfrm>
+            <a:off x="594360" y="2537460"/>
+            <a:ext cx="384048" cy="384048"/>
+          </a:xfrm>
+          <a:prstGeom prst="rect">
+            <a:avLst/>
+          </a:prstGeom>
+          <a:noFill/>
+          <a:ln/>
+        </p:spPr>
+        <p:txBody>
+          <a:bodyPr wrap="square" lIns="0" tIns="0" rIns="0" bIns="0" rtlCol="0" anchor="ctr"/>
+          <a:lstStyle/>
+          <a:p>
+            <a:pPr algn="ctr" indent="0" marL="0">
+              <a:buNone/>
+            </a:pPr>
+            <a:r>
+              <a:rPr lang="en-US" sz="1500" b="1" dirty="0">
+                <a:solidFill>
+                  <a:srgbClr val="FFFFFF"/>
+                </a:solidFill>
+                <a:latin typeface="Yu Gothic" pitchFamily="34" charset="0"/>
+                <a:ea typeface="Yu Gothic" pitchFamily="34" charset="-122"/>
+                <a:cs typeface="Yu Gothic" pitchFamily="34" charset="-120"/>
+              </a:rPr>
+              <a:t>2</a:t>
+            </a:r>
+            <a:endParaRPr lang="en-US" sz="1500" dirty="0"/>
+          </a:p>
+        </p:txBody>
+      </p:sp>
+      <p:sp>
+        <p:nvSpPr>
+          <p:cNvPr id="12" name="Shape 10"/>
+          <p:cNvSpPr/>
+          <p:nvPr/>
+        </p:nvSpPr>
+        <p:spPr>
+          <a:xfrm>
+            <a:off x="10561320" y="2523744"/>
+            <a:ext cx="1051560" cy="384048"/>
+          </a:xfrm>
+          <a:prstGeom prst="roundRect">
+            <a:avLst>
+              <a:gd name="adj" fmla="val 14286"/>
+            </a:avLst>
+          </a:prstGeom>
+          <a:solidFill>
+            <a:srgbClr val="FDF0E6"/>
+          </a:solidFill>
+          <a:ln/>
+        </p:spPr>
+      </p:sp>
+      <p:sp>
+        <p:nvSpPr>
+          <p:cNvPr id="13" name="Text 11"/>
+          <p:cNvSpPr/>
+          <p:nvPr/>
+        </p:nvSpPr>
+        <p:spPr>
+          <a:xfrm>
+            <a:off x="10561320" y="2523744"/>
+            <a:ext cx="1051560" cy="384048"/>
+          </a:xfrm>
+          <a:prstGeom prst="rect">
+            <a:avLst/>
+          </a:prstGeom>
+          <a:noFill/>
+          <a:ln/>
+        </p:spPr>
+        <p:txBody>
+          <a:bodyPr wrap="square" lIns="0" tIns="0" rIns="0" bIns="0" rtlCol="0" anchor="ctr"/>
+          <a:lstStyle/>
+          <a:p>
+            <a:pPr algn="ctr" indent="0" marL="0">
+              <a:buNone/>
+            </a:pPr>
+            <a:r>
+              <a:rPr lang="en-US" sz="950" b="1" dirty="0">
+                <a:solidFill>
+                  <a:srgbClr val="B45309"/>
+                </a:solidFill>
+                <a:latin typeface="Yu Gothic" pitchFamily="34" charset="0"/>
+                <a:ea typeface="Yu Gothic" pitchFamily="34" charset="-122"/>
+                <a:cs typeface="Yu Gothic" pitchFamily="34" charset="-120"/>
+              </a:rPr>
+              <a:t>課題③対応</a:t>
+            </a:r>
+            <a:endParaRPr lang="en-US" sz="950" dirty="0"/>
+          </a:p>
+        </p:txBody>
+      </p:sp>
+      <p:sp>
+        <p:nvSpPr>
+          <p:cNvPr id="14" name="Text 12"/>
+          <p:cNvSpPr/>
+          <p:nvPr/>
+        </p:nvSpPr>
+        <p:spPr>
+          <a:xfrm>
+            <a:off x="1188720" y="2468880"/>
+            <a:ext cx="9235440" cy="914400"/>
+          </a:xfrm>
+          <a:prstGeom prst="rect">
+            <a:avLst/>
+          </a:prstGeom>
+          <a:noFill/>
+          <a:ln/>
+        </p:spPr>
+        <p:txBody>
+          <a:bodyPr wrap="square" lIns="0" tIns="0" rIns="0" bIns="0" rtlCol="0" anchor="t"/>
+          <a:lstStyle/>
+          <a:p>
+            <a:pPr indent="0" marL="0">
+              <a:buNone/>
+            </a:pPr>
+            <a:r>
+              <a:rPr lang="en-US" sz="1300" b="1" dirty="0">
+                <a:solidFill>
+                  <a:srgbClr val="1B3A5C"/>
+                </a:solidFill>
+                <a:latin typeface="Yu Gothic" pitchFamily="34" charset="0"/>
+                <a:ea typeface="Yu Gothic" pitchFamily="34" charset="-122"/>
+                <a:cs typeface="Yu Gothic" pitchFamily="34" charset="-120"/>
+              </a:rPr>
+              <a:t>他社集客型イベントで求職者と直接交流
+</a:t>
+            </a:r>
+            <a:pPr indent="0" marL="0">
+              <a:buNone/>
+            </a:pPr>
+            <a:r>
+              <a:rPr lang="en-US" sz="1100" dirty="0">
+                <a:solidFill>
+                  <a:srgbClr val="374151"/>
+                </a:solidFill>
+                <a:latin typeface="Yu Gothic" pitchFamily="34" charset="0"/>
+                <a:ea typeface="Yu Gothic" pitchFamily="34" charset="-122"/>
+                <a:cs typeface="Yu Gothic" pitchFamily="34" charset="-120"/>
+              </a:rPr>
+              <a:t>ハローワーク説明会(8/28以降予約可)と、マイナビ転職フェア富山(10月・1月、20〜30代来場中心)等の合同説明会に参加。自社集客に依存せず、対面交流で情報不足への不安を解消する</a:t>
+            </a:r>
+            <a:endParaRPr lang="en-US" sz="1300" dirty="0"/>
+          </a:p>
+        </p:txBody>
+      </p:sp>
+      <p:sp>
+        <p:nvSpPr>
+          <p:cNvPr id="15" name="Shape 13"/>
+          <p:cNvSpPr/>
+          <p:nvPr/>
+        </p:nvSpPr>
+        <p:spPr>
+          <a:xfrm>
+            <a:off x="594360" y="3474720"/>
+            <a:ext cx="384048" cy="384048"/>
+          </a:xfrm>
+          <a:prstGeom prst="ellipse">
+            <a:avLst/>
+          </a:prstGeom>
+          <a:solidFill>
+            <a:srgbClr val="E8762C"/>
+          </a:solidFill>
+          <a:ln/>
+        </p:spPr>
+      </p:sp>
+      <p:sp>
+        <p:nvSpPr>
+          <p:cNvPr id="16" name="Text 14"/>
+          <p:cNvSpPr/>
+          <p:nvPr/>
+        </p:nvSpPr>
+        <p:spPr>
+          <a:xfrm>
+            <a:off x="594360" y="3470148"/>
+            <a:ext cx="384048" cy="384048"/>
+          </a:xfrm>
+          <a:prstGeom prst="rect">
+            <a:avLst/>
+          </a:prstGeom>
+          <a:noFill/>
+          <a:ln/>
+        </p:spPr>
+        <p:txBody>
+          <a:bodyPr wrap="square" lIns="0" tIns="0" rIns="0" bIns="0" rtlCol="0" anchor="ctr"/>
+          <a:lstStyle/>
+          <a:p>
+            <a:pPr algn="ctr" indent="0" marL="0">
+              <a:buNone/>
+            </a:pPr>
+            <a:r>
+              <a:rPr lang="en-US" sz="1500" b="1" dirty="0">
+                <a:solidFill>
+                  <a:srgbClr val="FFFFFF"/>
+                </a:solidFill>
+                <a:latin typeface="Yu Gothic" pitchFamily="34" charset="0"/>
+                <a:ea typeface="Yu Gothic" pitchFamily="34" charset="-122"/>
+                <a:cs typeface="Yu Gothic" pitchFamily="34" charset="-120"/>
+              </a:rPr>
+              <a:t>3</a:t>
+            </a:r>
+            <a:endParaRPr lang="en-US" sz="1500" dirty="0"/>
+          </a:p>
+        </p:txBody>
+      </p:sp>
+      <p:sp>
+        <p:nvSpPr>
+          <p:cNvPr id="17" name="Shape 15"/>
+          <p:cNvSpPr/>
+          <p:nvPr/>
+        </p:nvSpPr>
+        <p:spPr>
+          <a:xfrm>
+            <a:off x="10561320" y="3456432"/>
+            <a:ext cx="1051560" cy="384048"/>
+          </a:xfrm>
+          <a:prstGeom prst="roundRect">
+            <a:avLst>
+              <a:gd name="adj" fmla="val 14286"/>
+            </a:avLst>
+          </a:prstGeom>
+          <a:solidFill>
+            <a:srgbClr val="FDF0E6"/>
+          </a:solidFill>
+          <a:ln/>
+        </p:spPr>
+      </p:sp>
+      <p:sp>
+        <p:nvSpPr>
+          <p:cNvPr id="18" name="Text 16"/>
+          <p:cNvSpPr/>
+          <p:nvPr/>
+        </p:nvSpPr>
+        <p:spPr>
+          <a:xfrm>
+            <a:off x="10561320" y="3456432"/>
+            <a:ext cx="1051560" cy="384048"/>
+          </a:xfrm>
+          <a:prstGeom prst="rect">
+            <a:avLst/>
+          </a:prstGeom>
+          <a:noFill/>
+          <a:ln/>
+        </p:spPr>
+        <p:txBody>
+          <a:bodyPr wrap="square" lIns="0" tIns="0" rIns="0" bIns="0" rtlCol="0" anchor="ctr"/>
+          <a:lstStyle/>
+          <a:p>
+            <a:pPr algn="ctr" indent="0" marL="0">
+              <a:buNone/>
+            </a:pPr>
+            <a:r>
+              <a:rPr lang="en-US" sz="950" b="1" dirty="0">
+                <a:solidFill>
+                  <a:srgbClr val="B45309"/>
+                </a:solidFill>
+                <a:latin typeface="Yu Gothic" pitchFamily="34" charset="0"/>
+                <a:ea typeface="Yu Gothic" pitchFamily="34" charset="-122"/>
+                <a:cs typeface="Yu Gothic" pitchFamily="34" charset="-120"/>
+              </a:rPr>
+              <a:t>課題①対応</a:t>
+            </a:r>
+            <a:endParaRPr lang="en-US" sz="950" dirty="0"/>
+          </a:p>
+        </p:txBody>
+      </p:sp>
+      <p:sp>
+        <p:nvSpPr>
+          <p:cNvPr id="19" name="Text 17"/>
+          <p:cNvSpPr/>
+          <p:nvPr/>
+        </p:nvSpPr>
+        <p:spPr>
+          <a:xfrm>
+            <a:off x="1188720" y="3401568"/>
+            <a:ext cx="9235440" cy="914400"/>
+          </a:xfrm>
+          <a:prstGeom prst="rect">
+            <a:avLst/>
+          </a:prstGeom>
+          <a:noFill/>
+          <a:ln/>
+        </p:spPr>
+        <p:txBody>
+          <a:bodyPr wrap="square" lIns="0" tIns="0" rIns="0" bIns="0" rtlCol="0" anchor="t"/>
+          <a:lstStyle/>
+          <a:p>
+            <a:pPr indent="0" marL="0">
+              <a:buNone/>
+            </a:pPr>
+            <a:r>
+              <a:rPr lang="en-US" sz="1300" b="1" dirty="0">
+                <a:solidFill>
+                  <a:srgbClr val="1B3A5C"/>
+                </a:solidFill>
+                <a:latin typeface="Yu Gothic" pitchFamily="34" charset="0"/>
+                <a:ea typeface="Yu Gothic" pitchFamily="34" charset="-122"/>
+                <a:cs typeface="Yu Gothic" pitchFamily="34" charset="-120"/>
+              </a:rPr>
+              <a:t>未経験×20・30代への注力を継続
+</a:t>
+            </a:r>
+            <a:pPr indent="0" marL="0">
+              <a:buNone/>
+            </a:pPr>
+            <a:r>
+              <a:rPr lang="en-US" sz="1100" dirty="0">
+                <a:solidFill>
+                  <a:srgbClr val="374151"/>
+                </a:solidFill>
+                <a:latin typeface="Yu Gothic" pitchFamily="34" charset="0"/>
+                <a:ea typeface="Yu Gothic" pitchFamily="34" charset="-122"/>
+                <a:cs typeface="Yu Gothic" pitchFamily="34" charset="-120"/>
+              </a:rPr>
+              <a:t>経験者市場は構造的に小さいことが検証で判明済み。「オタク気質×AI」訴求と未経験育成(資格全額支援・3年で一人前)を前面に、未経験採用に投資を集中する</a:t>
+            </a:r>
+            <a:endParaRPr lang="en-US" sz="1300" dirty="0"/>
+          </a:p>
+        </p:txBody>
+      </p:sp>
+      <p:sp>
+        <p:nvSpPr>
+          <p:cNvPr id="20" name="Shape 18"/>
+          <p:cNvSpPr/>
+          <p:nvPr/>
+        </p:nvSpPr>
+        <p:spPr>
+          <a:xfrm>
+            <a:off x="594360" y="4407408"/>
+            <a:ext cx="384048" cy="384048"/>
+          </a:xfrm>
+          <a:prstGeom prst="ellipse">
+            <a:avLst/>
+          </a:prstGeom>
+          <a:solidFill>
+            <a:srgbClr val="5A7A99"/>
+          </a:solidFill>
+          <a:ln/>
+        </p:spPr>
+      </p:sp>
+      <p:sp>
+        <p:nvSpPr>
+          <p:cNvPr id="21" name="Text 19"/>
+          <p:cNvSpPr/>
+          <p:nvPr/>
+        </p:nvSpPr>
+        <p:spPr>
+          <a:xfrm>
+            <a:off x="594360" y="4402836"/>
+            <a:ext cx="384048" cy="384048"/>
+          </a:xfrm>
+          <a:prstGeom prst="rect">
+            <a:avLst/>
+          </a:prstGeom>
+          <a:noFill/>
+          <a:ln/>
+        </p:spPr>
+        <p:txBody>
+          <a:bodyPr wrap="square" lIns="0" tIns="0" rIns="0" bIns="0" rtlCol="0" anchor="ctr"/>
+          <a:lstStyle/>
+          <a:p>
+            <a:pPr algn="ctr" indent="0" marL="0">
+              <a:buNone/>
+            </a:pPr>
+            <a:r>
+              <a:rPr lang="en-US" sz="1500" b="1" dirty="0">
+                <a:solidFill>
+                  <a:srgbClr val="FFFFFF"/>
+                </a:solidFill>
+                <a:latin typeface="Yu Gothic" pitchFamily="34" charset="0"/>
+                <a:ea typeface="Yu Gothic" pitchFamily="34" charset="-122"/>
+                <a:cs typeface="Yu Gothic" pitchFamily="34" charset="-120"/>
+              </a:rPr>
+              <a:t>4</a:t>
+            </a:r>
+            <a:endParaRPr lang="en-US" sz="1500" dirty="0"/>
+          </a:p>
+        </p:txBody>
+      </p:sp>
+      <p:sp>
+        <p:nvSpPr>
+          <p:cNvPr id="22" name="Shape 20"/>
+          <p:cNvSpPr/>
+          <p:nvPr/>
+        </p:nvSpPr>
+        <p:spPr>
+          <a:xfrm>
+            <a:off x="10561320" y="4389120"/>
+            <a:ext cx="1051560" cy="384048"/>
+          </a:xfrm>
+          <a:prstGeom prst="roundRect">
+            <a:avLst>
+              <a:gd name="adj" fmla="val 14286"/>
+            </a:avLst>
+          </a:prstGeom>
+          <a:solidFill>
+            <a:srgbClr val="E5E7EB"/>
+          </a:solidFill>
+          <a:ln/>
+        </p:spPr>
+      </p:sp>
+      <p:sp>
+        <p:nvSpPr>
+          <p:cNvPr id="23" name="Text 21"/>
+          <p:cNvSpPr/>
+          <p:nvPr/>
+        </p:nvSpPr>
+        <p:spPr>
+          <a:xfrm>
+            <a:off x="10561320" y="4389120"/>
+            <a:ext cx="1051560" cy="384048"/>
+          </a:xfrm>
+          <a:prstGeom prst="rect">
+            <a:avLst/>
+          </a:prstGeom>
+          <a:noFill/>
+          <a:ln/>
+        </p:spPr>
+        <p:txBody>
+          <a:bodyPr wrap="square" lIns="0" tIns="0" rIns="0" bIns="0" rtlCol="0" anchor="ctr"/>
+          <a:lstStyle/>
+          <a:p>
+            <a:pPr algn="ctr" indent="0" marL="0">
+              <a:buNone/>
+            </a:pPr>
+            <a:r>
+              <a:rPr lang="en-US" sz="950" b="1" dirty="0">
+                <a:solidFill>
+                  <a:srgbClr val="6B7280"/>
+                </a:solidFill>
+                <a:latin typeface="Yu Gothic" pitchFamily="34" charset="0"/>
+                <a:ea typeface="Yu Gothic" pitchFamily="34" charset="-122"/>
+                <a:cs typeface="Yu Gothic" pitchFamily="34" charset="-120"/>
+              </a:rPr>
+              <a:t>補強対応</a:t>
+            </a:r>
+            <a:endParaRPr lang="en-US" sz="950" dirty="0"/>
+          </a:p>
+        </p:txBody>
+      </p:sp>
+      <p:sp>
+        <p:nvSpPr>
+          <p:cNvPr id="24" name="Text 22"/>
+          <p:cNvSpPr/>
+          <p:nvPr/>
+        </p:nvSpPr>
+        <p:spPr>
+          <a:xfrm>
+            <a:off x="1188720" y="4334256"/>
+            <a:ext cx="9235440" cy="914400"/>
+          </a:xfrm>
+          <a:prstGeom prst="rect">
+            <a:avLst/>
+          </a:prstGeom>
+          <a:noFill/>
+          <a:ln/>
+        </p:spPr>
+        <p:txBody>
+          <a:bodyPr wrap="square" lIns="0" tIns="0" rIns="0" bIns="0" rtlCol="0" anchor="t"/>
+          <a:lstStyle/>
+          <a:p>
+            <a:pPr indent="0" marL="0">
+              <a:buNone/>
+            </a:pPr>
+            <a:r>
+              <a:rPr lang="en-US" sz="1300" b="1" dirty="0">
+                <a:solidFill>
+                  <a:srgbClr val="1B3A5C"/>
+                </a:solidFill>
+                <a:latin typeface="Yu Gothic" pitchFamily="34" charset="0"/>
+                <a:ea typeface="Yu Gothic" pitchFamily="34" charset="-122"/>
+                <a:cs typeface="Yu Gothic" pitchFamily="34" charset="-120"/>
+              </a:rPr>
+              <a:t>20〜30代の選考移行率の改善
+</a:t>
+            </a:r>
+            <a:pPr indent="0" marL="0">
+              <a:buNone/>
+            </a:pPr>
+            <a:r>
+              <a:rPr lang="en-US" sz="1100" dirty="0">
+                <a:solidFill>
+                  <a:srgbClr val="374151"/>
+                </a:solidFill>
+                <a:latin typeface="Yu Gothic" pitchFamily="34" charset="0"/>
+                <a:ea typeface="Yu Gothic" pitchFamily="34" charset="-122"/>
+                <a:cs typeface="Yu Gothic" pitchFamily="34" charset="-120"/>
+              </a:rPr>
+              <a:t>初回接触を固定電話→SMS→LINEの順で徹底し若手の連絡途絶を防止。オンライン説明会への誘導を全応募者の標準フローにし、「応募→説明会参加」の移行率をKPIとして毎週計測</a:t>
+            </a:r>
+            <a:endParaRPr lang="en-US" sz="1300" dirty="0"/>
+          </a:p>
+        </p:txBody>
+      </p:sp>
+      <p:sp>
+        <p:nvSpPr>
+          <p:cNvPr id="25" name="Shape 23"/>
+          <p:cNvSpPr/>
+          <p:nvPr/>
+        </p:nvSpPr>
+        <p:spPr>
+          <a:xfrm>
+            <a:off x="594360" y="5340096"/>
+            <a:ext cx="384048" cy="384048"/>
+          </a:xfrm>
+          <a:prstGeom prst="ellipse">
+            <a:avLst/>
+          </a:prstGeom>
+          <a:solidFill>
+            <a:srgbClr val="5A7A99"/>
+          </a:solidFill>
+          <a:ln/>
+        </p:spPr>
+      </p:sp>
+      <p:sp>
+        <p:nvSpPr>
+          <p:cNvPr id="26" name="Text 24"/>
+          <p:cNvSpPr/>
+          <p:nvPr/>
+        </p:nvSpPr>
+        <p:spPr>
+          <a:xfrm>
+            <a:off x="594360" y="5335524"/>
+            <a:ext cx="384048" cy="384048"/>
+          </a:xfrm>
+          <a:prstGeom prst="rect">
+            <a:avLst/>
+          </a:prstGeom>
+          <a:noFill/>
+          <a:ln/>
+        </p:spPr>
+        <p:txBody>
+          <a:bodyPr wrap="square" lIns="0" tIns="0" rIns="0" bIns="0" rtlCol="0" anchor="ctr"/>
+          <a:lstStyle/>
+          <a:p>
+            <a:pPr algn="ctr" indent="0" marL="0">
+              <a:buNone/>
+            </a:pPr>
+            <a:r>
+              <a:rPr lang="en-US" sz="1500" b="1" dirty="0">
+                <a:solidFill>
+                  <a:srgbClr val="FFFFFF"/>
+                </a:solidFill>
+                <a:latin typeface="Yu Gothic" pitchFamily="34" charset="0"/>
+                <a:ea typeface="Yu Gothic" pitchFamily="34" charset="-122"/>
+                <a:cs typeface="Yu Gothic" pitchFamily="34" charset="-120"/>
+              </a:rPr>
+              <a:t>5</a:t>
+            </a:r>
+            <a:endParaRPr lang="en-US" sz="1500" dirty="0"/>
+          </a:p>
+        </p:txBody>
+      </p:sp>
+      <p:sp>
+        <p:nvSpPr>
+          <p:cNvPr id="27" name="Shape 25"/>
+          <p:cNvSpPr/>
+          <p:nvPr/>
+        </p:nvSpPr>
+        <p:spPr>
+          <a:xfrm>
+            <a:off x="10561320" y="5321808"/>
+            <a:ext cx="1051560" cy="384048"/>
+          </a:xfrm>
+          <a:prstGeom prst="roundRect">
+            <a:avLst>
+              <a:gd name="adj" fmla="val 14286"/>
+            </a:avLst>
+          </a:prstGeom>
+          <a:solidFill>
+            <a:srgbClr val="E5E7EB"/>
+          </a:solidFill>
+          <a:ln/>
+        </p:spPr>
+      </p:sp>
+      <p:sp>
+        <p:nvSpPr>
+          <p:cNvPr id="28" name="Text 26"/>
+          <p:cNvSpPr/>
+          <p:nvPr/>
+        </p:nvSpPr>
+        <p:spPr>
+          <a:xfrm>
+            <a:off x="10561320" y="5321808"/>
+            <a:ext cx="1051560" cy="384048"/>
+          </a:xfrm>
+          <a:prstGeom prst="rect">
+            <a:avLst/>
+          </a:prstGeom>
+          <a:noFill/>
+          <a:ln/>
+        </p:spPr>
+        <p:txBody>
+          <a:bodyPr wrap="square" lIns="0" tIns="0" rIns="0" bIns="0" rtlCol="0" anchor="ctr"/>
+          <a:lstStyle/>
+          <a:p>
+            <a:pPr algn="ctr" indent="0" marL="0">
+              <a:buNone/>
+            </a:pPr>
+            <a:r>
+              <a:rPr lang="en-US" sz="950" b="1" dirty="0">
+                <a:solidFill>
+                  <a:srgbClr val="6B7280"/>
+                </a:solidFill>
+                <a:latin typeface="Yu Gothic" pitchFamily="34" charset="0"/>
+                <a:ea typeface="Yu Gothic" pitchFamily="34" charset="-122"/>
+                <a:cs typeface="Yu Gothic" pitchFamily="34" charset="-120"/>
+              </a:rPr>
+              <a:t>補強対応</a:t>
+            </a:r>
+            <a:endParaRPr lang="en-US" sz="950" dirty="0"/>
+          </a:p>
+        </p:txBody>
+      </p:sp>
+      <p:sp>
+        <p:nvSpPr>
+          <p:cNvPr id="29" name="Text 27"/>
+          <p:cNvSpPr/>
+          <p:nvPr/>
+        </p:nvSpPr>
+        <p:spPr>
+          <a:xfrm>
+            <a:off x="1188720" y="5266944"/>
+            <a:ext cx="9235440" cy="914400"/>
+          </a:xfrm>
+          <a:prstGeom prst="rect">
+            <a:avLst/>
+          </a:prstGeom>
+          <a:noFill/>
+          <a:ln/>
+        </p:spPr>
+        <p:txBody>
+          <a:bodyPr wrap="square" lIns="0" tIns="0" rIns="0" bIns="0" rtlCol="0" anchor="t"/>
+          <a:lstStyle/>
+          <a:p>
+            <a:pPr indent="0" marL="0">
+              <a:buNone/>
+            </a:pPr>
+            <a:r>
+              <a:rPr lang="en-US" sz="1300" b="1" dirty="0">
+                <a:solidFill>
+                  <a:srgbClr val="1B3A5C"/>
+                </a:solidFill>
+                <a:latin typeface="Yu Gothic" pitchFamily="34" charset="0"/>
+                <a:ea typeface="Yu Gothic" pitchFamily="34" charset="-122"/>
+                <a:cs typeface="Yu Gothic" pitchFamily="34" charset="-120"/>
+              </a:rPr>
+              <a:t>基盤整備(中長期)
+</a:t>
+            </a:r>
+            <a:pPr indent="0" marL="0">
+              <a:buNone/>
+            </a:pPr>
+            <a:r>
+              <a:rPr lang="en-US" sz="1100" dirty="0">
+                <a:solidFill>
+                  <a:srgbClr val="374151"/>
+                </a:solidFill>
+                <a:latin typeface="Yu Gothic" pitchFamily="34" charset="0"/>
+                <a:ea typeface="Yu Gothic" pitchFamily="34" charset="-122"/>
+                <a:cs typeface="Yu Gothic" pitchFamily="34" charset="-120"/>
+              </a:rPr>
+              <a:t>LP・広告の効果測定(コンバージョン計測・GA4)の整備と、若年層応募の最大障壁である年間休日数(土曜出勤)の段階的見直しの検討</a:t>
+            </a:r>
+            <a:endParaRPr lang="en-US" sz="1300" dirty="0"/>
+          </a:p>
+        </p:txBody>
+      </p:sp>
+    </p:spTree>
+  </p:cSld>
+  <p:clrMapOvr>
+    <a:masterClrMapping/>
+  </p:clrMapOvr>
+</p:sld>
+</file>
+
+<file path=ppt/slides/slide14.xml><?xml version="1.0" encoding="utf-8"?>
+<p:sld xmlns:a="http://schemas.openxmlformats.org/drawingml/2006/main" xmlns:r="http://schemas.openxmlformats.org/officeDocument/2006/relationships" xmlns:p="http://schemas.openxmlformats.org/presentationml/2006/main">
+  <p:cSld name="Slide 14">
+    <p:bg>
+      <p:bgPr>
+        <a:solidFill>
+          <a:srgbClr val="FFFFFF"/>
+        </a:solidFill>
+      </p:bgPr>
+    </p:bg>
+    <p:spTree>
+      <p:nvGrpSpPr>
+        <p:cNvPr id="1" name=""/>
+        <p:cNvGrpSpPr/>
+        <p:nvPr/>
+      </p:nvGrpSpPr>
+      <p:grpSpPr>
+        <a:xfrm>
+          <a:off x="0" y="0"/>
+          <a:ext cx="0" cy="0"/>
+          <a:chOff x="0" y="0"/>
+          <a:chExt cx="0" cy="0"/>
+        </a:xfrm>
+      </p:grpSpPr>
+      <p:sp>
+        <p:nvSpPr>
+          <p:cNvPr id="2" name="Text 0"/>
+          <p:cNvSpPr/>
+          <p:nvPr/>
+        </p:nvSpPr>
+        <p:spPr>
+          <a:xfrm>
+            <a:off x="548640" y="292608"/>
+            <a:ext cx="9601200" cy="685800"/>
+          </a:xfrm>
+          <a:prstGeom prst="rect">
+            <a:avLst/>
+          </a:prstGeom>
+          <a:noFill/>
+          <a:ln/>
+        </p:spPr>
+        <p:txBody>
+          <a:bodyPr wrap="square" lIns="0" tIns="0" rIns="0" bIns="0" rtlCol="0" anchor="ctr"/>
+          <a:lstStyle/>
+          <a:p>
+            <a:pPr indent="0" marL="0">
+              <a:buNone/>
+            </a:pPr>
+            <a:r>
+              <a:rPr lang="en-US" sz="3000" b="1" dirty="0">
+                <a:solidFill>
+                  <a:srgbClr val="1B3A5C"/>
+                </a:solidFill>
+                <a:latin typeface="Yu Gothic" pitchFamily="34" charset="0"/>
+                <a:ea typeface="Yu Gothic" pitchFamily="34" charset="-122"/>
+                <a:cs typeface="Yu Gothic" pitchFamily="34" charset="-120"/>
+              </a:rPr>
+              <a:t>活動履歴 ─ 定例ミーティング・説明会</a:t>
+            </a:r>
+            <a:endParaRPr lang="en-US" sz="3000" dirty="0"/>
+          </a:p>
+        </p:txBody>
+      </p:sp>
+      <p:sp>
+        <p:nvSpPr>
+          <p:cNvPr id="3" name="Text 1"/>
+          <p:cNvSpPr/>
+          <p:nvPr/>
+        </p:nvSpPr>
+        <p:spPr>
+          <a:xfrm>
+            <a:off x="566928" y="932688"/>
+            <a:ext cx="10515600" cy="365760"/>
+          </a:xfrm>
+          <a:prstGeom prst="rect">
+            <a:avLst/>
+          </a:prstGeom>
+          <a:noFill/>
+          <a:ln/>
+        </p:spPr>
+        <p:txBody>
+          <a:bodyPr wrap="square" lIns="0" tIns="0" rIns="0" bIns="0" rtlCol="0" anchor="ctr"/>
+          <a:lstStyle/>
+          <a:p>
+            <a:pPr indent="0" marL="0">
+              <a:buNone/>
+            </a:pPr>
+            <a:r>
+              <a:rPr lang="en-US" sz="1300" dirty="0">
+                <a:solidFill>
+                  <a:srgbClr val="6B7280"/>
+                </a:solidFill>
+                <a:latin typeface="Yu Gothic" pitchFamily="34" charset="0"/>
+                <a:ea typeface="Yu Gothic" pitchFamily="34" charset="-122"/>
+                <a:cs typeface="Yu Gothic" pitchFamily="34" charset="-120"/>
+              </a:rPr>
+              <a:t>毎回議事録を共有し、決定事項を翌週までに実行するサイクルを継続</a:t>
+            </a:r>
+            <a:endParaRPr lang="en-US" sz="1300" dirty="0"/>
+          </a:p>
+        </p:txBody>
+      </p:sp>
+      <p:sp>
+        <p:nvSpPr>
+          <p:cNvPr id="4" name="Text 2"/>
+          <p:cNvSpPr/>
+          <p:nvPr/>
+        </p:nvSpPr>
+        <p:spPr>
+          <a:xfrm>
+            <a:off x="11292840" y="320040"/>
+            <a:ext cx="640080" cy="457200"/>
+          </a:xfrm>
+          <a:prstGeom prst="rect">
+            <a:avLst/>
+          </a:prstGeom>
+          <a:noFill/>
+          <a:ln/>
+        </p:spPr>
+        <p:txBody>
+          <a:bodyPr wrap="square" lIns="0" tIns="0" rIns="0" bIns="0" rtlCol="0" anchor="ctr"/>
+          <a:lstStyle/>
+          <a:p>
+            <a:pPr algn="r" indent="0" marL="0">
+              <a:buNone/>
+            </a:pPr>
+            <a:r>
+              <a:rPr lang="en-US" sz="1600" b="1" dirty="0">
+                <a:solidFill>
+                  <a:srgbClr val="5A7A99"/>
+                </a:solidFill>
+                <a:latin typeface="Arial" pitchFamily="34" charset="0"/>
+                <a:ea typeface="Arial" pitchFamily="34" charset="-122"/>
+                <a:cs typeface="Arial" pitchFamily="34" charset="-120"/>
+              </a:rPr>
+              <a:t>14</a:t>
+            </a:r>
+            <a:endParaRPr lang="en-US" sz="1600" dirty="0"/>
+          </a:p>
+        </p:txBody>
+      </p:sp>
       <p:graphicFrame>
         <p:nvGraphicFramePr>
-          <p:cNvPr id="13" name="Table 0"/>
+          <p:cNvPr id="15" name="Table 0"/>
           <p:cNvGraphicFramePr>
             <a:graphicFrameLocks noGrp="1"/>
           </p:cNvGraphicFramePr>
@@ -7069,7 +9037,7 @@
       </p:graphicFrame>
       <p:graphicFrame>
         <p:nvGraphicFramePr>
-          <p:cNvPr id="25" name="Table 1"/>
+          <p:cNvPr id="29" name="Table 1"/>
           <p:cNvGraphicFramePr>
             <a:graphicFrameLocks noGrp="1"/>
           </p:cNvGraphicFramePr>
@@ -8800,723 +10768,9 @@
 </p:sld>
 </file>
 
-<file path=ppt/slides/slide13.xml><?xml version="1.0" encoding="utf-8"?>
+<file path=ppt/slides/slide15.xml><?xml version="1.0" encoding="utf-8"?>
 <p:sld xmlns:a="http://schemas.openxmlformats.org/drawingml/2006/main" xmlns:r="http://schemas.openxmlformats.org/officeDocument/2006/relationships" xmlns:p="http://schemas.openxmlformats.org/presentationml/2006/main">
-  <p:cSld name="Slide 13">
-    <p:bg>
-      <p:bgPr>
-        <a:solidFill>
-          <a:srgbClr val="FFFFFF"/>
-        </a:solidFill>
-      </p:bgPr>
-    </p:bg>
-    <p:spTree>
-      <p:nvGrpSpPr>
-        <p:cNvPr id="1" name=""/>
-        <p:cNvGrpSpPr/>
-        <p:nvPr/>
-      </p:nvGrpSpPr>
-      <p:grpSpPr>
-        <a:xfrm>
-          <a:off x="0" y="0"/>
-          <a:ext cx="0" cy="0"/>
-          <a:chOff x="0" y="0"/>
-          <a:chExt cx="0" cy="0"/>
-        </a:xfrm>
-      </p:grpSpPr>
-      <p:sp>
-        <p:nvSpPr>
-          <p:cNvPr id="2" name="Text 0"/>
-          <p:cNvSpPr/>
-          <p:nvPr/>
-        </p:nvSpPr>
-        <p:spPr>
-          <a:xfrm>
-            <a:off x="548640" y="292608"/>
-            <a:ext cx="9601200" cy="685800"/>
-          </a:xfrm>
-          <a:prstGeom prst="rect">
-            <a:avLst/>
-          </a:prstGeom>
-          <a:noFill/>
-          <a:ln/>
-        </p:spPr>
-        <p:txBody>
-          <a:bodyPr wrap="square" lIns="0" tIns="0" rIns="0" bIns="0" rtlCol="0" anchor="ctr"/>
-          <a:lstStyle/>
-          <a:p>
-            <a:pPr indent="0" marL="0">
-              <a:buNone/>
-            </a:pPr>
-            <a:r>
-              <a:rPr lang="en-US" sz="3000" b="1" dirty="0">
-                <a:solidFill>
-                  <a:srgbClr val="1B3A5C"/>
-                </a:solidFill>
-                <a:latin typeface="Yu Gothic" pitchFamily="34" charset="0"/>
-                <a:ea typeface="Yu Gothic" pitchFamily="34" charset="-122"/>
-                <a:cs typeface="Yu Gothic" pitchFamily="34" charset="-120"/>
-              </a:rPr>
-              <a:t>今後のご提言</a:t>
-            </a:r>
-            <a:endParaRPr lang="en-US" sz="3000" dirty="0"/>
-          </a:p>
-        </p:txBody>
-      </p:sp>
-      <p:sp>
-        <p:nvSpPr>
-          <p:cNvPr id="3" name="Text 1"/>
-          <p:cNvSpPr/>
-          <p:nvPr/>
-        </p:nvSpPr>
-        <p:spPr>
-          <a:xfrm>
-            <a:off x="566928" y="932688"/>
-            <a:ext cx="10515600" cy="365760"/>
-          </a:xfrm>
-          <a:prstGeom prst="rect">
-            <a:avLst/>
-          </a:prstGeom>
-          <a:noFill/>
-          <a:ln/>
-        </p:spPr>
-        <p:txBody>
-          <a:bodyPr wrap="square" lIns="0" tIns="0" rIns="0" bIns="0" rtlCol="0" anchor="ctr"/>
-          <a:lstStyle/>
-          <a:p>
-            <a:pPr indent="0" marL="0">
-              <a:buNone/>
-            </a:pPr>
-            <a:r>
-              <a:rPr lang="en-US" sz="1300" dirty="0">
-                <a:solidFill>
-                  <a:srgbClr val="6B7280"/>
-                </a:solidFill>
-                <a:latin typeface="Yu Gothic" pitchFamily="34" charset="0"/>
-                <a:ea typeface="Yu Gothic" pitchFamily="34" charset="-122"/>
-                <a:cs typeface="Yu Gothic" pitchFamily="34" charset="-120"/>
-              </a:rPr>
-              <a:t>8月以降の転職市場再活性化(ピーク:9〜10月)を最大限に活かすために</a:t>
-            </a:r>
-            <a:endParaRPr lang="en-US" sz="1300" dirty="0"/>
-          </a:p>
-        </p:txBody>
-      </p:sp>
-      <p:sp>
-        <p:nvSpPr>
-          <p:cNvPr id="4" name="Text 2"/>
-          <p:cNvSpPr/>
-          <p:nvPr/>
-        </p:nvSpPr>
-        <p:spPr>
-          <a:xfrm>
-            <a:off x="11292840" y="320040"/>
-            <a:ext cx="640080" cy="457200"/>
-          </a:xfrm>
-          <a:prstGeom prst="rect">
-            <a:avLst/>
-          </a:prstGeom>
-          <a:noFill/>
-          <a:ln/>
-        </p:spPr>
-        <p:txBody>
-          <a:bodyPr wrap="square" lIns="0" tIns="0" rIns="0" bIns="0" rtlCol="0" anchor="ctr"/>
-          <a:lstStyle/>
-          <a:p>
-            <a:pPr algn="r" indent="0" marL="0">
-              <a:buNone/>
-            </a:pPr>
-            <a:r>
-              <a:rPr lang="en-US" sz="1600" b="1" dirty="0">
-                <a:solidFill>
-                  <a:srgbClr val="5A7A99"/>
-                </a:solidFill>
-                <a:latin typeface="Arial" pitchFamily="34" charset="0"/>
-                <a:ea typeface="Arial" pitchFamily="34" charset="-122"/>
-                <a:cs typeface="Arial" pitchFamily="34" charset="-120"/>
-              </a:rPr>
-              <a:t>13</a:t>
-            </a:r>
-            <a:endParaRPr lang="en-US" sz="1600" dirty="0"/>
-          </a:p>
-        </p:txBody>
-      </p:sp>
-      <p:sp>
-        <p:nvSpPr>
-          <p:cNvPr id="5" name="Shape 3"/>
-          <p:cNvSpPr/>
-          <p:nvPr/>
-        </p:nvSpPr>
-        <p:spPr>
-          <a:xfrm>
-            <a:off x="594360" y="1609344"/>
-            <a:ext cx="384048" cy="384048"/>
-          </a:xfrm>
-          <a:prstGeom prst="ellipse">
-            <a:avLst/>
-          </a:prstGeom>
-          <a:solidFill>
-            <a:srgbClr val="E8762C"/>
-          </a:solidFill>
-          <a:ln/>
-        </p:spPr>
-      </p:sp>
-      <p:sp>
-        <p:nvSpPr>
-          <p:cNvPr id="6" name="Text 4"/>
-          <p:cNvSpPr/>
-          <p:nvPr/>
-        </p:nvSpPr>
-        <p:spPr>
-          <a:xfrm>
-            <a:off x="594360" y="1604772"/>
-            <a:ext cx="384048" cy="384048"/>
-          </a:xfrm>
-          <a:prstGeom prst="rect">
-            <a:avLst/>
-          </a:prstGeom>
-          <a:noFill/>
-          <a:ln/>
-        </p:spPr>
-        <p:txBody>
-          <a:bodyPr wrap="square" lIns="0" tIns="0" rIns="0" bIns="0" rtlCol="0" anchor="ctr"/>
-          <a:lstStyle/>
-          <a:p>
-            <a:pPr algn="ctr" indent="0" marL="0">
-              <a:buNone/>
-            </a:pPr>
-            <a:r>
-              <a:rPr lang="en-US" sz="1500" b="1" dirty="0">
-                <a:solidFill>
-                  <a:srgbClr val="FFFFFF"/>
-                </a:solidFill>
-                <a:latin typeface="Yu Gothic" pitchFamily="34" charset="0"/>
-                <a:ea typeface="Yu Gothic" pitchFamily="34" charset="-122"/>
-                <a:cs typeface="Yu Gothic" pitchFamily="34" charset="-120"/>
-              </a:rPr>
-              <a:t>1</a:t>
-            </a:r>
-            <a:endParaRPr lang="en-US" sz="1500" dirty="0"/>
-          </a:p>
-        </p:txBody>
-      </p:sp>
-      <p:sp>
-        <p:nvSpPr>
-          <p:cNvPr id="7" name="Text 5"/>
-          <p:cNvSpPr/>
-          <p:nvPr/>
-        </p:nvSpPr>
-        <p:spPr>
-          <a:xfrm>
-            <a:off x="1188720" y="1536192"/>
-            <a:ext cx="10424160" cy="914400"/>
-          </a:xfrm>
-          <a:prstGeom prst="rect">
-            <a:avLst/>
-          </a:prstGeom>
-          <a:noFill/>
-          <a:ln/>
-        </p:spPr>
-        <p:txBody>
-          <a:bodyPr wrap="square" lIns="0" tIns="0" rIns="0" bIns="0" rtlCol="0" anchor="t"/>
-          <a:lstStyle/>
-          <a:p>
-            <a:pPr indent="0" marL="0">
-              <a:buNone/>
-            </a:pPr>
-            <a:r>
-              <a:rPr lang="en-US" sz="1300" b="1" dirty="0">
-                <a:solidFill>
-                  <a:srgbClr val="1B3A5C"/>
-                </a:solidFill>
-                <a:latin typeface="Yu Gothic" pitchFamily="34" charset="0"/>
-                <a:ea typeface="Yu Gothic" pitchFamily="34" charset="-122"/>
-                <a:cs typeface="Yu Gothic" pitchFamily="34" charset="-120"/>
-              </a:rPr>
-              <a:t>Instagram×HP導線の確立
-</a:t>
-            </a:r>
-            <a:pPr indent="0" marL="0">
-              <a:buNone/>
-            </a:pPr>
-            <a:r>
-              <a:rPr lang="en-US" sz="1100" dirty="0">
-                <a:solidFill>
-                  <a:srgbClr val="374151"/>
-                </a:solidFill>
-                <a:latin typeface="Yu Gothic" pitchFamily="34" charset="0"/>
-                <a:ea typeface="Yu Gothic" pitchFamily="34" charset="-122"/>
-                <a:cs typeface="Yu Gothic" pitchFamily="34" charset="-120"/>
-              </a:rPr>
-              <a:t>リニューアルHPとInstagramを紐付け、「求人媒体→Instagram→HP→説明会」の導線を完成させる。静止画+文字の定期投稿を継続し、会社の「人となり」で応募の質を高める</a:t>
-            </a:r>
-            <a:endParaRPr lang="en-US" sz="1300" dirty="0"/>
-          </a:p>
-        </p:txBody>
-      </p:sp>
-      <p:sp>
-        <p:nvSpPr>
-          <p:cNvPr id="8" name="Shape 6"/>
-          <p:cNvSpPr/>
-          <p:nvPr/>
-        </p:nvSpPr>
-        <p:spPr>
-          <a:xfrm>
-            <a:off x="594360" y="2542032"/>
-            <a:ext cx="384048" cy="384048"/>
-          </a:xfrm>
-          <a:prstGeom prst="ellipse">
-            <a:avLst/>
-          </a:prstGeom>
-          <a:solidFill>
-            <a:srgbClr val="E8762C"/>
-          </a:solidFill>
-          <a:ln/>
-        </p:spPr>
-      </p:sp>
-      <p:sp>
-        <p:nvSpPr>
-          <p:cNvPr id="9" name="Text 7"/>
-          <p:cNvSpPr/>
-          <p:nvPr/>
-        </p:nvSpPr>
-        <p:spPr>
-          <a:xfrm>
-            <a:off x="594360" y="2537460"/>
-            <a:ext cx="384048" cy="384048"/>
-          </a:xfrm>
-          <a:prstGeom prst="rect">
-            <a:avLst/>
-          </a:prstGeom>
-          <a:noFill/>
-          <a:ln/>
-        </p:spPr>
-        <p:txBody>
-          <a:bodyPr wrap="square" lIns="0" tIns="0" rIns="0" bIns="0" rtlCol="0" anchor="ctr"/>
-          <a:lstStyle/>
-          <a:p>
-            <a:pPr algn="ctr" indent="0" marL="0">
-              <a:buNone/>
-            </a:pPr>
-            <a:r>
-              <a:rPr lang="en-US" sz="1500" b="1" dirty="0">
-                <a:solidFill>
-                  <a:srgbClr val="FFFFFF"/>
-                </a:solidFill>
-                <a:latin typeface="Yu Gothic" pitchFamily="34" charset="0"/>
-                <a:ea typeface="Yu Gothic" pitchFamily="34" charset="-122"/>
-                <a:cs typeface="Yu Gothic" pitchFamily="34" charset="-120"/>
-              </a:rPr>
-              <a:t>2</a:t>
-            </a:r>
-            <a:endParaRPr lang="en-US" sz="1500" dirty="0"/>
-          </a:p>
-        </p:txBody>
-      </p:sp>
-      <p:sp>
-        <p:nvSpPr>
-          <p:cNvPr id="10" name="Text 8"/>
-          <p:cNvSpPr/>
-          <p:nvPr/>
-        </p:nvSpPr>
-        <p:spPr>
-          <a:xfrm>
-            <a:off x="1188720" y="2468880"/>
-            <a:ext cx="10424160" cy="914400"/>
-          </a:xfrm>
-          <a:prstGeom prst="rect">
-            <a:avLst/>
-          </a:prstGeom>
-          <a:noFill/>
-          <a:ln/>
-        </p:spPr>
-        <p:txBody>
-          <a:bodyPr wrap="square" lIns="0" tIns="0" rIns="0" bIns="0" rtlCol="0" anchor="t"/>
-          <a:lstStyle/>
-          <a:p>
-            <a:pPr indent="0" marL="0">
-              <a:buNone/>
-            </a:pPr>
-            <a:r>
-              <a:rPr lang="en-US" sz="1300" b="1" dirty="0">
-                <a:solidFill>
-                  <a:srgbClr val="1B3A5C"/>
-                </a:solidFill>
-                <a:latin typeface="Yu Gothic" pitchFamily="34" charset="0"/>
-                <a:ea typeface="Yu Gothic" pitchFamily="34" charset="-122"/>
-                <a:cs typeface="Yu Gothic" pitchFamily="34" charset="-120"/>
-              </a:rPr>
-              <a:t>転職フェア・職人スカウトの実行判断
-</a:t>
-            </a:r>
-            <a:pPr indent="0" marL="0">
-              <a:buNone/>
-            </a:pPr>
-            <a:r>
-              <a:rPr lang="en-US" sz="1100" dirty="0">
-                <a:solidFill>
-                  <a:srgbClr val="374151"/>
-                </a:solidFill>
-                <a:latin typeface="Yu Gothic" pitchFamily="34" charset="0"/>
-                <a:ea typeface="Yu Gothic" pitchFamily="34" charset="-122"/>
-                <a:cs typeface="Yu Gothic" pitchFamily="34" charset="-120"/>
-              </a:rPr>
-              <a:t>マイナビ転職フェア富山(10月・1月)は20〜30代来場が中心でターゲット合致。出展費用の交渉結果を踏まえ9月中に出展可否を判断。職人スカウトは北陸登録者数の回答次第で費用対効果を見極め</a:t>
-            </a:r>
-            <a:endParaRPr lang="en-US" sz="1300" dirty="0"/>
-          </a:p>
-        </p:txBody>
-      </p:sp>
-      <p:sp>
-        <p:nvSpPr>
-          <p:cNvPr id="11" name="Shape 9"/>
-          <p:cNvSpPr/>
-          <p:nvPr/>
-        </p:nvSpPr>
-        <p:spPr>
-          <a:xfrm>
-            <a:off x="594360" y="3474720"/>
-            <a:ext cx="384048" cy="384048"/>
-          </a:xfrm>
-          <a:prstGeom prst="ellipse">
-            <a:avLst/>
-          </a:prstGeom>
-          <a:solidFill>
-            <a:srgbClr val="E8762C"/>
-          </a:solidFill>
-          <a:ln/>
-        </p:spPr>
-      </p:sp>
-      <p:sp>
-        <p:nvSpPr>
-          <p:cNvPr id="12" name="Text 10"/>
-          <p:cNvSpPr/>
-          <p:nvPr/>
-        </p:nvSpPr>
-        <p:spPr>
-          <a:xfrm>
-            <a:off x="594360" y="3470148"/>
-            <a:ext cx="384048" cy="384048"/>
-          </a:xfrm>
-          <a:prstGeom prst="rect">
-            <a:avLst/>
-          </a:prstGeom>
-          <a:noFill/>
-          <a:ln/>
-        </p:spPr>
-        <p:txBody>
-          <a:bodyPr wrap="square" lIns="0" tIns="0" rIns="0" bIns="0" rtlCol="0" anchor="ctr"/>
-          <a:lstStyle/>
-          <a:p>
-            <a:pPr algn="ctr" indent="0" marL="0">
-              <a:buNone/>
-            </a:pPr>
-            <a:r>
-              <a:rPr lang="en-US" sz="1500" b="1" dirty="0">
-                <a:solidFill>
-                  <a:srgbClr val="FFFFFF"/>
-                </a:solidFill>
-                <a:latin typeface="Yu Gothic" pitchFamily="34" charset="0"/>
-                <a:ea typeface="Yu Gothic" pitchFamily="34" charset="-122"/>
-                <a:cs typeface="Yu Gothic" pitchFamily="34" charset="-120"/>
-              </a:rPr>
-              <a:t>3</a:t>
-            </a:r>
-            <a:endParaRPr lang="en-US" sz="1500" dirty="0"/>
-          </a:p>
-        </p:txBody>
-      </p:sp>
-      <p:sp>
-        <p:nvSpPr>
-          <p:cNvPr id="13" name="Text 11"/>
-          <p:cNvSpPr/>
-          <p:nvPr/>
-        </p:nvSpPr>
-        <p:spPr>
-          <a:xfrm>
-            <a:off x="1188720" y="3401568"/>
-            <a:ext cx="10424160" cy="914400"/>
-          </a:xfrm>
-          <a:prstGeom prst="rect">
-            <a:avLst/>
-          </a:prstGeom>
-          <a:noFill/>
-          <a:ln/>
-        </p:spPr>
-        <p:txBody>
-          <a:bodyPr wrap="square" lIns="0" tIns="0" rIns="0" bIns="0" rtlCol="0" anchor="t"/>
-          <a:lstStyle/>
-          <a:p>
-            <a:pPr indent="0" marL="0">
-              <a:buNone/>
-            </a:pPr>
-            <a:r>
-              <a:rPr lang="en-US" sz="1300" b="1" dirty="0">
-                <a:solidFill>
-                  <a:srgbClr val="1B3A5C"/>
-                </a:solidFill>
-                <a:latin typeface="Yu Gothic" pitchFamily="34" charset="0"/>
-                <a:ea typeface="Yu Gothic" pitchFamily="34" charset="-122"/>
-                <a:cs typeface="Yu Gothic" pitchFamily="34" charset="-120"/>
-              </a:rPr>
-              <a:t>20〜30代の選考移行率の改善(最重要)
-</a:t>
-            </a:r>
-            <a:pPr indent="0" marL="0">
-              <a:buNone/>
-            </a:pPr>
-            <a:r>
-              <a:rPr lang="en-US" sz="1100" dirty="0">
-                <a:solidFill>
-                  <a:srgbClr val="374151"/>
-                </a:solidFill>
-                <a:latin typeface="Yu Gothic" pitchFamily="34" charset="0"/>
-                <a:ea typeface="Yu Gothic" pitchFamily="34" charset="-122"/>
-                <a:cs typeface="Yu Gothic" pitchFamily="34" charset="-120"/>
-              </a:rPr>
-              <a:t>初回接触を24時間以内・固定電話→SMS→LINEの順で徹底し、若手の連絡途絶を防止。オンライン説明会への誘導を全応募者の標準フローにし、「応募→説明会参加」の移行率をKPIとして毎週計測</a:t>
-            </a:r>
-            <a:endParaRPr lang="en-US" sz="1300" dirty="0"/>
-          </a:p>
-        </p:txBody>
-      </p:sp>
-      <p:sp>
-        <p:nvSpPr>
-          <p:cNvPr id="14" name="Shape 12"/>
-          <p:cNvSpPr/>
-          <p:nvPr/>
-        </p:nvSpPr>
-        <p:spPr>
-          <a:xfrm>
-            <a:off x="594360" y="4407408"/>
-            <a:ext cx="384048" cy="384048"/>
-          </a:xfrm>
-          <a:prstGeom prst="ellipse">
-            <a:avLst/>
-          </a:prstGeom>
-          <a:solidFill>
-            <a:srgbClr val="E8762C"/>
-          </a:solidFill>
-          <a:ln/>
-        </p:spPr>
-      </p:sp>
-      <p:sp>
-        <p:nvSpPr>
-          <p:cNvPr id="15" name="Text 13"/>
-          <p:cNvSpPr/>
-          <p:nvPr/>
-        </p:nvSpPr>
-        <p:spPr>
-          <a:xfrm>
-            <a:off x="594360" y="4402836"/>
-            <a:ext cx="384048" cy="384048"/>
-          </a:xfrm>
-          <a:prstGeom prst="rect">
-            <a:avLst/>
-          </a:prstGeom>
-          <a:noFill/>
-          <a:ln/>
-        </p:spPr>
-        <p:txBody>
-          <a:bodyPr wrap="square" lIns="0" tIns="0" rIns="0" bIns="0" rtlCol="0" anchor="ctr"/>
-          <a:lstStyle/>
-          <a:p>
-            <a:pPr algn="ctr" indent="0" marL="0">
-              <a:buNone/>
-            </a:pPr>
-            <a:r>
-              <a:rPr lang="en-US" sz="1500" b="1" dirty="0">
-                <a:solidFill>
-                  <a:srgbClr val="FFFFFF"/>
-                </a:solidFill>
-                <a:latin typeface="Yu Gothic" pitchFamily="34" charset="0"/>
-                <a:ea typeface="Yu Gothic" pitchFamily="34" charset="-122"/>
-                <a:cs typeface="Yu Gothic" pitchFamily="34" charset="-120"/>
-              </a:rPr>
-              <a:t>4</a:t>
-            </a:r>
-            <a:endParaRPr lang="en-US" sz="1500" dirty="0"/>
-          </a:p>
-        </p:txBody>
-      </p:sp>
-      <p:sp>
-        <p:nvSpPr>
-          <p:cNvPr id="16" name="Text 14"/>
-          <p:cNvSpPr/>
-          <p:nvPr/>
-        </p:nvSpPr>
-        <p:spPr>
-          <a:xfrm>
-            <a:off x="1188720" y="4334256"/>
-            <a:ext cx="10424160" cy="914400"/>
-          </a:xfrm>
-          <a:prstGeom prst="rect">
-            <a:avLst/>
-          </a:prstGeom>
-          <a:noFill/>
-          <a:ln/>
-        </p:spPr>
-        <p:txBody>
-          <a:bodyPr wrap="square" lIns="0" tIns="0" rIns="0" bIns="0" rtlCol="0" anchor="t"/>
-          <a:lstStyle/>
-          <a:p>
-            <a:pPr indent="0" marL="0">
-              <a:buNone/>
-            </a:pPr>
-            <a:r>
-              <a:rPr lang="en-US" sz="1300" b="1" dirty="0">
-                <a:solidFill>
-                  <a:srgbClr val="1B3A5C"/>
-                </a:solidFill>
-                <a:latin typeface="Yu Gothic" pitchFamily="34" charset="0"/>
-                <a:ea typeface="Yu Gothic" pitchFamily="34" charset="-122"/>
-                <a:cs typeface="Yu Gothic" pitchFamily="34" charset="-120"/>
-              </a:rPr>
-              <a:t>休日制度の検討(中長期)
-</a:t>
-            </a:r>
-            <a:pPr indent="0" marL="0">
-              <a:buNone/>
-            </a:pPr>
-            <a:r>
-              <a:rPr lang="en-US" sz="1100" dirty="0">
-                <a:solidFill>
-                  <a:srgbClr val="374151"/>
-                </a:solidFill>
-                <a:latin typeface="Yu Gothic" pitchFamily="34" charset="0"/>
-                <a:ea typeface="Yu Gothic" pitchFamily="34" charset="-122"/>
-                <a:cs typeface="Yu Gothic" pitchFamily="34" charset="-120"/>
-              </a:rPr>
-              <a:t>若年層応募の最大障壁は「年間休日数」(競合は土日祝休み訴求)。土曜出勤の段階的見直しは、採用競争力に直結する経営テーマとしてご検討を推奨</a:t>
-            </a:r>
-            <a:endParaRPr lang="en-US" sz="1300" dirty="0"/>
-          </a:p>
-        </p:txBody>
-      </p:sp>
-      <p:sp>
-        <p:nvSpPr>
-          <p:cNvPr id="17" name="Shape 15"/>
-          <p:cNvSpPr/>
-          <p:nvPr/>
-        </p:nvSpPr>
-        <p:spPr>
-          <a:xfrm>
-            <a:off x="594360" y="5340096"/>
-            <a:ext cx="384048" cy="384048"/>
-          </a:xfrm>
-          <a:prstGeom prst="ellipse">
-            <a:avLst/>
-          </a:prstGeom>
-          <a:solidFill>
-            <a:srgbClr val="E8762C"/>
-          </a:solidFill>
-          <a:ln/>
-        </p:spPr>
-      </p:sp>
-      <p:sp>
-        <p:nvSpPr>
-          <p:cNvPr id="18" name="Text 16"/>
-          <p:cNvSpPr/>
-          <p:nvPr/>
-        </p:nvSpPr>
-        <p:spPr>
-          <a:xfrm>
-            <a:off x="594360" y="5335524"/>
-            <a:ext cx="384048" cy="384048"/>
-          </a:xfrm>
-          <a:prstGeom prst="rect">
-            <a:avLst/>
-          </a:prstGeom>
-          <a:noFill/>
-          <a:ln/>
-        </p:spPr>
-        <p:txBody>
-          <a:bodyPr wrap="square" lIns="0" tIns="0" rIns="0" bIns="0" rtlCol="0" anchor="ctr"/>
-          <a:lstStyle/>
-          <a:p>
-            <a:pPr algn="ctr" indent="0" marL="0">
-              <a:buNone/>
-            </a:pPr>
-            <a:r>
-              <a:rPr lang="en-US" sz="1500" b="1" dirty="0">
-                <a:solidFill>
-                  <a:srgbClr val="FFFFFF"/>
-                </a:solidFill>
-                <a:latin typeface="Yu Gothic" pitchFamily="34" charset="0"/>
-                <a:ea typeface="Yu Gothic" pitchFamily="34" charset="-122"/>
-                <a:cs typeface="Yu Gothic" pitchFamily="34" charset="-120"/>
-              </a:rPr>
-              <a:t>5</a:t>
-            </a:r>
-            <a:endParaRPr lang="en-US" sz="1500" dirty="0"/>
-          </a:p>
-        </p:txBody>
-      </p:sp>
-      <p:sp>
-        <p:nvSpPr>
-          <p:cNvPr id="19" name="Text 17"/>
-          <p:cNvSpPr/>
-          <p:nvPr/>
-        </p:nvSpPr>
-        <p:spPr>
-          <a:xfrm>
-            <a:off x="1188720" y="5266944"/>
-            <a:ext cx="10424160" cy="914400"/>
-          </a:xfrm>
-          <a:prstGeom prst="rect">
-            <a:avLst/>
-          </a:prstGeom>
-          <a:noFill/>
-          <a:ln/>
-        </p:spPr>
-        <p:txBody>
-          <a:bodyPr wrap="square" lIns="0" tIns="0" rIns="0" bIns="0" rtlCol="0" anchor="t"/>
-          <a:lstStyle/>
-          <a:p>
-            <a:pPr indent="0" marL="0">
-              <a:buNone/>
-            </a:pPr>
-            <a:r>
-              <a:rPr lang="en-US" sz="1300" b="1" dirty="0">
-                <a:solidFill>
-                  <a:srgbClr val="1B3A5C"/>
-                </a:solidFill>
-                <a:latin typeface="Yu Gothic" pitchFamily="34" charset="0"/>
-                <a:ea typeface="Yu Gothic" pitchFamily="34" charset="-122"/>
-                <a:cs typeface="Yu Gothic" pitchFamily="34" charset="-120"/>
-              </a:rPr>
-              <a:t>計測基盤の整備
-</a:t>
-            </a:r>
-            <a:pPr indent="0" marL="0">
-              <a:buNone/>
-            </a:pPr>
-            <a:r>
-              <a:rPr lang="en-US" sz="1100" dirty="0">
-                <a:solidFill>
-                  <a:srgbClr val="374151"/>
-                </a:solidFill>
-                <a:latin typeface="Yu Gothic" pitchFamily="34" charset="0"/>
-                <a:ea typeface="Yu Gothic" pitchFamily="34" charset="-122"/>
-                <a:cs typeface="Yu Gothic" pitchFamily="34" charset="-120"/>
-              </a:rPr>
-              <a:t>LP・広告の効果測定(コンバージョン計測・GA4)を整備し、8月以降の投資判断を数値で行える状態にする</a:t>
-            </a:r>
-            <a:endParaRPr lang="en-US" sz="1300" dirty="0"/>
-          </a:p>
-        </p:txBody>
-      </p:sp>
-    </p:spTree>
-  </p:cSld>
-  <p:clrMapOvr>
-    <a:masterClrMapping/>
-  </p:clrMapOvr>
-</p:sld>
-</file>
-
-<file path=ppt/slides/slide14.xml><?xml version="1.0" encoding="utf-8"?>
-<p:sld xmlns:a="http://schemas.openxmlformats.org/drawingml/2006/main" xmlns:r="http://schemas.openxmlformats.org/officeDocument/2006/relationships" xmlns:p="http://schemas.openxmlformats.org/presentationml/2006/main">
-  <p:cSld name="Slide 14">
+  <p:cSld name="Slide 15">
     <p:bg>
       <p:bgPr>
         <a:solidFill>
@@ -10856,7 +12110,7 @@
                 <a:ea typeface="Yu Gothic" pitchFamily="34" charset="-122"/>
                 <a:cs typeface="Yu Gothic" pitchFamily="34" charset="-120"/>
               </a:rPr>
-              <a:t>応募から選考への移行が壁(書類通過・面接0名)。20代の連絡途絶への対策と選考移行率の改善策を本レポートでご提案します。</a:t>
+              <a:t>応募から選考への移行が壁(書類通過・面接0名)。①経験者市場の不足 ②情報の透明性不足 ③求職者との接点不足 の3つの課題認識と対応策を後半でご提案します。</a:t>
             </a:r>
             <a:endParaRPr lang="en-US" sz="1250" dirty="0"/>
           </a:p>

</xml_diff>

<commit_message>
Add content plan slide: empathy / reassurance / stability themes
Co-Authored-By: Claude Fable 5 <noreply@anthropic.com>
Claude-Session: https://claude.ai/code/session_019t7NW6utTEgroUuPVV8xiA
</commit_message>
<xml_diff>
--- a/reports/matsushita-kogyo/松下工業様_採用強化支援_総括レポート.pptx
+++ b/reports/matsushita-kogyo/松下工業様_採用強化支援_総括レポート.pptx
@@ -24,9 +24,10 @@
     <p:sldId id="272" r:id="rId18"/>
     <p:sldId id="273" r:id="rId19"/>
     <p:sldId id="274" r:id="rId20"/>
+    <p:sldId id="275" r:id="rId21"/>
   </p:sldIdLst>
   <p:notesMasterIdLst>
-    <p:notesMasterId r:id="rId21"/>
+    <p:notesMasterId r:id="rId22"/>
   </p:notesMasterIdLst>
   <p:sldSz cx="12192000" cy="6858000"/>
   <p:notesSz cx="6858000" cy="12192000"/>
@@ -2199,6 +2200,94 @@
             <a:fld id="{F7021451-1387-4CA6-816F-3879F97B5CBC}" type="slidenum">
               <a:rPr lang="en-US"/>
               <a:t>2</a:t>
+            </a:fld>
+            <a:endParaRPr lang="en-US"/>
+          </a:p>
+        </p:txBody>
+      </p:sp>
+    </p:spTree>
+    <p:extLst>
+      <p:ext uri="{BB962C8B-B14F-4D97-AF65-F5344CB8AC3E}">
+        <p14:creationId xmlns:p14="http://schemas.microsoft.com/office/powerpoint/2010/main" val="1024086991"/>
+      </p:ext>
+    </p:extLst>
+  </p:cSld>
+  <p:clrMapOvr>
+    <a:masterClrMapping/>
+  </p:clrMapOvr>
+</p:notes>
+</file>
+
+<file path=ppt/notesSlides/notesSlide20.xml><?xml version="1.0" encoding="utf-8"?>
+<p:notes xmlns:a="http://schemas.openxmlformats.org/drawingml/2006/main" xmlns:r="http://schemas.openxmlformats.org/officeDocument/2006/relationships" xmlns:p="http://schemas.openxmlformats.org/presentationml/2006/main">
+  <p:cSld>
+    <p:spTree>
+      <p:nvGrpSpPr>
+        <p:cNvPr id="1" name=""/>
+        <p:cNvGrpSpPr/>
+        <p:nvPr/>
+      </p:nvGrpSpPr>
+      <p:grpSpPr>
+        <a:xfrm>
+          <a:off x="0" y="0"/>
+          <a:ext cx="0" cy="0"/>
+          <a:chOff x="0" y="0"/>
+          <a:chExt cx="0" cy="0"/>
+        </a:xfrm>
+      </p:grpSpPr>
+      <p:sp>
+        <p:nvSpPr>
+          <p:cNvPr id="2" name="Slide Image Placeholder 1"/>
+          <p:cNvSpPr>
+            <a:spLocks noGrp="1" noRot="1" noChangeAspect="1"/>
+          </p:cNvSpPr>
+          <p:nvPr>
+            <p:ph type="sldImg"/>
+          </p:nvPr>
+        </p:nvSpPr>
+        <p:spPr/>
+      </p:sp>
+      <p:sp>
+        <p:nvSpPr>
+          <p:cNvPr id="3" name="Notes Placeholder 2"/>
+          <p:cNvSpPr>
+            <a:spLocks noGrp="1"/>
+          </p:cNvSpPr>
+          <p:nvPr>
+            <p:ph type="body" idx="1"/>
+          </p:nvPr>
+        </p:nvSpPr>
+        <p:spPr/>
+        <p:txBody>
+          <a:bodyPr/>
+          <a:lstStyle/>
+          <a:p>
+            <a:r>
+              <a:rPr lang="en-US" dirty="0"/>
+              <a:t/>
+            </a:r>
+            <a:endParaRPr lang="en-US" dirty="0"/>
+          </a:p>
+        </p:txBody>
+      </p:sp>
+      <p:sp>
+        <p:nvSpPr>
+          <p:cNvPr id="4" name="Slide Number Placeholder 3"/>
+          <p:cNvSpPr>
+            <a:spLocks noGrp="1"/>
+          </p:cNvSpPr>
+          <p:nvPr>
+            <p:ph type="sldNum" sz="quarter" idx="10"/>
+          </p:nvPr>
+        </p:nvSpPr>
+        <p:spPr/>
+        <p:txBody>
+          <a:bodyPr/>
+          <a:lstStyle/>
+          <a:p>
+            <a:fld id="{F7021451-1387-4CA6-816F-3879F97B5CBC}" type="slidenum">
+              <a:rPr lang="en-US"/>
+              <a:t>20</a:t>
             </a:fld>
             <a:endParaRPr lang="en-US"/>
           </a:p>
@@ -8529,7 +8618,7 @@
                 <a:ea typeface="Yu Gothic" pitchFamily="34" charset="-122"/>
                 <a:cs typeface="Yu Gothic" pitchFamily="34" charset="-120"/>
               </a:rPr>
-              <a:t>Instagramで同テーマを定期投稿し、検索時の受け皿に(静止画+文字で社長が自走できる運用)</a:t>
+              <a:t>Instagramで「共感・安心・安定」を軸に定期投稿し、検索時の受け皿に(次頁のコンテンツプラン参照)</a:t>
             </a:r>
             <a:endParaRPr lang="en-US" sz="1050" dirty="0"/>
           </a:p>
@@ -8621,7 +8710,7 @@
                 <a:ea typeface="Yu Gothic" pitchFamily="34" charset="-122"/>
                 <a:cs typeface="Yu Gothic" pitchFamily="34" charset="-120"/>
               </a:rPr>
-              <a:t>課題③ 求職者との直接接点の不足</a:t>
+              <a:t>情報発信プラン ─ 共感・安心・安定</a:t>
             </a:r>
             <a:endParaRPr lang="en-US" sz="3000" dirty="0"/>
           </a:p>
@@ -8660,7 +8749,7 @@
                 <a:ea typeface="Yu Gothic" pitchFamily="34" charset="-122"/>
                 <a:cs typeface="Yu Gothic" pitchFamily="34" charset="-120"/>
               </a:rPr>
-              <a:t>情報の不透明性を補う最短ルートは「直接会って話す」こと ─ 集客は他社の力を借りる</a:t>
+              <a:t>透明性向上の鍵はHP・SNS(特にInstagram)での発信。3つの感情に訴求するコンテンツを継続投稿します</a:t>
             </a:r>
             <a:endParaRPr lang="en-US" sz="1300" dirty="0"/>
           </a:p>
@@ -8707,6 +8796,848 @@
       </p:sp>
       <p:sp>
         <p:nvSpPr>
+          <p:cNvPr id="5" name="Shape 3"/>
+          <p:cNvSpPr/>
+          <p:nvPr/>
+        </p:nvSpPr>
+        <p:spPr>
+          <a:xfrm>
+            <a:off x="548640" y="1691640"/>
+            <a:ext cx="3566160" cy="777240"/>
+          </a:xfrm>
+          <a:prstGeom prst="roundRect">
+            <a:avLst>
+              <a:gd name="adj" fmla="val 9412"/>
+            </a:avLst>
+          </a:prstGeom>
+          <a:solidFill>
+            <a:srgbClr val="E8762C"/>
+          </a:solidFill>
+          <a:ln/>
+        </p:spPr>
+      </p:sp>
+      <p:sp>
+        <p:nvSpPr>
+          <p:cNvPr id="6" name="Text 4"/>
+          <p:cNvSpPr/>
+          <p:nvPr/>
+        </p:nvSpPr>
+        <p:spPr>
+          <a:xfrm>
+            <a:off x="548640" y="1691640"/>
+            <a:ext cx="3566160" cy="777240"/>
+          </a:xfrm>
+          <a:prstGeom prst="rect">
+            <a:avLst/>
+          </a:prstGeom>
+          <a:noFill/>
+          <a:ln/>
+        </p:spPr>
+        <p:txBody>
+          <a:bodyPr wrap="square" lIns="0" tIns="0" rIns="0" bIns="0" rtlCol="0" anchor="ctr"/>
+          <a:lstStyle/>
+          <a:p>
+            <a:pPr algn="ctr" indent="0" marL="0">
+              <a:buNone/>
+            </a:pPr>
+            <a:r>
+              <a:rPr lang="en-US" sz="1500" b="1" dirty="0">
+                <a:solidFill>
+                  <a:srgbClr val="FFFFFF"/>
+                </a:solidFill>
+                <a:latin typeface="Yu Gothic" pitchFamily="34" charset="0"/>
+                <a:ea typeface="Yu Gothic" pitchFamily="34" charset="-122"/>
+                <a:cs typeface="Yu Gothic" pitchFamily="34" charset="-120"/>
+              </a:rPr>
+              <a:t>共感</a:t>
+            </a:r>
+            <a:endParaRPr lang="en-US" sz="1500" dirty="0"/>
+          </a:p>
+          <a:p>
+            <a:pPr algn="ctr" indent="0" marL="0">
+              <a:buNone/>
+            </a:pPr>
+            <a:r>
+              <a:rPr lang="en-US" sz="950" dirty="0">
+                <a:solidFill>
+                  <a:srgbClr val="FFFFFF"/>
+                </a:solidFill>
+                <a:latin typeface="Yu Gothic" pitchFamily="34" charset="0"/>
+                <a:ea typeface="Yu Gothic" pitchFamily="34" charset="-122"/>
+                <a:cs typeface="Yu Gothic" pitchFamily="34" charset="-120"/>
+              </a:rPr>
+              <a:t>「この会社、わかってくれそう」</a:t>
+            </a:r>
+            <a:endParaRPr lang="en-US" sz="1500" dirty="0"/>
+          </a:p>
+        </p:txBody>
+      </p:sp>
+      <p:sp>
+        <p:nvSpPr>
+          <p:cNvPr id="7" name="Shape 5"/>
+          <p:cNvSpPr/>
+          <p:nvPr/>
+        </p:nvSpPr>
+        <p:spPr>
+          <a:xfrm>
+            <a:off x="548640" y="2606040"/>
+            <a:ext cx="3566160" cy="2788920"/>
+          </a:xfrm>
+          <a:prstGeom prst="roundRect">
+            <a:avLst>
+              <a:gd name="adj" fmla="val 2623"/>
+            </a:avLst>
+          </a:prstGeom>
+          <a:solidFill>
+            <a:srgbClr val="F2F6FA"/>
+          </a:solidFill>
+          <a:ln/>
+        </p:spPr>
+      </p:sp>
+      <p:sp>
+        <p:nvSpPr>
+          <p:cNvPr id="8" name="Text 6"/>
+          <p:cNvSpPr/>
+          <p:nvPr/>
+        </p:nvSpPr>
+        <p:spPr>
+          <a:xfrm>
+            <a:off x="749808" y="2788920"/>
+            <a:ext cx="3154680" cy="2468880"/>
+          </a:xfrm>
+          <a:prstGeom prst="rect">
+            <a:avLst/>
+          </a:prstGeom>
+          <a:noFill/>
+          <a:ln/>
+        </p:spPr>
+        <p:txBody>
+          <a:bodyPr wrap="square" lIns="0" tIns="0" rIns="0" bIns="0" rtlCol="0" anchor="t"/>
+          <a:lstStyle/>
+          <a:p>
+            <a:pPr marL="342900" indent="-342900">
+              <a:spcAft>
+                <a:spcPts val="800"/>
+              </a:spcAft>
+              <a:buSzPct val="100000"/>
+              <a:buChar char="•"/>
+            </a:pPr>
+            <a:r>
+              <a:rPr lang="en-US" sz="980" dirty="0">
+                <a:solidFill>
+                  <a:srgbClr val="374151"/>
+                </a:solidFill>
+                <a:latin typeface="Yu Gothic" pitchFamily="34" charset="0"/>
+                <a:ea typeface="Yu Gothic" pitchFamily="34" charset="-122"/>
+                <a:cs typeface="Yu Gothic" pitchFamily="34" charset="-120"/>
+              </a:rPr>
+              <a:t>社員の転職ストーリー(前職は残業100時間超→今は17時帰宅、など実話ベース)</a:t>
+            </a:r>
+            <a:endParaRPr lang="en-US" sz="980" dirty="0"/>
+          </a:p>
+          <a:p>
+            <a:pPr marL="342900" indent="-342900">
+              <a:spcAft>
+                <a:spcPts val="800"/>
+              </a:spcAft>
+              <a:buSzPct val="100000"/>
+              <a:buChar char="•"/>
+            </a:pPr>
+            <a:r>
+              <a:rPr lang="en-US" sz="980" dirty="0">
+                <a:solidFill>
+                  <a:srgbClr val="374151"/>
+                </a:solidFill>
+                <a:latin typeface="Yu Gothic" pitchFamily="34" charset="0"/>
+                <a:ea typeface="Yu Gothic" pitchFamily="34" charset="-122"/>
+                <a:cs typeface="Yu Gothic" pitchFamily="34" charset="-120"/>
+              </a:rPr>
+              <a:t>「配管はパズルのように面白い」─ 仕事の魅力を職人自身の言葉で</a:t>
+            </a:r>
+            <a:endParaRPr lang="en-US" sz="980" dirty="0"/>
+          </a:p>
+          <a:p>
+            <a:pPr marL="342900" indent="-342900">
+              <a:spcAft>
+                <a:spcPts val="800"/>
+              </a:spcAft>
+              <a:buSzPct val="100000"/>
+              <a:buChar char="•"/>
+            </a:pPr>
+            <a:r>
+              <a:rPr lang="en-US" sz="980" dirty="0">
+                <a:solidFill>
+                  <a:srgbClr val="374151"/>
+                </a:solidFill>
+                <a:latin typeface="Yu Gothic" pitchFamily="34" charset="0"/>
+                <a:ea typeface="Yu Gothic" pitchFamily="34" charset="-122"/>
+                <a:cs typeface="Yu Gothic" pitchFamily="34" charset="-120"/>
+              </a:rPr>
+              <a:t>未経験1年目の失敗談と成長エピソード</a:t>
+            </a:r>
+            <a:endParaRPr lang="en-US" sz="980" dirty="0"/>
+          </a:p>
+          <a:p>
+            <a:pPr marL="342900" indent="-342900">
+              <a:spcAft>
+                <a:spcPts val="800"/>
+              </a:spcAft>
+              <a:buSzPct val="100000"/>
+              <a:buChar char="•"/>
+            </a:pPr>
+            <a:r>
+              <a:rPr lang="en-US" sz="980" dirty="0">
+                <a:solidFill>
+                  <a:srgbClr val="374151"/>
+                </a:solidFill>
+                <a:latin typeface="Yu Gothic" pitchFamily="34" charset="0"/>
+                <a:ea typeface="Yu Gothic" pitchFamily="34" charset="-122"/>
+                <a:cs typeface="Yu Gothic" pitchFamily="34" charset="-120"/>
+              </a:rPr>
+              <a:t>オタク気質・マニア心をくすぐる技術ネタ(工具・新工法紹介)</a:t>
+            </a:r>
+            <a:endParaRPr lang="en-US" sz="980" dirty="0"/>
+          </a:p>
+        </p:txBody>
+      </p:sp>
+      <p:sp>
+        <p:nvSpPr>
+          <p:cNvPr id="9" name="Shape 7"/>
+          <p:cNvSpPr/>
+          <p:nvPr/>
+        </p:nvSpPr>
+        <p:spPr>
+          <a:xfrm>
+            <a:off x="4379976" y="1691640"/>
+            <a:ext cx="3566160" cy="777240"/>
+          </a:xfrm>
+          <a:prstGeom prst="roundRect">
+            <a:avLst>
+              <a:gd name="adj" fmla="val 9412"/>
+            </a:avLst>
+          </a:prstGeom>
+          <a:solidFill>
+            <a:srgbClr val="1B3A5C"/>
+          </a:solidFill>
+          <a:ln/>
+        </p:spPr>
+      </p:sp>
+      <p:sp>
+        <p:nvSpPr>
+          <p:cNvPr id="10" name="Text 8"/>
+          <p:cNvSpPr/>
+          <p:nvPr/>
+        </p:nvSpPr>
+        <p:spPr>
+          <a:xfrm>
+            <a:off x="4379976" y="1691640"/>
+            <a:ext cx="3566160" cy="777240"/>
+          </a:xfrm>
+          <a:prstGeom prst="rect">
+            <a:avLst/>
+          </a:prstGeom>
+          <a:noFill/>
+          <a:ln/>
+        </p:spPr>
+        <p:txBody>
+          <a:bodyPr wrap="square" lIns="0" tIns="0" rIns="0" bIns="0" rtlCol="0" anchor="ctr"/>
+          <a:lstStyle/>
+          <a:p>
+            <a:pPr algn="ctr" indent="0" marL="0">
+              <a:buNone/>
+            </a:pPr>
+            <a:r>
+              <a:rPr lang="en-US" sz="1500" b="1" dirty="0">
+                <a:solidFill>
+                  <a:srgbClr val="FFFFFF"/>
+                </a:solidFill>
+                <a:latin typeface="Yu Gothic" pitchFamily="34" charset="0"/>
+                <a:ea typeface="Yu Gothic" pitchFamily="34" charset="-122"/>
+                <a:cs typeface="Yu Gothic" pitchFamily="34" charset="-120"/>
+              </a:rPr>
+              <a:t>安心</a:t>
+            </a:r>
+            <a:endParaRPr lang="en-US" sz="1500" dirty="0"/>
+          </a:p>
+          <a:p>
+            <a:pPr algn="ctr" indent="0" marL="0">
+              <a:buNone/>
+            </a:pPr>
+            <a:r>
+              <a:rPr lang="en-US" sz="950" dirty="0">
+                <a:solidFill>
+                  <a:srgbClr val="FFFFFF"/>
+                </a:solidFill>
+                <a:latin typeface="Yu Gothic" pitchFamily="34" charset="0"/>
+                <a:ea typeface="Yu Gothic" pitchFamily="34" charset="-122"/>
+                <a:cs typeface="Yu Gothic" pitchFamily="34" charset="-120"/>
+              </a:rPr>
+              <a:t>「ここでならやっていけそう」</a:t>
+            </a:r>
+            <a:endParaRPr lang="en-US" sz="1500" dirty="0"/>
+          </a:p>
+        </p:txBody>
+      </p:sp>
+      <p:sp>
+        <p:nvSpPr>
+          <p:cNvPr id="11" name="Shape 9"/>
+          <p:cNvSpPr/>
+          <p:nvPr/>
+        </p:nvSpPr>
+        <p:spPr>
+          <a:xfrm>
+            <a:off x="4379976" y="2606040"/>
+            <a:ext cx="3566160" cy="2788920"/>
+          </a:xfrm>
+          <a:prstGeom prst="roundRect">
+            <a:avLst>
+              <a:gd name="adj" fmla="val 2623"/>
+            </a:avLst>
+          </a:prstGeom>
+          <a:solidFill>
+            <a:srgbClr val="F2F6FA"/>
+          </a:solidFill>
+          <a:ln/>
+        </p:spPr>
+      </p:sp>
+      <p:sp>
+        <p:nvSpPr>
+          <p:cNvPr id="12" name="Text 10"/>
+          <p:cNvSpPr/>
+          <p:nvPr/>
+        </p:nvSpPr>
+        <p:spPr>
+          <a:xfrm>
+            <a:off x="4581144" y="2788920"/>
+            <a:ext cx="3154680" cy="2468880"/>
+          </a:xfrm>
+          <a:prstGeom prst="rect">
+            <a:avLst/>
+          </a:prstGeom>
+          <a:noFill/>
+          <a:ln/>
+        </p:spPr>
+        <p:txBody>
+          <a:bodyPr wrap="square" lIns="0" tIns="0" rIns="0" bIns="0" rtlCol="0" anchor="t"/>
+          <a:lstStyle/>
+          <a:p>
+            <a:pPr marL="342900" indent="-342900">
+              <a:spcAft>
+                <a:spcPts val="800"/>
+              </a:spcAft>
+              <a:buSzPct val="100000"/>
+              <a:buChar char="•"/>
+            </a:pPr>
+            <a:r>
+              <a:rPr lang="en-US" sz="980" dirty="0">
+                <a:solidFill>
+                  <a:srgbClr val="374151"/>
+                </a:solidFill>
+                <a:latin typeface="Yu Gothic" pitchFamily="34" charset="0"/>
+                <a:ea typeface="Yu Gothic" pitchFamily="34" charset="-122"/>
+                <a:cs typeface="Yu Gothic" pitchFamily="34" charset="-120"/>
+              </a:rPr>
+              <a:t>1日のスケジュール密着(出社〜17時退社まで)</a:t>
+            </a:r>
+            <a:endParaRPr lang="en-US" sz="980" dirty="0"/>
+          </a:p>
+          <a:p>
+            <a:pPr marL="342900" indent="-342900">
+              <a:spcAft>
+                <a:spcPts val="800"/>
+              </a:spcAft>
+              <a:buSzPct val="100000"/>
+              <a:buChar char="•"/>
+            </a:pPr>
+            <a:r>
+              <a:rPr lang="en-US" sz="980" dirty="0">
+                <a:solidFill>
+                  <a:srgbClr val="374151"/>
+                </a:solidFill>
+                <a:latin typeface="Yu Gothic" pitchFamily="34" charset="0"/>
+                <a:ea typeface="Yu Gothic" pitchFamily="34" charset="-122"/>
+                <a:cs typeface="Yu Gothic" pitchFamily="34" charset="-120"/>
+              </a:rPr>
+              <a:t>教育の流れ: 穴掘りから始まり約3年で一人前・資格費用は全額会社負担</a:t>
+            </a:r>
+            <a:endParaRPr lang="en-US" sz="980" dirty="0"/>
+          </a:p>
+          <a:p>
+            <a:pPr marL="342900" indent="-342900">
+              <a:spcAft>
+                <a:spcPts val="800"/>
+              </a:spcAft>
+              <a:buSzPct val="100000"/>
+              <a:buChar char="•"/>
+            </a:pPr>
+            <a:r>
+              <a:rPr lang="en-US" sz="980" dirty="0">
+                <a:solidFill>
+                  <a:srgbClr val="374151"/>
+                </a:solidFill>
+                <a:latin typeface="Yu Gothic" pitchFamily="34" charset="0"/>
+                <a:ea typeface="Yu Gothic" pitchFamily="34" charset="-122"/>
+                <a:cs typeface="Yu Gothic" pitchFamily="34" charset="-120"/>
+              </a:rPr>
+              <a:t>職場の雰囲気: 怒鳴る親方文化なし・さん付け文化・先輩の人柄紹介</a:t>
+            </a:r>
+            <a:endParaRPr lang="en-US" sz="980" dirty="0"/>
+          </a:p>
+          <a:p>
+            <a:pPr marL="342900" indent="-342900">
+              <a:spcAft>
+                <a:spcPts val="800"/>
+              </a:spcAft>
+              <a:buSzPct val="100000"/>
+              <a:buChar char="•"/>
+            </a:pPr>
+            <a:r>
+              <a:rPr lang="en-US" sz="980" dirty="0">
+                <a:solidFill>
+                  <a:srgbClr val="374151"/>
+                </a:solidFill>
+                <a:latin typeface="Yu Gothic" pitchFamily="34" charset="0"/>
+                <a:ea typeface="Yu Gothic" pitchFamily="34" charset="-122"/>
+                <a:cs typeface="Yu Gothic" pitchFamily="34" charset="-120"/>
+              </a:rPr>
+              <a:t>給与モデル・残業や休日の実態をありのまま開示</a:t>
+            </a:r>
+            <a:endParaRPr lang="en-US" sz="980" dirty="0"/>
+          </a:p>
+        </p:txBody>
+      </p:sp>
+      <p:sp>
+        <p:nvSpPr>
+          <p:cNvPr id="13" name="Shape 11"/>
+          <p:cNvSpPr/>
+          <p:nvPr/>
+        </p:nvSpPr>
+        <p:spPr>
+          <a:xfrm>
+            <a:off x="8211312" y="1691640"/>
+            <a:ext cx="3566160" cy="777240"/>
+          </a:xfrm>
+          <a:prstGeom prst="roundRect">
+            <a:avLst>
+              <a:gd name="adj" fmla="val 9412"/>
+            </a:avLst>
+          </a:prstGeom>
+          <a:solidFill>
+            <a:srgbClr val="5A7A99"/>
+          </a:solidFill>
+          <a:ln/>
+        </p:spPr>
+      </p:sp>
+      <p:sp>
+        <p:nvSpPr>
+          <p:cNvPr id="14" name="Text 12"/>
+          <p:cNvSpPr/>
+          <p:nvPr/>
+        </p:nvSpPr>
+        <p:spPr>
+          <a:xfrm>
+            <a:off x="8211312" y="1691640"/>
+            <a:ext cx="3566160" cy="777240"/>
+          </a:xfrm>
+          <a:prstGeom prst="rect">
+            <a:avLst/>
+          </a:prstGeom>
+          <a:noFill/>
+          <a:ln/>
+        </p:spPr>
+        <p:txBody>
+          <a:bodyPr wrap="square" lIns="0" tIns="0" rIns="0" bIns="0" rtlCol="0" anchor="ctr"/>
+          <a:lstStyle/>
+          <a:p>
+            <a:pPr algn="ctr" indent="0" marL="0">
+              <a:buNone/>
+            </a:pPr>
+            <a:r>
+              <a:rPr lang="en-US" sz="1500" b="1" dirty="0">
+                <a:solidFill>
+                  <a:srgbClr val="FFFFFF"/>
+                </a:solidFill>
+                <a:latin typeface="Yu Gothic" pitchFamily="34" charset="0"/>
+                <a:ea typeface="Yu Gothic" pitchFamily="34" charset="-122"/>
+                <a:cs typeface="Yu Gothic" pitchFamily="34" charset="-120"/>
+              </a:rPr>
+              <a:t>安定</a:t>
+            </a:r>
+            <a:endParaRPr lang="en-US" sz="1500" dirty="0"/>
+          </a:p>
+          <a:p>
+            <a:pPr algn="ctr" indent="0" marL="0">
+              <a:buNone/>
+            </a:pPr>
+            <a:r>
+              <a:rPr lang="en-US" sz="950" dirty="0">
+                <a:solidFill>
+                  <a:srgbClr val="FFFFFF"/>
+                </a:solidFill>
+                <a:latin typeface="Yu Gothic" pitchFamily="34" charset="0"/>
+                <a:ea typeface="Yu Gothic" pitchFamily="34" charset="-122"/>
+                <a:cs typeface="Yu Gothic" pitchFamily="34" charset="-120"/>
+              </a:rPr>
+              <a:t>「長く働ける会社だ」</a:t>
+            </a:r>
+            <a:endParaRPr lang="en-US" sz="1500" dirty="0"/>
+          </a:p>
+        </p:txBody>
+      </p:sp>
+      <p:sp>
+        <p:nvSpPr>
+          <p:cNvPr id="15" name="Shape 13"/>
+          <p:cNvSpPr/>
+          <p:nvPr/>
+        </p:nvSpPr>
+        <p:spPr>
+          <a:xfrm>
+            <a:off x="8211312" y="2606040"/>
+            <a:ext cx="3566160" cy="2788920"/>
+          </a:xfrm>
+          <a:prstGeom prst="roundRect">
+            <a:avLst>
+              <a:gd name="adj" fmla="val 2623"/>
+            </a:avLst>
+          </a:prstGeom>
+          <a:solidFill>
+            <a:srgbClr val="F2F6FA"/>
+          </a:solidFill>
+          <a:ln/>
+        </p:spPr>
+      </p:sp>
+      <p:sp>
+        <p:nvSpPr>
+          <p:cNvPr id="16" name="Text 14"/>
+          <p:cNvSpPr/>
+          <p:nvPr/>
+        </p:nvSpPr>
+        <p:spPr>
+          <a:xfrm>
+            <a:off x="8412480" y="2788920"/>
+            <a:ext cx="3154680" cy="2468880"/>
+          </a:xfrm>
+          <a:prstGeom prst="rect">
+            <a:avLst/>
+          </a:prstGeom>
+          <a:noFill/>
+          <a:ln/>
+        </p:spPr>
+        <p:txBody>
+          <a:bodyPr wrap="square" lIns="0" tIns="0" rIns="0" bIns="0" rtlCol="0" anchor="t"/>
+          <a:lstStyle/>
+          <a:p>
+            <a:pPr marL="342900" indent="-342900">
+              <a:spcAft>
+                <a:spcPts val="800"/>
+              </a:spcAft>
+              <a:buSzPct val="100000"/>
+              <a:buChar char="•"/>
+            </a:pPr>
+            <a:r>
+              <a:rPr lang="en-US" sz="980" dirty="0">
+                <a:solidFill>
+                  <a:srgbClr val="374151"/>
+                </a:solidFill>
+                <a:latin typeface="Yu Gothic" pitchFamily="34" charset="0"/>
+                <a:ea typeface="Yu Gothic" pitchFamily="34" charset="-122"/>
+                <a:cs typeface="Yu Gothic" pitchFamily="34" charset="-120"/>
+              </a:rPr>
+              <a:t>創業70年以上・地域インフラ(上下水道・ガス)を支える事業基盤</a:t>
+            </a:r>
+            <a:endParaRPr lang="en-US" sz="980" dirty="0"/>
+          </a:p>
+          <a:p>
+            <a:pPr marL="342900" indent="-342900">
+              <a:spcAft>
+                <a:spcPts val="800"/>
+              </a:spcAft>
+              <a:buSzPct val="100000"/>
+              <a:buChar char="•"/>
+            </a:pPr>
+            <a:r>
+              <a:rPr lang="en-US" sz="980" dirty="0">
+                <a:solidFill>
+                  <a:srgbClr val="374151"/>
+                </a:solidFill>
+                <a:latin typeface="Yu Gothic" pitchFamily="34" charset="0"/>
+                <a:ea typeface="Yu Gothic" pitchFamily="34" charset="-122"/>
+                <a:cs typeface="Yu Gothic" pitchFamily="34" charset="-120"/>
+              </a:rPr>
+              <a:t>官公庁案件・大手ガス会社との取引実績</a:t>
+            </a:r>
+            <a:endParaRPr lang="en-US" sz="980" dirty="0"/>
+          </a:p>
+          <a:p>
+            <a:pPr marL="342900" indent="-342900">
+              <a:spcAft>
+                <a:spcPts val="800"/>
+              </a:spcAft>
+              <a:buSzPct val="100000"/>
+              <a:buChar char="•"/>
+            </a:pPr>
+            <a:r>
+              <a:rPr lang="en-US" sz="980" dirty="0">
+                <a:solidFill>
+                  <a:srgbClr val="374151"/>
+                </a:solidFill>
+                <a:latin typeface="Yu Gothic" pitchFamily="34" charset="0"/>
+                <a:ea typeface="Yu Gothic" pitchFamily="34" charset="-122"/>
+                <a:cs typeface="Yu Gothic" pitchFamily="34" charset="-120"/>
+              </a:rPr>
+              <a:t>AIに代替されない技術=10年後もなくならない仕事という視点</a:t>
+            </a:r>
+            <a:endParaRPr lang="en-US" sz="980" dirty="0"/>
+          </a:p>
+          <a:p>
+            <a:pPr marL="342900" indent="-342900">
+              <a:spcAft>
+                <a:spcPts val="800"/>
+              </a:spcAft>
+              <a:buSzPct val="100000"/>
+              <a:buChar char="•"/>
+            </a:pPr>
+            <a:r>
+              <a:rPr lang="en-US" sz="980" dirty="0">
+                <a:solidFill>
+                  <a:srgbClr val="374151"/>
+                </a:solidFill>
+                <a:latin typeface="Yu Gothic" pitchFamily="34" charset="0"/>
+                <a:ea typeface="Yu Gothic" pitchFamily="34" charset="-122"/>
+                <a:cs typeface="Yu Gothic" pitchFamily="34" charset="-120"/>
+              </a:rPr>
+              <a:t>社員1人あたり資格11点以上・資格取得実績の見える化</a:t>
+            </a:r>
+            <a:endParaRPr lang="en-US" sz="980" dirty="0"/>
+          </a:p>
+        </p:txBody>
+      </p:sp>
+      <p:sp>
+        <p:nvSpPr>
+          <p:cNvPr id="17" name="Shape 15"/>
+          <p:cNvSpPr/>
+          <p:nvPr/>
+        </p:nvSpPr>
+        <p:spPr>
+          <a:xfrm>
+            <a:off x="548640" y="5577840"/>
+            <a:ext cx="11109960" cy="914400"/>
+          </a:xfrm>
+          <a:prstGeom prst="roundRect">
+            <a:avLst>
+              <a:gd name="adj" fmla="val 8000"/>
+            </a:avLst>
+          </a:prstGeom>
+          <a:solidFill>
+            <a:srgbClr val="1B3A5C"/>
+          </a:solidFill>
+          <a:ln/>
+        </p:spPr>
+      </p:sp>
+      <p:sp>
+        <p:nvSpPr>
+          <p:cNvPr id="18" name="Text 16"/>
+          <p:cNvSpPr/>
+          <p:nvPr/>
+        </p:nvSpPr>
+        <p:spPr>
+          <a:xfrm>
+            <a:off x="777240" y="5687568"/>
+            <a:ext cx="10698480" cy="731520"/>
+          </a:xfrm>
+          <a:prstGeom prst="rect">
+            <a:avLst/>
+          </a:prstGeom>
+          <a:noFill/>
+          <a:ln/>
+        </p:spPr>
+        <p:txBody>
+          <a:bodyPr wrap="square" lIns="0" tIns="0" rIns="0" bIns="0" rtlCol="0" anchor="t"/>
+          <a:lstStyle/>
+          <a:p>
+            <a:pPr indent="0" marL="0">
+              <a:buNone/>
+            </a:pPr>
+            <a:r>
+              <a:rPr lang="en-US" sz="1000" b="1" dirty="0">
+                <a:solidFill>
+                  <a:srgbClr val="E8762C"/>
+                </a:solidFill>
+                <a:latin typeface="Yu Gothic" pitchFamily="34" charset="0"/>
+                <a:ea typeface="Yu Gothic" pitchFamily="34" charset="-122"/>
+                <a:cs typeface="Yu Gothic" pitchFamily="34" charset="-120"/>
+              </a:rPr>
+              <a:t>参考事例: </a:t>
+            </a:r>
+            <a:pPr indent="0" marL="0">
+              <a:buNone/>
+            </a:pPr>
+            <a:r>
+              <a:rPr lang="en-US" sz="1000" dirty="0">
+                <a:solidFill>
+                  <a:srgbClr val="CADCFC"/>
+                </a:solidFill>
+                <a:latin typeface="Yu Gothic" pitchFamily="34" charset="0"/>
+                <a:ea typeface="Yu Gothic" pitchFamily="34" charset="-122"/>
+                <a:cs typeface="Yu Gothic" pitchFamily="34" charset="-120"/>
+              </a:rPr>
+              <a:t>採用サイト分析(HP制作会社と実施)では「画面の70%以上を写真に」「トップに社員の笑顔写真」を置いた企業や、現場の「泥臭さ」をあえて見せた採用サイトが応募獲得に成功。自社でもX投稿が250万ビューを2回記録しており、リアルな発信が届く土壌は実証済み ─ これをInstagram・HPで「共感・安心・安定」に整えて展開します。</a:t>
+            </a:r>
+            <a:endParaRPr lang="en-US" sz="1000" dirty="0"/>
+          </a:p>
+        </p:txBody>
+      </p:sp>
+    </p:spTree>
+  </p:cSld>
+  <p:clrMapOvr>
+    <a:masterClrMapping/>
+  </p:clrMapOvr>
+</p:sld>
+</file>
+
+<file path=ppt/slides/slide16.xml><?xml version="1.0" encoding="utf-8"?>
+<p:sld xmlns:a="http://schemas.openxmlformats.org/drawingml/2006/main" xmlns:r="http://schemas.openxmlformats.org/officeDocument/2006/relationships" xmlns:p="http://schemas.openxmlformats.org/presentationml/2006/main">
+  <p:cSld name="Slide 16">
+    <p:bg>
+      <p:bgPr>
+        <a:solidFill>
+          <a:srgbClr val="FFFFFF"/>
+        </a:solidFill>
+      </p:bgPr>
+    </p:bg>
+    <p:spTree>
+      <p:nvGrpSpPr>
+        <p:cNvPr id="1" name=""/>
+        <p:cNvGrpSpPr/>
+        <p:nvPr/>
+      </p:nvGrpSpPr>
+      <p:grpSpPr>
+        <a:xfrm>
+          <a:off x="0" y="0"/>
+          <a:ext cx="0" cy="0"/>
+          <a:chOff x="0" y="0"/>
+          <a:chExt cx="0" cy="0"/>
+        </a:xfrm>
+      </p:grpSpPr>
+      <p:sp>
+        <p:nvSpPr>
+          <p:cNvPr id="2" name="Text 0"/>
+          <p:cNvSpPr/>
+          <p:nvPr/>
+        </p:nvSpPr>
+        <p:spPr>
+          <a:xfrm>
+            <a:off x="548640" y="292608"/>
+            <a:ext cx="9601200" cy="685800"/>
+          </a:xfrm>
+          <a:prstGeom prst="rect">
+            <a:avLst/>
+          </a:prstGeom>
+          <a:noFill/>
+          <a:ln/>
+        </p:spPr>
+        <p:txBody>
+          <a:bodyPr wrap="square" lIns="0" tIns="0" rIns="0" bIns="0" rtlCol="0" anchor="ctr"/>
+          <a:lstStyle/>
+          <a:p>
+            <a:pPr indent="0" marL="0">
+              <a:buNone/>
+            </a:pPr>
+            <a:r>
+              <a:rPr lang="en-US" sz="3000" b="1" dirty="0">
+                <a:solidFill>
+                  <a:srgbClr val="1B3A5C"/>
+                </a:solidFill>
+                <a:latin typeface="Yu Gothic" pitchFamily="34" charset="0"/>
+                <a:ea typeface="Yu Gothic" pitchFamily="34" charset="-122"/>
+                <a:cs typeface="Yu Gothic" pitchFamily="34" charset="-120"/>
+              </a:rPr>
+              <a:t>課題③ 求職者との直接接点の不足</a:t>
+            </a:r>
+            <a:endParaRPr lang="en-US" sz="3000" dirty="0"/>
+          </a:p>
+        </p:txBody>
+      </p:sp>
+      <p:sp>
+        <p:nvSpPr>
+          <p:cNvPr id="3" name="Text 1"/>
+          <p:cNvSpPr/>
+          <p:nvPr/>
+        </p:nvSpPr>
+        <p:spPr>
+          <a:xfrm>
+            <a:off x="566928" y="932688"/>
+            <a:ext cx="10515600" cy="365760"/>
+          </a:xfrm>
+          <a:prstGeom prst="rect">
+            <a:avLst/>
+          </a:prstGeom>
+          <a:noFill/>
+          <a:ln/>
+        </p:spPr>
+        <p:txBody>
+          <a:bodyPr wrap="square" lIns="0" tIns="0" rIns="0" bIns="0" rtlCol="0" anchor="ctr"/>
+          <a:lstStyle/>
+          <a:p>
+            <a:pPr indent="0" marL="0">
+              <a:buNone/>
+            </a:pPr>
+            <a:r>
+              <a:rPr lang="en-US" sz="1300" dirty="0">
+                <a:solidFill>
+                  <a:srgbClr val="6B7280"/>
+                </a:solidFill>
+                <a:latin typeface="Yu Gothic" pitchFamily="34" charset="0"/>
+                <a:ea typeface="Yu Gothic" pitchFamily="34" charset="-122"/>
+                <a:cs typeface="Yu Gothic" pitchFamily="34" charset="-120"/>
+              </a:rPr>
+              <a:t>情報の不透明性を補う最短ルートは「直接会って話す」こと ─ 集客は他社の力を借りる</a:t>
+            </a:r>
+            <a:endParaRPr lang="en-US" sz="1300" dirty="0"/>
+          </a:p>
+        </p:txBody>
+      </p:sp>
+      <p:sp>
+        <p:nvSpPr>
+          <p:cNvPr id="4" name="Text 2"/>
+          <p:cNvSpPr/>
+          <p:nvPr/>
+        </p:nvSpPr>
+        <p:spPr>
+          <a:xfrm>
+            <a:off x="11292840" y="320040"/>
+            <a:ext cx="640080" cy="457200"/>
+          </a:xfrm>
+          <a:prstGeom prst="rect">
+            <a:avLst/>
+          </a:prstGeom>
+          <a:noFill/>
+          <a:ln/>
+        </p:spPr>
+        <p:txBody>
+          <a:bodyPr wrap="square" lIns="0" tIns="0" rIns="0" bIns="0" rtlCol="0" anchor="ctr"/>
+          <a:lstStyle/>
+          <a:p>
+            <a:pPr algn="r" indent="0" marL="0">
+              <a:buNone/>
+            </a:pPr>
+            <a:r>
+              <a:rPr lang="en-US" sz="1600" b="1" dirty="0">
+                <a:solidFill>
+                  <a:srgbClr val="5A7A99"/>
+                </a:solidFill>
+                <a:latin typeface="Arial" pitchFamily="34" charset="0"/>
+                <a:ea typeface="Arial" pitchFamily="34" charset="-122"/>
+                <a:cs typeface="Arial" pitchFamily="34" charset="-120"/>
+              </a:rPr>
+              <a:t>16</a:t>
+            </a:r>
+            <a:endParaRPr lang="en-US" sz="1600" dirty="0"/>
+          </a:p>
+        </p:txBody>
+      </p:sp>
+      <p:sp>
+        <p:nvSpPr>
           <p:cNvPr id="5" name="Text 3"/>
           <p:cNvSpPr/>
           <p:nvPr/>
@@ -8746,7 +9677,7 @@
       </p:sp>
       <p:graphicFrame>
         <p:nvGraphicFramePr>
-          <p:cNvPr id="16" name="Table 0"/>
+          <p:cNvPr id="17" name="Table 0"/>
           <p:cNvGraphicFramePr>
             <a:graphicFrameLocks noGrp="1"/>
           </p:cNvGraphicFramePr>
@@ -10099,1025 +11030,6 @@
 </p:sld>
 </file>
 
-<file path=ppt/slides/slide16.xml><?xml version="1.0" encoding="utf-8"?>
-<p:sld xmlns:a="http://schemas.openxmlformats.org/drawingml/2006/main" xmlns:r="http://schemas.openxmlformats.org/officeDocument/2006/relationships" xmlns:p="http://schemas.openxmlformats.org/presentationml/2006/main">
-  <p:cSld name="Slide 16">
-    <p:bg>
-      <p:bgPr>
-        <a:solidFill>
-          <a:srgbClr val="FFFFFF"/>
-        </a:solidFill>
-      </p:bgPr>
-    </p:bg>
-    <p:spTree>
-      <p:nvGrpSpPr>
-        <p:cNvPr id="1" name=""/>
-        <p:cNvGrpSpPr/>
-        <p:nvPr/>
-      </p:nvGrpSpPr>
-      <p:grpSpPr>
-        <a:xfrm>
-          <a:off x="0" y="0"/>
-          <a:ext cx="0" cy="0"/>
-          <a:chOff x="0" y="0"/>
-          <a:chExt cx="0" cy="0"/>
-        </a:xfrm>
-      </p:grpSpPr>
-      <p:sp>
-        <p:nvSpPr>
-          <p:cNvPr id="2" name="Text 0"/>
-          <p:cNvSpPr/>
-          <p:nvPr/>
-        </p:nvSpPr>
-        <p:spPr>
-          <a:xfrm>
-            <a:off x="548640" y="292608"/>
-            <a:ext cx="9601200" cy="685800"/>
-          </a:xfrm>
-          <a:prstGeom prst="rect">
-            <a:avLst/>
-          </a:prstGeom>
-          <a:noFill/>
-          <a:ln/>
-        </p:spPr>
-        <p:txBody>
-          <a:bodyPr wrap="square" lIns="0" tIns="0" rIns="0" bIns="0" rtlCol="0" anchor="ctr"/>
-          <a:lstStyle/>
-          <a:p>
-            <a:pPr indent="0" marL="0">
-              <a:buNone/>
-            </a:pPr>
-            <a:r>
-              <a:rPr lang="en-US" sz="3000" b="1" dirty="0">
-                <a:solidFill>
-                  <a:srgbClr val="1B3A5C"/>
-                </a:solidFill>
-                <a:latin typeface="Yu Gothic" pitchFamily="34" charset="0"/>
-                <a:ea typeface="Yu Gothic" pitchFamily="34" charset="-122"/>
-                <a:cs typeface="Yu Gothic" pitchFamily="34" charset="-120"/>
-              </a:rPr>
-              <a:t>今後のご提言 ─ 3つの課題に対応する打ち手</a:t>
-            </a:r>
-            <a:endParaRPr lang="en-US" sz="3000" dirty="0"/>
-          </a:p>
-        </p:txBody>
-      </p:sp>
-      <p:sp>
-        <p:nvSpPr>
-          <p:cNvPr id="3" name="Text 1"/>
-          <p:cNvSpPr/>
-          <p:nvPr/>
-        </p:nvSpPr>
-        <p:spPr>
-          <a:xfrm>
-            <a:off x="566928" y="932688"/>
-            <a:ext cx="10515600" cy="365760"/>
-          </a:xfrm>
-          <a:prstGeom prst="rect">
-            <a:avLst/>
-          </a:prstGeom>
-          <a:noFill/>
-          <a:ln/>
-        </p:spPr>
-        <p:txBody>
-          <a:bodyPr wrap="square" lIns="0" tIns="0" rIns="0" bIns="0" rtlCol="0" anchor="ctr"/>
-          <a:lstStyle/>
-          <a:p>
-            <a:pPr indent="0" marL="0">
-              <a:buNone/>
-            </a:pPr>
-            <a:r>
-              <a:rPr lang="en-US" sz="1300" dirty="0">
-                <a:solidFill>
-                  <a:srgbClr val="6B7280"/>
-                </a:solidFill>
-                <a:latin typeface="Yu Gothic" pitchFamily="34" charset="0"/>
-                <a:ea typeface="Yu Gothic" pitchFamily="34" charset="-122"/>
-                <a:cs typeface="Yu Gothic" pitchFamily="34" charset="-120"/>
-              </a:rPr>
-              <a:t>8月以降の転職市場再活性化(ピーク:9〜10月)を最大限に活かすために</a:t>
-            </a:r>
-            <a:endParaRPr lang="en-US" sz="1300" dirty="0"/>
-          </a:p>
-        </p:txBody>
-      </p:sp>
-      <p:sp>
-        <p:nvSpPr>
-          <p:cNvPr id="4" name="Text 2"/>
-          <p:cNvSpPr/>
-          <p:nvPr/>
-        </p:nvSpPr>
-        <p:spPr>
-          <a:xfrm>
-            <a:off x="11292840" y="320040"/>
-            <a:ext cx="640080" cy="457200"/>
-          </a:xfrm>
-          <a:prstGeom prst="rect">
-            <a:avLst/>
-          </a:prstGeom>
-          <a:noFill/>
-          <a:ln/>
-        </p:spPr>
-        <p:txBody>
-          <a:bodyPr wrap="square" lIns="0" tIns="0" rIns="0" bIns="0" rtlCol="0" anchor="ctr"/>
-          <a:lstStyle/>
-          <a:p>
-            <a:pPr algn="r" indent="0" marL="0">
-              <a:buNone/>
-            </a:pPr>
-            <a:r>
-              <a:rPr lang="en-US" sz="1600" b="1" dirty="0">
-                <a:solidFill>
-                  <a:srgbClr val="5A7A99"/>
-                </a:solidFill>
-                <a:latin typeface="Arial" pitchFamily="34" charset="0"/>
-                <a:ea typeface="Arial" pitchFamily="34" charset="-122"/>
-                <a:cs typeface="Arial" pitchFamily="34" charset="-120"/>
-              </a:rPr>
-              <a:t>16</a:t>
-            </a:r>
-            <a:endParaRPr lang="en-US" sz="1600" dirty="0"/>
-          </a:p>
-        </p:txBody>
-      </p:sp>
-      <p:sp>
-        <p:nvSpPr>
-          <p:cNvPr id="5" name="Shape 3"/>
-          <p:cNvSpPr/>
-          <p:nvPr/>
-        </p:nvSpPr>
-        <p:spPr>
-          <a:xfrm>
-            <a:off x="594360" y="1609344"/>
-            <a:ext cx="384048" cy="384048"/>
-          </a:xfrm>
-          <a:prstGeom prst="ellipse">
-            <a:avLst/>
-          </a:prstGeom>
-          <a:solidFill>
-            <a:srgbClr val="E8762C"/>
-          </a:solidFill>
-          <a:ln/>
-        </p:spPr>
-      </p:sp>
-      <p:sp>
-        <p:nvSpPr>
-          <p:cNvPr id="6" name="Text 4"/>
-          <p:cNvSpPr/>
-          <p:nvPr/>
-        </p:nvSpPr>
-        <p:spPr>
-          <a:xfrm>
-            <a:off x="594360" y="1604772"/>
-            <a:ext cx="384048" cy="384048"/>
-          </a:xfrm>
-          <a:prstGeom prst="rect">
-            <a:avLst/>
-          </a:prstGeom>
-          <a:noFill/>
-          <a:ln/>
-        </p:spPr>
-        <p:txBody>
-          <a:bodyPr wrap="square" lIns="0" tIns="0" rIns="0" bIns="0" rtlCol="0" anchor="ctr"/>
-          <a:lstStyle/>
-          <a:p>
-            <a:pPr algn="ctr" indent="0" marL="0">
-              <a:buNone/>
-            </a:pPr>
-            <a:r>
-              <a:rPr lang="en-US" sz="1500" b="1" dirty="0">
-                <a:solidFill>
-                  <a:srgbClr val="FFFFFF"/>
-                </a:solidFill>
-                <a:latin typeface="Yu Gothic" pitchFamily="34" charset="0"/>
-                <a:ea typeface="Yu Gothic" pitchFamily="34" charset="-122"/>
-                <a:cs typeface="Yu Gothic" pitchFamily="34" charset="-120"/>
-              </a:rPr>
-              <a:t>1</a:t>
-            </a:r>
-            <a:endParaRPr lang="en-US" sz="1500" dirty="0"/>
-          </a:p>
-        </p:txBody>
-      </p:sp>
-      <p:sp>
-        <p:nvSpPr>
-          <p:cNvPr id="7" name="Shape 5"/>
-          <p:cNvSpPr/>
-          <p:nvPr/>
-        </p:nvSpPr>
-        <p:spPr>
-          <a:xfrm>
-            <a:off x="10561320" y="1591056"/>
-            <a:ext cx="1051560" cy="384048"/>
-          </a:xfrm>
-          <a:prstGeom prst="roundRect">
-            <a:avLst>
-              <a:gd name="adj" fmla="val 14286"/>
-            </a:avLst>
-          </a:prstGeom>
-          <a:solidFill>
-            <a:srgbClr val="FDF0E6"/>
-          </a:solidFill>
-          <a:ln/>
-        </p:spPr>
-      </p:sp>
-      <p:sp>
-        <p:nvSpPr>
-          <p:cNvPr id="8" name="Text 6"/>
-          <p:cNvSpPr/>
-          <p:nvPr/>
-        </p:nvSpPr>
-        <p:spPr>
-          <a:xfrm>
-            <a:off x="10561320" y="1591056"/>
-            <a:ext cx="1051560" cy="384048"/>
-          </a:xfrm>
-          <a:prstGeom prst="rect">
-            <a:avLst/>
-          </a:prstGeom>
-          <a:noFill/>
-          <a:ln/>
-        </p:spPr>
-        <p:txBody>
-          <a:bodyPr wrap="square" lIns="0" tIns="0" rIns="0" bIns="0" rtlCol="0" anchor="ctr"/>
-          <a:lstStyle/>
-          <a:p>
-            <a:pPr algn="ctr" indent="0" marL="0">
-              <a:buNone/>
-            </a:pPr>
-            <a:r>
-              <a:rPr lang="en-US" sz="950" b="1" dirty="0">
-                <a:solidFill>
-                  <a:srgbClr val="B45309"/>
-                </a:solidFill>
-                <a:latin typeface="Yu Gothic" pitchFamily="34" charset="0"/>
-                <a:ea typeface="Yu Gothic" pitchFamily="34" charset="-122"/>
-                <a:cs typeface="Yu Gothic" pitchFamily="34" charset="-120"/>
-              </a:rPr>
-              <a:t>課題②対応</a:t>
-            </a:r>
-            <a:endParaRPr lang="en-US" sz="950" dirty="0"/>
-          </a:p>
-        </p:txBody>
-      </p:sp>
-      <p:sp>
-        <p:nvSpPr>
-          <p:cNvPr id="9" name="Text 7"/>
-          <p:cNvSpPr/>
-          <p:nvPr/>
-        </p:nvSpPr>
-        <p:spPr>
-          <a:xfrm>
-            <a:off x="1188720" y="1536192"/>
-            <a:ext cx="9235440" cy="914400"/>
-          </a:xfrm>
-          <a:prstGeom prst="rect">
-            <a:avLst/>
-          </a:prstGeom>
-          <a:noFill/>
-          <a:ln/>
-        </p:spPr>
-        <p:txBody>
-          <a:bodyPr wrap="square" lIns="0" tIns="0" rIns="0" bIns="0" rtlCol="0" anchor="t"/>
-          <a:lstStyle/>
-          <a:p>
-            <a:pPr indent="0" marL="0">
-              <a:buNone/>
-            </a:pPr>
-            <a:r>
-              <a:rPr lang="en-US" sz="1300" b="1" dirty="0">
-                <a:solidFill>
-                  <a:srgbClr val="1B3A5C"/>
-                </a:solidFill>
-                <a:latin typeface="Yu Gothic" pitchFamily="34" charset="0"/>
-                <a:ea typeface="Yu Gothic" pitchFamily="34" charset="-122"/>
-                <a:cs typeface="Yu Gothic" pitchFamily="34" charset="-120"/>
-              </a:rPr>
-              <a:t>採用HPリニューアル+Instagramで「情報の透明性」を確保
-</a:t>
-            </a:r>
-            <a:pPr indent="0" marL="0">
-              <a:buNone/>
-            </a:pPr>
-            <a:r>
-              <a:rPr lang="en-US" sz="1100" dirty="0">
-                <a:solidFill>
-                  <a:srgbClr val="374151"/>
-                </a:solidFill>
-                <a:latin typeface="Yu Gothic" pitchFamily="34" charset="0"/>
-                <a:ea typeface="Yu Gothic" pitchFamily="34" charset="-122"/>
-                <a:cs typeface="Yu Gothic" pitchFamily="34" charset="-120"/>
-              </a:rPr>
-              <a:t>「働き方・業務内容・どんな人が働いているか」を軸に発信を強化。リニューアルHP(お盆前完了予定)とInstagramを紐付け、求人から裏付けを取りに来た求職者が必ず情報に辿り着ける状態をつくる</a:t>
-            </a:r>
-            <a:endParaRPr lang="en-US" sz="1300" dirty="0"/>
-          </a:p>
-        </p:txBody>
-      </p:sp>
-      <p:sp>
-        <p:nvSpPr>
-          <p:cNvPr id="10" name="Shape 8"/>
-          <p:cNvSpPr/>
-          <p:nvPr/>
-        </p:nvSpPr>
-        <p:spPr>
-          <a:xfrm>
-            <a:off x="594360" y="2542032"/>
-            <a:ext cx="384048" cy="384048"/>
-          </a:xfrm>
-          <a:prstGeom prst="ellipse">
-            <a:avLst/>
-          </a:prstGeom>
-          <a:solidFill>
-            <a:srgbClr val="E8762C"/>
-          </a:solidFill>
-          <a:ln/>
-        </p:spPr>
-      </p:sp>
-      <p:sp>
-        <p:nvSpPr>
-          <p:cNvPr id="11" name="Text 9"/>
-          <p:cNvSpPr/>
-          <p:nvPr/>
-        </p:nvSpPr>
-        <p:spPr>
-          <a:xfrm>
-            <a:off x="594360" y="2537460"/>
-            <a:ext cx="384048" cy="384048"/>
-          </a:xfrm>
-          <a:prstGeom prst="rect">
-            <a:avLst/>
-          </a:prstGeom>
-          <a:noFill/>
-          <a:ln/>
-        </p:spPr>
-        <p:txBody>
-          <a:bodyPr wrap="square" lIns="0" tIns="0" rIns="0" bIns="0" rtlCol="0" anchor="ctr"/>
-          <a:lstStyle/>
-          <a:p>
-            <a:pPr algn="ctr" indent="0" marL="0">
-              <a:buNone/>
-            </a:pPr>
-            <a:r>
-              <a:rPr lang="en-US" sz="1500" b="1" dirty="0">
-                <a:solidFill>
-                  <a:srgbClr val="FFFFFF"/>
-                </a:solidFill>
-                <a:latin typeface="Yu Gothic" pitchFamily="34" charset="0"/>
-                <a:ea typeface="Yu Gothic" pitchFamily="34" charset="-122"/>
-                <a:cs typeface="Yu Gothic" pitchFamily="34" charset="-120"/>
-              </a:rPr>
-              <a:t>2</a:t>
-            </a:r>
-            <a:endParaRPr lang="en-US" sz="1500" dirty="0"/>
-          </a:p>
-        </p:txBody>
-      </p:sp>
-      <p:sp>
-        <p:nvSpPr>
-          <p:cNvPr id="12" name="Shape 10"/>
-          <p:cNvSpPr/>
-          <p:nvPr/>
-        </p:nvSpPr>
-        <p:spPr>
-          <a:xfrm>
-            <a:off x="10561320" y="2523744"/>
-            <a:ext cx="1051560" cy="384048"/>
-          </a:xfrm>
-          <a:prstGeom prst="roundRect">
-            <a:avLst>
-              <a:gd name="adj" fmla="val 14286"/>
-            </a:avLst>
-          </a:prstGeom>
-          <a:solidFill>
-            <a:srgbClr val="FDF0E6"/>
-          </a:solidFill>
-          <a:ln/>
-        </p:spPr>
-      </p:sp>
-      <p:sp>
-        <p:nvSpPr>
-          <p:cNvPr id="13" name="Text 11"/>
-          <p:cNvSpPr/>
-          <p:nvPr/>
-        </p:nvSpPr>
-        <p:spPr>
-          <a:xfrm>
-            <a:off x="10561320" y="2523744"/>
-            <a:ext cx="1051560" cy="384048"/>
-          </a:xfrm>
-          <a:prstGeom prst="rect">
-            <a:avLst/>
-          </a:prstGeom>
-          <a:noFill/>
-          <a:ln/>
-        </p:spPr>
-        <p:txBody>
-          <a:bodyPr wrap="square" lIns="0" tIns="0" rIns="0" bIns="0" rtlCol="0" anchor="ctr"/>
-          <a:lstStyle/>
-          <a:p>
-            <a:pPr algn="ctr" indent="0" marL="0">
-              <a:buNone/>
-            </a:pPr>
-            <a:r>
-              <a:rPr lang="en-US" sz="950" b="1" dirty="0">
-                <a:solidFill>
-                  <a:srgbClr val="B45309"/>
-                </a:solidFill>
-                <a:latin typeface="Yu Gothic" pitchFamily="34" charset="0"/>
-                <a:ea typeface="Yu Gothic" pitchFamily="34" charset="-122"/>
-                <a:cs typeface="Yu Gothic" pitchFamily="34" charset="-120"/>
-              </a:rPr>
-              <a:t>課題③対応</a:t>
-            </a:r>
-            <a:endParaRPr lang="en-US" sz="950" dirty="0"/>
-          </a:p>
-        </p:txBody>
-      </p:sp>
-      <p:sp>
-        <p:nvSpPr>
-          <p:cNvPr id="14" name="Text 12"/>
-          <p:cNvSpPr/>
-          <p:nvPr/>
-        </p:nvSpPr>
-        <p:spPr>
-          <a:xfrm>
-            <a:off x="1188720" y="2468880"/>
-            <a:ext cx="9235440" cy="914400"/>
-          </a:xfrm>
-          <a:prstGeom prst="rect">
-            <a:avLst/>
-          </a:prstGeom>
-          <a:noFill/>
-          <a:ln/>
-        </p:spPr>
-        <p:txBody>
-          <a:bodyPr wrap="square" lIns="0" tIns="0" rIns="0" bIns="0" rtlCol="0" anchor="t"/>
-          <a:lstStyle/>
-          <a:p>
-            <a:pPr indent="0" marL="0">
-              <a:buNone/>
-            </a:pPr>
-            <a:r>
-              <a:rPr lang="en-US" sz="1300" b="1" dirty="0">
-                <a:solidFill>
-                  <a:srgbClr val="1B3A5C"/>
-                </a:solidFill>
-                <a:latin typeface="Yu Gothic" pitchFamily="34" charset="0"/>
-                <a:ea typeface="Yu Gothic" pitchFamily="34" charset="-122"/>
-                <a:cs typeface="Yu Gothic" pitchFamily="34" charset="-120"/>
-              </a:rPr>
-              <a:t>他社集客型イベントで求職者と直接交流
-</a:t>
-            </a:r>
-            <a:pPr indent="0" marL="0">
-              <a:buNone/>
-            </a:pPr>
-            <a:r>
-              <a:rPr lang="en-US" sz="1100" dirty="0">
-                <a:solidFill>
-                  <a:srgbClr val="374151"/>
-                </a:solidFill>
-                <a:latin typeface="Yu Gothic" pitchFamily="34" charset="0"/>
-                <a:ea typeface="Yu Gothic" pitchFamily="34" charset="-122"/>
-                <a:cs typeface="Yu Gothic" pitchFamily="34" charset="-120"/>
-              </a:rPr>
-              <a:t>ハローワーク説明会(8/28以降予約可)と、マイナビ転職フェア富山(10月・1月、20〜30代来場中心)等の合同説明会に参加。自社集客に依存せず、対面交流で情報不足への不安を解消する</a:t>
-            </a:r>
-            <a:endParaRPr lang="en-US" sz="1300" dirty="0"/>
-          </a:p>
-        </p:txBody>
-      </p:sp>
-      <p:sp>
-        <p:nvSpPr>
-          <p:cNvPr id="15" name="Shape 13"/>
-          <p:cNvSpPr/>
-          <p:nvPr/>
-        </p:nvSpPr>
-        <p:spPr>
-          <a:xfrm>
-            <a:off x="594360" y="3474720"/>
-            <a:ext cx="384048" cy="384048"/>
-          </a:xfrm>
-          <a:prstGeom prst="ellipse">
-            <a:avLst/>
-          </a:prstGeom>
-          <a:solidFill>
-            <a:srgbClr val="E8762C"/>
-          </a:solidFill>
-          <a:ln/>
-        </p:spPr>
-      </p:sp>
-      <p:sp>
-        <p:nvSpPr>
-          <p:cNvPr id="16" name="Text 14"/>
-          <p:cNvSpPr/>
-          <p:nvPr/>
-        </p:nvSpPr>
-        <p:spPr>
-          <a:xfrm>
-            <a:off x="594360" y="3470148"/>
-            <a:ext cx="384048" cy="384048"/>
-          </a:xfrm>
-          <a:prstGeom prst="rect">
-            <a:avLst/>
-          </a:prstGeom>
-          <a:noFill/>
-          <a:ln/>
-        </p:spPr>
-        <p:txBody>
-          <a:bodyPr wrap="square" lIns="0" tIns="0" rIns="0" bIns="0" rtlCol="0" anchor="ctr"/>
-          <a:lstStyle/>
-          <a:p>
-            <a:pPr algn="ctr" indent="0" marL="0">
-              <a:buNone/>
-            </a:pPr>
-            <a:r>
-              <a:rPr lang="en-US" sz="1500" b="1" dirty="0">
-                <a:solidFill>
-                  <a:srgbClr val="FFFFFF"/>
-                </a:solidFill>
-                <a:latin typeface="Yu Gothic" pitchFamily="34" charset="0"/>
-                <a:ea typeface="Yu Gothic" pitchFamily="34" charset="-122"/>
-                <a:cs typeface="Yu Gothic" pitchFamily="34" charset="-120"/>
-              </a:rPr>
-              <a:t>3</a:t>
-            </a:r>
-            <a:endParaRPr lang="en-US" sz="1500" dirty="0"/>
-          </a:p>
-        </p:txBody>
-      </p:sp>
-      <p:sp>
-        <p:nvSpPr>
-          <p:cNvPr id="17" name="Shape 15"/>
-          <p:cNvSpPr/>
-          <p:nvPr/>
-        </p:nvSpPr>
-        <p:spPr>
-          <a:xfrm>
-            <a:off x="10561320" y="3456432"/>
-            <a:ext cx="1051560" cy="384048"/>
-          </a:xfrm>
-          <a:prstGeom prst="roundRect">
-            <a:avLst>
-              <a:gd name="adj" fmla="val 14286"/>
-            </a:avLst>
-          </a:prstGeom>
-          <a:solidFill>
-            <a:srgbClr val="FDF0E6"/>
-          </a:solidFill>
-          <a:ln/>
-        </p:spPr>
-      </p:sp>
-      <p:sp>
-        <p:nvSpPr>
-          <p:cNvPr id="18" name="Text 16"/>
-          <p:cNvSpPr/>
-          <p:nvPr/>
-        </p:nvSpPr>
-        <p:spPr>
-          <a:xfrm>
-            <a:off x="10561320" y="3456432"/>
-            <a:ext cx="1051560" cy="384048"/>
-          </a:xfrm>
-          <a:prstGeom prst="rect">
-            <a:avLst/>
-          </a:prstGeom>
-          <a:noFill/>
-          <a:ln/>
-        </p:spPr>
-        <p:txBody>
-          <a:bodyPr wrap="square" lIns="0" tIns="0" rIns="0" bIns="0" rtlCol="0" anchor="ctr"/>
-          <a:lstStyle/>
-          <a:p>
-            <a:pPr algn="ctr" indent="0" marL="0">
-              <a:buNone/>
-            </a:pPr>
-            <a:r>
-              <a:rPr lang="en-US" sz="950" b="1" dirty="0">
-                <a:solidFill>
-                  <a:srgbClr val="B45309"/>
-                </a:solidFill>
-                <a:latin typeface="Yu Gothic" pitchFamily="34" charset="0"/>
-                <a:ea typeface="Yu Gothic" pitchFamily="34" charset="-122"/>
-                <a:cs typeface="Yu Gothic" pitchFamily="34" charset="-120"/>
-              </a:rPr>
-              <a:t>課題①対応</a:t>
-            </a:r>
-            <a:endParaRPr lang="en-US" sz="950" dirty="0"/>
-          </a:p>
-        </p:txBody>
-      </p:sp>
-      <p:sp>
-        <p:nvSpPr>
-          <p:cNvPr id="19" name="Text 17"/>
-          <p:cNvSpPr/>
-          <p:nvPr/>
-        </p:nvSpPr>
-        <p:spPr>
-          <a:xfrm>
-            <a:off x="1188720" y="3401568"/>
-            <a:ext cx="9235440" cy="914400"/>
-          </a:xfrm>
-          <a:prstGeom prst="rect">
-            <a:avLst/>
-          </a:prstGeom>
-          <a:noFill/>
-          <a:ln/>
-        </p:spPr>
-        <p:txBody>
-          <a:bodyPr wrap="square" lIns="0" tIns="0" rIns="0" bIns="0" rtlCol="0" anchor="t"/>
-          <a:lstStyle/>
-          <a:p>
-            <a:pPr indent="0" marL="0">
-              <a:buNone/>
-            </a:pPr>
-            <a:r>
-              <a:rPr lang="en-US" sz="1300" b="1" dirty="0">
-                <a:solidFill>
-                  <a:srgbClr val="1B3A5C"/>
-                </a:solidFill>
-                <a:latin typeface="Yu Gothic" pitchFamily="34" charset="0"/>
-                <a:ea typeface="Yu Gothic" pitchFamily="34" charset="-122"/>
-                <a:cs typeface="Yu Gothic" pitchFamily="34" charset="-120"/>
-              </a:rPr>
-              <a:t>未経験×20・30代への注力を継続
-</a:t>
-            </a:r>
-            <a:pPr indent="0" marL="0">
-              <a:buNone/>
-            </a:pPr>
-            <a:r>
-              <a:rPr lang="en-US" sz="1100" dirty="0">
-                <a:solidFill>
-                  <a:srgbClr val="374151"/>
-                </a:solidFill>
-                <a:latin typeface="Yu Gothic" pitchFamily="34" charset="0"/>
-                <a:ea typeface="Yu Gothic" pitchFamily="34" charset="-122"/>
-                <a:cs typeface="Yu Gothic" pitchFamily="34" charset="-120"/>
-              </a:rPr>
-              <a:t>経験者市場は構造的に小さいことが検証で判明済み。「オタク気質×AI」訴求と未経験育成(資格全額支援・3年で一人前)を前面に、未経験採用に投資を集中する</a:t>
-            </a:r>
-            <a:endParaRPr lang="en-US" sz="1300" dirty="0"/>
-          </a:p>
-        </p:txBody>
-      </p:sp>
-      <p:sp>
-        <p:nvSpPr>
-          <p:cNvPr id="20" name="Shape 18"/>
-          <p:cNvSpPr/>
-          <p:nvPr/>
-        </p:nvSpPr>
-        <p:spPr>
-          <a:xfrm>
-            <a:off x="594360" y="4407408"/>
-            <a:ext cx="384048" cy="384048"/>
-          </a:xfrm>
-          <a:prstGeom prst="ellipse">
-            <a:avLst/>
-          </a:prstGeom>
-          <a:solidFill>
-            <a:srgbClr val="5A7A99"/>
-          </a:solidFill>
-          <a:ln/>
-        </p:spPr>
-      </p:sp>
-      <p:sp>
-        <p:nvSpPr>
-          <p:cNvPr id="21" name="Text 19"/>
-          <p:cNvSpPr/>
-          <p:nvPr/>
-        </p:nvSpPr>
-        <p:spPr>
-          <a:xfrm>
-            <a:off x="594360" y="4402836"/>
-            <a:ext cx="384048" cy="384048"/>
-          </a:xfrm>
-          <a:prstGeom prst="rect">
-            <a:avLst/>
-          </a:prstGeom>
-          <a:noFill/>
-          <a:ln/>
-        </p:spPr>
-        <p:txBody>
-          <a:bodyPr wrap="square" lIns="0" tIns="0" rIns="0" bIns="0" rtlCol="0" anchor="ctr"/>
-          <a:lstStyle/>
-          <a:p>
-            <a:pPr algn="ctr" indent="0" marL="0">
-              <a:buNone/>
-            </a:pPr>
-            <a:r>
-              <a:rPr lang="en-US" sz="1500" b="1" dirty="0">
-                <a:solidFill>
-                  <a:srgbClr val="FFFFFF"/>
-                </a:solidFill>
-                <a:latin typeface="Yu Gothic" pitchFamily="34" charset="0"/>
-                <a:ea typeface="Yu Gothic" pitchFamily="34" charset="-122"/>
-                <a:cs typeface="Yu Gothic" pitchFamily="34" charset="-120"/>
-              </a:rPr>
-              <a:t>4</a:t>
-            </a:r>
-            <a:endParaRPr lang="en-US" sz="1500" dirty="0"/>
-          </a:p>
-        </p:txBody>
-      </p:sp>
-      <p:sp>
-        <p:nvSpPr>
-          <p:cNvPr id="22" name="Shape 20"/>
-          <p:cNvSpPr/>
-          <p:nvPr/>
-        </p:nvSpPr>
-        <p:spPr>
-          <a:xfrm>
-            <a:off x="10561320" y="4389120"/>
-            <a:ext cx="1051560" cy="384048"/>
-          </a:xfrm>
-          <a:prstGeom prst="roundRect">
-            <a:avLst>
-              <a:gd name="adj" fmla="val 14286"/>
-            </a:avLst>
-          </a:prstGeom>
-          <a:solidFill>
-            <a:srgbClr val="E5E7EB"/>
-          </a:solidFill>
-          <a:ln/>
-        </p:spPr>
-      </p:sp>
-      <p:sp>
-        <p:nvSpPr>
-          <p:cNvPr id="23" name="Text 21"/>
-          <p:cNvSpPr/>
-          <p:nvPr/>
-        </p:nvSpPr>
-        <p:spPr>
-          <a:xfrm>
-            <a:off x="10561320" y="4389120"/>
-            <a:ext cx="1051560" cy="384048"/>
-          </a:xfrm>
-          <a:prstGeom prst="rect">
-            <a:avLst/>
-          </a:prstGeom>
-          <a:noFill/>
-          <a:ln/>
-        </p:spPr>
-        <p:txBody>
-          <a:bodyPr wrap="square" lIns="0" tIns="0" rIns="0" bIns="0" rtlCol="0" anchor="ctr"/>
-          <a:lstStyle/>
-          <a:p>
-            <a:pPr algn="ctr" indent="0" marL="0">
-              <a:buNone/>
-            </a:pPr>
-            <a:r>
-              <a:rPr lang="en-US" sz="950" b="1" dirty="0">
-                <a:solidFill>
-                  <a:srgbClr val="6B7280"/>
-                </a:solidFill>
-                <a:latin typeface="Yu Gothic" pitchFamily="34" charset="0"/>
-                <a:ea typeface="Yu Gothic" pitchFamily="34" charset="-122"/>
-                <a:cs typeface="Yu Gothic" pitchFamily="34" charset="-120"/>
-              </a:rPr>
-              <a:t>補強対応</a:t>
-            </a:r>
-            <a:endParaRPr lang="en-US" sz="950" dirty="0"/>
-          </a:p>
-        </p:txBody>
-      </p:sp>
-      <p:sp>
-        <p:nvSpPr>
-          <p:cNvPr id="24" name="Text 22"/>
-          <p:cNvSpPr/>
-          <p:nvPr/>
-        </p:nvSpPr>
-        <p:spPr>
-          <a:xfrm>
-            <a:off x="1188720" y="4334256"/>
-            <a:ext cx="9235440" cy="914400"/>
-          </a:xfrm>
-          <a:prstGeom prst="rect">
-            <a:avLst/>
-          </a:prstGeom>
-          <a:noFill/>
-          <a:ln/>
-        </p:spPr>
-        <p:txBody>
-          <a:bodyPr wrap="square" lIns="0" tIns="0" rIns="0" bIns="0" rtlCol="0" anchor="t"/>
-          <a:lstStyle/>
-          <a:p>
-            <a:pPr indent="0" marL="0">
-              <a:buNone/>
-            </a:pPr>
-            <a:r>
-              <a:rPr lang="en-US" sz="1300" b="1" dirty="0">
-                <a:solidFill>
-                  <a:srgbClr val="1B3A5C"/>
-                </a:solidFill>
-                <a:latin typeface="Yu Gothic" pitchFamily="34" charset="0"/>
-                <a:ea typeface="Yu Gothic" pitchFamily="34" charset="-122"/>
-                <a:cs typeface="Yu Gothic" pitchFamily="34" charset="-120"/>
-              </a:rPr>
-              <a:t>20〜30代の選考移行率の改善
-</a:t>
-            </a:r>
-            <a:pPr indent="0" marL="0">
-              <a:buNone/>
-            </a:pPr>
-            <a:r>
-              <a:rPr lang="en-US" sz="1100" dirty="0">
-                <a:solidFill>
-                  <a:srgbClr val="374151"/>
-                </a:solidFill>
-                <a:latin typeface="Yu Gothic" pitchFamily="34" charset="0"/>
-                <a:ea typeface="Yu Gothic" pitchFamily="34" charset="-122"/>
-                <a:cs typeface="Yu Gothic" pitchFamily="34" charset="-120"/>
-              </a:rPr>
-              <a:t>初回接触を固定電話→SMS→LINEの順で徹底し若手の連絡途絶を防止。オンライン説明会への誘導を全応募者の標準フローにし、「応募→説明会参加」の移行率をKPIとして毎週計測</a:t>
-            </a:r>
-            <a:endParaRPr lang="en-US" sz="1300" dirty="0"/>
-          </a:p>
-        </p:txBody>
-      </p:sp>
-      <p:sp>
-        <p:nvSpPr>
-          <p:cNvPr id="25" name="Shape 23"/>
-          <p:cNvSpPr/>
-          <p:nvPr/>
-        </p:nvSpPr>
-        <p:spPr>
-          <a:xfrm>
-            <a:off x="594360" y="5340096"/>
-            <a:ext cx="384048" cy="384048"/>
-          </a:xfrm>
-          <a:prstGeom prst="ellipse">
-            <a:avLst/>
-          </a:prstGeom>
-          <a:solidFill>
-            <a:srgbClr val="5A7A99"/>
-          </a:solidFill>
-          <a:ln/>
-        </p:spPr>
-      </p:sp>
-      <p:sp>
-        <p:nvSpPr>
-          <p:cNvPr id="26" name="Text 24"/>
-          <p:cNvSpPr/>
-          <p:nvPr/>
-        </p:nvSpPr>
-        <p:spPr>
-          <a:xfrm>
-            <a:off x="594360" y="5335524"/>
-            <a:ext cx="384048" cy="384048"/>
-          </a:xfrm>
-          <a:prstGeom prst="rect">
-            <a:avLst/>
-          </a:prstGeom>
-          <a:noFill/>
-          <a:ln/>
-        </p:spPr>
-        <p:txBody>
-          <a:bodyPr wrap="square" lIns="0" tIns="0" rIns="0" bIns="0" rtlCol="0" anchor="ctr"/>
-          <a:lstStyle/>
-          <a:p>
-            <a:pPr algn="ctr" indent="0" marL="0">
-              <a:buNone/>
-            </a:pPr>
-            <a:r>
-              <a:rPr lang="en-US" sz="1500" b="1" dirty="0">
-                <a:solidFill>
-                  <a:srgbClr val="FFFFFF"/>
-                </a:solidFill>
-                <a:latin typeface="Yu Gothic" pitchFamily="34" charset="0"/>
-                <a:ea typeface="Yu Gothic" pitchFamily="34" charset="-122"/>
-                <a:cs typeface="Yu Gothic" pitchFamily="34" charset="-120"/>
-              </a:rPr>
-              <a:t>5</a:t>
-            </a:r>
-            <a:endParaRPr lang="en-US" sz="1500" dirty="0"/>
-          </a:p>
-        </p:txBody>
-      </p:sp>
-      <p:sp>
-        <p:nvSpPr>
-          <p:cNvPr id="27" name="Shape 25"/>
-          <p:cNvSpPr/>
-          <p:nvPr/>
-        </p:nvSpPr>
-        <p:spPr>
-          <a:xfrm>
-            <a:off x="10561320" y="5321808"/>
-            <a:ext cx="1051560" cy="384048"/>
-          </a:xfrm>
-          <a:prstGeom prst="roundRect">
-            <a:avLst>
-              <a:gd name="adj" fmla="val 14286"/>
-            </a:avLst>
-          </a:prstGeom>
-          <a:solidFill>
-            <a:srgbClr val="E5E7EB"/>
-          </a:solidFill>
-          <a:ln/>
-        </p:spPr>
-      </p:sp>
-      <p:sp>
-        <p:nvSpPr>
-          <p:cNvPr id="28" name="Text 26"/>
-          <p:cNvSpPr/>
-          <p:nvPr/>
-        </p:nvSpPr>
-        <p:spPr>
-          <a:xfrm>
-            <a:off x="10561320" y="5321808"/>
-            <a:ext cx="1051560" cy="384048"/>
-          </a:xfrm>
-          <a:prstGeom prst="rect">
-            <a:avLst/>
-          </a:prstGeom>
-          <a:noFill/>
-          <a:ln/>
-        </p:spPr>
-        <p:txBody>
-          <a:bodyPr wrap="square" lIns="0" tIns="0" rIns="0" bIns="0" rtlCol="0" anchor="ctr"/>
-          <a:lstStyle/>
-          <a:p>
-            <a:pPr algn="ctr" indent="0" marL="0">
-              <a:buNone/>
-            </a:pPr>
-            <a:r>
-              <a:rPr lang="en-US" sz="950" b="1" dirty="0">
-                <a:solidFill>
-                  <a:srgbClr val="6B7280"/>
-                </a:solidFill>
-                <a:latin typeface="Yu Gothic" pitchFamily="34" charset="0"/>
-                <a:ea typeface="Yu Gothic" pitchFamily="34" charset="-122"/>
-                <a:cs typeface="Yu Gothic" pitchFamily="34" charset="-120"/>
-              </a:rPr>
-              <a:t>補強対応</a:t>
-            </a:r>
-            <a:endParaRPr lang="en-US" sz="950" dirty="0"/>
-          </a:p>
-        </p:txBody>
-      </p:sp>
-      <p:sp>
-        <p:nvSpPr>
-          <p:cNvPr id="29" name="Text 27"/>
-          <p:cNvSpPr/>
-          <p:nvPr/>
-        </p:nvSpPr>
-        <p:spPr>
-          <a:xfrm>
-            <a:off x="1188720" y="5266944"/>
-            <a:ext cx="9235440" cy="914400"/>
-          </a:xfrm>
-          <a:prstGeom prst="rect">
-            <a:avLst/>
-          </a:prstGeom>
-          <a:noFill/>
-          <a:ln/>
-        </p:spPr>
-        <p:txBody>
-          <a:bodyPr wrap="square" lIns="0" tIns="0" rIns="0" bIns="0" rtlCol="0" anchor="t"/>
-          <a:lstStyle/>
-          <a:p>
-            <a:pPr indent="0" marL="0">
-              <a:buNone/>
-            </a:pPr>
-            <a:r>
-              <a:rPr lang="en-US" sz="1300" b="1" dirty="0">
-                <a:solidFill>
-                  <a:srgbClr val="1B3A5C"/>
-                </a:solidFill>
-                <a:latin typeface="Yu Gothic" pitchFamily="34" charset="0"/>
-                <a:ea typeface="Yu Gothic" pitchFamily="34" charset="-122"/>
-                <a:cs typeface="Yu Gothic" pitchFamily="34" charset="-120"/>
-              </a:rPr>
-              <a:t>基盤整備(中長期)
-</a:t>
-            </a:r>
-            <a:pPr indent="0" marL="0">
-              <a:buNone/>
-            </a:pPr>
-            <a:r>
-              <a:rPr lang="en-US" sz="1100" dirty="0">
-                <a:solidFill>
-                  <a:srgbClr val="374151"/>
-                </a:solidFill>
-                <a:latin typeface="Yu Gothic" pitchFamily="34" charset="0"/>
-                <a:ea typeface="Yu Gothic" pitchFamily="34" charset="-122"/>
-                <a:cs typeface="Yu Gothic" pitchFamily="34" charset="-120"/>
-              </a:rPr>
-              <a:t>LP・広告の効果測定(コンバージョン計測・GA4)の整備と、若年層応募の最大障壁である年間休日数(土曜出勤)の段階的見直しの検討</a:t>
-            </a:r>
-            <a:endParaRPr lang="en-US" sz="1300" dirty="0"/>
-          </a:p>
-        </p:txBody>
-      </p:sp>
-    </p:spTree>
-  </p:cSld>
-  <p:clrMapOvr>
-    <a:masterClrMapping/>
-  </p:clrMapOvr>
-</p:sld>
-</file>
-
 <file path=ppt/slides/slide17.xml><?xml version="1.0" encoding="utf-8"?>
 <p:sld xmlns:a="http://schemas.openxmlformats.org/drawingml/2006/main" xmlns:r="http://schemas.openxmlformats.org/officeDocument/2006/relationships" xmlns:p="http://schemas.openxmlformats.org/presentationml/2006/main">
   <p:cSld name="Slide 17">
@@ -11175,7 +11087,7 @@
                 <a:ea typeface="Yu Gothic" pitchFamily="34" charset="-122"/>
                 <a:cs typeface="Yu Gothic" pitchFamily="34" charset="-120"/>
               </a:rPr>
-              <a:t>実行ロードマップ(2026年8月〜)</a:t>
+              <a:t>今後のご提言 ─ 3つの課題に対応する打ち手</a:t>
             </a:r>
             <a:endParaRPr lang="en-US" sz="3000" dirty="0"/>
           </a:p>
@@ -11214,7 +11126,7 @@
                 <a:ea typeface="Yu Gothic" pitchFamily="34" charset="-122"/>
                 <a:cs typeface="Yu Gothic" pitchFamily="34" charset="-120"/>
               </a:rPr>
-              <a:t>市場ピーク(9〜10月)に間に合わせる時系列プラン</a:t>
+              <a:t>8月以降の転職市場再活性化(ピーク:9〜10月)を最大限に活かすために</a:t>
             </a:r>
             <a:endParaRPr lang="en-US" sz="1300" dirty="0"/>
           </a:p>
@@ -11267,13 +11179,11 @@
         </p:nvSpPr>
         <p:spPr>
           <a:xfrm>
-            <a:off x="548640" y="1645920"/>
-            <a:ext cx="3566160" cy="685800"/>
-          </a:xfrm>
-          <a:prstGeom prst="roundRect">
-            <a:avLst>
-              <a:gd name="adj" fmla="val 10667"/>
-            </a:avLst>
+            <a:off x="594360" y="1609344"/>
+            <a:ext cx="384048" cy="384048"/>
+          </a:xfrm>
+          <a:prstGeom prst="ellipse">
+            <a:avLst/>
           </a:prstGeom>
           <a:solidFill>
             <a:srgbClr val="E8762C"/>
@@ -11289,8 +11199,8 @@
         </p:nvSpPr>
         <p:spPr>
           <a:xfrm>
-            <a:off x="548640" y="1645920"/>
-            <a:ext cx="3566160" cy="685800"/>
+            <a:off x="594360" y="1604772"/>
+            <a:ext cx="384048" cy="384048"/>
           </a:xfrm>
           <a:prstGeom prst="rect">
             <a:avLst/>
@@ -11306,7 +11216,7 @@
               <a:buNone/>
             </a:pPr>
             <a:r>
-              <a:rPr lang="en-US" sz="1600" b="1" dirty="0">
+              <a:rPr lang="en-US" sz="1500" b="1" dirty="0">
                 <a:solidFill>
                   <a:srgbClr val="FFFFFF"/>
                 </a:solidFill>
@@ -11314,23 +11224,9 @@
                 <a:ea typeface="Yu Gothic" pitchFamily="34" charset="-122"/>
                 <a:cs typeface="Yu Gothic" pitchFamily="34" charset="-120"/>
               </a:rPr>
-              <a:t>8月  </a:t>
-            </a:r>
-            <a:pPr algn="ctr" indent="0" marL="0">
-              <a:buNone/>
-            </a:pPr>
-            <a:r>
-              <a:rPr lang="en-US" sz="1200" dirty="0">
-                <a:solidFill>
-                  <a:srgbClr val="FFFFFF"/>
-                </a:solidFill>
-                <a:latin typeface="Yu Gothic" pitchFamily="34" charset="0"/>
-                <a:ea typeface="Yu Gothic" pitchFamily="34" charset="-122"/>
-                <a:cs typeface="Yu Gothic" pitchFamily="34" charset="-120"/>
-              </a:rPr>
-              <a:t>土台を仕上げる</a:t>
-            </a:r>
-            <a:endParaRPr lang="en-US" sz="1600" dirty="0"/>
+              <a:t>1</a:t>
+            </a:r>
+            <a:endParaRPr lang="en-US" sz="1500" dirty="0"/>
           </a:p>
         </p:txBody>
       </p:sp>
@@ -11342,16 +11238,16 @@
         </p:nvSpPr>
         <p:spPr>
           <a:xfrm>
-            <a:off x="548640" y="2468880"/>
-            <a:ext cx="3566160" cy="3749040"/>
+            <a:off x="10561320" y="1591056"/>
+            <a:ext cx="1051560" cy="384048"/>
           </a:xfrm>
           <a:prstGeom prst="roundRect">
             <a:avLst>
-              <a:gd name="adj" fmla="val 2051"/>
+              <a:gd name="adj" fmla="val 14286"/>
             </a:avLst>
           </a:prstGeom>
           <a:solidFill>
-            <a:srgbClr val="F2F6FA"/>
+            <a:srgbClr val="FDF0E6"/>
           </a:solidFill>
           <a:ln/>
         </p:spPr>
@@ -11364,8 +11260,47 @@
         </p:nvSpPr>
         <p:spPr>
           <a:xfrm>
-            <a:off x="777240" y="2697480"/>
-            <a:ext cx="3108960" cy="3291840"/>
+            <a:off x="10561320" y="1591056"/>
+            <a:ext cx="1051560" cy="384048"/>
+          </a:xfrm>
+          <a:prstGeom prst="rect">
+            <a:avLst/>
+          </a:prstGeom>
+          <a:noFill/>
+          <a:ln/>
+        </p:spPr>
+        <p:txBody>
+          <a:bodyPr wrap="square" lIns="0" tIns="0" rIns="0" bIns="0" rtlCol="0" anchor="ctr"/>
+          <a:lstStyle/>
+          <a:p>
+            <a:pPr algn="ctr" indent="0" marL="0">
+              <a:buNone/>
+            </a:pPr>
+            <a:r>
+              <a:rPr lang="en-US" sz="950" b="1" dirty="0">
+                <a:solidFill>
+                  <a:srgbClr val="B45309"/>
+                </a:solidFill>
+                <a:latin typeface="Yu Gothic" pitchFamily="34" charset="0"/>
+                <a:ea typeface="Yu Gothic" pitchFamily="34" charset="-122"/>
+                <a:cs typeface="Yu Gothic" pitchFamily="34" charset="-120"/>
+              </a:rPr>
+              <a:t>課題②対応</a:t>
+            </a:r>
+            <a:endParaRPr lang="en-US" sz="950" dirty="0"/>
+          </a:p>
+        </p:txBody>
+      </p:sp>
+      <p:sp>
+        <p:nvSpPr>
+          <p:cNvPr id="9" name="Text 7"/>
+          <p:cNvSpPr/>
+          <p:nvPr/>
+        </p:nvSpPr>
+        <p:spPr>
+          <a:xfrm>
+            <a:off x="1188720" y="1536192"/>
+            <a:ext cx="9235440" cy="914400"/>
           </a:xfrm>
           <a:prstGeom prst="rect">
             <a:avLst/>
@@ -11377,15 +11312,26 @@
           <a:bodyPr wrap="square" lIns="0" tIns="0" rIns="0" bIns="0" rtlCol="0" anchor="t"/>
           <a:lstStyle/>
           <a:p>
-            <a:pPr marL="342900" indent="-342900">
-              <a:spcAft>
-                <a:spcPts val="1000"/>
-              </a:spcAft>
-              <a:buSzPct val="100000"/>
-              <a:buChar char="•"/>
-            </a:pPr>
-            <a:r>
-              <a:rPr lang="en-US" sz="1050" dirty="0">
+            <a:pPr indent="0" marL="0">
+              <a:buNone/>
+            </a:pPr>
+            <a:r>
+              <a:rPr lang="en-US" sz="1300" b="1" dirty="0">
+                <a:solidFill>
+                  <a:srgbClr val="1B3A5C"/>
+                </a:solidFill>
+                <a:latin typeface="Yu Gothic" pitchFamily="34" charset="0"/>
+                <a:ea typeface="Yu Gothic" pitchFamily="34" charset="-122"/>
+                <a:cs typeface="Yu Gothic" pitchFamily="34" charset="-120"/>
+              </a:rPr>
+              <a:t>採用HPリニューアル+Instagramで「情報の透明性」を確保
+</a:t>
+            </a:r>
+            <a:pPr indent="0" marL="0">
+              <a:buNone/>
+            </a:pPr>
+            <a:r>
+              <a:rPr lang="en-US" sz="1100" dirty="0">
                 <a:solidFill>
                   <a:srgbClr val="374151"/>
                 </a:solidFill>
@@ -11393,107 +11339,103 @@
                 <a:ea typeface="Yu Gothic" pitchFamily="34" charset="-122"/>
                 <a:cs typeface="Yu Gothic" pitchFamily="34" charset="-120"/>
               </a:rPr>
-              <a:t>採用HPリニューアル完了(お盆前)・Instagram連携</a:t>
-            </a:r>
-            <a:endParaRPr lang="en-US" sz="1050" dirty="0"/>
-          </a:p>
-          <a:p>
-            <a:pPr marL="342900" indent="-342900">
-              <a:spcAft>
-                <a:spcPts val="1000"/>
-              </a:spcAft>
-              <a:buSzPct val="100000"/>
-              <a:buChar char="•"/>
-            </a:pPr>
-            <a:r>
-              <a:rPr lang="en-US" sz="1050" dirty="0">
-                <a:solidFill>
-                  <a:srgbClr val="374151"/>
-                </a:solidFill>
-                <a:latin typeface="Yu Gothic" pitchFamily="34" charset="0"/>
-                <a:ea typeface="Yu Gothic" pitchFamily="34" charset="-122"/>
-                <a:cs typeface="Yu Gothic" pitchFamily="34" charset="-120"/>
-              </a:rPr>
-              <a:t>Instagram定期投稿の開始(働き方・業務内容・働く人)</a:t>
-            </a:r>
-            <a:endParaRPr lang="en-US" sz="1050" dirty="0"/>
-          </a:p>
-          <a:p>
-            <a:pPr marL="342900" indent="-342900">
-              <a:spcAft>
-                <a:spcPts val="1000"/>
-              </a:spcAft>
-              <a:buSzPct val="100000"/>
-              <a:buChar char="•"/>
-            </a:pPr>
-            <a:r>
-              <a:rPr lang="en-US" sz="1050" dirty="0">
-                <a:solidFill>
-                  <a:srgbClr val="374151"/>
-                </a:solidFill>
-                <a:latin typeface="Yu Gothic" pitchFamily="34" charset="0"/>
-                <a:ea typeface="Yu Gothic" pitchFamily="34" charset="-122"/>
-                <a:cs typeface="Yu Gothic" pitchFamily="34" charset="-120"/>
-              </a:rPr>
-              <a:t>ハローワーク説明会の予約(8/28以降の枠)</a:t>
-            </a:r>
-            <a:endParaRPr lang="en-US" sz="1050" dirty="0"/>
-          </a:p>
-          <a:p>
-            <a:pPr marL="342900" indent="-342900">
-              <a:spcAft>
-                <a:spcPts val="1000"/>
-              </a:spcAft>
-              <a:buSzPct val="100000"/>
-              <a:buChar char="•"/>
-            </a:pPr>
-            <a:r>
-              <a:rPr lang="en-US" sz="1050" dirty="0">
-                <a:solidFill>
-                  <a:srgbClr val="374151"/>
-                </a:solidFill>
-                <a:latin typeface="Yu Gothic" pitchFamily="34" charset="0"/>
-                <a:ea typeface="Yu Gothic" pitchFamily="34" charset="-122"/>
-                <a:cs typeface="Yu Gothic" pitchFamily="34" charset="-120"/>
-              </a:rPr>
-              <a:t>SMS→LINEの連絡フローを全応募者に標準化</a:t>
-            </a:r>
-            <a:endParaRPr lang="en-US" sz="1050" dirty="0"/>
-          </a:p>
-        </p:txBody>
-      </p:sp>
-      <p:sp>
-        <p:nvSpPr>
-          <p:cNvPr id="9" name="Shape 7"/>
-          <p:cNvSpPr/>
-          <p:nvPr/>
-        </p:nvSpPr>
-        <p:spPr>
-          <a:xfrm>
-            <a:off x="4379976" y="1645920"/>
-            <a:ext cx="3566160" cy="685800"/>
+              <a:t>「働き方・業務内容・どんな人が働いているか」を軸に発信を強化。リニューアルHP(お盆前完了予定)とInstagramを紐付け、求人から裏付けを取りに来た求職者が必ず情報に辿り着ける状態をつくる</a:t>
+            </a:r>
+            <a:endParaRPr lang="en-US" sz="1300" dirty="0"/>
+          </a:p>
+        </p:txBody>
+      </p:sp>
+      <p:sp>
+        <p:nvSpPr>
+          <p:cNvPr id="10" name="Shape 8"/>
+          <p:cNvSpPr/>
+          <p:nvPr/>
+        </p:nvSpPr>
+        <p:spPr>
+          <a:xfrm>
+            <a:off x="594360" y="2542032"/>
+            <a:ext cx="384048" cy="384048"/>
+          </a:xfrm>
+          <a:prstGeom prst="ellipse">
+            <a:avLst/>
+          </a:prstGeom>
+          <a:solidFill>
+            <a:srgbClr val="E8762C"/>
+          </a:solidFill>
+          <a:ln/>
+        </p:spPr>
+      </p:sp>
+      <p:sp>
+        <p:nvSpPr>
+          <p:cNvPr id="11" name="Text 9"/>
+          <p:cNvSpPr/>
+          <p:nvPr/>
+        </p:nvSpPr>
+        <p:spPr>
+          <a:xfrm>
+            <a:off x="594360" y="2537460"/>
+            <a:ext cx="384048" cy="384048"/>
+          </a:xfrm>
+          <a:prstGeom prst="rect">
+            <a:avLst/>
+          </a:prstGeom>
+          <a:noFill/>
+          <a:ln/>
+        </p:spPr>
+        <p:txBody>
+          <a:bodyPr wrap="square" lIns="0" tIns="0" rIns="0" bIns="0" rtlCol="0" anchor="ctr"/>
+          <a:lstStyle/>
+          <a:p>
+            <a:pPr algn="ctr" indent="0" marL="0">
+              <a:buNone/>
+            </a:pPr>
+            <a:r>
+              <a:rPr lang="en-US" sz="1500" b="1" dirty="0">
+                <a:solidFill>
+                  <a:srgbClr val="FFFFFF"/>
+                </a:solidFill>
+                <a:latin typeface="Yu Gothic" pitchFamily="34" charset="0"/>
+                <a:ea typeface="Yu Gothic" pitchFamily="34" charset="-122"/>
+                <a:cs typeface="Yu Gothic" pitchFamily="34" charset="-120"/>
+              </a:rPr>
+              <a:t>2</a:t>
+            </a:r>
+            <a:endParaRPr lang="en-US" sz="1500" dirty="0"/>
+          </a:p>
+        </p:txBody>
+      </p:sp>
+      <p:sp>
+        <p:nvSpPr>
+          <p:cNvPr id="12" name="Shape 10"/>
+          <p:cNvSpPr/>
+          <p:nvPr/>
+        </p:nvSpPr>
+        <p:spPr>
+          <a:xfrm>
+            <a:off x="10561320" y="2523744"/>
+            <a:ext cx="1051560" cy="384048"/>
           </a:xfrm>
           <a:prstGeom prst="roundRect">
             <a:avLst>
-              <a:gd name="adj" fmla="val 10667"/>
+              <a:gd name="adj" fmla="val 14286"/>
             </a:avLst>
           </a:prstGeom>
           <a:solidFill>
-            <a:srgbClr val="1B3A5C"/>
+            <a:srgbClr val="FDF0E6"/>
           </a:solidFill>
           <a:ln/>
         </p:spPr>
       </p:sp>
       <p:sp>
         <p:nvSpPr>
-          <p:cNvPr id="10" name="Text 8"/>
-          <p:cNvSpPr/>
-          <p:nvPr/>
-        </p:nvSpPr>
-        <p:spPr>
-          <a:xfrm>
-            <a:off x="4379976" y="1645920"/>
-            <a:ext cx="3566160" cy="685800"/>
+          <p:cNvPr id="13" name="Text 11"/>
+          <p:cNvSpPr/>
+          <p:nvPr/>
+        </p:nvSpPr>
+        <p:spPr>
+          <a:xfrm>
+            <a:off x="10561320" y="2523744"/>
+            <a:ext cx="1051560" cy="384048"/>
           </a:xfrm>
           <a:prstGeom prst="rect">
             <a:avLst/>
@@ -11509,7 +11451,120 @@
               <a:buNone/>
             </a:pPr>
             <a:r>
-              <a:rPr lang="en-US" sz="1600" b="1" dirty="0">
+              <a:rPr lang="en-US" sz="950" b="1" dirty="0">
+                <a:solidFill>
+                  <a:srgbClr val="B45309"/>
+                </a:solidFill>
+                <a:latin typeface="Yu Gothic" pitchFamily="34" charset="0"/>
+                <a:ea typeface="Yu Gothic" pitchFamily="34" charset="-122"/>
+                <a:cs typeface="Yu Gothic" pitchFamily="34" charset="-120"/>
+              </a:rPr>
+              <a:t>課題③対応</a:t>
+            </a:r>
+            <a:endParaRPr lang="en-US" sz="950" dirty="0"/>
+          </a:p>
+        </p:txBody>
+      </p:sp>
+      <p:sp>
+        <p:nvSpPr>
+          <p:cNvPr id="14" name="Text 12"/>
+          <p:cNvSpPr/>
+          <p:nvPr/>
+        </p:nvSpPr>
+        <p:spPr>
+          <a:xfrm>
+            <a:off x="1188720" y="2468880"/>
+            <a:ext cx="9235440" cy="914400"/>
+          </a:xfrm>
+          <a:prstGeom prst="rect">
+            <a:avLst/>
+          </a:prstGeom>
+          <a:noFill/>
+          <a:ln/>
+        </p:spPr>
+        <p:txBody>
+          <a:bodyPr wrap="square" lIns="0" tIns="0" rIns="0" bIns="0" rtlCol="0" anchor="t"/>
+          <a:lstStyle/>
+          <a:p>
+            <a:pPr indent="0" marL="0">
+              <a:buNone/>
+            </a:pPr>
+            <a:r>
+              <a:rPr lang="en-US" sz="1300" b="1" dirty="0">
+                <a:solidFill>
+                  <a:srgbClr val="1B3A5C"/>
+                </a:solidFill>
+                <a:latin typeface="Yu Gothic" pitchFamily="34" charset="0"/>
+                <a:ea typeface="Yu Gothic" pitchFamily="34" charset="-122"/>
+                <a:cs typeface="Yu Gothic" pitchFamily="34" charset="-120"/>
+              </a:rPr>
+              <a:t>他社集客型イベントで求職者と直接交流
+</a:t>
+            </a:r>
+            <a:pPr indent="0" marL="0">
+              <a:buNone/>
+            </a:pPr>
+            <a:r>
+              <a:rPr lang="en-US" sz="1100" dirty="0">
+                <a:solidFill>
+                  <a:srgbClr val="374151"/>
+                </a:solidFill>
+                <a:latin typeface="Yu Gothic" pitchFamily="34" charset="0"/>
+                <a:ea typeface="Yu Gothic" pitchFamily="34" charset="-122"/>
+                <a:cs typeface="Yu Gothic" pitchFamily="34" charset="-120"/>
+              </a:rPr>
+              <a:t>ハローワーク説明会(8/28以降予約可)と、マイナビ転職フェア富山(10月・1月、20〜30代来場中心)等の合同説明会に参加。自社集客に依存せず、対面交流で情報不足への不安を解消する</a:t>
+            </a:r>
+            <a:endParaRPr lang="en-US" sz="1300" dirty="0"/>
+          </a:p>
+        </p:txBody>
+      </p:sp>
+      <p:sp>
+        <p:nvSpPr>
+          <p:cNvPr id="15" name="Shape 13"/>
+          <p:cNvSpPr/>
+          <p:nvPr/>
+        </p:nvSpPr>
+        <p:spPr>
+          <a:xfrm>
+            <a:off x="594360" y="3474720"/>
+            <a:ext cx="384048" cy="384048"/>
+          </a:xfrm>
+          <a:prstGeom prst="ellipse">
+            <a:avLst/>
+          </a:prstGeom>
+          <a:solidFill>
+            <a:srgbClr val="E8762C"/>
+          </a:solidFill>
+          <a:ln/>
+        </p:spPr>
+      </p:sp>
+      <p:sp>
+        <p:nvSpPr>
+          <p:cNvPr id="16" name="Text 14"/>
+          <p:cNvSpPr/>
+          <p:nvPr/>
+        </p:nvSpPr>
+        <p:spPr>
+          <a:xfrm>
+            <a:off x="594360" y="3470148"/>
+            <a:ext cx="384048" cy="384048"/>
+          </a:xfrm>
+          <a:prstGeom prst="rect">
+            <a:avLst/>
+          </a:prstGeom>
+          <a:noFill/>
+          <a:ln/>
+        </p:spPr>
+        <p:txBody>
+          <a:bodyPr wrap="square" lIns="0" tIns="0" rIns="0" bIns="0" rtlCol="0" anchor="ctr"/>
+          <a:lstStyle/>
+          <a:p>
+            <a:pPr algn="ctr" indent="0" marL="0">
+              <a:buNone/>
+            </a:pPr>
+            <a:r>
+              <a:rPr lang="en-US" sz="1500" b="1" dirty="0">
                 <a:solidFill>
                   <a:srgbClr val="FFFFFF"/>
                 </a:solidFill>
@@ -11517,58 +11572,83 @@
                 <a:ea typeface="Yu Gothic" pitchFamily="34" charset="-122"/>
                 <a:cs typeface="Yu Gothic" pitchFamily="34" charset="-120"/>
               </a:rPr>
-              <a:t>9月  </a:t>
-            </a:r>
-            <a:pPr algn="ctr" indent="0" marL="0">
-              <a:buNone/>
-            </a:pPr>
-            <a:r>
-              <a:rPr lang="en-US" sz="1200" dirty="0">
-                <a:solidFill>
-                  <a:srgbClr val="FFFFFF"/>
-                </a:solidFill>
-                <a:latin typeface="Yu Gothic" pitchFamily="34" charset="0"/>
-                <a:ea typeface="Yu Gothic" pitchFamily="34" charset="-122"/>
-                <a:cs typeface="Yu Gothic" pitchFamily="34" charset="-120"/>
-              </a:rPr>
-              <a:t>接点を仕込む</a:t>
-            </a:r>
-            <a:endParaRPr lang="en-US" sz="1600" dirty="0"/>
-          </a:p>
-        </p:txBody>
-      </p:sp>
-      <p:sp>
-        <p:nvSpPr>
-          <p:cNvPr id="11" name="Shape 9"/>
-          <p:cNvSpPr/>
-          <p:nvPr/>
-        </p:nvSpPr>
-        <p:spPr>
-          <a:xfrm>
-            <a:off x="4379976" y="2468880"/>
-            <a:ext cx="3566160" cy="3749040"/>
+              <a:t>3</a:t>
+            </a:r>
+            <a:endParaRPr lang="en-US" sz="1500" dirty="0"/>
+          </a:p>
+        </p:txBody>
+      </p:sp>
+      <p:sp>
+        <p:nvSpPr>
+          <p:cNvPr id="17" name="Shape 15"/>
+          <p:cNvSpPr/>
+          <p:nvPr/>
+        </p:nvSpPr>
+        <p:spPr>
+          <a:xfrm>
+            <a:off x="10561320" y="3456432"/>
+            <a:ext cx="1051560" cy="384048"/>
           </a:xfrm>
           <a:prstGeom prst="roundRect">
             <a:avLst>
-              <a:gd name="adj" fmla="val 2051"/>
+              <a:gd name="adj" fmla="val 14286"/>
             </a:avLst>
           </a:prstGeom>
           <a:solidFill>
-            <a:srgbClr val="F2F6FA"/>
+            <a:srgbClr val="FDF0E6"/>
           </a:solidFill>
           <a:ln/>
         </p:spPr>
       </p:sp>
       <p:sp>
         <p:nvSpPr>
-          <p:cNvPr id="12" name="Text 10"/>
-          <p:cNvSpPr/>
-          <p:nvPr/>
-        </p:nvSpPr>
-        <p:spPr>
-          <a:xfrm>
-            <a:off x="4608576" y="2697480"/>
-            <a:ext cx="3108960" cy="3291840"/>
+          <p:cNvPr id="18" name="Text 16"/>
+          <p:cNvSpPr/>
+          <p:nvPr/>
+        </p:nvSpPr>
+        <p:spPr>
+          <a:xfrm>
+            <a:off x="10561320" y="3456432"/>
+            <a:ext cx="1051560" cy="384048"/>
+          </a:xfrm>
+          <a:prstGeom prst="rect">
+            <a:avLst/>
+          </a:prstGeom>
+          <a:noFill/>
+          <a:ln/>
+        </p:spPr>
+        <p:txBody>
+          <a:bodyPr wrap="square" lIns="0" tIns="0" rIns="0" bIns="0" rtlCol="0" anchor="ctr"/>
+          <a:lstStyle/>
+          <a:p>
+            <a:pPr algn="ctr" indent="0" marL="0">
+              <a:buNone/>
+            </a:pPr>
+            <a:r>
+              <a:rPr lang="en-US" sz="950" b="1" dirty="0">
+                <a:solidFill>
+                  <a:srgbClr val="B45309"/>
+                </a:solidFill>
+                <a:latin typeface="Yu Gothic" pitchFamily="34" charset="0"/>
+                <a:ea typeface="Yu Gothic" pitchFamily="34" charset="-122"/>
+                <a:cs typeface="Yu Gothic" pitchFamily="34" charset="-120"/>
+              </a:rPr>
+              <a:t>課題①対応</a:t>
+            </a:r>
+            <a:endParaRPr lang="en-US" sz="950" dirty="0"/>
+          </a:p>
+        </p:txBody>
+      </p:sp>
+      <p:sp>
+        <p:nvSpPr>
+          <p:cNvPr id="19" name="Text 17"/>
+          <p:cNvSpPr/>
+          <p:nvPr/>
+        </p:nvSpPr>
+        <p:spPr>
+          <a:xfrm>
+            <a:off x="1188720" y="3401568"/>
+            <a:ext cx="9235440" cy="914400"/>
           </a:xfrm>
           <a:prstGeom prst="rect">
             <a:avLst/>
@@ -11580,15 +11660,26 @@
           <a:bodyPr wrap="square" lIns="0" tIns="0" rIns="0" bIns="0" rtlCol="0" anchor="t"/>
           <a:lstStyle/>
           <a:p>
-            <a:pPr marL="342900" indent="-342900">
-              <a:spcAft>
-                <a:spcPts val="1000"/>
-              </a:spcAft>
-              <a:buSzPct val="100000"/>
-              <a:buChar char="•"/>
-            </a:pPr>
-            <a:r>
-              <a:rPr lang="en-US" sz="1050" dirty="0">
+            <a:pPr indent="0" marL="0">
+              <a:buNone/>
+            </a:pPr>
+            <a:r>
+              <a:rPr lang="en-US" sz="1300" b="1" dirty="0">
+                <a:solidFill>
+                  <a:srgbClr val="1B3A5C"/>
+                </a:solidFill>
+                <a:latin typeface="Yu Gothic" pitchFamily="34" charset="0"/>
+                <a:ea typeface="Yu Gothic" pitchFamily="34" charset="-122"/>
+                <a:cs typeface="Yu Gothic" pitchFamily="34" charset="-120"/>
+              </a:rPr>
+              <a:t>未経験×20・30代への注力を継続
+</a:t>
+            </a:r>
+            <a:pPr indent="0" marL="0">
+              <a:buNone/>
+            </a:pPr>
+            <a:r>
+              <a:rPr lang="en-US" sz="1100" dirty="0">
                 <a:solidFill>
                   <a:srgbClr val="374151"/>
                 </a:solidFill>
@@ -11596,90 +11687,25 @@
                 <a:ea typeface="Yu Gothic" pitchFamily="34" charset="-122"/>
                 <a:cs typeface="Yu Gothic" pitchFamily="34" charset="-120"/>
               </a:rPr>
-              <a:t>マイナビ転職フェア出展の可否判断(費用交渉の結果を反映)</a:t>
-            </a:r>
-            <a:endParaRPr lang="en-US" sz="1050" dirty="0"/>
-          </a:p>
-          <a:p>
-            <a:pPr marL="342900" indent="-342900">
-              <a:spcAft>
-                <a:spcPts val="1000"/>
-              </a:spcAft>
-              <a:buSzPct val="100000"/>
-              <a:buChar char="•"/>
-            </a:pPr>
-            <a:r>
-              <a:rPr lang="en-US" sz="1050" dirty="0">
-                <a:solidFill>
-                  <a:srgbClr val="374151"/>
-                </a:solidFill>
-                <a:latin typeface="Yu Gothic" pitchFamily="34" charset="0"/>
-                <a:ea typeface="Yu Gothic" pitchFamily="34" charset="-122"/>
-                <a:cs typeface="Yu Gothic" pitchFamily="34" charset="-120"/>
-              </a:rPr>
-              <a:t>職人スカウトの費用対効果判断(北陸登録者数の回答受領後)</a:t>
-            </a:r>
-            <a:endParaRPr lang="en-US" sz="1050" dirty="0"/>
-          </a:p>
-          <a:p>
-            <a:pPr marL="342900" indent="-342900">
-              <a:spcAft>
-                <a:spcPts val="1000"/>
-              </a:spcAft>
-              <a:buSzPct val="100000"/>
-              <a:buChar char="•"/>
-            </a:pPr>
-            <a:r>
-              <a:rPr lang="en-US" sz="1050" dirty="0">
-                <a:solidFill>
-                  <a:srgbClr val="374151"/>
-                </a:solidFill>
-                <a:latin typeface="Yu Gothic" pitchFamily="34" charset="0"/>
-                <a:ea typeface="Yu Gothic" pitchFamily="34" charset="-122"/>
-                <a:cs typeface="Yu Gothic" pitchFamily="34" charset="-120"/>
-              </a:rPr>
-              <a:t>「応募→説明会参加」移行率のKPI週次計測を開始</a:t>
-            </a:r>
-            <a:endParaRPr lang="en-US" sz="1050" dirty="0"/>
-          </a:p>
-          <a:p>
-            <a:pPr marL="342900" indent="-342900">
-              <a:spcAft>
-                <a:spcPts val="1000"/>
-              </a:spcAft>
-              <a:buSzPct val="100000"/>
-              <a:buChar char="•"/>
-            </a:pPr>
-            <a:r>
-              <a:rPr lang="en-US" sz="1050" dirty="0">
-                <a:solidFill>
-                  <a:srgbClr val="374151"/>
-                </a:solidFill>
-                <a:latin typeface="Yu Gothic" pitchFamily="34" charset="0"/>
-                <a:ea typeface="Yu Gothic" pitchFamily="34" charset="-122"/>
-                <a:cs typeface="Yu Gothic" pitchFamily="34" charset="-120"/>
-              </a:rPr>
-              <a:t>求人・広告は20・30代向け2軸訴求へ予算集中</a:t>
-            </a:r>
-            <a:endParaRPr lang="en-US" sz="1050" dirty="0"/>
-          </a:p>
-        </p:txBody>
-      </p:sp>
-      <p:sp>
-        <p:nvSpPr>
-          <p:cNvPr id="13" name="Shape 11"/>
-          <p:cNvSpPr/>
-          <p:nvPr/>
-        </p:nvSpPr>
-        <p:spPr>
-          <a:xfrm>
-            <a:off x="8211312" y="1645920"/>
-            <a:ext cx="3566160" cy="685800"/>
-          </a:xfrm>
-          <a:prstGeom prst="roundRect">
-            <a:avLst>
-              <a:gd name="adj" fmla="val 10667"/>
-            </a:avLst>
+              <a:t>経験者市場は構造的に小さいことが検証で判明済み。「オタク気質×AI」訴求と未経験育成(資格全額支援・3年で一人前)を前面に、未経験採用に投資を集中する</a:t>
+            </a:r>
+            <a:endParaRPr lang="en-US" sz="1300" dirty="0"/>
+          </a:p>
+        </p:txBody>
+      </p:sp>
+      <p:sp>
+        <p:nvSpPr>
+          <p:cNvPr id="20" name="Shape 18"/>
+          <p:cNvSpPr/>
+          <p:nvPr/>
+        </p:nvSpPr>
+        <p:spPr>
+          <a:xfrm>
+            <a:off x="594360" y="4407408"/>
+            <a:ext cx="384048" cy="384048"/>
+          </a:xfrm>
+          <a:prstGeom prst="ellipse">
+            <a:avLst/>
           </a:prstGeom>
           <a:solidFill>
             <a:srgbClr val="5A7A99"/>
@@ -11689,14 +11715,14 @@
       </p:sp>
       <p:sp>
         <p:nvSpPr>
-          <p:cNvPr id="14" name="Text 12"/>
-          <p:cNvSpPr/>
-          <p:nvPr/>
-        </p:nvSpPr>
-        <p:spPr>
-          <a:xfrm>
-            <a:off x="8211312" y="1645920"/>
-            <a:ext cx="3566160" cy="685800"/>
+          <p:cNvPr id="21" name="Text 19"/>
+          <p:cNvSpPr/>
+          <p:nvPr/>
+        </p:nvSpPr>
+        <p:spPr>
+          <a:xfrm>
+            <a:off x="594360" y="4402836"/>
+            <a:ext cx="384048" cy="384048"/>
           </a:xfrm>
           <a:prstGeom prst="rect">
             <a:avLst/>
@@ -11712,7 +11738,7 @@
               <a:buNone/>
             </a:pPr>
             <a:r>
-              <a:rPr lang="en-US" sz="1600" b="1" dirty="0">
+              <a:rPr lang="en-US" sz="1500" b="1" dirty="0">
                 <a:solidFill>
                   <a:srgbClr val="FFFFFF"/>
                 </a:solidFill>
@@ -11720,58 +11746,83 @@
                 <a:ea typeface="Yu Gothic" pitchFamily="34" charset="-122"/>
                 <a:cs typeface="Yu Gothic" pitchFamily="34" charset="-120"/>
               </a:rPr>
-              <a:t>10月〜  </a:t>
-            </a:r>
-            <a:pPr algn="ctr" indent="0" marL="0">
-              <a:buNone/>
-            </a:pPr>
-            <a:r>
-              <a:rPr lang="en-US" sz="1200" dirty="0">
-                <a:solidFill>
-                  <a:srgbClr val="FFFFFF"/>
-                </a:solidFill>
-                <a:latin typeface="Yu Gothic" pitchFamily="34" charset="0"/>
-                <a:ea typeface="Yu Gothic" pitchFamily="34" charset="-122"/>
-                <a:cs typeface="Yu Gothic" pitchFamily="34" charset="-120"/>
-              </a:rPr>
-              <a:t>ピークで刈り取る</a:t>
-            </a:r>
-            <a:endParaRPr lang="en-US" sz="1600" dirty="0"/>
-          </a:p>
-        </p:txBody>
-      </p:sp>
-      <p:sp>
-        <p:nvSpPr>
-          <p:cNvPr id="15" name="Shape 13"/>
-          <p:cNvSpPr/>
-          <p:nvPr/>
-        </p:nvSpPr>
-        <p:spPr>
-          <a:xfrm>
-            <a:off x="8211312" y="2468880"/>
-            <a:ext cx="3566160" cy="3749040"/>
+              <a:t>4</a:t>
+            </a:r>
+            <a:endParaRPr lang="en-US" sz="1500" dirty="0"/>
+          </a:p>
+        </p:txBody>
+      </p:sp>
+      <p:sp>
+        <p:nvSpPr>
+          <p:cNvPr id="22" name="Shape 20"/>
+          <p:cNvSpPr/>
+          <p:nvPr/>
+        </p:nvSpPr>
+        <p:spPr>
+          <a:xfrm>
+            <a:off x="10561320" y="4389120"/>
+            <a:ext cx="1051560" cy="384048"/>
           </a:xfrm>
           <a:prstGeom prst="roundRect">
             <a:avLst>
-              <a:gd name="adj" fmla="val 2051"/>
+              <a:gd name="adj" fmla="val 14286"/>
             </a:avLst>
           </a:prstGeom>
           <a:solidFill>
-            <a:srgbClr val="F2F6FA"/>
+            <a:srgbClr val="E5E7EB"/>
           </a:solidFill>
           <a:ln/>
         </p:spPr>
       </p:sp>
       <p:sp>
         <p:nvSpPr>
-          <p:cNvPr id="16" name="Text 14"/>
-          <p:cNvSpPr/>
-          <p:nvPr/>
-        </p:nvSpPr>
-        <p:spPr>
-          <a:xfrm>
-            <a:off x="8439912" y="2697480"/>
-            <a:ext cx="3108960" cy="3291840"/>
+          <p:cNvPr id="23" name="Text 21"/>
+          <p:cNvSpPr/>
+          <p:nvPr/>
+        </p:nvSpPr>
+        <p:spPr>
+          <a:xfrm>
+            <a:off x="10561320" y="4389120"/>
+            <a:ext cx="1051560" cy="384048"/>
+          </a:xfrm>
+          <a:prstGeom prst="rect">
+            <a:avLst/>
+          </a:prstGeom>
+          <a:noFill/>
+          <a:ln/>
+        </p:spPr>
+        <p:txBody>
+          <a:bodyPr wrap="square" lIns="0" tIns="0" rIns="0" bIns="0" rtlCol="0" anchor="ctr"/>
+          <a:lstStyle/>
+          <a:p>
+            <a:pPr algn="ctr" indent="0" marL="0">
+              <a:buNone/>
+            </a:pPr>
+            <a:r>
+              <a:rPr lang="en-US" sz="950" b="1" dirty="0">
+                <a:solidFill>
+                  <a:srgbClr val="6B7280"/>
+                </a:solidFill>
+                <a:latin typeface="Yu Gothic" pitchFamily="34" charset="0"/>
+                <a:ea typeface="Yu Gothic" pitchFamily="34" charset="-122"/>
+                <a:cs typeface="Yu Gothic" pitchFamily="34" charset="-120"/>
+              </a:rPr>
+              <a:t>補強対応</a:t>
+            </a:r>
+            <a:endParaRPr lang="en-US" sz="950" dirty="0"/>
+          </a:p>
+        </p:txBody>
+      </p:sp>
+      <p:sp>
+        <p:nvSpPr>
+          <p:cNvPr id="24" name="Text 22"/>
+          <p:cNvSpPr/>
+          <p:nvPr/>
+        </p:nvSpPr>
+        <p:spPr>
+          <a:xfrm>
+            <a:off x="1188720" y="4334256"/>
+            <a:ext cx="9235440" cy="914400"/>
           </a:xfrm>
           <a:prstGeom prst="rect">
             <a:avLst/>
@@ -11783,15 +11834,26 @@
           <a:bodyPr wrap="square" lIns="0" tIns="0" rIns="0" bIns="0" rtlCol="0" anchor="t"/>
           <a:lstStyle/>
           <a:p>
-            <a:pPr marL="342900" indent="-342900">
-              <a:spcAft>
-                <a:spcPts val="1000"/>
-              </a:spcAft>
-              <a:buSzPct val="100000"/>
-              <a:buChar char="•"/>
-            </a:pPr>
-            <a:r>
-              <a:rPr lang="en-US" sz="1050" dirty="0">
+            <a:pPr indent="0" marL="0">
+              <a:buNone/>
+            </a:pPr>
+            <a:r>
+              <a:rPr lang="en-US" sz="1300" b="1" dirty="0">
+                <a:solidFill>
+                  <a:srgbClr val="1B3A5C"/>
+                </a:solidFill>
+                <a:latin typeface="Yu Gothic" pitchFamily="34" charset="0"/>
+                <a:ea typeface="Yu Gothic" pitchFamily="34" charset="-122"/>
+                <a:cs typeface="Yu Gothic" pitchFamily="34" charset="-120"/>
+              </a:rPr>
+              <a:t>20〜30代の選考移行率の改善
+</a:t>
+            </a:r>
+            <a:pPr indent="0" marL="0">
+              <a:buNone/>
+            </a:pPr>
+            <a:r>
+              <a:rPr lang="en-US" sz="1100" dirty="0">
                 <a:solidFill>
                   <a:srgbClr val="374151"/>
                 </a:solidFill>
@@ -11799,20 +11861,173 @@
                 <a:ea typeface="Yu Gothic" pitchFamily="34" charset="-122"/>
                 <a:cs typeface="Yu Gothic" pitchFamily="34" charset="-120"/>
               </a:rPr>
-              <a:t>ハローワーク説明会・転職フェア(10月/1月)へ参加</a:t>
-            </a:r>
-            <a:endParaRPr lang="en-US" sz="1050" dirty="0"/>
-          </a:p>
-          <a:p>
-            <a:pPr marL="342900" indent="-342900">
-              <a:spcAft>
-                <a:spcPts val="1000"/>
-              </a:spcAft>
-              <a:buSzPct val="100000"/>
-              <a:buChar char="•"/>
-            </a:pPr>
-            <a:r>
-              <a:rPr lang="en-US" sz="1050" dirty="0">
+              <a:t>初回接触を固定電話→SMS→LINEの順で徹底し若手の連絡途絶を防止。オンライン説明会への誘導を全応募者の標準フローにし、「応募→説明会参加」の移行率をKPIとして毎週計測</a:t>
+            </a:r>
+            <a:endParaRPr lang="en-US" sz="1300" dirty="0"/>
+          </a:p>
+        </p:txBody>
+      </p:sp>
+      <p:sp>
+        <p:nvSpPr>
+          <p:cNvPr id="25" name="Shape 23"/>
+          <p:cNvSpPr/>
+          <p:nvPr/>
+        </p:nvSpPr>
+        <p:spPr>
+          <a:xfrm>
+            <a:off x="594360" y="5340096"/>
+            <a:ext cx="384048" cy="384048"/>
+          </a:xfrm>
+          <a:prstGeom prst="ellipse">
+            <a:avLst/>
+          </a:prstGeom>
+          <a:solidFill>
+            <a:srgbClr val="5A7A99"/>
+          </a:solidFill>
+          <a:ln/>
+        </p:spPr>
+      </p:sp>
+      <p:sp>
+        <p:nvSpPr>
+          <p:cNvPr id="26" name="Text 24"/>
+          <p:cNvSpPr/>
+          <p:nvPr/>
+        </p:nvSpPr>
+        <p:spPr>
+          <a:xfrm>
+            <a:off x="594360" y="5335524"/>
+            <a:ext cx="384048" cy="384048"/>
+          </a:xfrm>
+          <a:prstGeom prst="rect">
+            <a:avLst/>
+          </a:prstGeom>
+          <a:noFill/>
+          <a:ln/>
+        </p:spPr>
+        <p:txBody>
+          <a:bodyPr wrap="square" lIns="0" tIns="0" rIns="0" bIns="0" rtlCol="0" anchor="ctr"/>
+          <a:lstStyle/>
+          <a:p>
+            <a:pPr algn="ctr" indent="0" marL="0">
+              <a:buNone/>
+            </a:pPr>
+            <a:r>
+              <a:rPr lang="en-US" sz="1500" b="1" dirty="0">
+                <a:solidFill>
+                  <a:srgbClr val="FFFFFF"/>
+                </a:solidFill>
+                <a:latin typeface="Yu Gothic" pitchFamily="34" charset="0"/>
+                <a:ea typeface="Yu Gothic" pitchFamily="34" charset="-122"/>
+                <a:cs typeface="Yu Gothic" pitchFamily="34" charset="-120"/>
+              </a:rPr>
+              <a:t>5</a:t>
+            </a:r>
+            <a:endParaRPr lang="en-US" sz="1500" dirty="0"/>
+          </a:p>
+        </p:txBody>
+      </p:sp>
+      <p:sp>
+        <p:nvSpPr>
+          <p:cNvPr id="27" name="Shape 25"/>
+          <p:cNvSpPr/>
+          <p:nvPr/>
+        </p:nvSpPr>
+        <p:spPr>
+          <a:xfrm>
+            <a:off x="10561320" y="5321808"/>
+            <a:ext cx="1051560" cy="384048"/>
+          </a:xfrm>
+          <a:prstGeom prst="roundRect">
+            <a:avLst>
+              <a:gd name="adj" fmla="val 14286"/>
+            </a:avLst>
+          </a:prstGeom>
+          <a:solidFill>
+            <a:srgbClr val="E5E7EB"/>
+          </a:solidFill>
+          <a:ln/>
+        </p:spPr>
+      </p:sp>
+      <p:sp>
+        <p:nvSpPr>
+          <p:cNvPr id="28" name="Text 26"/>
+          <p:cNvSpPr/>
+          <p:nvPr/>
+        </p:nvSpPr>
+        <p:spPr>
+          <a:xfrm>
+            <a:off x="10561320" y="5321808"/>
+            <a:ext cx="1051560" cy="384048"/>
+          </a:xfrm>
+          <a:prstGeom prst="rect">
+            <a:avLst/>
+          </a:prstGeom>
+          <a:noFill/>
+          <a:ln/>
+        </p:spPr>
+        <p:txBody>
+          <a:bodyPr wrap="square" lIns="0" tIns="0" rIns="0" bIns="0" rtlCol="0" anchor="ctr"/>
+          <a:lstStyle/>
+          <a:p>
+            <a:pPr algn="ctr" indent="0" marL="0">
+              <a:buNone/>
+            </a:pPr>
+            <a:r>
+              <a:rPr lang="en-US" sz="950" b="1" dirty="0">
+                <a:solidFill>
+                  <a:srgbClr val="6B7280"/>
+                </a:solidFill>
+                <a:latin typeface="Yu Gothic" pitchFamily="34" charset="0"/>
+                <a:ea typeface="Yu Gothic" pitchFamily="34" charset="-122"/>
+                <a:cs typeface="Yu Gothic" pitchFamily="34" charset="-120"/>
+              </a:rPr>
+              <a:t>補強対応</a:t>
+            </a:r>
+            <a:endParaRPr lang="en-US" sz="950" dirty="0"/>
+          </a:p>
+        </p:txBody>
+      </p:sp>
+      <p:sp>
+        <p:nvSpPr>
+          <p:cNvPr id="29" name="Text 27"/>
+          <p:cNvSpPr/>
+          <p:nvPr/>
+        </p:nvSpPr>
+        <p:spPr>
+          <a:xfrm>
+            <a:off x="1188720" y="5266944"/>
+            <a:ext cx="9235440" cy="914400"/>
+          </a:xfrm>
+          <a:prstGeom prst="rect">
+            <a:avLst/>
+          </a:prstGeom>
+          <a:noFill/>
+          <a:ln/>
+        </p:spPr>
+        <p:txBody>
+          <a:bodyPr wrap="square" lIns="0" tIns="0" rIns="0" bIns="0" rtlCol="0" anchor="t"/>
+          <a:lstStyle/>
+          <a:p>
+            <a:pPr indent="0" marL="0">
+              <a:buNone/>
+            </a:pPr>
+            <a:r>
+              <a:rPr lang="en-US" sz="1300" b="1" dirty="0">
+                <a:solidFill>
+                  <a:srgbClr val="1B3A5C"/>
+                </a:solidFill>
+                <a:latin typeface="Yu Gothic" pitchFamily="34" charset="0"/>
+                <a:ea typeface="Yu Gothic" pitchFamily="34" charset="-122"/>
+                <a:cs typeface="Yu Gothic" pitchFamily="34" charset="-120"/>
+              </a:rPr>
+              <a:t>基盤整備(中長期)
+</a:t>
+            </a:r>
+            <a:pPr indent="0" marL="0">
+              <a:buNone/>
+            </a:pPr>
+            <a:r>
+              <a:rPr lang="en-US" sz="1100" dirty="0">
                 <a:solidFill>
                   <a:srgbClr val="374151"/>
                 </a:solidFill>
@@ -11820,51 +12035,9 @@
                 <a:ea typeface="Yu Gothic" pitchFamily="34" charset="-122"/>
                 <a:cs typeface="Yu Gothic" pitchFamily="34" charset="-120"/>
               </a:rPr>
-              <a:t>フェア来場者をオンライン説明会・LINEへ接続</a:t>
-            </a:r>
-            <a:endParaRPr lang="en-US" sz="1050" dirty="0"/>
-          </a:p>
-          <a:p>
-            <a:pPr marL="342900" indent="-342900">
-              <a:spcAft>
-                <a:spcPts val="1000"/>
-              </a:spcAft>
-              <a:buSzPct val="100000"/>
-              <a:buChar char="•"/>
-            </a:pPr>
-            <a:r>
-              <a:rPr lang="en-US" sz="1050" dirty="0">
-                <a:solidFill>
-                  <a:srgbClr val="374151"/>
-                </a:solidFill>
-                <a:latin typeface="Yu Gothic" pitchFamily="34" charset="0"/>
-                <a:ea typeface="Yu Gothic" pitchFamily="34" charset="-122"/>
-                <a:cs typeface="Yu Gothic" pitchFamily="34" charset="-120"/>
-              </a:rPr>
-              <a:t>Instagram・HPの反応を見てコンテンツを月次で改善</a:t>
-            </a:r>
-            <a:endParaRPr lang="en-US" sz="1050" dirty="0"/>
-          </a:p>
-          <a:p>
-            <a:pPr marL="342900" indent="-342900">
-              <a:spcAft>
-                <a:spcPts val="1000"/>
-              </a:spcAft>
-              <a:buSzPct val="100000"/>
-              <a:buChar char="•"/>
-            </a:pPr>
-            <a:r>
-              <a:rPr lang="en-US" sz="1050" dirty="0">
-                <a:solidFill>
-                  <a:srgbClr val="374151"/>
-                </a:solidFill>
-                <a:latin typeface="Yu Gothic" pitchFamily="34" charset="0"/>
-                <a:ea typeface="Yu Gothic" pitchFamily="34" charset="-122"/>
-                <a:cs typeface="Yu Gothic" pitchFamily="34" charset="-120"/>
-              </a:rPr>
-              <a:t>年間休日数の見直し検討(中長期・経営テーマ)</a:t>
-            </a:r>
-            <a:endParaRPr lang="en-US" sz="1050" dirty="0"/>
+              <a:t>LP・広告の効果測定(コンバージョン計測・GA4)の整備と、若年層応募の最大障壁である年間休日数(土曜出勤)の段階的見直しの検討</a:t>
+            </a:r>
+            <a:endParaRPr lang="en-US" sz="1300" dirty="0"/>
           </a:p>
         </p:txBody>
       </p:sp>
@@ -11933,7 +12106,7 @@
                 <a:ea typeface="Yu Gothic" pitchFamily="34" charset="-122"/>
                 <a:cs typeface="Yu Gothic" pitchFamily="34" charset="-120"/>
               </a:rPr>
-              <a:t>活動履歴 ─ 定例ミーティング・説明会</a:t>
+              <a:t>実行ロードマップ(2026年8月〜)</a:t>
             </a:r>
             <a:endParaRPr lang="en-US" sz="3000" dirty="0"/>
           </a:p>
@@ -11972,7 +12145,7 @@
                 <a:ea typeface="Yu Gothic" pitchFamily="34" charset="-122"/>
                 <a:cs typeface="Yu Gothic" pitchFamily="34" charset="-120"/>
               </a:rPr>
-              <a:t>毎回議事録を共有し、決定事項を翌週までに実行するサイクルを継続</a:t>
+              <a:t>市場ピーク(9〜10月)に間に合わせる時系列プラン</a:t>
             </a:r>
             <a:endParaRPr lang="en-US" sz="1300" dirty="0"/>
           </a:p>
@@ -12017,9 +12190,767 @@
           </a:p>
         </p:txBody>
       </p:sp>
+      <p:sp>
+        <p:nvSpPr>
+          <p:cNvPr id="5" name="Shape 3"/>
+          <p:cNvSpPr/>
+          <p:nvPr/>
+        </p:nvSpPr>
+        <p:spPr>
+          <a:xfrm>
+            <a:off x="548640" y="1645920"/>
+            <a:ext cx="3566160" cy="685800"/>
+          </a:xfrm>
+          <a:prstGeom prst="roundRect">
+            <a:avLst>
+              <a:gd name="adj" fmla="val 10667"/>
+            </a:avLst>
+          </a:prstGeom>
+          <a:solidFill>
+            <a:srgbClr val="E8762C"/>
+          </a:solidFill>
+          <a:ln/>
+        </p:spPr>
+      </p:sp>
+      <p:sp>
+        <p:nvSpPr>
+          <p:cNvPr id="6" name="Text 4"/>
+          <p:cNvSpPr/>
+          <p:nvPr/>
+        </p:nvSpPr>
+        <p:spPr>
+          <a:xfrm>
+            <a:off x="548640" y="1645920"/>
+            <a:ext cx="3566160" cy="685800"/>
+          </a:xfrm>
+          <a:prstGeom prst="rect">
+            <a:avLst/>
+          </a:prstGeom>
+          <a:noFill/>
+          <a:ln/>
+        </p:spPr>
+        <p:txBody>
+          <a:bodyPr wrap="square" lIns="0" tIns="0" rIns="0" bIns="0" rtlCol="0" anchor="ctr"/>
+          <a:lstStyle/>
+          <a:p>
+            <a:pPr algn="ctr" indent="0" marL="0">
+              <a:buNone/>
+            </a:pPr>
+            <a:r>
+              <a:rPr lang="en-US" sz="1600" b="1" dirty="0">
+                <a:solidFill>
+                  <a:srgbClr val="FFFFFF"/>
+                </a:solidFill>
+                <a:latin typeface="Yu Gothic" pitchFamily="34" charset="0"/>
+                <a:ea typeface="Yu Gothic" pitchFamily="34" charset="-122"/>
+                <a:cs typeface="Yu Gothic" pitchFamily="34" charset="-120"/>
+              </a:rPr>
+              <a:t>8月  </a:t>
+            </a:r>
+            <a:pPr algn="ctr" indent="0" marL="0">
+              <a:buNone/>
+            </a:pPr>
+            <a:r>
+              <a:rPr lang="en-US" sz="1200" dirty="0">
+                <a:solidFill>
+                  <a:srgbClr val="FFFFFF"/>
+                </a:solidFill>
+                <a:latin typeface="Yu Gothic" pitchFamily="34" charset="0"/>
+                <a:ea typeface="Yu Gothic" pitchFamily="34" charset="-122"/>
+                <a:cs typeface="Yu Gothic" pitchFamily="34" charset="-120"/>
+              </a:rPr>
+              <a:t>土台を仕上げる</a:t>
+            </a:r>
+            <a:endParaRPr lang="en-US" sz="1600" dirty="0"/>
+          </a:p>
+        </p:txBody>
+      </p:sp>
+      <p:sp>
+        <p:nvSpPr>
+          <p:cNvPr id="7" name="Shape 5"/>
+          <p:cNvSpPr/>
+          <p:nvPr/>
+        </p:nvSpPr>
+        <p:spPr>
+          <a:xfrm>
+            <a:off x="548640" y="2468880"/>
+            <a:ext cx="3566160" cy="3749040"/>
+          </a:xfrm>
+          <a:prstGeom prst="roundRect">
+            <a:avLst>
+              <a:gd name="adj" fmla="val 2051"/>
+            </a:avLst>
+          </a:prstGeom>
+          <a:solidFill>
+            <a:srgbClr val="F2F6FA"/>
+          </a:solidFill>
+          <a:ln/>
+        </p:spPr>
+      </p:sp>
+      <p:sp>
+        <p:nvSpPr>
+          <p:cNvPr id="8" name="Text 6"/>
+          <p:cNvSpPr/>
+          <p:nvPr/>
+        </p:nvSpPr>
+        <p:spPr>
+          <a:xfrm>
+            <a:off x="777240" y="2697480"/>
+            <a:ext cx="3108960" cy="3291840"/>
+          </a:xfrm>
+          <a:prstGeom prst="rect">
+            <a:avLst/>
+          </a:prstGeom>
+          <a:noFill/>
+          <a:ln/>
+        </p:spPr>
+        <p:txBody>
+          <a:bodyPr wrap="square" lIns="0" tIns="0" rIns="0" bIns="0" rtlCol="0" anchor="t"/>
+          <a:lstStyle/>
+          <a:p>
+            <a:pPr marL="342900" indent="-342900">
+              <a:spcAft>
+                <a:spcPts val="1000"/>
+              </a:spcAft>
+              <a:buSzPct val="100000"/>
+              <a:buChar char="•"/>
+            </a:pPr>
+            <a:r>
+              <a:rPr lang="en-US" sz="1050" dirty="0">
+                <a:solidFill>
+                  <a:srgbClr val="374151"/>
+                </a:solidFill>
+                <a:latin typeface="Yu Gothic" pitchFamily="34" charset="0"/>
+                <a:ea typeface="Yu Gothic" pitchFamily="34" charset="-122"/>
+                <a:cs typeface="Yu Gothic" pitchFamily="34" charset="-120"/>
+              </a:rPr>
+              <a:t>採用HPリニューアル完了(お盆前)・Instagram連携</a:t>
+            </a:r>
+            <a:endParaRPr lang="en-US" sz="1050" dirty="0"/>
+          </a:p>
+          <a:p>
+            <a:pPr marL="342900" indent="-342900">
+              <a:spcAft>
+                <a:spcPts val="1000"/>
+              </a:spcAft>
+              <a:buSzPct val="100000"/>
+              <a:buChar char="•"/>
+            </a:pPr>
+            <a:r>
+              <a:rPr lang="en-US" sz="1050" dirty="0">
+                <a:solidFill>
+                  <a:srgbClr val="374151"/>
+                </a:solidFill>
+                <a:latin typeface="Yu Gothic" pitchFamily="34" charset="0"/>
+                <a:ea typeface="Yu Gothic" pitchFamily="34" charset="-122"/>
+                <a:cs typeface="Yu Gothic" pitchFamily="34" charset="-120"/>
+              </a:rPr>
+              <a:t>Instagram定期投稿の開始(共感・安心・安定の3テーマ)</a:t>
+            </a:r>
+            <a:endParaRPr lang="en-US" sz="1050" dirty="0"/>
+          </a:p>
+          <a:p>
+            <a:pPr marL="342900" indent="-342900">
+              <a:spcAft>
+                <a:spcPts val="1000"/>
+              </a:spcAft>
+              <a:buSzPct val="100000"/>
+              <a:buChar char="•"/>
+            </a:pPr>
+            <a:r>
+              <a:rPr lang="en-US" sz="1050" dirty="0">
+                <a:solidFill>
+                  <a:srgbClr val="374151"/>
+                </a:solidFill>
+                <a:latin typeface="Yu Gothic" pitchFamily="34" charset="0"/>
+                <a:ea typeface="Yu Gothic" pitchFamily="34" charset="-122"/>
+                <a:cs typeface="Yu Gothic" pitchFamily="34" charset="-120"/>
+              </a:rPr>
+              <a:t>ハローワーク説明会の予約(8/28以降の枠)</a:t>
+            </a:r>
+            <a:endParaRPr lang="en-US" sz="1050" dirty="0"/>
+          </a:p>
+          <a:p>
+            <a:pPr marL="342900" indent="-342900">
+              <a:spcAft>
+                <a:spcPts val="1000"/>
+              </a:spcAft>
+              <a:buSzPct val="100000"/>
+              <a:buChar char="•"/>
+            </a:pPr>
+            <a:r>
+              <a:rPr lang="en-US" sz="1050" dirty="0">
+                <a:solidFill>
+                  <a:srgbClr val="374151"/>
+                </a:solidFill>
+                <a:latin typeface="Yu Gothic" pitchFamily="34" charset="0"/>
+                <a:ea typeface="Yu Gothic" pitchFamily="34" charset="-122"/>
+                <a:cs typeface="Yu Gothic" pitchFamily="34" charset="-120"/>
+              </a:rPr>
+              <a:t>SMS→LINEの連絡フローを全応募者に標準化</a:t>
+            </a:r>
+            <a:endParaRPr lang="en-US" sz="1050" dirty="0"/>
+          </a:p>
+        </p:txBody>
+      </p:sp>
+      <p:sp>
+        <p:nvSpPr>
+          <p:cNvPr id="9" name="Shape 7"/>
+          <p:cNvSpPr/>
+          <p:nvPr/>
+        </p:nvSpPr>
+        <p:spPr>
+          <a:xfrm>
+            <a:off x="4379976" y="1645920"/>
+            <a:ext cx="3566160" cy="685800"/>
+          </a:xfrm>
+          <a:prstGeom prst="roundRect">
+            <a:avLst>
+              <a:gd name="adj" fmla="val 10667"/>
+            </a:avLst>
+          </a:prstGeom>
+          <a:solidFill>
+            <a:srgbClr val="1B3A5C"/>
+          </a:solidFill>
+          <a:ln/>
+        </p:spPr>
+      </p:sp>
+      <p:sp>
+        <p:nvSpPr>
+          <p:cNvPr id="10" name="Text 8"/>
+          <p:cNvSpPr/>
+          <p:nvPr/>
+        </p:nvSpPr>
+        <p:spPr>
+          <a:xfrm>
+            <a:off x="4379976" y="1645920"/>
+            <a:ext cx="3566160" cy="685800"/>
+          </a:xfrm>
+          <a:prstGeom prst="rect">
+            <a:avLst/>
+          </a:prstGeom>
+          <a:noFill/>
+          <a:ln/>
+        </p:spPr>
+        <p:txBody>
+          <a:bodyPr wrap="square" lIns="0" tIns="0" rIns="0" bIns="0" rtlCol="0" anchor="ctr"/>
+          <a:lstStyle/>
+          <a:p>
+            <a:pPr algn="ctr" indent="0" marL="0">
+              <a:buNone/>
+            </a:pPr>
+            <a:r>
+              <a:rPr lang="en-US" sz="1600" b="1" dirty="0">
+                <a:solidFill>
+                  <a:srgbClr val="FFFFFF"/>
+                </a:solidFill>
+                <a:latin typeface="Yu Gothic" pitchFamily="34" charset="0"/>
+                <a:ea typeface="Yu Gothic" pitchFamily="34" charset="-122"/>
+                <a:cs typeface="Yu Gothic" pitchFamily="34" charset="-120"/>
+              </a:rPr>
+              <a:t>9月  </a:t>
+            </a:r>
+            <a:pPr algn="ctr" indent="0" marL="0">
+              <a:buNone/>
+            </a:pPr>
+            <a:r>
+              <a:rPr lang="en-US" sz="1200" dirty="0">
+                <a:solidFill>
+                  <a:srgbClr val="FFFFFF"/>
+                </a:solidFill>
+                <a:latin typeface="Yu Gothic" pitchFamily="34" charset="0"/>
+                <a:ea typeface="Yu Gothic" pitchFamily="34" charset="-122"/>
+                <a:cs typeface="Yu Gothic" pitchFamily="34" charset="-120"/>
+              </a:rPr>
+              <a:t>接点を仕込む</a:t>
+            </a:r>
+            <a:endParaRPr lang="en-US" sz="1600" dirty="0"/>
+          </a:p>
+        </p:txBody>
+      </p:sp>
+      <p:sp>
+        <p:nvSpPr>
+          <p:cNvPr id="11" name="Shape 9"/>
+          <p:cNvSpPr/>
+          <p:nvPr/>
+        </p:nvSpPr>
+        <p:spPr>
+          <a:xfrm>
+            <a:off x="4379976" y="2468880"/>
+            <a:ext cx="3566160" cy="3749040"/>
+          </a:xfrm>
+          <a:prstGeom prst="roundRect">
+            <a:avLst>
+              <a:gd name="adj" fmla="val 2051"/>
+            </a:avLst>
+          </a:prstGeom>
+          <a:solidFill>
+            <a:srgbClr val="F2F6FA"/>
+          </a:solidFill>
+          <a:ln/>
+        </p:spPr>
+      </p:sp>
+      <p:sp>
+        <p:nvSpPr>
+          <p:cNvPr id="12" name="Text 10"/>
+          <p:cNvSpPr/>
+          <p:nvPr/>
+        </p:nvSpPr>
+        <p:spPr>
+          <a:xfrm>
+            <a:off x="4608576" y="2697480"/>
+            <a:ext cx="3108960" cy="3291840"/>
+          </a:xfrm>
+          <a:prstGeom prst="rect">
+            <a:avLst/>
+          </a:prstGeom>
+          <a:noFill/>
+          <a:ln/>
+        </p:spPr>
+        <p:txBody>
+          <a:bodyPr wrap="square" lIns="0" tIns="0" rIns="0" bIns="0" rtlCol="0" anchor="t"/>
+          <a:lstStyle/>
+          <a:p>
+            <a:pPr marL="342900" indent="-342900">
+              <a:spcAft>
+                <a:spcPts val="1000"/>
+              </a:spcAft>
+              <a:buSzPct val="100000"/>
+              <a:buChar char="•"/>
+            </a:pPr>
+            <a:r>
+              <a:rPr lang="en-US" sz="1050" dirty="0">
+                <a:solidFill>
+                  <a:srgbClr val="374151"/>
+                </a:solidFill>
+                <a:latin typeface="Yu Gothic" pitchFamily="34" charset="0"/>
+                <a:ea typeface="Yu Gothic" pitchFamily="34" charset="-122"/>
+                <a:cs typeface="Yu Gothic" pitchFamily="34" charset="-120"/>
+              </a:rPr>
+              <a:t>マイナビ転職フェア出展の可否判断(費用交渉の結果を反映)</a:t>
+            </a:r>
+            <a:endParaRPr lang="en-US" sz="1050" dirty="0"/>
+          </a:p>
+          <a:p>
+            <a:pPr marL="342900" indent="-342900">
+              <a:spcAft>
+                <a:spcPts val="1000"/>
+              </a:spcAft>
+              <a:buSzPct val="100000"/>
+              <a:buChar char="•"/>
+            </a:pPr>
+            <a:r>
+              <a:rPr lang="en-US" sz="1050" dirty="0">
+                <a:solidFill>
+                  <a:srgbClr val="374151"/>
+                </a:solidFill>
+                <a:latin typeface="Yu Gothic" pitchFamily="34" charset="0"/>
+                <a:ea typeface="Yu Gothic" pitchFamily="34" charset="-122"/>
+                <a:cs typeface="Yu Gothic" pitchFamily="34" charset="-120"/>
+              </a:rPr>
+              <a:t>職人スカウトの費用対効果判断(北陸登録者数の回答受領後)</a:t>
+            </a:r>
+            <a:endParaRPr lang="en-US" sz="1050" dirty="0"/>
+          </a:p>
+          <a:p>
+            <a:pPr marL="342900" indent="-342900">
+              <a:spcAft>
+                <a:spcPts val="1000"/>
+              </a:spcAft>
+              <a:buSzPct val="100000"/>
+              <a:buChar char="•"/>
+            </a:pPr>
+            <a:r>
+              <a:rPr lang="en-US" sz="1050" dirty="0">
+                <a:solidFill>
+                  <a:srgbClr val="374151"/>
+                </a:solidFill>
+                <a:latin typeface="Yu Gothic" pitchFamily="34" charset="0"/>
+                <a:ea typeface="Yu Gothic" pitchFamily="34" charset="-122"/>
+                <a:cs typeface="Yu Gothic" pitchFamily="34" charset="-120"/>
+              </a:rPr>
+              <a:t>「応募→説明会参加」移行率のKPI週次計測を開始</a:t>
+            </a:r>
+            <a:endParaRPr lang="en-US" sz="1050" dirty="0"/>
+          </a:p>
+          <a:p>
+            <a:pPr marL="342900" indent="-342900">
+              <a:spcAft>
+                <a:spcPts val="1000"/>
+              </a:spcAft>
+              <a:buSzPct val="100000"/>
+              <a:buChar char="•"/>
+            </a:pPr>
+            <a:r>
+              <a:rPr lang="en-US" sz="1050" dirty="0">
+                <a:solidFill>
+                  <a:srgbClr val="374151"/>
+                </a:solidFill>
+                <a:latin typeface="Yu Gothic" pitchFamily="34" charset="0"/>
+                <a:ea typeface="Yu Gothic" pitchFamily="34" charset="-122"/>
+                <a:cs typeface="Yu Gothic" pitchFamily="34" charset="-120"/>
+              </a:rPr>
+              <a:t>求人・広告は20・30代向け2軸訴求へ予算集中</a:t>
+            </a:r>
+            <a:endParaRPr lang="en-US" sz="1050" dirty="0"/>
+          </a:p>
+        </p:txBody>
+      </p:sp>
+      <p:sp>
+        <p:nvSpPr>
+          <p:cNvPr id="13" name="Shape 11"/>
+          <p:cNvSpPr/>
+          <p:nvPr/>
+        </p:nvSpPr>
+        <p:spPr>
+          <a:xfrm>
+            <a:off x="8211312" y="1645920"/>
+            <a:ext cx="3566160" cy="685800"/>
+          </a:xfrm>
+          <a:prstGeom prst="roundRect">
+            <a:avLst>
+              <a:gd name="adj" fmla="val 10667"/>
+            </a:avLst>
+          </a:prstGeom>
+          <a:solidFill>
+            <a:srgbClr val="5A7A99"/>
+          </a:solidFill>
+          <a:ln/>
+        </p:spPr>
+      </p:sp>
+      <p:sp>
+        <p:nvSpPr>
+          <p:cNvPr id="14" name="Text 12"/>
+          <p:cNvSpPr/>
+          <p:nvPr/>
+        </p:nvSpPr>
+        <p:spPr>
+          <a:xfrm>
+            <a:off x="8211312" y="1645920"/>
+            <a:ext cx="3566160" cy="685800"/>
+          </a:xfrm>
+          <a:prstGeom prst="rect">
+            <a:avLst/>
+          </a:prstGeom>
+          <a:noFill/>
+          <a:ln/>
+        </p:spPr>
+        <p:txBody>
+          <a:bodyPr wrap="square" lIns="0" tIns="0" rIns="0" bIns="0" rtlCol="0" anchor="ctr"/>
+          <a:lstStyle/>
+          <a:p>
+            <a:pPr algn="ctr" indent="0" marL="0">
+              <a:buNone/>
+            </a:pPr>
+            <a:r>
+              <a:rPr lang="en-US" sz="1600" b="1" dirty="0">
+                <a:solidFill>
+                  <a:srgbClr val="FFFFFF"/>
+                </a:solidFill>
+                <a:latin typeface="Yu Gothic" pitchFamily="34" charset="0"/>
+                <a:ea typeface="Yu Gothic" pitchFamily="34" charset="-122"/>
+                <a:cs typeface="Yu Gothic" pitchFamily="34" charset="-120"/>
+              </a:rPr>
+              <a:t>10月〜  </a:t>
+            </a:r>
+            <a:pPr algn="ctr" indent="0" marL="0">
+              <a:buNone/>
+            </a:pPr>
+            <a:r>
+              <a:rPr lang="en-US" sz="1200" dirty="0">
+                <a:solidFill>
+                  <a:srgbClr val="FFFFFF"/>
+                </a:solidFill>
+                <a:latin typeface="Yu Gothic" pitchFamily="34" charset="0"/>
+                <a:ea typeface="Yu Gothic" pitchFamily="34" charset="-122"/>
+                <a:cs typeface="Yu Gothic" pitchFamily="34" charset="-120"/>
+              </a:rPr>
+              <a:t>ピークで刈り取る</a:t>
+            </a:r>
+            <a:endParaRPr lang="en-US" sz="1600" dirty="0"/>
+          </a:p>
+        </p:txBody>
+      </p:sp>
+      <p:sp>
+        <p:nvSpPr>
+          <p:cNvPr id="15" name="Shape 13"/>
+          <p:cNvSpPr/>
+          <p:nvPr/>
+        </p:nvSpPr>
+        <p:spPr>
+          <a:xfrm>
+            <a:off x="8211312" y="2468880"/>
+            <a:ext cx="3566160" cy="3749040"/>
+          </a:xfrm>
+          <a:prstGeom prst="roundRect">
+            <a:avLst>
+              <a:gd name="adj" fmla="val 2051"/>
+            </a:avLst>
+          </a:prstGeom>
+          <a:solidFill>
+            <a:srgbClr val="F2F6FA"/>
+          </a:solidFill>
+          <a:ln/>
+        </p:spPr>
+      </p:sp>
+      <p:sp>
+        <p:nvSpPr>
+          <p:cNvPr id="16" name="Text 14"/>
+          <p:cNvSpPr/>
+          <p:nvPr/>
+        </p:nvSpPr>
+        <p:spPr>
+          <a:xfrm>
+            <a:off x="8439912" y="2697480"/>
+            <a:ext cx="3108960" cy="3291840"/>
+          </a:xfrm>
+          <a:prstGeom prst="rect">
+            <a:avLst/>
+          </a:prstGeom>
+          <a:noFill/>
+          <a:ln/>
+        </p:spPr>
+        <p:txBody>
+          <a:bodyPr wrap="square" lIns="0" tIns="0" rIns="0" bIns="0" rtlCol="0" anchor="t"/>
+          <a:lstStyle/>
+          <a:p>
+            <a:pPr marL="342900" indent="-342900">
+              <a:spcAft>
+                <a:spcPts val="1000"/>
+              </a:spcAft>
+              <a:buSzPct val="100000"/>
+              <a:buChar char="•"/>
+            </a:pPr>
+            <a:r>
+              <a:rPr lang="en-US" sz="1050" dirty="0">
+                <a:solidFill>
+                  <a:srgbClr val="374151"/>
+                </a:solidFill>
+                <a:latin typeface="Yu Gothic" pitchFamily="34" charset="0"/>
+                <a:ea typeface="Yu Gothic" pitchFamily="34" charset="-122"/>
+                <a:cs typeface="Yu Gothic" pitchFamily="34" charset="-120"/>
+              </a:rPr>
+              <a:t>ハローワーク説明会・転職フェア(10月/1月)へ参加</a:t>
+            </a:r>
+            <a:endParaRPr lang="en-US" sz="1050" dirty="0"/>
+          </a:p>
+          <a:p>
+            <a:pPr marL="342900" indent="-342900">
+              <a:spcAft>
+                <a:spcPts val="1000"/>
+              </a:spcAft>
+              <a:buSzPct val="100000"/>
+              <a:buChar char="•"/>
+            </a:pPr>
+            <a:r>
+              <a:rPr lang="en-US" sz="1050" dirty="0">
+                <a:solidFill>
+                  <a:srgbClr val="374151"/>
+                </a:solidFill>
+                <a:latin typeface="Yu Gothic" pitchFamily="34" charset="0"/>
+                <a:ea typeface="Yu Gothic" pitchFamily="34" charset="-122"/>
+                <a:cs typeface="Yu Gothic" pitchFamily="34" charset="-120"/>
+              </a:rPr>
+              <a:t>フェア来場者をオンライン説明会・LINEへ接続</a:t>
+            </a:r>
+            <a:endParaRPr lang="en-US" sz="1050" dirty="0"/>
+          </a:p>
+          <a:p>
+            <a:pPr marL="342900" indent="-342900">
+              <a:spcAft>
+                <a:spcPts val="1000"/>
+              </a:spcAft>
+              <a:buSzPct val="100000"/>
+              <a:buChar char="•"/>
+            </a:pPr>
+            <a:r>
+              <a:rPr lang="en-US" sz="1050" dirty="0">
+                <a:solidFill>
+                  <a:srgbClr val="374151"/>
+                </a:solidFill>
+                <a:latin typeface="Yu Gothic" pitchFamily="34" charset="0"/>
+                <a:ea typeface="Yu Gothic" pitchFamily="34" charset="-122"/>
+                <a:cs typeface="Yu Gothic" pitchFamily="34" charset="-120"/>
+              </a:rPr>
+              <a:t>Instagram・HPの反応を見てコンテンツを月次で改善</a:t>
+            </a:r>
+            <a:endParaRPr lang="en-US" sz="1050" dirty="0"/>
+          </a:p>
+          <a:p>
+            <a:pPr marL="342900" indent="-342900">
+              <a:spcAft>
+                <a:spcPts val="1000"/>
+              </a:spcAft>
+              <a:buSzPct val="100000"/>
+              <a:buChar char="•"/>
+            </a:pPr>
+            <a:r>
+              <a:rPr lang="en-US" sz="1050" dirty="0">
+                <a:solidFill>
+                  <a:srgbClr val="374151"/>
+                </a:solidFill>
+                <a:latin typeface="Yu Gothic" pitchFamily="34" charset="0"/>
+                <a:ea typeface="Yu Gothic" pitchFamily="34" charset="-122"/>
+                <a:cs typeface="Yu Gothic" pitchFamily="34" charset="-120"/>
+              </a:rPr>
+              <a:t>年間休日数の見直し検討(中長期・経営テーマ)</a:t>
+            </a:r>
+            <a:endParaRPr lang="en-US" sz="1050" dirty="0"/>
+          </a:p>
+        </p:txBody>
+      </p:sp>
+    </p:spTree>
+  </p:cSld>
+  <p:clrMapOvr>
+    <a:masterClrMapping/>
+  </p:clrMapOvr>
+</p:sld>
+</file>
+
+<file path=ppt/slides/slide19.xml><?xml version="1.0" encoding="utf-8"?>
+<p:sld xmlns:a="http://schemas.openxmlformats.org/drawingml/2006/main" xmlns:r="http://schemas.openxmlformats.org/officeDocument/2006/relationships" xmlns:p="http://schemas.openxmlformats.org/presentationml/2006/main">
+  <p:cSld name="Slide 19">
+    <p:bg>
+      <p:bgPr>
+        <a:solidFill>
+          <a:srgbClr val="FFFFFF"/>
+        </a:solidFill>
+      </p:bgPr>
+    </p:bg>
+    <p:spTree>
+      <p:nvGrpSpPr>
+        <p:cNvPr id="1" name=""/>
+        <p:cNvGrpSpPr/>
+        <p:nvPr/>
+      </p:nvGrpSpPr>
+      <p:grpSpPr>
+        <a:xfrm>
+          <a:off x="0" y="0"/>
+          <a:ext cx="0" cy="0"/>
+          <a:chOff x="0" y="0"/>
+          <a:chExt cx="0" cy="0"/>
+        </a:xfrm>
+      </p:grpSpPr>
+      <p:sp>
+        <p:nvSpPr>
+          <p:cNvPr id="2" name="Text 0"/>
+          <p:cNvSpPr/>
+          <p:nvPr/>
+        </p:nvSpPr>
+        <p:spPr>
+          <a:xfrm>
+            <a:off x="548640" y="292608"/>
+            <a:ext cx="9601200" cy="685800"/>
+          </a:xfrm>
+          <a:prstGeom prst="rect">
+            <a:avLst/>
+          </a:prstGeom>
+          <a:noFill/>
+          <a:ln/>
+        </p:spPr>
+        <p:txBody>
+          <a:bodyPr wrap="square" lIns="0" tIns="0" rIns="0" bIns="0" rtlCol="0" anchor="ctr"/>
+          <a:lstStyle/>
+          <a:p>
+            <a:pPr indent="0" marL="0">
+              <a:buNone/>
+            </a:pPr>
+            <a:r>
+              <a:rPr lang="en-US" sz="3000" b="1" dirty="0">
+                <a:solidFill>
+                  <a:srgbClr val="1B3A5C"/>
+                </a:solidFill>
+                <a:latin typeface="Yu Gothic" pitchFamily="34" charset="0"/>
+                <a:ea typeface="Yu Gothic" pitchFamily="34" charset="-122"/>
+                <a:cs typeface="Yu Gothic" pitchFamily="34" charset="-120"/>
+              </a:rPr>
+              <a:t>活動履歴 ─ 定例ミーティング・説明会</a:t>
+            </a:r>
+            <a:endParaRPr lang="en-US" sz="3000" dirty="0"/>
+          </a:p>
+        </p:txBody>
+      </p:sp>
+      <p:sp>
+        <p:nvSpPr>
+          <p:cNvPr id="3" name="Text 1"/>
+          <p:cNvSpPr/>
+          <p:nvPr/>
+        </p:nvSpPr>
+        <p:spPr>
+          <a:xfrm>
+            <a:off x="566928" y="932688"/>
+            <a:ext cx="10515600" cy="365760"/>
+          </a:xfrm>
+          <a:prstGeom prst="rect">
+            <a:avLst/>
+          </a:prstGeom>
+          <a:noFill/>
+          <a:ln/>
+        </p:spPr>
+        <p:txBody>
+          <a:bodyPr wrap="square" lIns="0" tIns="0" rIns="0" bIns="0" rtlCol="0" anchor="ctr"/>
+          <a:lstStyle/>
+          <a:p>
+            <a:pPr indent="0" marL="0">
+              <a:buNone/>
+            </a:pPr>
+            <a:r>
+              <a:rPr lang="en-US" sz="1300" dirty="0">
+                <a:solidFill>
+                  <a:srgbClr val="6B7280"/>
+                </a:solidFill>
+                <a:latin typeface="Yu Gothic" pitchFamily="34" charset="0"/>
+                <a:ea typeface="Yu Gothic" pitchFamily="34" charset="-122"/>
+                <a:cs typeface="Yu Gothic" pitchFamily="34" charset="-120"/>
+              </a:rPr>
+              <a:t>毎回議事録を共有し、決定事項を翌週までに実行するサイクルを継続</a:t>
+            </a:r>
+            <a:endParaRPr lang="en-US" sz="1300" dirty="0"/>
+          </a:p>
+        </p:txBody>
+      </p:sp>
+      <p:sp>
+        <p:nvSpPr>
+          <p:cNvPr id="4" name="Text 2"/>
+          <p:cNvSpPr/>
+          <p:nvPr/>
+        </p:nvSpPr>
+        <p:spPr>
+          <a:xfrm>
+            <a:off x="11292840" y="320040"/>
+            <a:ext cx="640080" cy="457200"/>
+          </a:xfrm>
+          <a:prstGeom prst="rect">
+            <a:avLst/>
+          </a:prstGeom>
+          <a:noFill/>
+          <a:ln/>
+        </p:spPr>
+        <p:txBody>
+          <a:bodyPr wrap="square" lIns="0" tIns="0" rIns="0" bIns="0" rtlCol="0" anchor="ctr"/>
+          <a:lstStyle/>
+          <a:p>
+            <a:pPr algn="r" indent="0" marL="0">
+              <a:buNone/>
+            </a:pPr>
+            <a:r>
+              <a:rPr lang="en-US" sz="1600" b="1" dirty="0">
+                <a:solidFill>
+                  <a:srgbClr val="5A7A99"/>
+                </a:solidFill>
+                <a:latin typeface="Arial" pitchFamily="34" charset="0"/>
+                <a:ea typeface="Arial" pitchFamily="34" charset="-122"/>
+                <a:cs typeface="Arial" pitchFamily="34" charset="-120"/>
+              </a:rPr>
+              <a:t>19</a:t>
+            </a:r>
+            <a:endParaRPr lang="en-US" sz="1600" dirty="0"/>
+          </a:p>
+        </p:txBody>
+      </p:sp>
       <p:graphicFrame>
         <p:nvGraphicFramePr>
-          <p:cNvPr id="19" name="Table 0"/>
+          <p:cNvPr id="20" name="Table 0"/>
           <p:cNvGraphicFramePr>
             <a:graphicFrameLocks noGrp="1"/>
           </p:cNvGraphicFramePr>
@@ -13705,7 +14636,7 @@
       </p:graphicFrame>
       <p:graphicFrame>
         <p:nvGraphicFramePr>
-          <p:cNvPr id="37" name="Table 1"/>
+          <p:cNvPr id="39" name="Table 1"/>
           <p:cNvGraphicFramePr>
             <a:graphicFrameLocks noGrp="1"/>
           </p:cNvGraphicFramePr>
@@ -15436,209 +16367,6 @@
 </p:sld>
 </file>
 
-<file path=ppt/slides/slide19.xml><?xml version="1.0" encoding="utf-8"?>
-<p:sld xmlns:a="http://schemas.openxmlformats.org/drawingml/2006/main" xmlns:r="http://schemas.openxmlformats.org/officeDocument/2006/relationships" xmlns:p="http://schemas.openxmlformats.org/presentationml/2006/main">
-  <p:cSld name="Slide 19">
-    <p:bg>
-      <p:bgPr>
-        <a:solidFill>
-          <a:srgbClr val="12293F"/>
-        </a:solidFill>
-      </p:bgPr>
-    </p:bg>
-    <p:spTree>
-      <p:nvGrpSpPr>
-        <p:cNvPr id="1" name=""/>
-        <p:cNvGrpSpPr/>
-        <p:nvPr/>
-      </p:nvGrpSpPr>
-      <p:grpSpPr>
-        <a:xfrm>
-          <a:off x="0" y="0"/>
-          <a:ext cx="0" cy="0"/>
-          <a:chOff x="0" y="0"/>
-          <a:chExt cx="0" cy="0"/>
-        </a:xfrm>
-      </p:grpSpPr>
-      <p:sp>
-        <p:nvSpPr>
-          <p:cNvPr id="2" name="Shape 0"/>
-          <p:cNvSpPr/>
-          <p:nvPr/>
-        </p:nvSpPr>
-        <p:spPr>
-          <a:xfrm>
-            <a:off x="-1645920" y="-1645920"/>
-            <a:ext cx="4206240" cy="4206240"/>
-          </a:xfrm>
-          <a:prstGeom prst="ellipse">
-            <a:avLst/>
-          </a:prstGeom>
-          <a:solidFill>
-            <a:srgbClr val="1B3A5C"/>
-          </a:solidFill>
-          <a:ln/>
-        </p:spPr>
-      </p:sp>
-      <p:sp>
-        <p:nvSpPr>
-          <p:cNvPr id="3" name="Text 1"/>
-          <p:cNvSpPr/>
-          <p:nvPr/>
-        </p:nvSpPr>
-        <p:spPr>
-          <a:xfrm>
-            <a:off x="914400" y="2103120"/>
-            <a:ext cx="10332720" cy="1554480"/>
-          </a:xfrm>
-          <a:prstGeom prst="rect">
-            <a:avLst/>
-          </a:prstGeom>
-          <a:noFill/>
-          <a:ln/>
-        </p:spPr>
-        <p:txBody>
-          <a:bodyPr wrap="square" lIns="0" tIns="0" rIns="0" bIns="0" rtlCol="0" anchor="ctr"/>
-          <a:lstStyle/>
-          <a:p>
-            <a:pPr indent="0" marL="0">
-              <a:buNone/>
-            </a:pPr>
-            <a:r>
-              <a:rPr lang="en-US" sz="3400" b="1" dirty="0">
-                <a:solidFill>
-                  <a:srgbClr val="FFFFFF"/>
-                </a:solidFill>
-                <a:latin typeface="Yu Gothic" pitchFamily="34" charset="0"/>
-                <a:ea typeface="Yu Gothic" pitchFamily="34" charset="-122"/>
-                <a:cs typeface="Yu Gothic" pitchFamily="34" charset="-120"/>
-              </a:rPr>
-              <a:t>引き続き、松下工業様の</a:t>
-            </a:r>
-            <a:endParaRPr lang="en-US" sz="3400" dirty="0"/>
-          </a:p>
-          <a:p>
-            <a:pPr indent="0" marL="0">
-              <a:buNone/>
-            </a:pPr>
-            <a:r>
-              <a:rPr lang="en-US" sz="3400" b="1" dirty="0">
-                <a:solidFill>
-                  <a:srgbClr val="FFFFFF"/>
-                </a:solidFill>
-                <a:latin typeface="Yu Gothic" pitchFamily="34" charset="0"/>
-                <a:ea typeface="Yu Gothic" pitchFamily="34" charset="-122"/>
-                <a:cs typeface="Yu Gothic" pitchFamily="34" charset="-120"/>
-              </a:rPr>
-              <a:t>採用成功に伴走いたします</a:t>
-            </a:r>
-            <a:endParaRPr lang="en-US" sz="3400" dirty="0"/>
-          </a:p>
-        </p:txBody>
-      </p:sp>
-      <p:sp>
-        <p:nvSpPr>
-          <p:cNvPr id="4" name="Text 2"/>
-          <p:cNvSpPr/>
-          <p:nvPr/>
-        </p:nvSpPr>
-        <p:spPr>
-          <a:xfrm>
-            <a:off x="932688" y="3794760"/>
-            <a:ext cx="10058400" cy="822960"/>
-          </a:xfrm>
-          <a:prstGeom prst="rect">
-            <a:avLst/>
-          </a:prstGeom>
-          <a:noFill/>
-          <a:ln/>
-        </p:spPr>
-        <p:txBody>
-          <a:bodyPr wrap="square" lIns="0" tIns="0" rIns="0" bIns="0" rtlCol="0" anchor="ctr"/>
-          <a:lstStyle/>
-          <a:p>
-            <a:pPr indent="0" marL="0">
-              <a:buNone/>
-            </a:pPr>
-            <a:r>
-              <a:rPr lang="en-US" sz="1400" dirty="0">
-                <a:solidFill>
-                  <a:srgbClr val="CADCFC"/>
-                </a:solidFill>
-                <a:latin typeface="Yu Gothic" pitchFamily="34" charset="0"/>
-                <a:ea typeface="Yu Gothic" pitchFamily="34" charset="-122"/>
-                <a:cs typeface="Yu Gothic" pitchFamily="34" charset="-120"/>
-              </a:rPr>
-              <a:t>9ヶ月間、密なご協力をいただき誠にありがとうございました。</a:t>
-            </a:r>
-            <a:endParaRPr lang="en-US" sz="1400" dirty="0"/>
-          </a:p>
-          <a:p>
-            <a:pPr indent="0" marL="0">
-              <a:buNone/>
-            </a:pPr>
-            <a:r>
-              <a:rPr lang="en-US" sz="1400" dirty="0">
-                <a:solidFill>
-                  <a:srgbClr val="CADCFC"/>
-                </a:solidFill>
-                <a:latin typeface="Yu Gothic" pitchFamily="34" charset="0"/>
-                <a:ea typeface="Yu Gothic" pitchFamily="34" charset="-122"/>
-                <a:cs typeface="Yu Gothic" pitchFamily="34" charset="-120"/>
-              </a:rPr>
-              <a:t>築き上げた採用基盤と検証結果を、これからの成果につなげてまいります。</a:t>
-            </a:r>
-            <a:endParaRPr lang="en-US" sz="1400" dirty="0"/>
-          </a:p>
-        </p:txBody>
-      </p:sp>
-      <p:sp>
-        <p:nvSpPr>
-          <p:cNvPr id="5" name="Text 3"/>
-          <p:cNvSpPr/>
-          <p:nvPr/>
-        </p:nvSpPr>
-        <p:spPr>
-          <a:xfrm>
-            <a:off x="932688" y="5852160"/>
-            <a:ext cx="7315200" cy="365760"/>
-          </a:xfrm>
-          <a:prstGeom prst="rect">
-            <a:avLst/>
-          </a:prstGeom>
-          <a:noFill/>
-          <a:ln/>
-        </p:spPr>
-        <p:txBody>
-          <a:bodyPr wrap="square" lIns="0" tIns="0" rIns="0" bIns="0" rtlCol="0" anchor="ctr"/>
-          <a:lstStyle/>
-          <a:p>
-            <a:pPr indent="0" marL="0">
-              <a:buNone/>
-            </a:pPr>
-            <a:r>
-              <a:rPr lang="en-US" sz="1200" dirty="0">
-                <a:solidFill>
-                  <a:srgbClr val="9FB8D4"/>
-                </a:solidFill>
-                <a:latin typeface="Yu Gothic" pitchFamily="34" charset="0"/>
-                <a:ea typeface="Yu Gothic" pitchFamily="34" charset="-122"/>
-                <a:cs typeface="Yu Gothic" pitchFamily="34" charset="-120"/>
-              </a:rPr>
-              <a:t>Talenco  担当:佐々木 純平</a:t>
-            </a:r>
-            <a:endParaRPr lang="en-US" sz="1200" dirty="0"/>
-          </a:p>
-        </p:txBody>
-      </p:sp>
-    </p:spTree>
-  </p:cSld>
-  <p:clrMapOvr>
-    <a:masterClrMapping/>
-  </p:clrMapOvr>
-</p:sld>
-</file>
-
 <file path=ppt/slides/slide2.xml><?xml version="1.0" encoding="utf-8"?>
 <p:sld xmlns:a="http://schemas.openxmlformats.org/drawingml/2006/main" xmlns:r="http://schemas.openxmlformats.org/officeDocument/2006/relationships" xmlns:p="http://schemas.openxmlformats.org/presentationml/2006/main">
   <p:cSld name="Slide 2">
@@ -16781,6 +17509,209 @@
               <a:t>応募から選考への移行が壁(書類通過・面接0名)。①経験者市場の不足 ②情報の透明性不足 ③求職者との接点不足 の3つの課題認識と対応策を後半でご提案します。</a:t>
             </a:r>
             <a:endParaRPr lang="en-US" sz="1250" dirty="0"/>
+          </a:p>
+        </p:txBody>
+      </p:sp>
+    </p:spTree>
+  </p:cSld>
+  <p:clrMapOvr>
+    <a:masterClrMapping/>
+  </p:clrMapOvr>
+</p:sld>
+</file>
+
+<file path=ppt/slides/slide20.xml><?xml version="1.0" encoding="utf-8"?>
+<p:sld xmlns:a="http://schemas.openxmlformats.org/drawingml/2006/main" xmlns:r="http://schemas.openxmlformats.org/officeDocument/2006/relationships" xmlns:p="http://schemas.openxmlformats.org/presentationml/2006/main">
+  <p:cSld name="Slide 20">
+    <p:bg>
+      <p:bgPr>
+        <a:solidFill>
+          <a:srgbClr val="12293F"/>
+        </a:solidFill>
+      </p:bgPr>
+    </p:bg>
+    <p:spTree>
+      <p:nvGrpSpPr>
+        <p:cNvPr id="1" name=""/>
+        <p:cNvGrpSpPr/>
+        <p:nvPr/>
+      </p:nvGrpSpPr>
+      <p:grpSpPr>
+        <a:xfrm>
+          <a:off x="0" y="0"/>
+          <a:ext cx="0" cy="0"/>
+          <a:chOff x="0" y="0"/>
+          <a:chExt cx="0" cy="0"/>
+        </a:xfrm>
+      </p:grpSpPr>
+      <p:sp>
+        <p:nvSpPr>
+          <p:cNvPr id="2" name="Shape 0"/>
+          <p:cNvSpPr/>
+          <p:nvPr/>
+        </p:nvSpPr>
+        <p:spPr>
+          <a:xfrm>
+            <a:off x="-1645920" y="-1645920"/>
+            <a:ext cx="4206240" cy="4206240"/>
+          </a:xfrm>
+          <a:prstGeom prst="ellipse">
+            <a:avLst/>
+          </a:prstGeom>
+          <a:solidFill>
+            <a:srgbClr val="1B3A5C"/>
+          </a:solidFill>
+          <a:ln/>
+        </p:spPr>
+      </p:sp>
+      <p:sp>
+        <p:nvSpPr>
+          <p:cNvPr id="3" name="Text 1"/>
+          <p:cNvSpPr/>
+          <p:nvPr/>
+        </p:nvSpPr>
+        <p:spPr>
+          <a:xfrm>
+            <a:off x="914400" y="2103120"/>
+            <a:ext cx="10332720" cy="1554480"/>
+          </a:xfrm>
+          <a:prstGeom prst="rect">
+            <a:avLst/>
+          </a:prstGeom>
+          <a:noFill/>
+          <a:ln/>
+        </p:spPr>
+        <p:txBody>
+          <a:bodyPr wrap="square" lIns="0" tIns="0" rIns="0" bIns="0" rtlCol="0" anchor="ctr"/>
+          <a:lstStyle/>
+          <a:p>
+            <a:pPr indent="0" marL="0">
+              <a:buNone/>
+            </a:pPr>
+            <a:r>
+              <a:rPr lang="en-US" sz="3400" b="1" dirty="0">
+                <a:solidFill>
+                  <a:srgbClr val="FFFFFF"/>
+                </a:solidFill>
+                <a:latin typeface="Yu Gothic" pitchFamily="34" charset="0"/>
+                <a:ea typeface="Yu Gothic" pitchFamily="34" charset="-122"/>
+                <a:cs typeface="Yu Gothic" pitchFamily="34" charset="-120"/>
+              </a:rPr>
+              <a:t>引き続き、松下工業様の</a:t>
+            </a:r>
+            <a:endParaRPr lang="en-US" sz="3400" dirty="0"/>
+          </a:p>
+          <a:p>
+            <a:pPr indent="0" marL="0">
+              <a:buNone/>
+            </a:pPr>
+            <a:r>
+              <a:rPr lang="en-US" sz="3400" b="1" dirty="0">
+                <a:solidFill>
+                  <a:srgbClr val="FFFFFF"/>
+                </a:solidFill>
+                <a:latin typeface="Yu Gothic" pitchFamily="34" charset="0"/>
+                <a:ea typeface="Yu Gothic" pitchFamily="34" charset="-122"/>
+                <a:cs typeface="Yu Gothic" pitchFamily="34" charset="-120"/>
+              </a:rPr>
+              <a:t>採用成功に伴走いたします</a:t>
+            </a:r>
+            <a:endParaRPr lang="en-US" sz="3400" dirty="0"/>
+          </a:p>
+        </p:txBody>
+      </p:sp>
+      <p:sp>
+        <p:nvSpPr>
+          <p:cNvPr id="4" name="Text 2"/>
+          <p:cNvSpPr/>
+          <p:nvPr/>
+        </p:nvSpPr>
+        <p:spPr>
+          <a:xfrm>
+            <a:off x="932688" y="3794760"/>
+            <a:ext cx="10058400" cy="822960"/>
+          </a:xfrm>
+          <a:prstGeom prst="rect">
+            <a:avLst/>
+          </a:prstGeom>
+          <a:noFill/>
+          <a:ln/>
+        </p:spPr>
+        <p:txBody>
+          <a:bodyPr wrap="square" lIns="0" tIns="0" rIns="0" bIns="0" rtlCol="0" anchor="ctr"/>
+          <a:lstStyle/>
+          <a:p>
+            <a:pPr indent="0" marL="0">
+              <a:buNone/>
+            </a:pPr>
+            <a:r>
+              <a:rPr lang="en-US" sz="1400" dirty="0">
+                <a:solidFill>
+                  <a:srgbClr val="CADCFC"/>
+                </a:solidFill>
+                <a:latin typeface="Yu Gothic" pitchFamily="34" charset="0"/>
+                <a:ea typeface="Yu Gothic" pitchFamily="34" charset="-122"/>
+                <a:cs typeface="Yu Gothic" pitchFamily="34" charset="-120"/>
+              </a:rPr>
+              <a:t>9ヶ月間、密なご協力をいただき誠にありがとうございました。</a:t>
+            </a:r>
+            <a:endParaRPr lang="en-US" sz="1400" dirty="0"/>
+          </a:p>
+          <a:p>
+            <a:pPr indent="0" marL="0">
+              <a:buNone/>
+            </a:pPr>
+            <a:r>
+              <a:rPr lang="en-US" sz="1400" dirty="0">
+                <a:solidFill>
+                  <a:srgbClr val="CADCFC"/>
+                </a:solidFill>
+                <a:latin typeface="Yu Gothic" pitchFamily="34" charset="0"/>
+                <a:ea typeface="Yu Gothic" pitchFamily="34" charset="-122"/>
+                <a:cs typeface="Yu Gothic" pitchFamily="34" charset="-120"/>
+              </a:rPr>
+              <a:t>築き上げた採用基盤と検証結果を、これからの成果につなげてまいります。</a:t>
+            </a:r>
+            <a:endParaRPr lang="en-US" sz="1400" dirty="0"/>
+          </a:p>
+        </p:txBody>
+      </p:sp>
+      <p:sp>
+        <p:nvSpPr>
+          <p:cNvPr id="5" name="Text 3"/>
+          <p:cNvSpPr/>
+          <p:nvPr/>
+        </p:nvSpPr>
+        <p:spPr>
+          <a:xfrm>
+            <a:off x="932688" y="5852160"/>
+            <a:ext cx="7315200" cy="365760"/>
+          </a:xfrm>
+          <a:prstGeom prst="rect">
+            <a:avLst/>
+          </a:prstGeom>
+          <a:noFill/>
+          <a:ln/>
+        </p:spPr>
+        <p:txBody>
+          <a:bodyPr wrap="square" lIns="0" tIns="0" rIns="0" bIns="0" rtlCol="0" anchor="ctr"/>
+          <a:lstStyle/>
+          <a:p>
+            <a:pPr indent="0" marL="0">
+              <a:buNone/>
+            </a:pPr>
+            <a:r>
+              <a:rPr lang="en-US" sz="1200" dirty="0">
+                <a:solidFill>
+                  <a:srgbClr val="9FB8D4"/>
+                </a:solidFill>
+                <a:latin typeface="Yu Gothic" pitchFamily="34" charset="0"/>
+                <a:ea typeface="Yu Gothic" pitchFamily="34" charset="-122"/>
+                <a:cs typeface="Yu Gothic" pitchFamily="34" charset="-120"/>
+              </a:rPr>
+              <a:t>Talenco  担当:佐々木 純平</a:t>
+            </a:r>
+            <a:endParaRPr lang="en-US" sz="1200" dirty="0"/>
           </a:p>
         </p:txBody>
       </p:sp>

</xml_diff>